<commit_message>
Deploying to gh-pages from @ ManuelePasini/slides-markdown@5f9ba76222d325d2ac7f20b7887be6024d4e6f25 🚀
</commit_message>
<xml_diff>
--- a/3rd_year_slides.pptx
+++ b/3rd_year_slides.pptx
@@ -10,6 +10,7 @@
     <p:sldId id="258" r:id="rId4"/>
     <p:sldId id="259" r:id="rId5"/>
     <p:sldId id="260" r:id="rId6"/>
+    <p:sldId id="261" r:id="rId7"/>
   </p:sldIdLst>
   <p:sldSz cx="9144000" cy="5143500" type="screen16x9"/>
   <p:notesSz cx="6858000" cy="9144000"/>
@@ -3213,7 +3214,7 @@
             <a:pPr lvl="2"/>
             <a:r>
               <a:rPr/>
-              <a:t>Database / Data engineering</a:t>
+              <a:t>Database / Data Engineering</a:t>
             </a:r>
           </a:p>
           <a:p>
@@ -3256,7 +3257,7 @@
       </p:grpSpPr>
       <p:pic>
         <p:nvPicPr>
-          <p:cNvPr descr="https://github.com/ManuelePasini/slides-markdown/blob/master/slides/images/phd3rdyear/dataplat.png?raw=true" id="0" name="Picture 1"/>
+          <p:cNvPr descr="https://github.com/ManuelePasini/slides-markdown/blob/master/slides/images/dt/dt.png?raw=true" id="0" name="Picture 1"/>
           <p:cNvPicPr>
             <a:picLocks noGrp="1" noChangeAspect="1"/>
           </p:cNvPicPr>
@@ -3270,7 +3271,67 @@
         </p:blipFill>
         <p:spPr bwMode="auto">
           <a:xfrm>
-            <a:off x="457200" y="1485900"/>
+            <a:off x="457200" y="1422400"/>
+            <a:ext cx="4038600" cy="2438400"/>
+          </a:xfrm>
+          <a:prstGeom prst="rect">
+            <a:avLst/>
+          </a:prstGeom>
+          <a:noFill/>
+          <a:ln w="9525">
+            <a:noFill/>
+            <a:headEnd/>
+            <a:tailEnd/>
+          </a:ln>
+        </p:spPr>
+      </p:pic>
+      <p:sp>
+        <p:nvSpPr>
+          <p:cNvPr id="1" name="TextBox 3"/>
+          <p:cNvSpPr txBox="1"/>
+          <p:nvPr/>
+        </p:nvSpPr>
+        <p:spPr>
+          <a:xfrm>
+            <a:off x="457200" y="4076700"/>
+            <a:ext cx="4038600" cy="508000"/>
+          </a:xfrm>
+          <a:prstGeom prst="rect">
+            <a:avLst/>
+          </a:prstGeom>
+          <a:noFill/>
+        </p:spPr>
+        <p:txBody>
+          <a:bodyPr/>
+          <a:lstStyle/>
+          <a:p>
+            <a:pPr lvl="0" indent="0" marL="0" algn="ctr">
+              <a:buNone/>
+            </a:pPr>
+            <a:r>
+              <a:rPr/>
+              <a:t>Digital Twin functional view</a:t>
+            </a:r>
+          </a:p>
+        </p:txBody>
+      </p:sp>
+      <p:pic>
+        <p:nvPicPr>
+          <p:cNvPr descr="https://github.com/ManuelePasini/slides-markdown/blob/master/slides/images/phd3rdyear/dataplat.png?raw=true" id="0" name="Picture 1"/>
+          <p:cNvPicPr>
+            <a:picLocks noGrp="1" noChangeAspect="1"/>
+          </p:cNvPicPr>
+          <p:nvPr/>
+        </p:nvPicPr>
+        <p:blipFill>
+          <a:blip r:embed="rId3"/>
+          <a:stretch>
+            <a:fillRect/>
+          </a:stretch>
+        </p:blipFill>
+        <p:spPr bwMode="auto">
+          <a:xfrm>
+            <a:off x="4648200" y="1485900"/>
             <a:ext cx="4038600" cy="2298700"/>
           </a:xfrm>
           <a:prstGeom prst="rect">
@@ -3292,66 +3353,6 @@
         </p:nvSpPr>
         <p:spPr>
           <a:xfrm>
-            <a:off x="457200" y="4076700"/>
-            <a:ext cx="4038600" cy="508000"/>
-          </a:xfrm>
-          <a:prstGeom prst="rect">
-            <a:avLst/>
-          </a:prstGeom>
-          <a:noFill/>
-        </p:spPr>
-        <p:txBody>
-          <a:bodyPr/>
-          <a:lstStyle/>
-          <a:p>
-            <a:pPr lvl="0" indent="0" marL="0" algn="ctr">
-              <a:buNone/>
-            </a:pPr>
-            <a:r>
-              <a:rPr/>
-              <a:t>An example of a data pipeline</a:t>
-            </a:r>
-          </a:p>
-        </p:txBody>
-      </p:sp>
-      <p:pic>
-        <p:nvPicPr>
-          <p:cNvPr descr="https://github.com/ManuelePasini/slides-markdown/blob/master/slides/images/dt/dt.png?raw=true" id="0" name="Picture 1"/>
-          <p:cNvPicPr>
-            <a:picLocks noGrp="1" noChangeAspect="1"/>
-          </p:cNvPicPr>
-          <p:nvPr/>
-        </p:nvPicPr>
-        <p:blipFill>
-          <a:blip r:embed="rId3"/>
-          <a:stretch>
-            <a:fillRect/>
-          </a:stretch>
-        </p:blipFill>
-        <p:spPr bwMode="auto">
-          <a:xfrm>
-            <a:off x="4648200" y="1422400"/>
-            <a:ext cx="4038600" cy="2438400"/>
-          </a:xfrm>
-          <a:prstGeom prst="rect">
-            <a:avLst/>
-          </a:prstGeom>
-          <a:noFill/>
-          <a:ln w="9525">
-            <a:noFill/>
-            <a:headEnd/>
-            <a:tailEnd/>
-          </a:ln>
-        </p:spPr>
-      </p:pic>
-      <p:sp>
-        <p:nvSpPr>
-          <p:cNvPr id="1" name="TextBox 3"/>
-          <p:cNvSpPr txBox="1"/>
-          <p:nvPr/>
-        </p:nvSpPr>
-        <p:spPr>
-          <a:xfrm>
             <a:off x="4648200" y="4076700"/>
             <a:ext cx="4038600" cy="508000"/>
           </a:xfrm>
@@ -3369,7 +3370,7 @@
             </a:pPr>
             <a:r>
               <a:rPr/>
-              <a:t>Digital Twin functional view</a:t>
+              <a:t>An example of a generic data platform with its components and layers</a:t>
             </a:r>
           </a:p>
         </p:txBody>
@@ -3438,12 +3439,8 @@
           <a:p>
             <a:pPr lvl="0"/>
             <a:r>
-              <a:rPr b="1"/>
-              <a:t>Definition</a:t>
-            </a:r>
-            <a:r>
               <a:rPr/>
-              <a:t>: physical entity + virtual representation, connected via </a:t>
+              <a:t>Digital Twin (DT): physical entity + virtual representation, connected via </a:t>
             </a:r>
             <a:r>
               <a:rPr b="1"/>
@@ -3455,13 +3452,6 @@
             </a:r>
           </a:p>
           <a:p>
-            <a:pPr lvl="1"/>
-            <a:r>
-              <a:rPr/>
-              <a:t>Digital Model → Digital Shadow → Digital Twin (Kritzinger et al.)</a:t>
-            </a:r>
-          </a:p>
-          <a:p>
             <a:pPr lvl="0"/>
             <a:r>
               <a:rPr/>
@@ -3479,41 +3469,25 @@
             <a:pPr lvl="1"/>
             <a:r>
               <a:rPr/>
-              <a:t>3-component model (Grieves) → </a:t>
-            </a:r>
+              <a:t>5D model (Tao et al.): physical entity, virtual model, connection, data, service</a:t>
+            </a:r>
+          </a:p>
+          <a:p>
+            <a:pPr lvl="0"/>
+            <a:r>
+              <a:rPr/>
+              <a:t>Scale: Single - Digital Twins Ecosystems</a:t>
+            </a:r>
+          </a:p>
+          <a:p>
+            <a:pPr lvl="0"/>
             <a:r>
               <a:rPr b="1"/>
-              <a:t>5D model</a:t>
+              <a:t>Data is not a by-product</a:t>
             </a:r>
             <a:r>
               <a:rPr/>
-              <a:t>: physical entity, virtual model, connection, data, service (Tao et al.)</a:t>
-            </a:r>
-          </a:p>
-          <a:p>
-            <a:pPr lvl="0"/>
-            <a:r>
-              <a:rPr/>
-              <a:t>Scale: unit-level → system-level → </a:t>
-            </a:r>
-            <a:r>
-              <a:rPr b="1"/>
-              <a:t>System of Systems</a:t>
-            </a:r>
-          </a:p>
-          <a:p>
-            <a:pPr lvl="0"/>
-            <a:r>
-              <a:rPr/>
-              <a:t>Data is not a by-product — it’s the element connecting </a:t>
-            </a:r>
-            <a:r>
-              <a:rPr i="1"/>
-              <a:t>every</a:t>
-            </a:r>
-            <a:r>
-              <a:rPr/>
-              <a:t> dimension</a:t>
+              <a:t> — it’s the element connecting every dimension</a:t>
             </a:r>
           </a:p>
         </p:txBody>
@@ -3540,124 +3514,132 @@
           <a:chExt cx="0" cy="0"/>
         </a:xfrm>
       </p:grpSpPr>
-      <p:sp>
-        <p:nvSpPr>
-          <p:cNvPr id="2" name="Title 1"/>
-          <p:cNvSpPr>
-            <a:spLocks noGrp="1"/>
-          </p:cNvSpPr>
-          <p:nvPr>
-            <p:ph type="title"/>
-          </p:nvPr>
-        </p:nvSpPr>
-        <p:spPr/>
-        <p:txBody>
-          <a:bodyPr/>
-          <a:lstStyle/>
-          <a:p>
-            <a:pPr lvl="0" indent="0" marL="0">
+      <p:pic>
+        <p:nvPicPr>
+          <p:cNvPr descr="https://github.com/ManuelePasini/slides-markdown/blob/master/slides/images/dt/5dim.png?raw=true" id="0" name="Picture 1"/>
+          <p:cNvPicPr>
+            <a:picLocks noGrp="1" noChangeAspect="1"/>
+          </p:cNvPicPr>
+          <p:nvPr/>
+        </p:nvPicPr>
+        <p:blipFill>
+          <a:blip r:embed="rId2"/>
+          <a:stretch>
+            <a:fillRect/>
+          </a:stretch>
+        </p:blipFill>
+        <p:spPr bwMode="auto">
+          <a:xfrm>
+            <a:off x="457200" y="1435100"/>
+            <a:ext cx="4038600" cy="2413000"/>
+          </a:xfrm>
+          <a:prstGeom prst="rect">
+            <a:avLst/>
+          </a:prstGeom>
+          <a:noFill/>
+          <a:ln w="9525">
+            <a:noFill/>
+            <a:headEnd/>
+            <a:tailEnd/>
+          </a:ln>
+        </p:spPr>
+      </p:pic>
+      <p:sp>
+        <p:nvSpPr>
+          <p:cNvPr id="1" name="TextBox 3"/>
+          <p:cNvSpPr txBox="1"/>
+          <p:nvPr/>
+        </p:nvSpPr>
+        <p:spPr>
+          <a:xfrm>
+            <a:off x="457200" y="4076700"/>
+            <a:ext cx="4038600" cy="508000"/>
+          </a:xfrm>
+          <a:prstGeom prst="rect">
+            <a:avLst/>
+          </a:prstGeom>
+          <a:noFill/>
+        </p:spPr>
+        <p:txBody>
+          <a:bodyPr/>
+          <a:lstStyle/>
+          <a:p>
+            <a:pPr lvl="0" indent="0" marL="0" algn="ctr">
               <a:buNone/>
             </a:pPr>
             <a:r>
               <a:rPr/>
-              <a:t>Digital Twin Data &amp; Open Challenges</a:t>
-            </a:r>
-          </a:p>
-        </p:txBody>
-      </p:sp>
-      <p:sp>
-        <p:nvSpPr>
-          <p:cNvPr id="3" name="Content Placeholder 2"/>
-          <p:cNvSpPr>
-            <a:spLocks noGrp="1"/>
-          </p:cNvSpPr>
-          <p:nvPr>
-            <p:ph idx="1"/>
-          </p:nvPr>
-        </p:nvSpPr>
-        <p:spPr/>
-        <p:txBody>
-          <a:bodyPr/>
-          <a:lstStyle/>
-          <a:p>
-            <a:pPr lvl="0"/>
+              <a:t>5-Dimensional DT (Fei, Tao 2020)</a:t>
+            </a:r>
+          </a:p>
+        </p:txBody>
+      </p:sp>
+      <p:pic>
+        <p:nvPicPr>
+          <p:cNvPr descr="https://github.com/ManuelePasini/slides-markdown/blob/master/slides/images/dt/dt_data.png?raw=true" id="0" name="Picture 1"/>
+          <p:cNvPicPr>
+            <a:picLocks noGrp="1" noChangeAspect="1"/>
+          </p:cNvPicPr>
+          <p:nvPr/>
+        </p:nvPicPr>
+        <p:blipFill>
+          <a:blip r:embed="rId3"/>
+          <a:stretch>
+            <a:fillRect/>
+          </a:stretch>
+        </p:blipFill>
+        <p:spPr bwMode="auto">
+          <a:xfrm>
+            <a:off x="4648200" y="1358900"/>
+            <a:ext cx="4038600" cy="2552700"/>
+          </a:xfrm>
+          <a:prstGeom prst="rect">
+            <a:avLst/>
+          </a:prstGeom>
+          <a:noFill/>
+          <a:ln w="9525">
+            <a:noFill/>
+            <a:headEnd/>
+            <a:tailEnd/>
+          </a:ln>
+        </p:spPr>
+      </p:pic>
+      <p:sp>
+        <p:nvSpPr>
+          <p:cNvPr id="1" name="TextBox 3"/>
+          <p:cNvSpPr txBox="1"/>
+          <p:nvPr/>
+        </p:nvSpPr>
+        <p:spPr>
+          <a:xfrm>
+            <a:off x="4648200" y="4076700"/>
+            <a:ext cx="4038600" cy="508000"/>
+          </a:xfrm>
+          <a:prstGeom prst="rect">
+            <a:avLst/>
+          </a:prstGeom>
+          <a:noFill/>
+        </p:spPr>
+        <p:txBody>
+          <a:bodyPr/>
+          <a:lstStyle/>
+          <a:p>
+            <a:pPr lvl="0" indent="0" marL="0" algn="ctr">
+              <a:buNone/>
+            </a:pPr>
             <a:r>
               <a:rPr/>
-              <a:t>DT data is highly </a:t>
-            </a:r>
-            <a:r>
-              <a:rPr b="1"/>
-              <a:t>heterogeneous</a:t>
+              <a:t>Digital Twin Data (</a:t>
+            </a:r>
+            <a:r>
+              <a:rPr>
+                <a:hlinkClick r:id="rId4"/>
+              </a:rPr>
+              <a:t>Fei, Tao 2023</a:t>
             </a:r>
             <a:r>
               <a:rPr/>
-              <a:t>: structured / unstructured, sensor / simulation / imagery</a:t>
-            </a:r>
-          </a:p>
-          <a:p>
-            <a:pPr lvl="0"/>
-            <a:r>
-              <a:rPr/>
-              <a:t>Shaped by domain: manufacturing, automotive, agriculture → different needs</a:t>
-            </a:r>
-          </a:p>
-          <a:p>
-            <a:pPr lvl="0"/>
-            <a:r>
-              <a:rPr/>
-              <a:t>Big-data traits: </a:t>
-            </a:r>
-            <a:r>
-              <a:rPr b="1"/>
-              <a:t>volume, variety, velocity</a:t>
-            </a:r>
-            <a:r>
-              <a:rPr/>
-              <a:t> + data </a:t>
-            </a:r>
-            <a:r>
-              <a:rPr b="1"/>
-              <a:t>quality/veracity</a:t>
-            </a:r>
-          </a:p>
-          <a:p>
-            <a:pPr lvl="0"/>
-            <a:r>
-              <a:rPr/>
-              <a:t>Two complementary challenges:</a:t>
-            </a:r>
-          </a:p>
-          <a:p>
-            <a:pPr lvl="1"/>
-            <a:r>
-              <a:rPr b="1"/>
-              <a:t>Standardization</a:t>
-            </a:r>
-            <a:r>
-              <a:rPr/>
-              <a:t> → shared building blocks (DT) / infrastructure &amp; data models (DTE)</a:t>
-            </a:r>
-          </a:p>
-          <a:p>
-            <a:pPr lvl="1"/>
-            <a:r>
-              <a:rPr b="1"/>
-              <a:t>Interoperability</a:t>
-            </a:r>
-            <a:r>
-              <a:rPr/>
-              <a:t> → technical, syntactic, semantic, … levels (Acharya et al.)</a:t>
-            </a:r>
-          </a:p>
-          <a:p>
-            <a:pPr lvl="0"/>
-            <a:r>
-              <a:rPr/>
-              <a:t>⇒ Fragmentation is the current bottleneck for Digital Twin </a:t>
-            </a:r>
-            <a:r>
-              <a:rPr b="1"/>
-              <a:t>Ecosystems</a:t>
+              <a:t>)</a:t>
             </a:r>
           </a:p>
         </p:txBody>
@@ -3668,6 +3650,150 @@
 </file>
 
 <file path=ppt/slides/slide5.xml><?xml version="1.0" encoding="utf-8"?>
+<p:sld xmlns:a="http://schemas.openxmlformats.org/drawingml/2006/main" xmlns:r="http://schemas.openxmlformats.org/officeDocument/2006/relationships" xmlns:p="http://schemas.openxmlformats.org/presentationml/2006/main">
+  <p:cSld>
+    <p:spTree>
+      <p:nvGrpSpPr>
+        <p:cNvPr id="1" name=""/>
+        <p:cNvGrpSpPr/>
+        <p:nvPr/>
+      </p:nvGrpSpPr>
+      <p:grpSpPr>
+        <a:xfrm>
+          <a:off x="0" y="0"/>
+          <a:ext cx="0" cy="0"/>
+          <a:chOff x="0" y="0"/>
+          <a:chExt cx="0" cy="0"/>
+        </a:xfrm>
+      </p:grpSpPr>
+      <p:sp>
+        <p:nvSpPr>
+          <p:cNvPr id="2" name="Title 1"/>
+          <p:cNvSpPr>
+            <a:spLocks noGrp="1"/>
+          </p:cNvSpPr>
+          <p:nvPr>
+            <p:ph type="title"/>
+          </p:nvPr>
+        </p:nvSpPr>
+        <p:spPr/>
+        <p:txBody>
+          <a:bodyPr/>
+          <a:lstStyle/>
+          <a:p>
+            <a:pPr lvl="0" indent="0" marL="0">
+              <a:buNone/>
+            </a:pPr>
+            <a:r>
+              <a:rPr/>
+              <a:t>Digital Twin Data &amp; Open Challenges</a:t>
+            </a:r>
+          </a:p>
+        </p:txBody>
+      </p:sp>
+      <p:sp>
+        <p:nvSpPr>
+          <p:cNvPr id="3" name="Content Placeholder 2"/>
+          <p:cNvSpPr>
+            <a:spLocks noGrp="1"/>
+          </p:cNvSpPr>
+          <p:nvPr>
+            <p:ph idx="1"/>
+          </p:nvPr>
+        </p:nvSpPr>
+        <p:spPr/>
+        <p:txBody>
+          <a:bodyPr/>
+          <a:lstStyle/>
+          <a:p>
+            <a:pPr lvl="0"/>
+            <a:r>
+              <a:rPr/>
+              <a:t>DT data is highly </a:t>
+            </a:r>
+            <a:r>
+              <a:rPr b="1"/>
+              <a:t>heterogeneous</a:t>
+            </a:r>
+            <a:r>
+              <a:rPr/>
+              <a:t>: structured / unstructured, sensor / simulation / imagery</a:t>
+            </a:r>
+          </a:p>
+          <a:p>
+            <a:pPr lvl="0"/>
+            <a:r>
+              <a:rPr/>
+              <a:t>Shaped by domain: manufacturing, automotive, agriculture → different needs</a:t>
+            </a:r>
+          </a:p>
+          <a:p>
+            <a:pPr lvl="0"/>
+            <a:r>
+              <a:rPr/>
+              <a:t>Big-data traits: </a:t>
+            </a:r>
+            <a:r>
+              <a:rPr b="1"/>
+              <a:t>volume, variety, velocity</a:t>
+            </a:r>
+            <a:r>
+              <a:rPr/>
+              <a:t> + data </a:t>
+            </a:r>
+            <a:r>
+              <a:rPr b="1"/>
+              <a:t>quality/veracity</a:t>
+            </a:r>
+          </a:p>
+          <a:p>
+            <a:pPr lvl="0"/>
+            <a:r>
+              <a:rPr/>
+              <a:t>Two complementary challenges:</a:t>
+            </a:r>
+          </a:p>
+          <a:p>
+            <a:pPr lvl="1"/>
+            <a:r>
+              <a:rPr b="1"/>
+              <a:t>Standardization</a:t>
+            </a:r>
+            <a:r>
+              <a:rPr/>
+              <a:t> → shared building blocks (DT) / infrastructure &amp; data models (DTE)</a:t>
+            </a:r>
+          </a:p>
+          <a:p>
+            <a:pPr lvl="1"/>
+            <a:r>
+              <a:rPr b="1"/>
+              <a:t>Interoperability</a:t>
+            </a:r>
+            <a:r>
+              <a:rPr/>
+              <a:t> → technical, syntactic, semantic, … levels (Acharya et al.)</a:t>
+            </a:r>
+          </a:p>
+          <a:p>
+            <a:pPr lvl="0"/>
+            <a:r>
+              <a:rPr/>
+              <a:t>⇒ Fragmentation is the current bottleneck for Digital Twin </a:t>
+            </a:r>
+            <a:r>
+              <a:rPr b="1"/>
+              <a:t>Ecosystems</a:t>
+            </a:r>
+          </a:p>
+        </p:txBody>
+      </p:sp>
+    </p:spTree>
+  </p:cSld>
+</p:sld>
+</file>
+
+<file path=ppt/slides/slide6.xml><?xml version="1.0" encoding="utf-8"?>
 <p:sld xmlns:a="http://schemas.openxmlformats.org/drawingml/2006/main" xmlns:r="http://schemas.openxmlformats.org/officeDocument/2006/relationships" xmlns:p="http://schemas.openxmlformats.org/presentationml/2006/main">
   <p:cSld>
     <p:spTree>

</xml_diff>

<commit_message>
Deploying to gh-pages from @ ManuelePasini/slides-markdown@5aca1b9d42b366c178b6fac9d3d4547a25c1db25 🚀
</commit_message>
<xml_diff>
--- a/3rd_year_slides.pptx
+++ b/3rd_year_slides.pptx
@@ -3455,7 +3455,17 @@
             <a:pPr lvl="0"/>
             <a:r>
               <a:rPr/>
-              <a:t>No universally accepted definition (Wuni et al.: 358 definitions surveyed)</a:t>
+              <a:t>No universally accepted definition (</a:t>
+            </a:r>
+            <a:r>
+              <a:rPr>
+                <a:hlinkClick r:id="rId2"/>
+              </a:rPr>
+              <a:t>Wuni et al</a:t>
+            </a:r>
+            <a:r>
+              <a:rPr/>
+              <a:t>.: 358 definitions surveyed)</a:t>
             </a:r>
           </a:p>
           <a:p>
@@ -3469,7 +3479,17 @@
             <a:pPr lvl="1"/>
             <a:r>
               <a:rPr/>
-              <a:t>5D model (Tao et al.): physical entity, virtual model, connection, data, service</a:t>
+              <a:t>5D model (</a:t>
+            </a:r>
+            <a:r>
+              <a:rPr>
+                <a:hlinkClick r:id="rId3"/>
+              </a:rPr>
+              <a:t>Tao et al.</a:t>
+            </a:r>
+            <a:r>
+              <a:rPr/>
+              <a:t>): physical entity, virtual model, connection, data, service</a:t>
             </a:r>
           </a:p>
           <a:p>

</xml_diff>

<commit_message>
Deploying to gh-pages from @ ManuelePasini/slides-markdown@e3ec809d43a509f80309c6c33d80a75d9b11f09b 🚀
</commit_message>
<xml_diff>
--- a/3rd_year_slides.pptx
+++ b/3rd_year_slides.pptx
@@ -3186,7 +3186,7 @@
             <a:pPr lvl="0"/>
             <a:r>
               <a:rPr b="1"/>
-              <a:t>Who am I ?</a:t>
+              <a:t>Hi!</a:t>
             </a:r>
           </a:p>
           <a:p>
@@ -3200,7 +3200,7 @@
             <a:pPr lvl="1"/>
             <a:r>
               <a:rPr/>
-              <a:t>Supervisor: Matteo Golfarelli, Marco Patella, Davide Maltoni</a:t>
+              <a:t>Supervisors: Matteo Golfarelli, Marco Patella, Davide Maltoni</a:t>
             </a:r>
           </a:p>
           <a:p>
@@ -3429,7 +3429,7 @@
             <a:spLocks noGrp="1"/>
           </p:cNvSpPr>
           <p:nvPr>
-            <p:ph idx="1"/>
+            <p:ph idx="1" sz="half"/>
           </p:nvPr>
         </p:nvSpPr>
         <p:spPr/>
@@ -3440,7 +3440,7 @@
             <a:pPr lvl="0"/>
             <a:r>
               <a:rPr/>
-              <a:t>Digital Twin (DT): physical entity + virtual representation, connected via </a:t>
+              <a:t>Digital Twin (DT): physical entity (PE) + virtual representation (VE), connected via </a:t>
             </a:r>
             <a:r>
               <a:rPr b="1"/>
@@ -3461,7 +3461,7 @@
               <a:rPr>
                 <a:hlinkClick r:id="rId2"/>
               </a:rPr>
-              <a:t>Wuni et al</a:t>
+              <a:t>Wuni et al.</a:t>
             </a:r>
             <a:r>
               <a:rPr/>
@@ -3489,14 +3489,14 @@
             </a:r>
             <a:r>
               <a:rPr/>
-              <a:t>): physical entity, virtual model, connection, data, service</a:t>
+              <a:t>): PE, VE, connection, data, service</a:t>
             </a:r>
           </a:p>
           <a:p>
             <a:pPr lvl="0"/>
             <a:r>
               <a:rPr/>
-              <a:t>Scale: Single - Digital Twins Ecosystems</a:t>
+              <a:t>Scale: Single DT - Digital Twins Ecosystems (DTE)</a:t>
             </a:r>
           </a:p>
           <a:p>
@@ -3507,7 +3507,77 @@
             </a:r>
             <a:r>
               <a:rPr/>
-              <a:t> — it’s the element connecting every dimension</a:t>
+              <a:t> — it’s the component connecting every dimension</a:t>
+            </a:r>
+          </a:p>
+        </p:txBody>
+      </p:sp>
+      <p:pic>
+        <p:nvPicPr>
+          <p:cNvPr descr="https://github.com/ManuelePasini/slides-markdown/blob/master/slides/images/dt/dt_data.png?raw=true" id="0" name="Picture 1"/>
+          <p:cNvPicPr>
+            <a:picLocks noGrp="1" noChangeAspect="1"/>
+          </p:cNvPicPr>
+          <p:nvPr/>
+        </p:nvPicPr>
+        <p:blipFill>
+          <a:blip r:embed="rId4"/>
+          <a:stretch>
+            <a:fillRect/>
+          </a:stretch>
+        </p:blipFill>
+        <p:spPr bwMode="auto">
+          <a:xfrm>
+            <a:off x="4648200" y="1358900"/>
+            <a:ext cx="4038600" cy="2552700"/>
+          </a:xfrm>
+          <a:prstGeom prst="rect">
+            <a:avLst/>
+          </a:prstGeom>
+          <a:noFill/>
+          <a:ln w="9525">
+            <a:noFill/>
+            <a:headEnd/>
+            <a:tailEnd/>
+          </a:ln>
+        </p:spPr>
+      </p:pic>
+      <p:sp>
+        <p:nvSpPr>
+          <p:cNvPr id="1" name="TextBox 3"/>
+          <p:cNvSpPr txBox="1"/>
+          <p:nvPr/>
+        </p:nvSpPr>
+        <p:spPr>
+          <a:xfrm>
+            <a:off x="4648200" y="4076700"/>
+            <a:ext cx="4038600" cy="508000"/>
+          </a:xfrm>
+          <a:prstGeom prst="rect">
+            <a:avLst/>
+          </a:prstGeom>
+          <a:noFill/>
+        </p:spPr>
+        <p:txBody>
+          <a:bodyPr/>
+          <a:lstStyle/>
+          <a:p>
+            <a:pPr lvl="0" indent="0" marL="0" algn="ctr">
+              <a:buNone/>
+            </a:pPr>
+            <a:r>
+              <a:rPr/>
+              <a:t>Characterizing Digital Twin data (</a:t>
+            </a:r>
+            <a:r>
+              <a:rPr>
+                <a:hlinkClick r:id="rId5"/>
+              </a:rPr>
+              <a:t>Fei, Tao 2023</a:t>
+            </a:r>
+            <a:r>
+              <a:rPr/>
+              <a:t>)</a:t>
             </a:r>
           </a:p>
         </p:txBody>
@@ -3589,7 +3659,17 @@
             </a:pPr>
             <a:r>
               <a:rPr/>
-              <a:t>5-Dimensional DT (Fei, Tao 2020)</a:t>
+              <a:t>5-Dimensional DT (</a:t>
+            </a:r>
+            <a:r>
+              <a:rPr>
+                <a:hlinkClick r:id="rId3"/>
+              </a:rPr>
+              <a:t>Tao et al.</a:t>
+            </a:r>
+            <a:r>
+              <a:rPr/>
+              <a:t>)</a:t>
             </a:r>
           </a:p>
         </p:txBody>
@@ -3603,7 +3683,7 @@
           <p:nvPr/>
         </p:nvPicPr>
         <p:blipFill>
-          <a:blip r:embed="rId3"/>
+          <a:blip r:embed="rId4"/>
           <a:stretch>
             <a:fillRect/>
           </a:stretch>
@@ -3649,11 +3729,11 @@
             </a:pPr>
             <a:r>
               <a:rPr/>
-              <a:t>Digital Twin Data (</a:t>
+              <a:t>Characterizing Digital Twin data (</a:t>
             </a:r>
             <a:r>
               <a:rPr>
-                <a:hlinkClick r:id="rId4"/>
+                <a:hlinkClick r:id="rId5"/>
               </a:rPr>
               <a:t>Fei, Tao 2023</a:t>
             </a:r>

</xml_diff>

<commit_message>
Deploying to gh-pages from @ ManuelePasini/slides-markdown@9a50dd83a27c79ed04683f3ae008a17481111070 🚀
</commit_message>
<xml_diff>
--- a/3rd_year_slides.pptx
+++ b/3rd_year_slides.pptx
@@ -3514,7 +3514,7 @@
       </p:sp>
       <p:pic>
         <p:nvPicPr>
-          <p:cNvPr descr="https://github.com/ManuelePasini/slides-markdown/blob/master/slides/images/dt/dt_data.png?raw=true" id="0" name="Picture 1"/>
+          <p:cNvPr descr="https://github.com/ManuelePasini/slides-markdown/blob/master/slides/images/dt/dt.png?raw=true" id="0" name="Picture 1"/>
           <p:cNvPicPr>
             <a:picLocks noGrp="1" noChangeAspect="1"/>
           </p:cNvPicPr>
@@ -3528,8 +3528,8 @@
         </p:blipFill>
         <p:spPr bwMode="auto">
           <a:xfrm>
-            <a:off x="4648200" y="1358900"/>
-            <a:ext cx="4038600" cy="2552700"/>
+            <a:off x="4648200" y="1422400"/>
+            <a:ext cx="4038600" cy="2438400"/>
           </a:xfrm>
           <a:prstGeom prst="rect">
             <a:avLst/>
@@ -3567,17 +3567,7 @@
             </a:pPr>
             <a:r>
               <a:rPr/>
-              <a:t>Characterizing Digital Twin data (</a:t>
-            </a:r>
-            <a:r>
-              <a:rPr>
-                <a:hlinkClick r:id="rId5"/>
-              </a:rPr>
-              <a:t>Fei, Tao 2023</a:t>
-            </a:r>
-            <a:r>
-              <a:rPr/>
-              <a:t>)</a:t>
+              <a:t>Digital Twin functional view</a:t>
             </a:r>
           </a:p>
         </p:txBody>

</xml_diff>

<commit_message>
Deploying to gh-pages from @ ManuelePasini/slides-markdown@9290b42bfd5f638950a86a3cee9338f48e333164 🚀
</commit_message>
<xml_diff>
--- a/3rd_year_slides.pptx
+++ b/3rd_year_slides.pptx
@@ -3200,7 +3200,7 @@
             <a:pPr lvl="1"/>
             <a:r>
               <a:rPr/>
-              <a:t>Supervisors: Matteo Golfarelli, Marco Patella, Davide Maltoni</a:t>
+              <a:t>Supervisor: Matteo Golfarelli</a:t>
             </a:r>
           </a:p>
           <a:p>
@@ -3455,24 +3455,24 @@
             <a:pPr lvl="0"/>
             <a:r>
               <a:rPr/>
-              <a:t>No universally accepted definition (</a:t>
+              <a:t>Reference architectures:</a:t>
+            </a:r>
+          </a:p>
+          <a:p>
+            <a:pPr lvl="1"/>
+            <a:r>
+              <a:rPr/>
+              <a:t>3D model (</a:t>
             </a:r>
             <a:r>
               <a:rPr>
                 <a:hlinkClick r:id="rId2"/>
               </a:rPr>
-              <a:t>Wuni et al.</a:t>
-            </a:r>
-            <a:r>
-              <a:rPr/>
-              <a:t>.: 358 definitions surveyed)</a:t>
-            </a:r>
-          </a:p>
-          <a:p>
-            <a:pPr lvl="0"/>
-            <a:r>
-              <a:rPr/>
-              <a:t>Reference architectures:</a:t>
+              <a:t>M. Grieves</a:t>
+            </a:r>
+            <a:r>
+              <a:rPr/>
+              <a:t>)</a:t>
             </a:r>
           </a:p>
           <a:p>
@@ -3490,13 +3490,6 @@
             <a:r>
               <a:rPr/>
               <a:t>): PE, VE, connection, data, service</a:t>
-            </a:r>
-          </a:p>
-          <a:p>
-            <a:pPr lvl="0"/>
-            <a:r>
-              <a:rPr/>
-              <a:t>Scale: Single DT - Digital Twins Ecosystems (DTE)</a:t>
             </a:r>
           </a:p>
           <a:p>
@@ -3567,7 +3560,7 @@
             </a:pPr>
             <a:r>
               <a:rPr/>
-              <a:t>Digital Twin functional view</a:t>
+              <a:t>Grieves 3D Model</a:t>
             </a:r>
           </a:p>
         </p:txBody>
@@ -3776,7 +3769,7 @@
             </a:pPr>
             <a:r>
               <a:rPr/>
-              <a:t>Digital Twin Data &amp; Open Challenges</a:t>
+              <a:t>The Challenge: Fragmentation</a:t>
             </a:r>
           </a:p>
         </p:txBody>
@@ -3799,81 +3792,97 @@
             <a:pPr lvl="0"/>
             <a:r>
               <a:rPr/>
-              <a:t>DT data is highly </a:t>
+              <a:t>Digital Twins adopted across </a:t>
             </a:r>
             <a:r>
               <a:rPr b="1"/>
-              <a:t>heterogeneous</a:t>
-            </a:r>
-            <a:r>
-              <a:rPr/>
-              <a:t>: structured / unstructured, sensor / simulation / imagery</a:t>
+              <a:t>many independent domains</a:t>
+            </a:r>
+            <a:r>
+              <a:rPr/>
+              <a:t>:</a:t>
+            </a:r>
+          </a:p>
+          <a:p>
+            <a:pPr lvl="1"/>
+            <a:r>
+              <a:rPr/>
+              <a:t>manufacturing, energy, aerospace, healthcare, agriculture, smart cities, transportation…</a:t>
             </a:r>
           </a:p>
           <a:p>
             <a:pPr lvl="0"/>
             <a:r>
               <a:rPr/>
-              <a:t>Shaped by domain: manufacturing, automotive, agriculture → different needs</a:t>
+              <a:t>No universally accepted definition (</a:t>
+            </a:r>
+            <a:r>
+              <a:rPr>
+                <a:hlinkClick r:id="rId2"/>
+              </a:rPr>
+              <a:t>Wuni et al.</a:t>
+            </a:r>
+            <a:r>
+              <a:rPr/>
+              <a:t>: 358 definitions surveyed)</a:t>
             </a:r>
           </a:p>
           <a:p>
             <a:pPr lvl="0"/>
             <a:r>
               <a:rPr/>
-              <a:t>Big-data traits: </a:t>
-            </a:r>
+              <a:t>Most application builds its own:</a:t>
+            </a:r>
+          </a:p>
+          <a:p>
+            <a:pPr lvl="1"/>
+            <a:r>
+              <a:rPr/>
+              <a:t>architecture and technological stack</a:t>
+            </a:r>
+          </a:p>
+          <a:p>
+            <a:pPr lvl="1"/>
+            <a:r>
+              <a:rPr/>
+              <a:t>data representation</a:t>
+            </a:r>
+          </a:p>
+          <a:p>
+            <a:pPr lvl="0"/>
+            <a:r>
+              <a:rPr/>
+              <a:t>Result: isolated, application-specific Digital Twins </a:t>
+            </a:r>
+          </a:p>
+          <a:p>
+            <a:pPr lvl="1"/>
+            <a:r>
+              <a:rPr/>
+              <a:t>data isolation</a:t>
+            </a:r>
+          </a:p>
+          <a:p>
+            <a:pPr lvl="1"/>
+            <a:r>
+              <a:rPr/>
+              <a:t>architectural heterogeneity</a:t>
+            </a:r>
+          </a:p>
+          <a:p>
+            <a:pPr lvl="1"/>
+            <a:r>
+              <a:rPr/>
+              <a:t>limited scalability</a:t>
+            </a:r>
+          </a:p>
+          <a:p>
+            <a:pPr lvl="0" indent="0" marL="0">
+              <a:buNone/>
+            </a:pPr>
             <a:r>
               <a:rPr b="1"/>
-              <a:t>volume, variety, velocity</a:t>
-            </a:r>
-            <a:r>
-              <a:rPr/>
-              <a:t> + data </a:t>
-            </a:r>
-            <a:r>
-              <a:rPr b="1"/>
-              <a:t>quality/veracity</a:t>
-            </a:r>
-          </a:p>
-          <a:p>
-            <a:pPr lvl="0"/>
-            <a:r>
-              <a:rPr/>
-              <a:t>Two complementary challenges:</a:t>
-            </a:r>
-          </a:p>
-          <a:p>
-            <a:pPr lvl="1"/>
-            <a:r>
-              <a:rPr b="1"/>
-              <a:t>Standardization</a:t>
-            </a:r>
-            <a:r>
-              <a:rPr/>
-              <a:t> → shared building blocks (DT) / infrastructure &amp; data models (DTE)</a:t>
-            </a:r>
-          </a:p>
-          <a:p>
-            <a:pPr lvl="1"/>
-            <a:r>
-              <a:rPr b="1"/>
-              <a:t>Interoperability</a:t>
-            </a:r>
-            <a:r>
-              <a:rPr/>
-              <a:t> → technical, syntactic, semantic, … levels (Acharya et al.)</a:t>
-            </a:r>
-          </a:p>
-          <a:p>
-            <a:pPr lvl="0"/>
-            <a:r>
-              <a:rPr/>
-              <a:t>⇒ Fragmentation is the current bottleneck for Digital Twin </a:t>
-            </a:r>
-            <a:r>
-              <a:rPr b="1"/>
-              <a:t>Ecosystems</a:t>
+              <a:t>Fragmentation &amp; Heterogeneity → limited standardization &amp; interoperability</a:t>
             </a:r>
           </a:p>
         </p:txBody>
@@ -3920,7 +3929,7 @@
             </a:pPr>
             <a:r>
               <a:rPr/>
-              <a:t>A Data-Oriented Perspective</a:t>
+              <a:t>Digital Twin Platform: A Data-Oriented Perspective</a:t>
             </a:r>
           </a:p>
         </p:txBody>
@@ -3939,6 +3948,20 @@
         <p:txBody>
           <a:bodyPr/>
           <a:lstStyle/>
+          <a:p>
+            <a:pPr lvl="0"/>
+            <a:r>
+              <a:rPr/>
+              <a:t>A Digital Twin is a data-intensive application</a:t>
+            </a:r>
+          </a:p>
+          <a:p>
+            <a:pPr lvl="1"/>
+            <a:r>
+              <a:rPr/>
+              <a:t>heterogeneous data: structured/unstructured, sensor/simulation/imagery, domain-specific</a:t>
+            </a:r>
+          </a:p>
           <a:p>
             <a:pPr lvl="0"/>
             <a:r>
@@ -3947,105 +3970,68 @@
             </a:r>
             <a:r>
               <a:rPr/>
-              <a:t>: software and data dimensions are modular, not independent</a:t>
+              <a:t>: separate the software and data dimensions</a:t>
+            </a:r>
+          </a:p>
+          <a:p>
+            <a:pPr lvl="1"/>
+            <a:r>
+              <a:rPr/>
+              <a:t>software dimension → substantial work, increasingly mature</a:t>
+            </a:r>
+          </a:p>
+          <a:p>
+            <a:pPr lvl="1"/>
+            <a:r>
+              <a:rPr/>
+              <a:t>data dimension → far less mature ⇐ </a:t>
+            </a:r>
+            <a:r>
+              <a:rPr b="1"/>
+              <a:t>focus of my research</a:t>
             </a:r>
           </a:p>
           <a:p>
             <a:pPr lvl="0"/>
             <a:r>
               <a:rPr/>
-              <a:t>Standardization &amp; interoperability, decomposed:</a:t>
+              <a:t>⇒ </a:t>
+            </a:r>
+            <a:r>
+              <a:rPr b="1"/>
+              <a:t>Data standardization should lead</a:t>
+            </a:r>
+            <a:r>
+              <a:rPr/>
+              <a:t> the standardization effort</a:t>
             </a:r>
           </a:p>
           <a:p>
             <a:pPr lvl="1"/>
             <a:r>
               <a:rPr/>
-              <a:t>software side → increasingly mature</a:t>
+              <a:t>Data standardization entails interoperability!</a:t>
+            </a:r>
+          </a:p>
+          <a:p>
+            <a:pPr lvl="0"/>
+            <a:r>
+              <a:rPr/>
+              <a:t>Digital Twin Platform (DTP):</a:t>
             </a:r>
           </a:p>
           <a:p>
             <a:pPr lvl="1"/>
             <a:r>
-              <a:rPr b="1"/>
-              <a:t>data side → the harder, less mature half</a:t>
-            </a:r>
-            <a:r>
-              <a:rPr/>
-              <a:t> ⇐ focus of this thesis</a:t>
-            </a:r>
-          </a:p>
-          <a:p>
-            <a:pPr lvl="0"/>
-            <a:r>
-              <a:rPr b="1"/>
-              <a:t>Digital Twin Platform (DTP)</a:t>
-            </a:r>
-            <a:r>
-              <a:rPr/>
-              <a:t>:</a:t>
+              <a:rPr/>
+              <a:t>hosts DTs across their lifecycle, but organized around data</a:t>
             </a:r>
           </a:p>
           <a:p>
             <a:pPr lvl="1"/>
             <a:r>
-              <a:rPr i="1"/>
-              <a:t>is</a:t>
-            </a:r>
-            <a:r>
-              <a:rPr/>
-              <a:t> a software environment, hosting DTs across their lifecycle</a:t>
-            </a:r>
-          </a:p>
-          <a:p>
-            <a:pPr lvl="1"/>
-            <a:r>
-              <a:rPr/>
-              <a:t>but organized </a:t>
-            </a:r>
-            <a:r>
-              <a:rPr b="1"/>
-              <a:t>around data</a:t>
-            </a:r>
-            <a:r>
-              <a:rPr/>
-              <a:t>, not around DT-specific software</a:t>
-            </a:r>
-          </a:p>
-          <a:p>
-            <a:pPr lvl="1"/>
-            <a:r>
-              <a:rPr/>
-              <a:t>agnostic to how a DT is built — if it respects the platform’s data models</a:t>
-            </a:r>
-          </a:p>
-          <a:p>
-            <a:pPr lvl="0"/>
-            <a:r>
-              <a:rPr/>
-              <a:t>Two pillars:</a:t>
-            </a:r>
-          </a:p>
-          <a:p>
-            <a:pPr lvl="1"/>
-            <a:r>
-              <a:rPr b="1"/>
-              <a:t>Data Platforms</a:t>
-            </a:r>
-            <a:r>
-              <a:rPr/>
-              <a:t> → infrastructural standardization</a:t>
-            </a:r>
-          </a:p>
-          <a:p>
-            <a:pPr lvl="1"/>
-            <a:r>
-              <a:rPr b="1"/>
-              <a:t>Data Models &amp; Governance</a:t>
-            </a:r>
-            <a:r>
-              <a:rPr/>
-              <a:t> → semantic interoperability</a:t>
+              <a:rPr/>
+              <a:t>agnostic to how a DT is implemented — as long as it respects the platform’s data models</a:t>
             </a:r>
           </a:p>
         </p:txBody>

</xml_diff>

<commit_message>
Deploying to gh-pages from @ ManuelePasini/slides-markdown@ec7ef55d839fefafd2f2b4f595007d4563f88f4f 🚀
</commit_message>
<xml_diff>
--- a/3rd_year_slides.pptx
+++ b/3rd_year_slides.pptx
@@ -3882,7 +3882,7 @@
             </a:pPr>
             <a:r>
               <a:rPr b="1"/>
-              <a:t>Fragmentation &amp; Heterogeneity → limited standardization &amp; interoperability</a:t>
+              <a:t>Fragmentation → limited standardization &amp; interoperability</a:t>
             </a:r>
           </a:p>
         </p:txBody>
@@ -3956,13 +3956,6 @@
             </a:r>
           </a:p>
           <a:p>
-            <a:pPr lvl="1"/>
-            <a:r>
-              <a:rPr/>
-              <a:t>heterogeneous data: structured/unstructured, sensor/simulation/imagery, domain-specific</a:t>
-            </a:r>
-          </a:p>
-          <a:p>
             <a:pPr lvl="0"/>
             <a:r>
               <a:rPr b="1"/>
@@ -3977,25 +3970,22 @@
             <a:pPr lvl="1"/>
             <a:r>
               <a:rPr/>
-              <a:t>software dimension → substantial work, increasingly mature</a:t>
+              <a:t>Software dimension → substantial work, increasingly mature</a:t>
             </a:r>
           </a:p>
           <a:p>
             <a:pPr lvl="1"/>
             <a:r>
               <a:rPr/>
-              <a:t>data dimension → far less mature ⇐ </a:t>
+              <a:t>Data dimension → far less mature ⇐ </a:t>
             </a:r>
             <a:r>
               <a:rPr b="1"/>
               <a:t>focus of my research</a:t>
             </a:r>
-          </a:p>
-          <a:p>
-            <a:pPr lvl="0"/>
             <a:r>
               <a:rPr/>
-              <a:t>⇒ </a:t>
+              <a:t> ⇒ </a:t>
             </a:r>
             <a:r>
               <a:rPr b="1"/>
@@ -4007,7 +3997,7 @@
             </a:r>
           </a:p>
           <a:p>
-            <a:pPr lvl="1"/>
+            <a:pPr lvl="2"/>
             <a:r>
               <a:rPr/>
               <a:t>Data standardization entails interoperability!</a:t>

</xml_diff>

<commit_message>
Deploying to gh-pages from @ ManuelePasini/slides-markdown@3224354f68dc88ee7ff9b74f7950600bc6338711 🚀
</commit_message>
<xml_diff>
--- a/3rd_year_slides.pptx
+++ b/3rd_year_slides.pptx
@@ -11,6 +11,9 @@
     <p:sldId id="259" r:id="rId5"/>
     <p:sldId id="260" r:id="rId6"/>
     <p:sldId id="261" r:id="rId7"/>
+    <p:sldId id="262" r:id="rId8"/>
+    <p:sldId id="263" r:id="rId9"/>
+    <p:sldId id="264" r:id="rId10"/>
   </p:sldIdLst>
   <p:sldSz cx="9144000" cy="5143500" type="screen16x9"/>
   <p:notesSz cx="6858000" cy="9144000"/>
@@ -3559,8 +3562,14 @@
               <a:buNone/>
             </a:pPr>
             <a:r>
+              <a:rPr>
+                <a:hlinkClick r:id="rId5"/>
+              </a:rPr>
+              <a:t>M. Grieves</a:t>
+            </a:r>
+            <a:r>
               <a:rPr/>
-              <a:t>Grieves 3D Model</a:t>
+              <a:t> 3D Model</a:t>
             </a:r>
           </a:p>
         </p:txBody>
@@ -3792,15 +3801,7 @@
             <a:pPr lvl="0"/>
             <a:r>
               <a:rPr/>
-              <a:t>Digital Twins adopted across </a:t>
-            </a:r>
-            <a:r>
-              <a:rPr b="1"/>
-              <a:t>many independent domains</a:t>
-            </a:r>
-            <a:r>
-              <a:rPr/>
-              <a:t>:</a:t>
+              <a:t>Digital Twins adopted across many independent domains:</a:t>
             </a:r>
           </a:p>
           <a:p>
@@ -3873,7 +3874,7 @@
             <a:pPr lvl="1"/>
             <a:r>
               <a:rPr/>
-              <a:t>limited scalability</a:t>
+              <a:t>scalability issues</a:t>
             </a:r>
           </a:p>
           <a:p>
@@ -3983,24 +3984,16 @@
               <a:rPr b="1"/>
               <a:t>focus of my research</a:t>
             </a:r>
+          </a:p>
+          <a:p>
+            <a:pPr lvl="0"/>
+            <a:r>
+              <a:rPr b="1"/>
+              <a:t>Standardization should start from data</a:t>
+            </a:r>
             <a:r>
               <a:rPr/>
-              <a:t> ⇒ </a:t>
-            </a:r>
-            <a:r>
-              <a:rPr b="1"/>
-              <a:t>Data standardization should lead</a:t>
-            </a:r>
-            <a:r>
-              <a:rPr/>
-              <a:t> the standardization effort</a:t>
-            </a:r>
-          </a:p>
-          <a:p>
-            <a:pPr lvl="2"/>
-            <a:r>
-              <a:rPr/>
-              <a:t>Data standardization entails interoperability!</a:t>
+              <a:t>, not from software</a:t>
             </a:r>
           </a:p>
           <a:p>
@@ -4022,6 +4015,217 @@
             <a:r>
               <a:rPr/>
               <a:t>agnostic to how a DT is implemented — as long as it respects the platform’s data models</a:t>
+            </a:r>
+          </a:p>
+        </p:txBody>
+      </p:sp>
+    </p:spTree>
+  </p:cSld>
+</p:sld>
+</file>
+
+<file path=ppt/slides/slide7.xml><?xml version="1.0" encoding="utf-8"?>
+<p:sld xmlns:a="http://schemas.openxmlformats.org/drawingml/2006/main" xmlns:r="http://schemas.openxmlformats.org/officeDocument/2006/relationships" xmlns:p="http://schemas.openxmlformats.org/presentationml/2006/main">
+  <p:cSld>
+    <p:spTree>
+      <p:nvGrpSpPr>
+        <p:cNvPr id="1" name=""/>
+        <p:cNvGrpSpPr/>
+        <p:nvPr/>
+      </p:nvGrpSpPr>
+      <p:grpSpPr>
+        <a:xfrm>
+          <a:off x="0" y="0"/>
+          <a:ext cx="0" cy="0"/>
+          <a:chOff x="0" y="0"/>
+          <a:chExt cx="0" cy="0"/>
+        </a:xfrm>
+      </p:grpSpPr>
+      <p:sp>
+        <p:nvSpPr>
+          <p:cNvPr id="2" name="Title 1"/>
+          <p:cNvSpPr>
+            <a:spLocks noGrp="1"/>
+          </p:cNvSpPr>
+          <p:nvPr>
+            <p:ph type="title"/>
+          </p:nvPr>
+        </p:nvSpPr>
+        <p:spPr/>
+        <p:txBody>
+          <a:bodyPr/>
+          <a:lstStyle/>
+          <a:p>
+            <a:pPr lvl="0" indent="0" marL="0">
+              <a:buNone/>
+            </a:pPr>
+            <a:r>
+              <a:rPr/>
+              <a:t>Prescriptive watering: Data-driven optimization of water consumption in kiwifruit orchards</a:t>
+            </a:r>
+          </a:p>
+        </p:txBody>
+      </p:sp>
+    </p:spTree>
+  </p:cSld>
+</p:sld>
+</file>
+
+<file path=ppt/slides/slide8.xml><?xml version="1.0" encoding="utf-8"?>
+<p:sld xmlns:a="http://schemas.openxmlformats.org/drawingml/2006/main" xmlns:r="http://schemas.openxmlformats.org/officeDocument/2006/relationships" xmlns:p="http://schemas.openxmlformats.org/presentationml/2006/main">
+  <p:cSld>
+    <p:spTree>
+      <p:nvGrpSpPr>
+        <p:cNvPr id="1" name=""/>
+        <p:cNvGrpSpPr/>
+        <p:nvPr/>
+      </p:nvGrpSpPr>
+      <p:grpSpPr>
+        <a:xfrm>
+          <a:off x="0" y="0"/>
+          <a:ext cx="0" cy="0"/>
+          <a:chOff x="0" y="0"/>
+          <a:chExt cx="0" cy="0"/>
+        </a:xfrm>
+      </p:grpSpPr>
+      <p:sp>
+        <p:nvSpPr>
+          <p:cNvPr id="2" name="Title 1"/>
+          <p:cNvSpPr>
+            <a:spLocks noGrp="1"/>
+          </p:cNvSpPr>
+          <p:nvPr>
+            <p:ph type="title"/>
+          </p:nvPr>
+        </p:nvSpPr>
+        <p:spPr/>
+        <p:txBody>
+          <a:bodyPr/>
+          <a:lstStyle/>
+          <a:p>
+            <a:pPr lvl="0" indent="0" marL="0">
+              <a:buNone/>
+            </a:pPr>
+            <a:r>
+              <a:rPr/>
+              <a:t>STGraph: A Multistore for Spatio-Temporal Property Graphs and Time-Series Data</a:t>
+            </a:r>
+          </a:p>
+        </p:txBody>
+      </p:sp>
+      <p:pic>
+        <p:nvPicPr>
+          <p:cNvPr descr="https://github.com/ManuelePasini/slides-markdown/blob/master/slides/images/phd3rdyear/STGraph.svg" id="0" name="Picture 1"/>
+          <p:cNvPicPr>
+            <a:picLocks noGrp="1" noChangeAspect="1"/>
+          </p:cNvPicPr>
+          <p:nvPr/>
+        </p:nvPicPr>
+        <p:blipFill>
+          <a:blip r:embed="rId2"/>
+          <a:stretch>
+            <a:fillRect/>
+          </a:stretch>
+        </p:blipFill>
+        <p:spPr bwMode="auto">
+          <a:xfrm>
+            <a:off x="2413000" y="1193800"/>
+            <a:ext cx="4318000" cy="2882900"/>
+          </a:xfrm>
+          <a:prstGeom prst="rect">
+            <a:avLst/>
+          </a:prstGeom>
+          <a:noFill/>
+          <a:ln w="9525">
+            <a:noFill/>
+            <a:headEnd/>
+            <a:tailEnd/>
+          </a:ln>
+        </p:spPr>
+      </p:pic>
+      <p:sp>
+        <p:nvSpPr>
+          <p:cNvPr id="1" name="TextBox 3"/>
+          <p:cNvSpPr txBox="1"/>
+          <p:nvPr/>
+        </p:nvSpPr>
+        <p:spPr>
+          <a:xfrm>
+            <a:off x="457200" y="4076700"/>
+            <a:ext cx="8229600" cy="508000"/>
+          </a:xfrm>
+          <a:prstGeom prst="rect">
+            <a:avLst/>
+          </a:prstGeom>
+          <a:noFill/>
+        </p:spPr>
+        <p:txBody>
+          <a:bodyPr/>
+          <a:lstStyle/>
+          <a:p>
+            <a:pPr lvl="0" indent="0" marL="0" algn="ctr">
+              <a:buNone/>
+            </a:pPr>
+            <a:r>
+              <a:rPr/>
+              <a:t>Characterizing Digital Twin data (</a:t>
+            </a:r>
+            <a:r>
+              <a:rPr>
+                <a:hlinkClick r:id="rId3"/>
+              </a:rPr>
+              <a:t>Fei, Tao 2023</a:t>
+            </a:r>
+            <a:r>
+              <a:rPr/>
+              <a:t>)</a:t>
+            </a:r>
+          </a:p>
+        </p:txBody>
+      </p:sp>
+    </p:spTree>
+  </p:cSld>
+</p:sld>
+</file>
+
+<file path=ppt/slides/slide9.xml><?xml version="1.0" encoding="utf-8"?>
+<p:sld xmlns:a="http://schemas.openxmlformats.org/drawingml/2006/main" xmlns:r="http://schemas.openxmlformats.org/officeDocument/2006/relationships" xmlns:p="http://schemas.openxmlformats.org/presentationml/2006/main">
+  <p:cSld>
+    <p:spTree>
+      <p:nvGrpSpPr>
+        <p:cNvPr id="1" name=""/>
+        <p:cNvGrpSpPr/>
+        <p:nvPr/>
+      </p:nvGrpSpPr>
+      <p:grpSpPr>
+        <a:xfrm>
+          <a:off x="0" y="0"/>
+          <a:ext cx="0" cy="0"/>
+          <a:chOff x="0" y="0"/>
+          <a:chExt cx="0" cy="0"/>
+        </a:xfrm>
+      </p:grpSpPr>
+      <p:sp>
+        <p:nvSpPr>
+          <p:cNvPr id="3" name="Content Placeholder 2"/>
+          <p:cNvSpPr>
+            <a:spLocks noGrp="1"/>
+          </p:cNvSpPr>
+          <p:nvPr>
+            <p:ph idx="1"/>
+          </p:nvPr>
+        </p:nvSpPr>
+        <p:spPr/>
+        <p:txBody>
+          <a:bodyPr/>
+          <a:lstStyle/>
+          <a:p>
+            <a:pPr lvl="0" indent="0" marL="0">
+              <a:buNone/>
+            </a:pPr>
+            <a:r>
+              <a:rPr/>
+              <a:t> ## Anomaly Detection in Complex Sensor Networks ## LLM-Assisted Metadata Query Answering on Data Warehouses</a:t>
             </a:r>
           </a:p>
         </p:txBody>

</xml_diff>

<commit_message>
Deploying to gh-pages from @ ManuelePasini/slides-markdown@5f046957acf690c173153df202cb0a0bf27e3585 🚀
</commit_message>
<xml_diff>
--- a/3rd_year_slides.pptx
+++ b/3rd_year_slides.pptx
@@ -14,6 +14,7 @@
     <p:sldId id="262" r:id="rId8"/>
     <p:sldId id="263" r:id="rId9"/>
     <p:sldId id="264" r:id="rId10"/>
+    <p:sldId id="265" r:id="rId11"/>
   </p:sldIdLst>
   <p:sldSz cx="9144000" cy="5143500" type="screen16x9"/>
   <p:notesSz cx="6858000" cy="9144000"/>
@@ -3241,6 +3242,53 @@
 </p:sld>
 </file>
 
+<file path=ppt/slides/slide10.xml><?xml version="1.0" encoding="utf-8"?>
+<p:sld xmlns:a="http://schemas.openxmlformats.org/drawingml/2006/main" xmlns:r="http://schemas.openxmlformats.org/officeDocument/2006/relationships" xmlns:p="http://schemas.openxmlformats.org/presentationml/2006/main">
+  <p:cSld>
+    <p:spTree>
+      <p:nvGrpSpPr>
+        <p:cNvPr id="1" name=""/>
+        <p:cNvGrpSpPr/>
+        <p:nvPr/>
+      </p:nvGrpSpPr>
+      <p:grpSpPr>
+        <a:xfrm>
+          <a:off x="0" y="0"/>
+          <a:ext cx="0" cy="0"/>
+          <a:chOff x="0" y="0"/>
+          <a:chExt cx="0" cy="0"/>
+        </a:xfrm>
+      </p:grpSpPr>
+      <p:sp>
+        <p:nvSpPr>
+          <p:cNvPr id="2" name="Title 1"/>
+          <p:cNvSpPr>
+            <a:spLocks noGrp="1"/>
+          </p:cNvSpPr>
+          <p:nvPr>
+            <p:ph type="title"/>
+          </p:nvPr>
+        </p:nvSpPr>
+        <p:spPr/>
+        <p:txBody>
+          <a:bodyPr/>
+          <a:lstStyle/>
+          <a:p>
+            <a:pPr lvl="0" indent="0" marL="0">
+              <a:buNone/>
+            </a:pPr>
+            <a:r>
+              <a:rPr/>
+              <a:t>LLM-Assisted Metadata Query Answering on Data Warehouses</a:t>
+            </a:r>
+          </a:p>
+        </p:txBody>
+      </p:sp>
+    </p:spTree>
+  </p:cSld>
+</p:sld>
+</file>
+
 <file path=ppt/slides/slide2.xml><?xml version="1.0" encoding="utf-8"?>
 <p:sld xmlns:a="http://schemas.openxmlformats.org/drawingml/2006/main" xmlns:r="http://schemas.openxmlformats.org/officeDocument/2006/relationships" xmlns:p="http://schemas.openxmlformats.org/presentationml/2006/main">
   <p:cSld>
@@ -3978,11 +4026,7 @@
             <a:pPr lvl="1"/>
             <a:r>
               <a:rPr/>
-              <a:t>Data dimension → far less mature ⇐ </a:t>
-            </a:r>
-            <a:r>
-              <a:rPr b="1"/>
-              <a:t>focus of my research</a:t>
+              <a:t>Data dimension → far less mature ⇐ focus of my research</a:t>
             </a:r>
           </a:p>
           <a:p>
@@ -3990,10 +4034,6 @@
             <a:r>
               <a:rPr b="1"/>
               <a:t>Standardization should start from data</a:t>
-            </a:r>
-            <a:r>
-              <a:rPr/>
-              <a:t>, not from software</a:t>
             </a:r>
           </a:p>
           <a:p>
@@ -4115,7 +4155,7 @@
       </p:sp>
       <p:pic>
         <p:nvPicPr>
-          <p:cNvPr descr="https://github.com/ManuelePasini/slides-markdown/blob/master/slides/images/phd3rdyear/STGraph.svg" id="0" name="Picture 1"/>
+          <p:cNvPr descr="https://github.com/ManuelePasini/slides-markdown/blob/master/slides/images/phd3rdyear/STGraph.svg?raw=true" id="0" name="Picture 1"/>
           <p:cNvPicPr>
             <a:picLocks noGrp="1" noChangeAspect="1"/>
           </p:cNvPicPr>
@@ -4207,12 +4247,12 @@
       </p:grpSpPr>
       <p:sp>
         <p:nvSpPr>
-          <p:cNvPr id="3" name="Content Placeholder 2"/>
-          <p:cNvSpPr>
-            <a:spLocks noGrp="1"/>
-          </p:cNvSpPr>
-          <p:nvPr>
-            <p:ph idx="1"/>
+          <p:cNvPr id="2" name="Title 1"/>
+          <p:cNvSpPr>
+            <a:spLocks noGrp="1"/>
+          </p:cNvSpPr>
+          <p:nvPr>
+            <p:ph type="title"/>
           </p:nvPr>
         </p:nvSpPr>
         <p:spPr/>
@@ -4225,7 +4265,7 @@
             </a:pPr>
             <a:r>
               <a:rPr/>
-              <a:t> ## Anomaly Detection in Complex Sensor Networks ## LLM-Assisted Metadata Query Answering on Data Warehouses</a:t>
+              <a:t>Anomaly Detection in Complex Sensor Networks</a:t>
             </a:r>
           </a:p>
         </p:txBody>

</xml_diff>

<commit_message>
Deploying to gh-pages from @ ManuelePasini/slides-markdown@1908d7ebf20d3c42a79afe1e560e8e0446dbdfa3 🚀
</commit_message>
<xml_diff>
--- a/3rd_year_slides.pptx
+++ b/3rd_year_slides.pptx
@@ -15,6 +15,8 @@
     <p:sldId id="263" r:id="rId9"/>
     <p:sldId id="264" r:id="rId10"/>
     <p:sldId id="265" r:id="rId11"/>
+    <p:sldId id="266" r:id="rId12"/>
+    <p:sldId id="267" r:id="rId13"/>
   </p:sldIdLst>
   <p:sldSz cx="9144000" cy="5143500" type="screen16x9"/>
   <p:notesSz cx="6858000" cy="9144000"/>
@@ -3279,6 +3281,254 @@
             </a:pPr>
             <a:r>
               <a:rPr/>
+              <a:t>STGraph: A Multistore for Spatio-Temporal Property Graphs and Time-Series Data</a:t>
+            </a:r>
+          </a:p>
+        </p:txBody>
+      </p:sp>
+      <p:sp>
+        <p:nvSpPr>
+          <p:cNvPr id="3" name="Content Placeholder 2"/>
+          <p:cNvSpPr>
+            <a:spLocks noGrp="1"/>
+          </p:cNvSpPr>
+          <p:nvPr>
+            <p:ph idx="1"/>
+          </p:nvPr>
+        </p:nvSpPr>
+        <p:spPr/>
+        <p:txBody>
+          <a:bodyPr/>
+          <a:lstStyle/>
+          <a:p>
+            <a:pPr lvl="0" indent="0" marL="0">
+              <a:spcBef>
+                <a:spcPts val="3000"/>
+              </a:spcBef>
+              <a:buNone/>
+            </a:pPr>
+            <a:r>
+              <a:rPr b="1"/>
+              <a:t>Under review @ VLDB 2027</a:t>
+            </a:r>
+          </a:p>
+          <a:p>
+            <a:pPr lvl="0"/>
+            <a:r>
+              <a:rPr/>
+              <a:t>Key points: :::: {.columns} ::: {.column width=“50%”}</a:t>
+            </a:r>
+          </a:p>
+          <a:p>
+            <a:pPr lvl="1"/>
+            <a:r>
+              <a:rPr/>
+              <a:t>Optimized streaming ingestion of data;</a:t>
+            </a:r>
+          </a:p>
+          <a:p>
+            <a:pPr lvl="1"/>
+            <a:r>
+              <a:rPr/>
+              <a:t>Query optimization through filter-pushdown ::: ::: {.column width=“50%”}</a:t>
+            </a:r>
+          </a:p>
+          <a:p>
+            <a:pPr lvl="1"/>
+            <a:r>
+              <a:rPr/>
+              <a:t>TS events as graph nodes:</a:t>
+            </a:r>
+          </a:p>
+          <a:p>
+            <a:pPr lvl="2"/>
+            <a:r>
+              <a:rPr/>
+              <a:t>can also hold edges and properties</a:t>
+            </a:r>
+          </a:p>
+          <a:p>
+            <a:pPr lvl="2"/>
+            <a:r>
+              <a:rPr/>
+              <a:t>materialized on graph at query time (saving storage).</a:t>
+            </a:r>
+          </a:p>
+          <a:p>
+            <a:pPr lvl="1"/>
+            <a:r>
+              <a:rPr/>
+              <a:t>Support for different temporal semantics</a:t>
+            </a:r>
+          </a:p>
+          <a:p>
+            <a:pPr lvl="2"/>
+            <a:r>
+              <a:rPr/>
+              <a:t>(e.g., continuous path (default), consecutive path) . ::: ::::</a:t>
+            </a:r>
+          </a:p>
+        </p:txBody>
+      </p:sp>
+      <p:pic>
+        <p:nvPicPr>
+          <p:cNvPr descr="https://github.com/ManuelePasini/slides-markdown/blob/master/slides/images/phd3rdyear/datamodel.svg?raw=true" id="0" name="Picture 1"/>
+          <p:cNvPicPr>
+            <a:picLocks noGrp="1" noChangeAspect="1"/>
+          </p:cNvPicPr>
+          <p:nvPr/>
+        </p:nvPicPr>
+        <p:blipFill>
+          <a:blip r:embed="rId2"/>
+          <a:stretch>
+            <a:fillRect/>
+          </a:stretch>
+        </p:blipFill>
+        <p:spPr bwMode="auto">
+          <a:xfrm>
+            <a:off x="2413000" y="1193800"/>
+            <a:ext cx="4318000" cy="2882900"/>
+          </a:xfrm>
+          <a:prstGeom prst="rect">
+            <a:avLst/>
+          </a:prstGeom>
+          <a:noFill/>
+          <a:ln w="9525">
+            <a:noFill/>
+            <a:headEnd/>
+            <a:tailEnd/>
+          </a:ln>
+        </p:spPr>
+      </p:pic>
+      <p:sp>
+        <p:nvSpPr>
+          <p:cNvPr id="1" name="TextBox 3"/>
+          <p:cNvSpPr txBox="1"/>
+          <p:nvPr/>
+        </p:nvSpPr>
+        <p:spPr>
+          <a:xfrm>
+            <a:off x="457200" y="4076700"/>
+            <a:ext cx="8229600" cy="508000"/>
+          </a:xfrm>
+          <a:prstGeom prst="rect">
+            <a:avLst/>
+          </a:prstGeom>
+          <a:noFill/>
+        </p:spPr>
+        <p:txBody>
+          <a:bodyPr/>
+          <a:lstStyle/>
+          <a:p>
+            <a:pPr lvl="0" indent="0" marL="0" algn="ctr">
+              <a:buNone/>
+            </a:pPr>
+            <a:r>
+              <a:rPr/>
+              <a:t>Characterizing Digital Twin data (</a:t>
+            </a:r>
+            <a:r>
+              <a:rPr>
+                <a:hlinkClick r:id="rId3"/>
+              </a:rPr>
+              <a:t>Fei, Tao 2023</a:t>
+            </a:r>
+            <a:r>
+              <a:rPr/>
+              <a:t>)</a:t>
+            </a:r>
+          </a:p>
+        </p:txBody>
+      </p:sp>
+    </p:spTree>
+  </p:cSld>
+</p:sld>
+</file>
+
+<file path=ppt/slides/slide11.xml><?xml version="1.0" encoding="utf-8"?>
+<p:sld xmlns:a="http://schemas.openxmlformats.org/drawingml/2006/main" xmlns:r="http://schemas.openxmlformats.org/officeDocument/2006/relationships" xmlns:p="http://schemas.openxmlformats.org/presentationml/2006/main">
+  <p:cSld>
+    <p:spTree>
+      <p:nvGrpSpPr>
+        <p:cNvPr id="1" name=""/>
+        <p:cNvGrpSpPr/>
+        <p:nvPr/>
+      </p:nvGrpSpPr>
+      <p:grpSpPr>
+        <a:xfrm>
+          <a:off x="0" y="0"/>
+          <a:ext cx="0" cy="0"/>
+          <a:chOff x="0" y="0"/>
+          <a:chExt cx="0" cy="0"/>
+        </a:xfrm>
+      </p:grpSpPr>
+      <p:sp>
+        <p:nvSpPr>
+          <p:cNvPr id="2" name="Title 1"/>
+          <p:cNvSpPr>
+            <a:spLocks noGrp="1"/>
+          </p:cNvSpPr>
+          <p:nvPr>
+            <p:ph type="title"/>
+          </p:nvPr>
+        </p:nvSpPr>
+        <p:spPr/>
+        <p:txBody>
+          <a:bodyPr/>
+          <a:lstStyle/>
+          <a:p>
+            <a:pPr lvl="0" indent="0" marL="0">
+              <a:buNone/>
+            </a:pPr>
+            <a:r>
+              <a:rPr/>
+              <a:t>Anomaly Detection in Complex Sensor Networks</a:t>
+            </a:r>
+          </a:p>
+        </p:txBody>
+      </p:sp>
+    </p:spTree>
+  </p:cSld>
+</p:sld>
+</file>
+
+<file path=ppt/slides/slide12.xml><?xml version="1.0" encoding="utf-8"?>
+<p:sld xmlns:a="http://schemas.openxmlformats.org/drawingml/2006/main" xmlns:r="http://schemas.openxmlformats.org/officeDocument/2006/relationships" xmlns:p="http://schemas.openxmlformats.org/presentationml/2006/main">
+  <p:cSld>
+    <p:spTree>
+      <p:nvGrpSpPr>
+        <p:cNvPr id="1" name=""/>
+        <p:cNvGrpSpPr/>
+        <p:nvPr/>
+      </p:nvGrpSpPr>
+      <p:grpSpPr>
+        <a:xfrm>
+          <a:off x="0" y="0"/>
+          <a:ext cx="0" cy="0"/>
+          <a:chOff x="0" y="0"/>
+          <a:chExt cx="0" cy="0"/>
+        </a:xfrm>
+      </p:grpSpPr>
+      <p:sp>
+        <p:nvSpPr>
+          <p:cNvPr id="2" name="Title 1"/>
+          <p:cNvSpPr>
+            <a:spLocks noGrp="1"/>
+          </p:cNvSpPr>
+          <p:nvPr>
+            <p:ph type="title"/>
+          </p:nvPr>
+        </p:nvSpPr>
+        <p:spPr/>
+        <p:txBody>
+          <a:bodyPr/>
+          <a:lstStyle/>
+          <a:p>
+            <a:pPr lvl="0" indent="0" marL="0">
+              <a:buNone/>
+            </a:pPr>
+            <a:r>
+              <a:rPr/>
               <a:t>LLM-Assisted Metadata Query Answering on Data Warehouses</a:t>
             </a:r>
           </a:p>
@@ -4153,72 +4403,30 @@
           </a:p>
         </p:txBody>
       </p:sp>
-      <p:pic>
-        <p:nvPicPr>
-          <p:cNvPr descr="https://github.com/ManuelePasini/slides-markdown/blob/master/slides/images/phd3rdyear/STGraph.svg?raw=true" id="0" name="Picture 1"/>
-          <p:cNvPicPr>
-            <a:picLocks noGrp="1" noChangeAspect="1"/>
-          </p:cNvPicPr>
-          <p:nvPr/>
-        </p:nvPicPr>
-        <p:blipFill>
-          <a:blip r:embed="rId2"/>
-          <a:stretch>
-            <a:fillRect/>
-          </a:stretch>
-        </p:blipFill>
-        <p:spPr bwMode="auto">
-          <a:xfrm>
-            <a:off x="2413000" y="1193800"/>
-            <a:ext cx="4318000" cy="2882900"/>
-          </a:xfrm>
-          <a:prstGeom prst="rect">
-            <a:avLst/>
-          </a:prstGeom>
-          <a:noFill/>
-          <a:ln w="9525">
-            <a:noFill/>
-            <a:headEnd/>
-            <a:tailEnd/>
-          </a:ln>
-        </p:spPr>
-      </p:pic>
-      <p:sp>
-        <p:nvSpPr>
-          <p:cNvPr id="1" name="TextBox 3"/>
-          <p:cNvSpPr txBox="1"/>
-          <p:nvPr/>
-        </p:nvSpPr>
-        <p:spPr>
-          <a:xfrm>
-            <a:off x="457200" y="4076700"/>
-            <a:ext cx="8229600" cy="508000"/>
-          </a:xfrm>
-          <a:prstGeom prst="rect">
-            <a:avLst/>
-          </a:prstGeom>
-          <a:noFill/>
-        </p:spPr>
-        <p:txBody>
-          <a:bodyPr/>
-          <a:lstStyle/>
-          <a:p>
-            <a:pPr lvl="0" indent="0" marL="0" algn="ctr">
+      <p:sp>
+        <p:nvSpPr>
+          <p:cNvPr id="3" name="Content Placeholder 2"/>
+          <p:cNvSpPr>
+            <a:spLocks noGrp="1"/>
+          </p:cNvSpPr>
+          <p:nvPr>
+            <p:ph idx="1"/>
+          </p:nvPr>
+        </p:nvSpPr>
+        <p:spPr/>
+        <p:txBody>
+          <a:bodyPr/>
+          <a:lstStyle/>
+          <a:p>
+            <a:pPr lvl="0" indent="0" marL="0">
+              <a:spcBef>
+                <a:spcPts val="3000"/>
+              </a:spcBef>
               <a:buNone/>
             </a:pPr>
             <a:r>
-              <a:rPr/>
-              <a:t>Characterizing Digital Twin data (</a:t>
-            </a:r>
-            <a:r>
-              <a:rPr>
-                <a:hlinkClick r:id="rId3"/>
-              </a:rPr>
-              <a:t>Fei, Tao 2023</a:t>
-            </a:r>
-            <a:r>
-              <a:rPr/>
-              <a:t>)</a:t>
+              <a:rPr b="1"/>
+              <a:t>Under review @ VLDB 2027</a:t>
             </a:r>
           </a:p>
         </p:txBody>
@@ -4247,25 +4455,121 @@
       </p:grpSpPr>
       <p:sp>
         <p:nvSpPr>
-          <p:cNvPr id="2" name="Title 1"/>
-          <p:cNvSpPr>
-            <a:spLocks noGrp="1"/>
-          </p:cNvSpPr>
-          <p:nvPr>
-            <p:ph type="title"/>
-          </p:nvPr>
-        </p:nvSpPr>
-        <p:spPr/>
-        <p:txBody>
-          <a:bodyPr/>
-          <a:lstStyle/>
-          <a:p>
-            <a:pPr lvl="0" indent="0" marL="0">
+          <p:cNvPr id="3" name="Content Placeholder 2"/>
+          <p:cNvSpPr>
+            <a:spLocks noGrp="1"/>
+          </p:cNvSpPr>
+          <p:nvPr>
+            <p:ph idx="1" sz="half"/>
+          </p:nvPr>
+        </p:nvSpPr>
+        <p:spPr/>
+        <p:txBody>
+          <a:bodyPr/>
+          <a:lstStyle/>
+          <a:p>
+            <a:pPr lvl="0"/>
+            <a:r>
+              <a:rPr/>
+              <a:t>A multistore data structure for large spatio-temporal property graphs</a:t>
+            </a:r>
+          </a:p>
+          <a:p>
+            <a:pPr lvl="1"/>
+            <a:r>
+              <a:rPr/>
+              <a:t>Unified graph conceptual model on top of heterogeneous storage</a:t>
+            </a:r>
+          </a:p>
+          <a:p>
+            <a:pPr lvl="2"/>
+            <a:r>
+              <a:rPr/>
+              <a:t>Low-evolving data on Graph storage</a:t>
+            </a:r>
+          </a:p>
+          <a:p>
+            <a:pPr lvl="2"/>
+            <a:r>
+              <a:rPr/>
+              <a:t>Highly-dynamic data on Time-Series storage</a:t>
+            </a:r>
+          </a:p>
+          <a:p>
+            <a:pPr lvl="1"/>
+            <a:r>
+              <a:rPr/>
+              <a:t>Transparent graph query interface.</a:t>
+            </a:r>
+          </a:p>
+        </p:txBody>
+      </p:sp>
+      <p:pic>
+        <p:nvPicPr>
+          <p:cNvPr descr="https://github.com/ManuelePasini/slides-markdown/blob/master/slides/images/phd3rdyear/arch.svg?raw=true" id="0" name="Picture 1"/>
+          <p:cNvPicPr>
+            <a:picLocks noGrp="1" noChangeAspect="1"/>
+          </p:cNvPicPr>
+          <p:nvPr/>
+        </p:nvPicPr>
+        <p:blipFill>
+          <a:blip r:embed="rId2"/>
+          <a:stretch>
+            <a:fillRect/>
+          </a:stretch>
+        </p:blipFill>
+        <p:spPr bwMode="auto">
+          <a:xfrm>
+            <a:off x="4648200" y="1333500"/>
+            <a:ext cx="4038600" cy="2603500"/>
+          </a:xfrm>
+          <a:prstGeom prst="rect">
+            <a:avLst/>
+          </a:prstGeom>
+          <a:noFill/>
+          <a:ln w="9525">
+            <a:noFill/>
+            <a:headEnd/>
+            <a:tailEnd/>
+          </a:ln>
+        </p:spPr>
+      </p:pic>
+      <p:sp>
+        <p:nvSpPr>
+          <p:cNvPr id="1" name="TextBox 3"/>
+          <p:cNvSpPr txBox="1"/>
+          <p:nvPr/>
+        </p:nvSpPr>
+        <p:spPr>
+          <a:xfrm>
+            <a:off x="4648200" y="4076700"/>
+            <a:ext cx="4038600" cy="508000"/>
+          </a:xfrm>
+          <a:prstGeom prst="rect">
+            <a:avLst/>
+          </a:prstGeom>
+          <a:noFill/>
+        </p:spPr>
+        <p:txBody>
+          <a:bodyPr/>
+          <a:lstStyle/>
+          <a:p>
+            <a:pPr lvl="0" indent="0" marL="0" algn="ctr">
               <a:buNone/>
             </a:pPr>
             <a:r>
               <a:rPr/>
-              <a:t>Anomaly Detection in Complex Sensor Networks</a:t>
+              <a:t>Characterizing Digital Twin data (</a:t>
+            </a:r>
+            <a:r>
+              <a:rPr>
+                <a:hlinkClick r:id="rId3"/>
+              </a:rPr>
+              <a:t>Fei, Tao 2023</a:t>
+            </a:r>
+            <a:r>
+              <a:rPr/>
+              <a:t>)</a:t>
             </a:r>
           </a:p>
         </p:txBody>

</xml_diff>

<commit_message>
Deploying to gh-pages from @ ManuelePasini/slides-markdown@8cf27baaccc1873f5c83ea18b4532e54fd19ab7e 🚀
</commit_message>
<xml_diff>
--- a/3rd_year_slides.pptx
+++ b/3rd_year_slides.pptx
@@ -17,6 +17,8 @@
     <p:sldId id="265" r:id="rId11"/>
     <p:sldId id="266" r:id="rId12"/>
     <p:sldId id="267" r:id="rId13"/>
+    <p:sldId id="268" r:id="rId14"/>
+    <p:sldId id="269" r:id="rId15"/>
   </p:sldIdLst>
   <p:sldSz cx="9144000" cy="5143500" type="screen16x9"/>
   <p:notesSz cx="6858000" cy="9144000"/>
@@ -3316,60 +3318,114 @@
             <a:pPr lvl="0"/>
             <a:r>
               <a:rPr/>
-              <a:t>Key points: :::: {.columns} ::: {.column width=“50%”}</a:t>
-            </a:r>
-          </a:p>
-          <a:p>
-            <a:pPr lvl="1"/>
-            <a:r>
-              <a:rPr/>
-              <a:t>Optimized streaming ingestion of data;</a:t>
-            </a:r>
-          </a:p>
-          <a:p>
-            <a:pPr lvl="1"/>
-            <a:r>
-              <a:rPr/>
-              <a:t>Query optimization through filter-pushdown ::: ::: {.column width=“50%”}</a:t>
-            </a:r>
-          </a:p>
-          <a:p>
-            <a:pPr lvl="1"/>
-            <a:r>
-              <a:rPr/>
-              <a:t>TS events as graph nodes:</a:t>
-            </a:r>
-          </a:p>
-          <a:p>
-            <a:pPr lvl="2"/>
-            <a:r>
-              <a:rPr/>
-              <a:t>can also hold edges and properties</a:t>
-            </a:r>
-          </a:p>
-          <a:p>
-            <a:pPr lvl="2"/>
-            <a:r>
-              <a:rPr/>
-              <a:t>materialized on graph at query time (saving storage).</a:t>
-            </a:r>
-          </a:p>
-          <a:p>
-            <a:pPr lvl="1"/>
-            <a:r>
-              <a:rPr/>
-              <a:t>Support for different temporal semantics</a:t>
-            </a:r>
-          </a:p>
-          <a:p>
-            <a:pPr lvl="2"/>
-            <a:r>
-              <a:rPr/>
-              <a:t>(e.g., continuous path (default), consecutive path) . ::: ::::</a:t>
-            </a:r>
-          </a:p>
-        </p:txBody>
-      </p:sp>
+              <a:t>Key points:</a:t>
+            </a:r>
+          </a:p>
+        </p:txBody>
+      </p:sp>
+    </p:spTree>
+  </p:cSld>
+</p:sld>
+</file>
+
+<file path=ppt/slides/slide11.xml><?xml version="1.0" encoding="utf-8"?>
+<p:sld xmlns:a="http://schemas.openxmlformats.org/drawingml/2006/main" xmlns:r="http://schemas.openxmlformats.org/officeDocument/2006/relationships" xmlns:p="http://schemas.openxmlformats.org/presentationml/2006/main">
+  <p:cSld>
+    <p:spTree>
+      <p:nvGrpSpPr>
+        <p:cNvPr id="1" name=""/>
+        <p:cNvGrpSpPr/>
+        <p:nvPr/>
+      </p:nvGrpSpPr>
+      <p:grpSpPr>
+        <a:xfrm>
+          <a:off x="0" y="0"/>
+          <a:ext cx="0" cy="0"/>
+          <a:chOff x="0" y="0"/>
+          <a:chExt cx="0" cy="0"/>
+        </a:xfrm>
+      </p:grpSpPr>
+      <p:sp>
+        <p:nvSpPr>
+          <p:cNvPr id="3" name="Content Placeholder 2"/>
+          <p:cNvSpPr>
+            <a:spLocks noGrp="1"/>
+          </p:cNvSpPr>
+          <p:nvPr>
+            <p:ph idx="1" sz="half"/>
+          </p:nvPr>
+        </p:nvSpPr>
+        <p:spPr/>
+        <p:txBody>
+          <a:bodyPr/>
+          <a:lstStyle/>
+          <a:p>
+            <a:pPr lvl="0" indent="0">
+              <a:buNone/>
+            </a:pPr>
+            <a:r>
+              <a:rPr>
+                <a:latin typeface="Courier"/>
+              </a:rPr>
+              <a:t>- Optimized streaming ingestion of data;
+- Query optimization through filter-pushdown</a:t>
+            </a:r>
+          </a:p>
+        </p:txBody>
+      </p:sp>
+      <p:sp>
+        <p:nvSpPr>
+          <p:cNvPr id="4" name="Content Placeholder 3"/>
+          <p:cNvSpPr>
+            <a:spLocks noGrp="1"/>
+          </p:cNvSpPr>
+          <p:nvPr>
+            <p:ph idx="2" sz="half"/>
+          </p:nvPr>
+        </p:nvSpPr>
+        <p:spPr/>
+        <p:txBody>
+          <a:bodyPr/>
+          <a:lstStyle/>
+          <a:p>
+            <a:pPr lvl="0" indent="0">
+              <a:buNone/>
+            </a:pPr>
+            <a:r>
+              <a:rPr>
+                <a:latin typeface="Courier"/>
+              </a:rPr>
+              <a:t>- TS events as graph nodes:
+    - can also hold edges and properties
+    - materialized on graph at query time (saving storage).
+- Support for different temporal semantics 
+    - (e.g., continuous path (default), consecutive path) .</a:t>
+            </a:r>
+          </a:p>
+        </p:txBody>
+      </p:sp>
+    </p:spTree>
+  </p:cSld>
+</p:sld>
+</file>
+
+<file path=ppt/slides/slide12.xml><?xml version="1.0" encoding="utf-8"?>
+<p:sld xmlns:a="http://schemas.openxmlformats.org/drawingml/2006/main" xmlns:r="http://schemas.openxmlformats.org/officeDocument/2006/relationships" xmlns:p="http://schemas.openxmlformats.org/presentationml/2006/main">
+  <p:cSld>
+    <p:spTree>
+      <p:nvGrpSpPr>
+        <p:cNvPr id="1" name=""/>
+        <p:cNvGrpSpPr/>
+        <p:nvPr/>
+      </p:nvGrpSpPr>
+      <p:grpSpPr>
+        <a:xfrm>
+          <a:off x="0" y="0"/>
+          <a:ext cx="0" cy="0"/>
+          <a:chOff x="0" y="0"/>
+          <a:chExt cx="0" cy="0"/>
+        </a:xfrm>
+      </p:grpSpPr>
       <p:pic>
         <p:nvPicPr>
           <p:cNvPr descr="https://github.com/ManuelePasini/slides-markdown/blob/master/slides/images/phd3rdyear/datamodel.svg?raw=true" id="0" name="Picture 1"/>
@@ -3445,7 +3501,7 @@
 </p:sld>
 </file>
 
-<file path=ppt/slides/slide11.xml><?xml version="1.0" encoding="utf-8"?>
+<file path=ppt/slides/slide13.xml><?xml version="1.0" encoding="utf-8"?>
 <p:sld xmlns:a="http://schemas.openxmlformats.org/drawingml/2006/main" xmlns:r="http://schemas.openxmlformats.org/officeDocument/2006/relationships" xmlns:p="http://schemas.openxmlformats.org/presentationml/2006/main">
   <p:cSld>
     <p:spTree>
@@ -3492,7 +3548,7 @@
 </p:sld>
 </file>
 
-<file path=ppt/slides/slide12.xml><?xml version="1.0" encoding="utf-8"?>
+<file path=ppt/slides/slide14.xml><?xml version="1.0" encoding="utf-8"?>
 <p:sld xmlns:a="http://schemas.openxmlformats.org/drawingml/2006/main" xmlns:r="http://schemas.openxmlformats.org/officeDocument/2006/relationships" xmlns:p="http://schemas.openxmlformats.org/presentationml/2006/main">
   <p:cSld>
     <p:spTree>

</xml_diff>

<commit_message>
Deploying to gh-pages from @ ManuelePasini/slides-markdown@862884e4726bc1da951456c3fe1bf43991cdd305 🚀
</commit_message>
<xml_diff>
--- a/3rd_year_slides.pptx
+++ b/3rd_year_slides.pptx
@@ -19,6 +19,7 @@
     <p:sldId id="267" r:id="rId13"/>
     <p:sldId id="268" r:id="rId14"/>
     <p:sldId id="269" r:id="rId15"/>
+    <p:sldId id="270" r:id="rId16"/>
   </p:sldIdLst>
   <p:sldSz cx="9144000" cy="5143500" type="screen16x9"/>
   <p:notesSz cx="6858000" cy="9144000"/>
@@ -3263,169 +3264,6 @@
           <a:chExt cx="0" cy="0"/>
         </a:xfrm>
       </p:grpSpPr>
-      <p:sp>
-        <p:nvSpPr>
-          <p:cNvPr id="2" name="Title 1"/>
-          <p:cNvSpPr>
-            <a:spLocks noGrp="1"/>
-          </p:cNvSpPr>
-          <p:nvPr>
-            <p:ph type="title"/>
-          </p:nvPr>
-        </p:nvSpPr>
-        <p:spPr/>
-        <p:txBody>
-          <a:bodyPr/>
-          <a:lstStyle/>
-          <a:p>
-            <a:pPr lvl="0" indent="0" marL="0">
-              <a:buNone/>
-            </a:pPr>
-            <a:r>
-              <a:rPr/>
-              <a:t>STGraph: A Multistore for Spatio-Temporal Property Graphs and Time-Series Data</a:t>
-            </a:r>
-          </a:p>
-        </p:txBody>
-      </p:sp>
-      <p:sp>
-        <p:nvSpPr>
-          <p:cNvPr id="3" name="Content Placeholder 2"/>
-          <p:cNvSpPr>
-            <a:spLocks noGrp="1"/>
-          </p:cNvSpPr>
-          <p:nvPr>
-            <p:ph idx="1"/>
-          </p:nvPr>
-        </p:nvSpPr>
-        <p:spPr/>
-        <p:txBody>
-          <a:bodyPr/>
-          <a:lstStyle/>
-          <a:p>
-            <a:pPr lvl="0" indent="0" marL="0">
-              <a:spcBef>
-                <a:spcPts val="3000"/>
-              </a:spcBef>
-              <a:buNone/>
-            </a:pPr>
-            <a:r>
-              <a:rPr b="1"/>
-              <a:t>Under review @ VLDB 2027</a:t>
-            </a:r>
-          </a:p>
-          <a:p>
-            <a:pPr lvl="0"/>
-            <a:r>
-              <a:rPr/>
-              <a:t>Key points:</a:t>
-            </a:r>
-          </a:p>
-        </p:txBody>
-      </p:sp>
-    </p:spTree>
-  </p:cSld>
-</p:sld>
-</file>
-
-<file path=ppt/slides/slide11.xml><?xml version="1.0" encoding="utf-8"?>
-<p:sld xmlns:a="http://schemas.openxmlformats.org/drawingml/2006/main" xmlns:r="http://schemas.openxmlformats.org/officeDocument/2006/relationships" xmlns:p="http://schemas.openxmlformats.org/presentationml/2006/main">
-  <p:cSld>
-    <p:spTree>
-      <p:nvGrpSpPr>
-        <p:cNvPr id="1" name=""/>
-        <p:cNvGrpSpPr/>
-        <p:nvPr/>
-      </p:nvGrpSpPr>
-      <p:grpSpPr>
-        <a:xfrm>
-          <a:off x="0" y="0"/>
-          <a:ext cx="0" cy="0"/>
-          <a:chOff x="0" y="0"/>
-          <a:chExt cx="0" cy="0"/>
-        </a:xfrm>
-      </p:grpSpPr>
-      <p:sp>
-        <p:nvSpPr>
-          <p:cNvPr id="3" name="Content Placeholder 2"/>
-          <p:cNvSpPr>
-            <a:spLocks noGrp="1"/>
-          </p:cNvSpPr>
-          <p:nvPr>
-            <p:ph idx="1" sz="half"/>
-          </p:nvPr>
-        </p:nvSpPr>
-        <p:spPr/>
-        <p:txBody>
-          <a:bodyPr/>
-          <a:lstStyle/>
-          <a:p>
-            <a:pPr lvl="0" indent="0">
-              <a:buNone/>
-            </a:pPr>
-            <a:r>
-              <a:rPr>
-                <a:latin typeface="Courier"/>
-              </a:rPr>
-              <a:t>- Optimized streaming ingestion of data;
-- Query optimization through filter-pushdown</a:t>
-            </a:r>
-          </a:p>
-        </p:txBody>
-      </p:sp>
-      <p:sp>
-        <p:nvSpPr>
-          <p:cNvPr id="4" name="Content Placeholder 3"/>
-          <p:cNvSpPr>
-            <a:spLocks noGrp="1"/>
-          </p:cNvSpPr>
-          <p:nvPr>
-            <p:ph idx="2" sz="half"/>
-          </p:nvPr>
-        </p:nvSpPr>
-        <p:spPr/>
-        <p:txBody>
-          <a:bodyPr/>
-          <a:lstStyle/>
-          <a:p>
-            <a:pPr lvl="0" indent="0">
-              <a:buNone/>
-            </a:pPr>
-            <a:r>
-              <a:rPr>
-                <a:latin typeface="Courier"/>
-              </a:rPr>
-              <a:t>- TS events as graph nodes:
-    - can also hold edges and properties
-    - materialized on graph at query time (saving storage).
-- Support for different temporal semantics 
-    - (e.g., continuous path (default), consecutive path) .</a:t>
-            </a:r>
-          </a:p>
-        </p:txBody>
-      </p:sp>
-    </p:spTree>
-  </p:cSld>
-</p:sld>
-</file>
-
-<file path=ppt/slides/slide12.xml><?xml version="1.0" encoding="utf-8"?>
-<p:sld xmlns:a="http://schemas.openxmlformats.org/drawingml/2006/main" xmlns:r="http://schemas.openxmlformats.org/officeDocument/2006/relationships" xmlns:p="http://schemas.openxmlformats.org/presentationml/2006/main">
-  <p:cSld>
-    <p:spTree>
-      <p:nvGrpSpPr>
-        <p:cNvPr id="1" name=""/>
-        <p:cNvGrpSpPr/>
-        <p:nvPr/>
-      </p:nvGrpSpPr>
-      <p:grpSpPr>
-        <a:xfrm>
-          <a:off x="0" y="0"/>
-          <a:ext cx="0" cy="0"/>
-          <a:chOff x="0" y="0"/>
-          <a:chExt cx="0" cy="0"/>
-        </a:xfrm>
-      </p:grpSpPr>
       <p:pic>
         <p:nvPicPr>
           <p:cNvPr descr="https://github.com/ManuelePasini/slides-markdown/blob/master/slides/images/phd3rdyear/datamodel.svg?raw=true" id="0" name="Picture 1"/>
@@ -3481,17 +3319,170 @@
             </a:pPr>
             <a:r>
               <a:rPr/>
-              <a:t>Characterizing Digital Twin data (</a:t>
-            </a:r>
+              <a:t>STGraph Data Model</a:t>
+            </a:r>
+          </a:p>
+        </p:txBody>
+      </p:sp>
+    </p:spTree>
+  </p:cSld>
+</p:sld>
+</file>
+
+<file path=ppt/slides/slide11.xml><?xml version="1.0" encoding="utf-8"?>
+<p:sld xmlns:a="http://schemas.openxmlformats.org/drawingml/2006/main" xmlns:r="http://schemas.openxmlformats.org/officeDocument/2006/relationships" xmlns:p="http://schemas.openxmlformats.org/presentationml/2006/main">
+  <p:cSld>
+    <p:spTree>
+      <p:nvGrpSpPr>
+        <p:cNvPr id="1" name=""/>
+        <p:cNvGrpSpPr/>
+        <p:nvPr/>
+      </p:nvGrpSpPr>
+      <p:grpSpPr>
+        <a:xfrm>
+          <a:off x="0" y="0"/>
+          <a:ext cx="0" cy="0"/>
+          <a:chOff x="0" y="0"/>
+          <a:chExt cx="0" cy="0"/>
+        </a:xfrm>
+      </p:grpSpPr>
+      <p:sp>
+        <p:nvSpPr>
+          <p:cNvPr id="2" name="Title 1"/>
+          <p:cNvSpPr>
+            <a:spLocks noGrp="1"/>
+          </p:cNvSpPr>
+          <p:nvPr>
+            <p:ph type="title"/>
+          </p:nvPr>
+        </p:nvSpPr>
+        <p:spPr/>
+        <p:txBody>
+          <a:bodyPr/>
+          <a:lstStyle/>
+          <a:p>
+            <a:pPr lvl="0" indent="0" marL="0">
+              <a:buNone/>
+            </a:pPr>
+            <a:r>
+              <a:rPr/>
+              <a:t>STGraph: A Multistore for Spatio-Temporal Property Graphs and Time-Series Data</a:t>
+            </a:r>
+          </a:p>
+        </p:txBody>
+      </p:sp>
+      <p:sp>
+        <p:nvSpPr>
+          <p:cNvPr id="3" name="Content Placeholder 2"/>
+          <p:cNvSpPr>
+            <a:spLocks noGrp="1"/>
+          </p:cNvSpPr>
+          <p:nvPr>
+            <p:ph idx="1"/>
+          </p:nvPr>
+        </p:nvSpPr>
+        <p:spPr/>
+        <p:txBody>
+          <a:bodyPr/>
+          <a:lstStyle/>
+          <a:p>
+            <a:pPr lvl="0" indent="0" marL="0">
+              <a:spcBef>
+                <a:spcPts val="3000"/>
+              </a:spcBef>
+              <a:buNone/>
+            </a:pPr>
+            <a:r>
+              <a:rPr b="1"/>
+              <a:t>Under review @ VLDB 2027</a:t>
+            </a:r>
+          </a:p>
+          <a:p>
+            <a:pPr lvl="0"/>
+            <a:r>
+              <a:rPr/>
+              <a:t>Key points:</a:t>
+            </a:r>
+          </a:p>
+        </p:txBody>
+      </p:sp>
+    </p:spTree>
+  </p:cSld>
+</p:sld>
+</file>
+
+<file path=ppt/slides/slide12.xml><?xml version="1.0" encoding="utf-8"?>
+<p:sld xmlns:a="http://schemas.openxmlformats.org/drawingml/2006/main" xmlns:r="http://schemas.openxmlformats.org/officeDocument/2006/relationships" xmlns:p="http://schemas.openxmlformats.org/presentationml/2006/main">
+  <p:cSld>
+    <p:spTree>
+      <p:nvGrpSpPr>
+        <p:cNvPr id="1" name=""/>
+        <p:cNvGrpSpPr/>
+        <p:nvPr/>
+      </p:nvGrpSpPr>
+      <p:grpSpPr>
+        <a:xfrm>
+          <a:off x="0" y="0"/>
+          <a:ext cx="0" cy="0"/>
+          <a:chOff x="0" y="0"/>
+          <a:chExt cx="0" cy="0"/>
+        </a:xfrm>
+      </p:grpSpPr>
+      <p:sp>
+        <p:nvSpPr>
+          <p:cNvPr id="3" name="Content Placeholder 2"/>
+          <p:cNvSpPr>
+            <a:spLocks noGrp="1"/>
+          </p:cNvSpPr>
+          <p:nvPr>
+            <p:ph idx="1" sz="half"/>
+          </p:nvPr>
+        </p:nvSpPr>
+        <p:spPr/>
+        <p:txBody>
+          <a:bodyPr/>
+          <a:lstStyle/>
+          <a:p>
+            <a:pPr lvl="0" indent="0">
+              <a:buNone/>
+            </a:pPr>
             <a:r>
               <a:rPr>
-                <a:hlinkClick r:id="rId3"/>
+                <a:latin typeface="Courier"/>
               </a:rPr>
-              <a:t>Fei, Tao 2023</a:t>
-            </a:r>
-            <a:r>
-              <a:rPr/>
-              <a:t>)</a:t>
+              <a:t>- Optimized streaming ingestion of data;
+- Query optimization through filter-pushdown</a:t>
+            </a:r>
+          </a:p>
+        </p:txBody>
+      </p:sp>
+      <p:sp>
+        <p:nvSpPr>
+          <p:cNvPr id="4" name="Content Placeholder 3"/>
+          <p:cNvSpPr>
+            <a:spLocks noGrp="1"/>
+          </p:cNvSpPr>
+          <p:nvPr>
+            <p:ph idx="2" sz="half"/>
+          </p:nvPr>
+        </p:nvSpPr>
+        <p:spPr/>
+        <p:txBody>
+          <a:bodyPr/>
+          <a:lstStyle/>
+          <a:p>
+            <a:pPr lvl="0" indent="0">
+              <a:buNone/>
+            </a:pPr>
+            <a:r>
+              <a:rPr>
+                <a:latin typeface="Courier"/>
+              </a:rPr>
+              <a:t>- TS events as graph nodes:
+    - can also hold edges and properties
+    - materialized on graph at query time (saving storage).
+- Support for different temporal semantics 
+    - (e.g., continuous path (default), consecutive path) .</a:t>
             </a:r>
           </a:p>
         </p:txBody>
@@ -3518,27 +3509,62 @@
           <a:chExt cx="0" cy="0"/>
         </a:xfrm>
       </p:grpSpPr>
-      <p:sp>
-        <p:nvSpPr>
-          <p:cNvPr id="2" name="Title 1"/>
-          <p:cNvSpPr>
-            <a:spLocks noGrp="1"/>
-          </p:cNvSpPr>
-          <p:nvPr>
-            <p:ph type="title"/>
-          </p:nvPr>
-        </p:nvSpPr>
-        <p:spPr/>
-        <p:txBody>
-          <a:bodyPr/>
-          <a:lstStyle/>
-          <a:p>
-            <a:pPr lvl="0" indent="0" marL="0">
+      <p:pic>
+        <p:nvPicPr>
+          <p:cNvPr descr="https://github.com/ManuelePasini/slides-markdown/blob/master/slides/images/phd3rdyear/example.svg?raw=true" id="0" name="Picture 1"/>
+          <p:cNvPicPr>
+            <a:picLocks noGrp="1" noChangeAspect="1"/>
+          </p:cNvPicPr>
+          <p:nvPr/>
+        </p:nvPicPr>
+        <p:blipFill>
+          <a:blip r:embed="rId2"/>
+          <a:stretch>
+            <a:fillRect/>
+          </a:stretch>
+        </p:blipFill>
+        <p:spPr bwMode="auto">
+          <a:xfrm>
+            <a:off x="2413000" y="1193800"/>
+            <a:ext cx="4318000" cy="2882900"/>
+          </a:xfrm>
+          <a:prstGeom prst="rect">
+            <a:avLst/>
+          </a:prstGeom>
+          <a:noFill/>
+          <a:ln w="9525">
+            <a:noFill/>
+            <a:headEnd/>
+            <a:tailEnd/>
+          </a:ln>
+        </p:spPr>
+      </p:pic>
+      <p:sp>
+        <p:nvSpPr>
+          <p:cNvPr id="1" name="TextBox 3"/>
+          <p:cNvSpPr txBox="1"/>
+          <p:nvPr/>
+        </p:nvSpPr>
+        <p:spPr>
+          <a:xfrm>
+            <a:off x="457200" y="4076700"/>
+            <a:ext cx="8229600" cy="508000"/>
+          </a:xfrm>
+          <a:prstGeom prst="rect">
+            <a:avLst/>
+          </a:prstGeom>
+          <a:noFill/>
+        </p:spPr>
+        <p:txBody>
+          <a:bodyPr/>
+          <a:lstStyle/>
+          <a:p>
+            <a:pPr lvl="0" indent="0" marL="0" algn="ctr">
               <a:buNone/>
             </a:pPr>
             <a:r>
               <a:rPr/>
-              <a:t>Anomaly Detection in Complex Sensor Networks</a:t>
+              <a:t>Querying STGraph</a:t>
             </a:r>
           </a:p>
         </p:txBody>
@@ -3549,6 +3575,53 @@
 </file>
 
 <file path=ppt/slides/slide14.xml><?xml version="1.0" encoding="utf-8"?>
+<p:sld xmlns:a="http://schemas.openxmlformats.org/drawingml/2006/main" xmlns:r="http://schemas.openxmlformats.org/officeDocument/2006/relationships" xmlns:p="http://schemas.openxmlformats.org/presentationml/2006/main">
+  <p:cSld>
+    <p:spTree>
+      <p:nvGrpSpPr>
+        <p:cNvPr id="1" name=""/>
+        <p:cNvGrpSpPr/>
+        <p:nvPr/>
+      </p:nvGrpSpPr>
+      <p:grpSpPr>
+        <a:xfrm>
+          <a:off x="0" y="0"/>
+          <a:ext cx="0" cy="0"/>
+          <a:chOff x="0" y="0"/>
+          <a:chExt cx="0" cy="0"/>
+        </a:xfrm>
+      </p:grpSpPr>
+      <p:sp>
+        <p:nvSpPr>
+          <p:cNvPr id="2" name="Title 1"/>
+          <p:cNvSpPr>
+            <a:spLocks noGrp="1"/>
+          </p:cNvSpPr>
+          <p:nvPr>
+            <p:ph type="title"/>
+          </p:nvPr>
+        </p:nvSpPr>
+        <p:spPr/>
+        <p:txBody>
+          <a:bodyPr/>
+          <a:lstStyle/>
+          <a:p>
+            <a:pPr lvl="0" indent="0" marL="0">
+              <a:buNone/>
+            </a:pPr>
+            <a:r>
+              <a:rPr/>
+              <a:t>Anomaly Detection in Complex Sensor Networks</a:t>
+            </a:r>
+          </a:p>
+        </p:txBody>
+      </p:sp>
+    </p:spTree>
+  </p:cSld>
+</p:sld>
+</file>
+
+<file path=ppt/slides/slide15.xml><?xml version="1.0" encoding="utf-8"?>
 <p:sld xmlns:a="http://schemas.openxmlformats.org/drawingml/2006/main" xmlns:r="http://schemas.openxmlformats.org/officeDocument/2006/relationships" xmlns:p="http://schemas.openxmlformats.org/presentationml/2006/main">
   <p:cSld>
     <p:spTree>
@@ -4615,17 +4688,7 @@
             </a:pPr>
             <a:r>
               <a:rPr/>
-              <a:t>Characterizing Digital Twin data (</a:t>
-            </a:r>
-            <a:r>
-              <a:rPr>
-                <a:hlinkClick r:id="rId3"/>
-              </a:rPr>
-              <a:t>Fei, Tao 2023</a:t>
-            </a:r>
-            <a:r>
-              <a:rPr/>
-              <a:t>)</a:t>
+              <a:t>STGraph System Architecture</a:t>
             </a:r>
           </a:p>
         </p:txBody>

</xml_diff>

<commit_message>
Deploying to gh-pages from @ ManuelePasini/slides-markdown@0c8466c159cd58831e41adb5d393b8fdc52343b9 🚀
</commit_message>
<xml_diff>
--- a/3rd_year_slides.pptx
+++ b/3rd_year_slides.pptx
@@ -3366,7 +3366,7 @@
             </a:pPr>
             <a:r>
               <a:rPr/>
-              <a:t>STGraph: A Multistore for Spatio-Temporal Property Graphs and Time-Series Data</a:t>
+              <a:t>STGraph: A Multistore for Temporal Property Graphs and Time-Series Data</a:t>
             </a:r>
           </a:p>
         </p:txBody>
@@ -3395,13 +3395,6 @@
             <a:r>
               <a:rPr b="1"/>
               <a:t>Under review @ VLDB 2027</a:t>
-            </a:r>
-          </a:p>
-          <a:p>
-            <a:pPr lvl="0"/>
-            <a:r>
-              <a:rPr/>
-              <a:t>Key points:</a:t>
             </a:r>
           </a:p>
         </p:txBody>
@@ -3443,15 +3436,24 @@
           <a:bodyPr/>
           <a:lstStyle/>
           <a:p>
-            <a:pPr lvl="0" indent="0">
-              <a:buNone/>
-            </a:pPr>
-            <a:r>
-              <a:rPr>
-                <a:latin typeface="Courier"/>
-              </a:rPr>
-              <a:t>- Optimized streaming ingestion of data;
-- Query optimization through filter-pushdown</a:t>
+            <a:pPr lvl="0"/>
+            <a:r>
+              <a:rPr/>
+              <a:t>Key points:</a:t>
+            </a:r>
+          </a:p>
+          <a:p>
+            <a:pPr lvl="1"/>
+            <a:r>
+              <a:rPr/>
+              <a:t>Optimized streaming ingestion of data;</a:t>
+            </a:r>
+          </a:p>
+          <a:p>
+            <a:pPr lvl="1"/>
+            <a:r>
+              <a:rPr/>
+              <a:t>Query optimization through filter-pushdown</a:t>
             </a:r>
           </a:p>
         </p:txBody>

</xml_diff>

<commit_message>
Deploying to gh-pages from @ ManuelePasini/slides-markdown@05b3bf19a07d7ab6d6c8eacbd2d3d3377c453dfd 🚀
</commit_message>
<xml_diff>
--- a/3rd_year_slides.pptx
+++ b/3rd_year_slides.pptx
@@ -18,8 +18,6 @@
     <p:sldId id="266" r:id="rId12"/>
     <p:sldId id="267" r:id="rId13"/>
     <p:sldId id="268" r:id="rId14"/>
-    <p:sldId id="269" r:id="rId15"/>
-    <p:sldId id="270" r:id="rId16"/>
   </p:sldIdLst>
   <p:sldSz cx="9144000" cy="5143500" type="screen16x9"/>
   <p:notesSz cx="6858000" cy="9144000"/>
@@ -3264,163 +3262,31 @@
           <a:chExt cx="0" cy="0"/>
         </a:xfrm>
       </p:grpSpPr>
-      <p:pic>
-        <p:nvPicPr>
-          <p:cNvPr descr="https://github.com/ManuelePasini/slides-markdown/blob/master/slides/images/phd3rdyear/datamodel.svg?raw=true" id="0" name="Picture 1"/>
-          <p:cNvPicPr>
-            <a:picLocks noGrp="1" noChangeAspect="1"/>
-          </p:cNvPicPr>
-          <p:nvPr/>
-        </p:nvPicPr>
-        <p:blipFill>
-          <a:blip r:embed="rId2"/>
-          <a:stretch>
-            <a:fillRect/>
-          </a:stretch>
-        </p:blipFill>
-        <p:spPr bwMode="auto">
-          <a:xfrm>
-            <a:off x="2413000" y="1193800"/>
-            <a:ext cx="4318000" cy="2882900"/>
-          </a:xfrm>
-          <a:prstGeom prst="rect">
-            <a:avLst/>
-          </a:prstGeom>
-          <a:noFill/>
-          <a:ln w="9525">
-            <a:noFill/>
-            <a:headEnd/>
-            <a:tailEnd/>
-          </a:ln>
-        </p:spPr>
-      </p:pic>
-      <p:sp>
-        <p:nvSpPr>
-          <p:cNvPr id="1" name="TextBox 3"/>
-          <p:cNvSpPr txBox="1"/>
-          <p:nvPr/>
-        </p:nvSpPr>
-        <p:spPr>
-          <a:xfrm>
-            <a:off x="457200" y="4076700"/>
-            <a:ext cx="8229600" cy="508000"/>
-          </a:xfrm>
-          <a:prstGeom prst="rect">
-            <a:avLst/>
-          </a:prstGeom>
-          <a:noFill/>
-        </p:spPr>
-        <p:txBody>
-          <a:bodyPr/>
-          <a:lstStyle/>
-          <a:p>
-            <a:pPr lvl="0" indent="0" marL="0" algn="ctr">
+      <p:sp>
+        <p:nvSpPr>
+          <p:cNvPr id="2" name="Title 1"/>
+          <p:cNvSpPr>
+            <a:spLocks noGrp="1"/>
+          </p:cNvSpPr>
+          <p:nvPr>
+            <p:ph type="title"/>
+          </p:nvPr>
+        </p:nvSpPr>
+        <p:spPr/>
+        <p:txBody>
+          <a:bodyPr/>
+          <a:lstStyle/>
+          <a:p>
+            <a:pPr lvl="0" indent="0" marL="0">
               <a:buNone/>
             </a:pPr>
             <a:r>
               <a:rPr/>
-              <a:t>STGraph Data Model</a:t>
-            </a:r>
-          </a:p>
-        </p:txBody>
-      </p:sp>
-    </p:spTree>
-  </p:cSld>
-</p:sld>
-</file>
-
-<file path=ppt/slides/slide11.xml><?xml version="1.0" encoding="utf-8"?>
-<p:sld xmlns:a="http://schemas.openxmlformats.org/drawingml/2006/main" xmlns:r="http://schemas.openxmlformats.org/officeDocument/2006/relationships" xmlns:p="http://schemas.openxmlformats.org/presentationml/2006/main">
-  <p:cSld>
-    <p:spTree>
-      <p:nvGrpSpPr>
-        <p:cNvPr id="1" name=""/>
-        <p:cNvGrpSpPr/>
-        <p:nvPr/>
-      </p:nvGrpSpPr>
-      <p:grpSpPr>
-        <a:xfrm>
-          <a:off x="0" y="0"/>
-          <a:ext cx="0" cy="0"/>
-          <a:chOff x="0" y="0"/>
-          <a:chExt cx="0" cy="0"/>
-        </a:xfrm>
-      </p:grpSpPr>
-      <p:sp>
-        <p:nvSpPr>
-          <p:cNvPr id="2" name="Title 1"/>
-          <p:cNvSpPr>
-            <a:spLocks noGrp="1"/>
-          </p:cNvSpPr>
-          <p:nvPr>
-            <p:ph type="title"/>
-          </p:nvPr>
-        </p:nvSpPr>
-        <p:spPr/>
-        <p:txBody>
-          <a:bodyPr/>
-          <a:lstStyle/>
-          <a:p>
-            <a:pPr lvl="0" indent="0" marL="0">
-              <a:buNone/>
-            </a:pPr>
-            <a:r>
-              <a:rPr/>
               <a:t>STGraph: A Multistore for Temporal Property Graphs and Time-Series Data</a:t>
             </a:r>
           </a:p>
         </p:txBody>
       </p:sp>
-      <p:sp>
-        <p:nvSpPr>
-          <p:cNvPr id="3" name="Content Placeholder 2"/>
-          <p:cNvSpPr>
-            <a:spLocks noGrp="1"/>
-          </p:cNvSpPr>
-          <p:nvPr>
-            <p:ph idx="1"/>
-          </p:nvPr>
-        </p:nvSpPr>
-        <p:spPr/>
-        <p:txBody>
-          <a:bodyPr/>
-          <a:lstStyle/>
-          <a:p>
-            <a:pPr lvl="0" indent="0" marL="0">
-              <a:spcBef>
-                <a:spcPts val="3000"/>
-              </a:spcBef>
-              <a:buNone/>
-            </a:pPr>
-            <a:r>
-              <a:rPr b="1"/>
-              <a:t>Under review @ VLDB 2027</a:t>
-            </a:r>
-          </a:p>
-        </p:txBody>
-      </p:sp>
-    </p:spTree>
-  </p:cSld>
-</p:sld>
-</file>
-
-<file path=ppt/slides/slide12.xml><?xml version="1.0" encoding="utf-8"?>
-<p:sld xmlns:a="http://schemas.openxmlformats.org/drawingml/2006/main" xmlns:r="http://schemas.openxmlformats.org/officeDocument/2006/relationships" xmlns:p="http://schemas.openxmlformats.org/presentationml/2006/main">
-  <p:cSld>
-    <p:spTree>
-      <p:nvGrpSpPr>
-        <p:cNvPr id="1" name=""/>
-        <p:cNvGrpSpPr/>
-        <p:nvPr/>
-      </p:nvGrpSpPr>
-      <p:grpSpPr>
-        <a:xfrm>
-          <a:off x="0" y="0"/>
-          <a:ext cx="0" cy="0"/>
-          <a:chOff x="0" y="0"/>
-          <a:chExt cx="0" cy="0"/>
-        </a:xfrm>
-      </p:grpSpPr>
       <p:sp>
         <p:nvSpPr>
           <p:cNvPr id="3" name="Content Placeholder 2"/>
@@ -3494,7 +3360,7 @@
 </p:sld>
 </file>
 
-<file path=ppt/slides/slide13.xml><?xml version="1.0" encoding="utf-8"?>
+<file path=ppt/slides/slide11.xml><?xml version="1.0" encoding="utf-8"?>
 <p:sld xmlns:a="http://schemas.openxmlformats.org/drawingml/2006/main" xmlns:r="http://schemas.openxmlformats.org/officeDocument/2006/relationships" xmlns:p="http://schemas.openxmlformats.org/presentationml/2006/main">
   <p:cSld>
     <p:spTree>
@@ -3576,7 +3442,7 @@
 </p:sld>
 </file>
 
-<file path=ppt/slides/slide14.xml><?xml version="1.0" encoding="utf-8"?>
+<file path=ppt/slides/slide12.xml><?xml version="1.0" encoding="utf-8"?>
 <p:sld xmlns:a="http://schemas.openxmlformats.org/drawingml/2006/main" xmlns:r="http://schemas.openxmlformats.org/officeDocument/2006/relationships" xmlns:p="http://schemas.openxmlformats.org/presentationml/2006/main">
   <p:cSld>
     <p:spTree>
@@ -3623,7 +3489,7 @@
 </p:sld>
 </file>
 
-<file path=ppt/slides/slide15.xml><?xml version="1.0" encoding="utf-8"?>
+<file path=ppt/slides/slide13.xml><?xml version="1.0" encoding="utf-8"?>
 <p:sld xmlns:a="http://schemas.openxmlformats.org/drawingml/2006/main" xmlns:r="http://schemas.openxmlformats.org/officeDocument/2006/relationships" xmlns:p="http://schemas.openxmlformats.org/presentationml/2006/main">
   <p:cSld>
     <p:spTree>
@@ -4529,7 +4395,7 @@
             </a:pPr>
             <a:r>
               <a:rPr/>
-              <a:t>STGraph: A Multistore for Spatio-Temporal Property Graphs and Time-Series Data</a:t>
+              <a:t>STGraph: A Multistore for Spatio-Temporal Property Graphs and Time-Series Data . Under review @ VLDB 2027</a:t>
             </a:r>
           </a:p>
         </p:txBody>
@@ -4541,56 +4407,6 @@
             <a:spLocks noGrp="1"/>
           </p:cNvSpPr>
           <p:nvPr>
-            <p:ph idx="1"/>
-          </p:nvPr>
-        </p:nvSpPr>
-        <p:spPr/>
-        <p:txBody>
-          <a:bodyPr/>
-          <a:lstStyle/>
-          <a:p>
-            <a:pPr lvl="0" indent="0" marL="0">
-              <a:spcBef>
-                <a:spcPts val="3000"/>
-              </a:spcBef>
-              <a:buNone/>
-            </a:pPr>
-            <a:r>
-              <a:rPr b="1"/>
-              <a:t>Under review @ VLDB 2027</a:t>
-            </a:r>
-          </a:p>
-        </p:txBody>
-      </p:sp>
-    </p:spTree>
-  </p:cSld>
-</p:sld>
-</file>
-
-<file path=ppt/slides/slide9.xml><?xml version="1.0" encoding="utf-8"?>
-<p:sld xmlns:a="http://schemas.openxmlformats.org/drawingml/2006/main" xmlns:r="http://schemas.openxmlformats.org/officeDocument/2006/relationships" xmlns:p="http://schemas.openxmlformats.org/presentationml/2006/main">
-  <p:cSld>
-    <p:spTree>
-      <p:nvGrpSpPr>
-        <p:cNvPr id="1" name=""/>
-        <p:cNvGrpSpPr/>
-        <p:nvPr/>
-      </p:nvGrpSpPr>
-      <p:grpSpPr>
-        <a:xfrm>
-          <a:off x="0" y="0"/>
-          <a:ext cx="0" cy="0"/>
-          <a:chOff x="0" y="0"/>
-          <a:chExt cx="0" cy="0"/>
-        </a:xfrm>
-      </p:grpSpPr>
-      <p:sp>
-        <p:nvSpPr>
-          <p:cNvPr id="3" name="Content Placeholder 2"/>
-          <p:cNvSpPr>
-            <a:spLocks noGrp="1"/>
-          </p:cNvSpPr>
-          <p:nvPr>
             <p:ph idx="1" sz="half"/>
           </p:nvPr>
         </p:nvSpPr>
@@ -4609,7 +4425,7 @@
             <a:pPr lvl="1"/>
             <a:r>
               <a:rPr/>
-              <a:t>Unified graph conceptual model on top of heterogeneous storage</a:t>
+              <a:t>Graph data model on top of heterogeneous storage</a:t>
             </a:r>
           </a:p>
           <a:p>
@@ -4691,6 +4507,88 @@
             <a:r>
               <a:rPr/>
               <a:t>STGraph System Architecture</a:t>
+            </a:r>
+          </a:p>
+        </p:txBody>
+      </p:sp>
+    </p:spTree>
+  </p:cSld>
+</p:sld>
+</file>
+
+<file path=ppt/slides/slide9.xml><?xml version="1.0" encoding="utf-8"?>
+<p:sld xmlns:a="http://schemas.openxmlformats.org/drawingml/2006/main" xmlns:r="http://schemas.openxmlformats.org/officeDocument/2006/relationships" xmlns:p="http://schemas.openxmlformats.org/presentationml/2006/main">
+  <p:cSld>
+    <p:spTree>
+      <p:nvGrpSpPr>
+        <p:cNvPr id="1" name=""/>
+        <p:cNvGrpSpPr/>
+        <p:nvPr/>
+      </p:nvGrpSpPr>
+      <p:grpSpPr>
+        <a:xfrm>
+          <a:off x="0" y="0"/>
+          <a:ext cx="0" cy="0"/>
+          <a:chOff x="0" y="0"/>
+          <a:chExt cx="0" cy="0"/>
+        </a:xfrm>
+      </p:grpSpPr>
+      <p:pic>
+        <p:nvPicPr>
+          <p:cNvPr descr="https://github.com/ManuelePasini/slides-markdown/blob/master/slides/images/phd3rdyear/datamodel.svg?raw=true" id="0" name="Picture 1"/>
+          <p:cNvPicPr>
+            <a:picLocks noGrp="1" noChangeAspect="1"/>
+          </p:cNvPicPr>
+          <p:nvPr/>
+        </p:nvPicPr>
+        <p:blipFill>
+          <a:blip r:embed="rId2"/>
+          <a:stretch>
+            <a:fillRect/>
+          </a:stretch>
+        </p:blipFill>
+        <p:spPr bwMode="auto">
+          <a:xfrm>
+            <a:off x="2413000" y="1193800"/>
+            <a:ext cx="4318000" cy="2882900"/>
+          </a:xfrm>
+          <a:prstGeom prst="rect">
+            <a:avLst/>
+          </a:prstGeom>
+          <a:noFill/>
+          <a:ln w="9525">
+            <a:noFill/>
+            <a:headEnd/>
+            <a:tailEnd/>
+          </a:ln>
+        </p:spPr>
+      </p:pic>
+      <p:sp>
+        <p:nvSpPr>
+          <p:cNvPr id="1" name="TextBox 3"/>
+          <p:cNvSpPr txBox="1"/>
+          <p:nvPr/>
+        </p:nvSpPr>
+        <p:spPr>
+          <a:xfrm>
+            <a:off x="457200" y="4076700"/>
+            <a:ext cx="8229600" cy="508000"/>
+          </a:xfrm>
+          <a:prstGeom prst="rect">
+            <a:avLst/>
+          </a:prstGeom>
+          <a:noFill/>
+        </p:spPr>
+        <p:txBody>
+          <a:bodyPr/>
+          <a:lstStyle/>
+          <a:p>
+            <a:pPr lvl="0" indent="0" marL="0" algn="ctr">
+              <a:buNone/>
+            </a:pPr>
+            <a:r>
+              <a:rPr/>
+              <a:t>STGraph Data Model</a:t>
             </a:r>
           </a:p>
         </p:txBody>

</xml_diff>

<commit_message>
Deploying to gh-pages from @ ManuelePasini/slides-markdown@429c0c268b6d5cdc4f13ed59ad07ad305647551c 🚀
</commit_message>
<xml_diff>
--- a/3rd_year_slides.pptx
+++ b/3rd_year_slides.pptx
@@ -3282,7 +3282,7 @@
             </a:pPr>
             <a:r>
               <a:rPr/>
-              <a:t>STGraph: A Multistore for Temporal Property Graphs and Time-Series Data</a:t>
+              <a:t>STGraph: A Multistore for Spatio-Temporal Property Graphs and Time-Series Data</a:t>
             </a:r>
           </a:p>
         </p:txBody>
@@ -3305,52 +3305,72 @@
             <a:pPr lvl="0"/>
             <a:r>
               <a:rPr/>
-              <a:t>Key points:</a:t>
+              <a:t> Graph data model </a:t>
             </a:r>
           </a:p>
           <a:p>
             <a:pPr lvl="1"/>
             <a:r>
               <a:rPr/>
-              <a:t>Optimized streaming ingestion of data;</a:t>
+              <a:t>TS events as graph nodes:</a:t>
+            </a:r>
+          </a:p>
+          <a:p>
+            <a:pPr lvl="2"/>
+            <a:r>
+              <a:rPr/>
+              <a:t>can also hold edges and properties</a:t>
+            </a:r>
+          </a:p>
+          <a:p>
+            <a:pPr lvl="2"/>
+            <a:r>
+              <a:rPr/>
+              <a:t>materialized on graph at query time (saving storage).</a:t>
+            </a:r>
+          </a:p>
+        </p:txBody>
+      </p:sp>
+      <p:sp>
+        <p:nvSpPr>
+          <p:cNvPr id="4" name="Content Placeholder 3"/>
+          <p:cNvSpPr>
+            <a:spLocks noGrp="1"/>
+          </p:cNvSpPr>
+          <p:nvPr>
+            <p:ph idx="2" sz="half"/>
+          </p:nvPr>
+        </p:nvSpPr>
+        <p:spPr/>
+        <p:txBody>
+          <a:bodyPr/>
+          <a:lstStyle/>
+          <a:p>
+            <a:pPr lvl="0"/>
+            <a:r>
+              <a:rPr/>
+              <a:t>Hybrid storage:</a:t>
             </a:r>
           </a:p>
           <a:p>
             <a:pPr lvl="1"/>
             <a:r>
               <a:rPr/>
+              <a:t>Dedicated Time-Series streaming ingestion of data;</a:t>
+            </a:r>
+          </a:p>
+          <a:p>
+            <a:pPr lvl="1"/>
+            <a:r>
+              <a:rPr/>
               <a:t>Query optimization through filter-pushdown</a:t>
             </a:r>
           </a:p>
-        </p:txBody>
-      </p:sp>
-      <p:sp>
-        <p:nvSpPr>
-          <p:cNvPr id="4" name="Content Placeholder 3"/>
-          <p:cNvSpPr>
-            <a:spLocks noGrp="1"/>
-          </p:cNvSpPr>
-          <p:nvPr>
-            <p:ph idx="2" sz="half"/>
-          </p:nvPr>
-        </p:nvSpPr>
-        <p:spPr/>
-        <p:txBody>
-          <a:bodyPr/>
-          <a:lstStyle/>
-          <a:p>
-            <a:pPr lvl="0" indent="0">
-              <a:buNone/>
-            </a:pPr>
-            <a:r>
-              <a:rPr>
-                <a:latin typeface="Courier"/>
-              </a:rPr>
-              <a:t>- TS events as graph nodes:
-    - can also hold edges and properties
-    - materialized on graph at query time (saving storage).
-- Support for different temporal semantics 
-    - (e.g., continuous path (default), consecutive path) .</a:t>
+          <a:p>
+            <a:pPr lvl="1"/>
+            <a:r>
+              <a:rPr/>
+              <a:t>Efficient graph traversal &amp; temporal reasoning</a:t>
             </a:r>
           </a:p>
         </p:txBody>
@@ -3480,6 +3500,36 @@
             <a:r>
               <a:rPr/>
               <a:t>Anomaly Detection in Complex Sensor Networks</a:t>
+            </a:r>
+          </a:p>
+        </p:txBody>
+      </p:sp>
+      <p:sp>
+        <p:nvSpPr>
+          <p:cNvPr id="3" name="Content Placeholder 2"/>
+          <p:cNvSpPr>
+            <a:spLocks noGrp="1"/>
+          </p:cNvSpPr>
+          <p:nvPr>
+            <p:ph idx="1"/>
+          </p:nvPr>
+        </p:nvSpPr>
+        <p:spPr/>
+        <p:txBody>
+          <a:bodyPr/>
+          <a:lstStyle/>
+          <a:p>
+            <a:pPr lvl="0"/>
+            <a:r>
+              <a:rPr/>
+              <a:t>Complex sensor networks are increasingly common</a:t>
+            </a:r>
+          </a:p>
+          <a:p>
+            <a:pPr lvl="0"/>
+            <a:r>
+              <a:rPr/>
+              <a:t>Anomaly detection in time-series data is a well-known research field</a:t>
             </a:r>
           </a:p>
         </p:txBody>

</xml_diff>

<commit_message>
Deploying to gh-pages from @ ManuelePasini/slides-markdown@1b55f94e4b627d6496c0886d8ed6a830008eaea4 🚀
</commit_message>
<xml_diff>
--- a/3rd_year_slides.pptx
+++ b/3rd_year_slides.pptx
@@ -3305,58 +3305,37 @@
             <a:pPr lvl="0"/>
             <a:r>
               <a:rPr/>
-              <a:t> Graph data model </a:t>
+              <a:t>Property Graph data model: - TS events (nodes) can hold edges and properties - edges built at query time</a:t>
+            </a:r>
+          </a:p>
+        </p:txBody>
+      </p:sp>
+      <p:sp>
+        <p:nvSpPr>
+          <p:cNvPr id="4" name="Content Placeholder 3"/>
+          <p:cNvSpPr>
+            <a:spLocks noGrp="1"/>
+          </p:cNvSpPr>
+          <p:nvPr>
+            <p:ph idx="2" sz="half"/>
+          </p:nvPr>
+        </p:nvSpPr>
+        <p:spPr/>
+        <p:txBody>
+          <a:bodyPr/>
+          <a:lstStyle/>
+          <a:p>
+            <a:pPr lvl="0"/>
+            <a:r>
+              <a:rPr/>
+              <a:t>Hybrid storage:</a:t>
             </a:r>
           </a:p>
           <a:p>
             <a:pPr lvl="1"/>
             <a:r>
               <a:rPr/>
-              <a:t>TS events as graph nodes:</a:t>
-            </a:r>
-          </a:p>
-          <a:p>
-            <a:pPr lvl="2"/>
-            <a:r>
-              <a:rPr/>
-              <a:t>can also hold edges and properties</a:t>
-            </a:r>
-          </a:p>
-          <a:p>
-            <a:pPr lvl="2"/>
-            <a:r>
-              <a:rPr/>
-              <a:t>materialized on graph at query time (saving storage).</a:t>
-            </a:r>
-          </a:p>
-        </p:txBody>
-      </p:sp>
-      <p:sp>
-        <p:nvSpPr>
-          <p:cNvPr id="4" name="Content Placeholder 3"/>
-          <p:cNvSpPr>
-            <a:spLocks noGrp="1"/>
-          </p:cNvSpPr>
-          <p:nvPr>
-            <p:ph idx="2" sz="half"/>
-          </p:nvPr>
-        </p:nvSpPr>
-        <p:spPr/>
-        <p:txBody>
-          <a:bodyPr/>
-          <a:lstStyle/>
-          <a:p>
-            <a:pPr lvl="0"/>
-            <a:r>
-              <a:rPr/>
-              <a:t>Hybrid storage:</a:t>
-            </a:r>
-          </a:p>
-          <a:p>
-            <a:pPr lvl="1"/>
-            <a:r>
-              <a:rPr/>
-              <a:t>Dedicated Time-Series streaming ingestion of data;</a:t>
+              <a:t>Dedicated Time-Series streaming ingestion of data</a:t>
             </a:r>
           </a:p>
           <a:p>
@@ -3530,6 +3509,73 @@
             <a:r>
               <a:rPr/>
               <a:t>Anomaly detection in time-series data is a well-known research field</a:t>
+            </a:r>
+          </a:p>
+          <a:p>
+            <a:pPr lvl="0"/>
+            <a:r>
+              <a:rPr/>
+              <a:t>**What about anomalies that are cross-time series?*</a:t>
+            </a:r>
+          </a:p>
+        </p:txBody>
+      </p:sp>
+      <p:pic>
+        <p:nvPicPr>
+          <p:cNvPr descr="https://github.com/ManuelePasini/slides-markdown/blob/master/slides/images/phd3rdyear/n2g_example.svg?raw=true" id="0" name="Picture 1"/>
+          <p:cNvPicPr>
+            <a:picLocks noGrp="1" noChangeAspect="1"/>
+          </p:cNvPicPr>
+          <p:nvPr/>
+        </p:nvPicPr>
+        <p:blipFill>
+          <a:blip r:embed="rId2"/>
+          <a:stretch>
+            <a:fillRect/>
+          </a:stretch>
+        </p:blipFill>
+        <p:spPr bwMode="auto">
+          <a:xfrm>
+            <a:off x="2413000" y="1193800"/>
+            <a:ext cx="4318000" cy="2882900"/>
+          </a:xfrm>
+          <a:prstGeom prst="rect">
+            <a:avLst/>
+          </a:prstGeom>
+          <a:noFill/>
+          <a:ln w="9525">
+            <a:noFill/>
+            <a:headEnd/>
+            <a:tailEnd/>
+          </a:ln>
+        </p:spPr>
+      </p:pic>
+      <p:sp>
+        <p:nvSpPr>
+          <p:cNvPr id="1" name="TextBox 3"/>
+          <p:cNvSpPr txBox="1"/>
+          <p:nvPr/>
+        </p:nvSpPr>
+        <p:spPr>
+          <a:xfrm>
+            <a:off x="457200" y="4076700"/>
+            <a:ext cx="8229600" cy="508000"/>
+          </a:xfrm>
+          <a:prstGeom prst="rect">
+            <a:avLst/>
+          </a:prstGeom>
+          <a:noFill/>
+        </p:spPr>
+        <p:txBody>
+          <a:bodyPr/>
+          <a:lstStyle/>
+          <a:p>
+            <a:pPr lvl="0" indent="0" marL="0" algn="ctr">
+              <a:buNone/>
+            </a:pPr>
+            <a:r>
+              <a:rPr/>
+              <a:t>An example of cross-time series anomaly</a:t>
             </a:r>
           </a:p>
         </p:txBody>

</xml_diff>

<commit_message>
Deploying to gh-pages from @ ManuelePasini/slides-markdown@0e185eecbe7c4b86bc6d5b3adad5e029772c6989 🚀
</commit_message>
<xml_diff>
--- a/3rd_year_slides.pptx
+++ b/3rd_year_slides.pptx
@@ -3305,7 +3305,21 @@
             <a:pPr lvl="0"/>
             <a:r>
               <a:rPr/>
-              <a:t>Property Graph data model: - TS events (nodes) can hold edges and properties - edges built at query time</a:t>
+              <a:t>Property Graph data model:</a:t>
+            </a:r>
+          </a:p>
+          <a:p>
+            <a:pPr lvl="1"/>
+            <a:r>
+              <a:rPr/>
+              <a:t>TS events (nodes) can hold edges and properties</a:t>
+            </a:r>
+          </a:p>
+          <a:p>
+            <a:pPr lvl="1"/>
+            <a:r>
+              <a:rPr/>
+              <a:t>edges built at query time</a:t>
             </a:r>
           </a:p>
         </p:txBody>

</xml_diff>

<commit_message>
Deploying to gh-pages from @ ManuelePasini/slides-markdown@de89055da4aa0fa0f6f88319eaba9ca071257a1f 🚀
</commit_message>
<xml_diff>
--- a/3rd_year_slides.pptx
+++ b/3rd_year_slides.pptx
@@ -18,6 +18,7 @@
     <p:sldId id="266" r:id="rId12"/>
     <p:sldId id="267" r:id="rId13"/>
     <p:sldId id="268" r:id="rId14"/>
+    <p:sldId id="269" r:id="rId15"/>
   </p:sldIdLst>
   <p:sldSz cx="9144000" cy="5143500" type="screen16x9"/>
   <p:notesSz cx="6858000" cy="9144000"/>
@@ -3528,15 +3529,37 @@
           <a:p>
             <a:pPr lvl="0"/>
             <a:r>
-              <a:rPr/>
-              <a:t>**What about anomalies that are cross-time series?*</a:t>
-            </a:r>
-          </a:p>
-        </p:txBody>
-      </p:sp>
+              <a:rPr b="1"/>
+              <a:t>What about anomalies that are cross-time series?</a:t>
+            </a:r>
+          </a:p>
+        </p:txBody>
+      </p:sp>
+    </p:spTree>
+  </p:cSld>
+</p:sld>
+</file>
+
+<file path=ppt/slides/slide13.xml><?xml version="1.0" encoding="utf-8"?>
+<p:sld xmlns:a="http://schemas.openxmlformats.org/drawingml/2006/main" xmlns:r="http://schemas.openxmlformats.org/officeDocument/2006/relationships" xmlns:p="http://schemas.openxmlformats.org/presentationml/2006/main">
+  <p:cSld>
+    <p:spTree>
+      <p:nvGrpSpPr>
+        <p:cNvPr id="1" name=""/>
+        <p:cNvGrpSpPr/>
+        <p:nvPr/>
+      </p:nvGrpSpPr>
+      <p:grpSpPr>
+        <a:xfrm>
+          <a:off x="0" y="0"/>
+          <a:ext cx="0" cy="0"/>
+          <a:chOff x="0" y="0"/>
+          <a:chExt cx="0" cy="0"/>
+        </a:xfrm>
+      </p:grpSpPr>
       <p:pic>
         <p:nvPicPr>
-          <p:cNvPr descr="https://github.com/ManuelePasini/slides-markdown/blob/master/slides/images/phd3rdyear/n2g_example.svg?raw=true" id="0" name="Picture 1"/>
+          <p:cNvPr descr="https://github.com/ManuelePasini/slides-markdown/blob/master/slides/images/phd3rdyear/n2g_agro.svg?raw=true" id="0" name="Picture 1"/>
           <p:cNvPicPr>
             <a:picLocks noGrp="1" noChangeAspect="1"/>
           </p:cNvPicPr>
@@ -3550,8 +3573,8 @@
         </p:blipFill>
         <p:spPr bwMode="auto">
           <a:xfrm>
-            <a:off x="2413000" y="1193800"/>
-            <a:ext cx="4318000" cy="2882900"/>
+            <a:off x="457200" y="1295400"/>
+            <a:ext cx="4038600" cy="2692400"/>
           </a:xfrm>
           <a:prstGeom prst="rect">
             <a:avLst/>
@@ -3573,7 +3596,7 @@
         <p:spPr>
           <a:xfrm>
             <a:off x="457200" y="4076700"/>
-            <a:ext cx="8229600" cy="508000"/>
+            <a:ext cx="4038600" cy="508000"/>
           </a:xfrm>
           <a:prstGeom prst="rect">
             <a:avLst/>
@@ -3594,12 +3617,72 @@
           </a:p>
         </p:txBody>
       </p:sp>
+      <p:pic>
+        <p:nvPicPr>
+          <p:cNvPr descr="https://github.com/ManuelePasini/slides-markdown/blob/master/slides/images/phd3rdyear/n2g_er.svg?raw=true" id="0" name="Picture 1"/>
+          <p:cNvPicPr>
+            <a:picLocks noGrp="1" noChangeAspect="1"/>
+          </p:cNvPicPr>
+          <p:nvPr/>
+        </p:nvPicPr>
+        <p:blipFill>
+          <a:blip r:embed="rId3"/>
+          <a:stretch>
+            <a:fillRect/>
+          </a:stretch>
+        </p:blipFill>
+        <p:spPr bwMode="auto">
+          <a:xfrm>
+            <a:off x="4648200" y="1295400"/>
+            <a:ext cx="4038600" cy="2692400"/>
+          </a:xfrm>
+          <a:prstGeom prst="rect">
+            <a:avLst/>
+          </a:prstGeom>
+          <a:noFill/>
+          <a:ln w="9525">
+            <a:noFill/>
+            <a:headEnd/>
+            <a:tailEnd/>
+          </a:ln>
+        </p:spPr>
+      </p:pic>
+      <p:sp>
+        <p:nvSpPr>
+          <p:cNvPr id="1" name="TextBox 3"/>
+          <p:cNvSpPr txBox="1"/>
+          <p:nvPr/>
+        </p:nvSpPr>
+        <p:spPr>
+          <a:xfrm>
+            <a:off x="4648200" y="4076700"/>
+            <a:ext cx="4038600" cy="508000"/>
+          </a:xfrm>
+          <a:prstGeom prst="rect">
+            <a:avLst/>
+          </a:prstGeom>
+          <a:noFill/>
+        </p:spPr>
+        <p:txBody>
+          <a:bodyPr/>
+          <a:lstStyle/>
+          <a:p>
+            <a:pPr lvl="0" indent="0" marL="0" algn="ctr">
+              <a:buNone/>
+            </a:pPr>
+            <a:r>
+              <a:rPr/>
+              <a:t>An example of cross-time series anomaly</a:t>
+            </a:r>
+          </a:p>
+        </p:txBody>
+      </p:sp>
     </p:spTree>
   </p:cSld>
 </p:sld>
 </file>
 
-<file path=ppt/slides/slide13.xml><?xml version="1.0" encoding="utf-8"?>
+<file path=ppt/slides/slide14.xml><?xml version="1.0" encoding="utf-8"?>
 <p:sld xmlns:a="http://schemas.openxmlformats.org/drawingml/2006/main" xmlns:r="http://schemas.openxmlformats.org/officeDocument/2006/relationships" xmlns:p="http://schemas.openxmlformats.org/presentationml/2006/main">
   <p:cSld>
     <p:spTree>

</xml_diff>

<commit_message>
Deploying to gh-pages from @ ManuelePasini/slides-markdown@226cd9fe8c208ed58380b3abdab88e92af9196da 🚀
</commit_message>
<xml_diff>
--- a/3rd_year_slides.pptx
+++ b/3rd_year_slides.pptx
@@ -3320,7 +3320,7 @@
             <a:pPr lvl="1"/>
             <a:r>
               <a:rPr/>
-              <a:t>edges built at query time</a:t>
+              <a:t>Edges built at query time</a:t>
             </a:r>
           </a:p>
         </p:txBody>
@@ -4742,8 +4742,8 @@
         </p:blipFill>
         <p:spPr bwMode="auto">
           <a:xfrm>
-            <a:off x="2413000" y="1193800"/>
-            <a:ext cx="4318000" cy="2882900"/>
+            <a:off x="457200" y="1295400"/>
+            <a:ext cx="4038600" cy="2692400"/>
           </a:xfrm>
           <a:prstGeom prst="rect">
             <a:avLst/>
@@ -4765,7 +4765,7 @@
         <p:spPr>
           <a:xfrm>
             <a:off x="457200" y="4076700"/>
-            <a:ext cx="8229600" cy="508000"/>
+            <a:ext cx="4038600" cy="508000"/>
           </a:xfrm>
           <a:prstGeom prst="rect">
             <a:avLst/>

</xml_diff>

<commit_message>
Deploying to gh-pages from @ ManuelePasini/slides-markdown@090b71283604a55ac951ada56d132e2f876d8301 🚀
</commit_message>
<xml_diff>
--- a/3rd_year_slides.pptx
+++ b/3rd_year_slides.pptx
@@ -3512,6 +3512,27 @@
         <p:txBody>
           <a:bodyPr/>
           <a:lstStyle/>
+          <a:p>
+            <a:pPr lvl="0"/>
+            <a:r>
+              <a:rPr/>
+              <a:t>Complex sensor networks are increasingly common</a:t>
+            </a:r>
+          </a:p>
+          <a:p>
+            <a:pPr lvl="0"/>
+            <a:r>
+              <a:rPr/>
+              <a:t>Anomaly detection in time-series data is a well-known research field</a:t>
+            </a:r>
+          </a:p>
+          <a:p>
+            <a:pPr lvl="0"/>
+            <a:r>
+              <a:rPr b="1"/>
+              <a:t>What about anomalies that are cross-time series?</a:t>
+            </a:r>
+          </a:p>
           <a:p>
             <a:pPr lvl="0"/>
             <a:r>

</xml_diff>

<commit_message>
Deploying to gh-pages from @ ManuelePasini/slides-markdown@988dd8305a0d817ba89b6908b309fc3b1a68d2ab 🚀
</commit_message>
<xml_diff>
--- a/3rd_year_slides.pptx
+++ b/3rd_year_slides.pptx
@@ -18,7 +18,6 @@
     <p:sldId id="266" r:id="rId12"/>
     <p:sldId id="267" r:id="rId13"/>
     <p:sldId id="268" r:id="rId14"/>
-    <p:sldId id="269" r:id="rId15"/>
   </p:sldIdLst>
   <p:sldSz cx="9144000" cy="5143500" type="screen16x9"/>
   <p:notesSz cx="6858000" cy="9144000"/>
@@ -3534,24 +3533,31 @@
             </a:r>
           </a:p>
           <a:p>
-            <a:pPr lvl="0"/>
-            <a:r>
-              <a:rPr/>
-              <a:t>Complex sensor networks are increasingly common</a:t>
-            </a:r>
-          </a:p>
-          <a:p>
-            <a:pPr lvl="0"/>
-            <a:r>
-              <a:rPr/>
-              <a:t>Anomaly detection in time-series data is a well-known research field</a:t>
-            </a:r>
-          </a:p>
-          <a:p>
-            <a:pPr lvl="0"/>
-            <a:r>
-              <a:rPr b="1"/>
-              <a:t>What about anomalies that are cross-time series?</a:t>
+            <a:pPr lvl="0" indent="0" marL="0">
+              <a:buNone/>
+            </a:pPr>
+          </a:p>
+          <a:p>
+            <a:pPr lvl="0" indent="0" marL="0">
+              <a:buNone/>
+            </a:pPr>
+            <a:r>
+              <a:rPr/>
+              <a:t>An example of cross-time series anomaly</a:t>
+            </a:r>
+          </a:p>
+          <a:p>
+            <a:pPr lvl="0" indent="0" marL="0">
+              <a:buNone/>
+            </a:pPr>
+          </a:p>
+          <a:p>
+            <a:pPr lvl="0" indent="0" marL="0">
+              <a:buNone/>
+            </a:pPr>
+            <a:r>
+              <a:rPr/>
+              <a:t>An example of cross-time series anomaly</a:t>
             </a:r>
           </a:p>
         </p:txBody>
@@ -3562,148 +3568,6 @@
 </file>
 
 <file path=ppt/slides/slide13.xml><?xml version="1.0" encoding="utf-8"?>
-<p:sld xmlns:a="http://schemas.openxmlformats.org/drawingml/2006/main" xmlns:r="http://schemas.openxmlformats.org/officeDocument/2006/relationships" xmlns:p="http://schemas.openxmlformats.org/presentationml/2006/main">
-  <p:cSld>
-    <p:spTree>
-      <p:nvGrpSpPr>
-        <p:cNvPr id="1" name=""/>
-        <p:cNvGrpSpPr/>
-        <p:nvPr/>
-      </p:nvGrpSpPr>
-      <p:grpSpPr>
-        <a:xfrm>
-          <a:off x="0" y="0"/>
-          <a:ext cx="0" cy="0"/>
-          <a:chOff x="0" y="0"/>
-          <a:chExt cx="0" cy="0"/>
-        </a:xfrm>
-      </p:grpSpPr>
-      <p:pic>
-        <p:nvPicPr>
-          <p:cNvPr descr="https://github.com/ManuelePasini/slides-markdown/blob/master/slides/images/phd3rdyear/n2g_agro.svg?raw=true" id="0" name="Picture 1"/>
-          <p:cNvPicPr>
-            <a:picLocks noGrp="1" noChangeAspect="1"/>
-          </p:cNvPicPr>
-          <p:nvPr/>
-        </p:nvPicPr>
-        <p:blipFill>
-          <a:blip r:embed="rId2"/>
-          <a:stretch>
-            <a:fillRect/>
-          </a:stretch>
-        </p:blipFill>
-        <p:spPr bwMode="auto">
-          <a:xfrm>
-            <a:off x="457200" y="1295400"/>
-            <a:ext cx="4038600" cy="2692400"/>
-          </a:xfrm>
-          <a:prstGeom prst="rect">
-            <a:avLst/>
-          </a:prstGeom>
-          <a:noFill/>
-          <a:ln w="9525">
-            <a:noFill/>
-            <a:headEnd/>
-            <a:tailEnd/>
-          </a:ln>
-        </p:spPr>
-      </p:pic>
-      <p:sp>
-        <p:nvSpPr>
-          <p:cNvPr id="1" name="TextBox 3"/>
-          <p:cNvSpPr txBox="1"/>
-          <p:nvPr/>
-        </p:nvSpPr>
-        <p:spPr>
-          <a:xfrm>
-            <a:off x="457200" y="4076700"/>
-            <a:ext cx="4038600" cy="508000"/>
-          </a:xfrm>
-          <a:prstGeom prst="rect">
-            <a:avLst/>
-          </a:prstGeom>
-          <a:noFill/>
-        </p:spPr>
-        <p:txBody>
-          <a:bodyPr/>
-          <a:lstStyle/>
-          <a:p>
-            <a:pPr lvl="0" indent="0" marL="0" algn="ctr">
-              <a:buNone/>
-            </a:pPr>
-            <a:r>
-              <a:rPr/>
-              <a:t>An example of cross-time series anomaly</a:t>
-            </a:r>
-          </a:p>
-        </p:txBody>
-      </p:sp>
-      <p:pic>
-        <p:nvPicPr>
-          <p:cNvPr descr="https://github.com/ManuelePasini/slides-markdown/blob/master/slides/images/phd3rdyear/n2g_er.svg?raw=true" id="0" name="Picture 1"/>
-          <p:cNvPicPr>
-            <a:picLocks noGrp="1" noChangeAspect="1"/>
-          </p:cNvPicPr>
-          <p:nvPr/>
-        </p:nvPicPr>
-        <p:blipFill>
-          <a:blip r:embed="rId3"/>
-          <a:stretch>
-            <a:fillRect/>
-          </a:stretch>
-        </p:blipFill>
-        <p:spPr bwMode="auto">
-          <a:xfrm>
-            <a:off x="4648200" y="1295400"/>
-            <a:ext cx="4038600" cy="2692400"/>
-          </a:xfrm>
-          <a:prstGeom prst="rect">
-            <a:avLst/>
-          </a:prstGeom>
-          <a:noFill/>
-          <a:ln w="9525">
-            <a:noFill/>
-            <a:headEnd/>
-            <a:tailEnd/>
-          </a:ln>
-        </p:spPr>
-      </p:pic>
-      <p:sp>
-        <p:nvSpPr>
-          <p:cNvPr id="1" name="TextBox 3"/>
-          <p:cNvSpPr txBox="1"/>
-          <p:nvPr/>
-        </p:nvSpPr>
-        <p:spPr>
-          <a:xfrm>
-            <a:off x="4648200" y="4076700"/>
-            <a:ext cx="4038600" cy="508000"/>
-          </a:xfrm>
-          <a:prstGeom prst="rect">
-            <a:avLst/>
-          </a:prstGeom>
-          <a:noFill/>
-        </p:spPr>
-        <p:txBody>
-          <a:bodyPr/>
-          <a:lstStyle/>
-          <a:p>
-            <a:pPr lvl="0" indent="0" marL="0" algn="ctr">
-              <a:buNone/>
-            </a:pPr>
-            <a:r>
-              <a:rPr/>
-              <a:t>An example of cross-time series anomaly</a:t>
-            </a:r>
-          </a:p>
-        </p:txBody>
-      </p:sp>
-    </p:spTree>
-  </p:cSld>
-</p:sld>
-</file>
-
-<file path=ppt/slides/slide14.xml><?xml version="1.0" encoding="utf-8"?>
 <p:sld xmlns:a="http://schemas.openxmlformats.org/drawingml/2006/main" xmlns:r="http://schemas.openxmlformats.org/officeDocument/2006/relationships" xmlns:p="http://schemas.openxmlformats.org/presentationml/2006/main">
   <p:cSld>
     <p:spTree>

</xml_diff>

<commit_message>
Deploying to gh-pages from @ ManuelePasini/slides-markdown@a4824d25ccc3441f905caabc88ecab318c8ad0e4 🚀
</commit_message>
<xml_diff>
--- a/3rd_year_slides.pptx
+++ b/3rd_year_slides.pptx
@@ -18,6 +18,7 @@
     <p:sldId id="266" r:id="rId12"/>
     <p:sldId id="267" r:id="rId13"/>
     <p:sldId id="268" r:id="rId14"/>
+    <p:sldId id="269" r:id="rId15"/>
   </p:sldIdLst>
   <p:sldSz cx="9144000" cy="5143500" type="screen16x9"/>
   <p:notesSz cx="6858000" cy="9144000"/>
@@ -3532,34 +3533,6 @@
               <a:t>What about anomalies that are cross-time series?</a:t>
             </a:r>
           </a:p>
-          <a:p>
-            <a:pPr lvl="0" indent="0" marL="0">
-              <a:buNone/>
-            </a:pPr>
-          </a:p>
-          <a:p>
-            <a:pPr lvl="0" indent="0" marL="0">
-              <a:buNone/>
-            </a:pPr>
-            <a:r>
-              <a:rPr/>
-              <a:t>An example of cross-time series anomaly</a:t>
-            </a:r>
-          </a:p>
-          <a:p>
-            <a:pPr lvl="0" indent="0" marL="0">
-              <a:buNone/>
-            </a:pPr>
-          </a:p>
-          <a:p>
-            <a:pPr lvl="0" indent="0" marL="0">
-              <a:buNone/>
-            </a:pPr>
-            <a:r>
-              <a:rPr/>
-              <a:t>An example of cross-time series anomaly</a:t>
-            </a:r>
-          </a:p>
         </p:txBody>
       </p:sp>
     </p:spTree>
@@ -3568,6 +3541,148 @@
 </file>
 
 <file path=ppt/slides/slide13.xml><?xml version="1.0" encoding="utf-8"?>
+<p:sld xmlns:a="http://schemas.openxmlformats.org/drawingml/2006/main" xmlns:r="http://schemas.openxmlformats.org/officeDocument/2006/relationships" xmlns:p="http://schemas.openxmlformats.org/presentationml/2006/main">
+  <p:cSld>
+    <p:spTree>
+      <p:nvGrpSpPr>
+        <p:cNvPr id="1" name=""/>
+        <p:cNvGrpSpPr/>
+        <p:nvPr/>
+      </p:nvGrpSpPr>
+      <p:grpSpPr>
+        <a:xfrm>
+          <a:off x="0" y="0"/>
+          <a:ext cx="0" cy="0"/>
+          <a:chOff x="0" y="0"/>
+          <a:chExt cx="0" cy="0"/>
+        </a:xfrm>
+      </p:grpSpPr>
+      <p:pic>
+        <p:nvPicPr>
+          <p:cNvPr descr="https://github.com/ManuelePasini/slides-markdown/blob/master/slides/images/phd3rdyear/n2g_agro.svg?raw=true" id="0" name="Picture 1"/>
+          <p:cNvPicPr>
+            <a:picLocks noGrp="1" noChangeAspect="1"/>
+          </p:cNvPicPr>
+          <p:nvPr/>
+        </p:nvPicPr>
+        <p:blipFill>
+          <a:blip r:embed="rId2"/>
+          <a:stretch>
+            <a:fillRect/>
+          </a:stretch>
+        </p:blipFill>
+        <p:spPr bwMode="auto">
+          <a:xfrm>
+            <a:off x="457200" y="1295400"/>
+            <a:ext cx="4038600" cy="2692400"/>
+          </a:xfrm>
+          <a:prstGeom prst="rect">
+            <a:avLst/>
+          </a:prstGeom>
+          <a:noFill/>
+          <a:ln w="9525">
+            <a:noFill/>
+            <a:headEnd/>
+            <a:tailEnd/>
+          </a:ln>
+        </p:spPr>
+      </p:pic>
+      <p:sp>
+        <p:nvSpPr>
+          <p:cNvPr id="1" name="TextBox 3"/>
+          <p:cNvSpPr txBox="1"/>
+          <p:nvPr/>
+        </p:nvSpPr>
+        <p:spPr>
+          <a:xfrm>
+            <a:off x="457200" y="4076700"/>
+            <a:ext cx="4038600" cy="508000"/>
+          </a:xfrm>
+          <a:prstGeom prst="rect">
+            <a:avLst/>
+          </a:prstGeom>
+          <a:noFill/>
+        </p:spPr>
+        <p:txBody>
+          <a:bodyPr/>
+          <a:lstStyle/>
+          <a:p>
+            <a:pPr lvl="0" indent="0" marL="0" algn="ctr">
+              <a:buNone/>
+            </a:pPr>
+            <a:r>
+              <a:rPr/>
+              <a:t>An example of cross-time series anomaly</a:t>
+            </a:r>
+          </a:p>
+        </p:txBody>
+      </p:sp>
+      <p:pic>
+        <p:nvPicPr>
+          <p:cNvPr descr="https://github.com/ManuelePasini/slides-markdown/blob/master/slides/images/phd3rdyear/n2g_er.svg?raw=true" id="0" name="Picture 1"/>
+          <p:cNvPicPr>
+            <a:picLocks noGrp="1" noChangeAspect="1"/>
+          </p:cNvPicPr>
+          <p:nvPr/>
+        </p:nvPicPr>
+        <p:blipFill>
+          <a:blip r:embed="rId3"/>
+          <a:stretch>
+            <a:fillRect/>
+          </a:stretch>
+        </p:blipFill>
+        <p:spPr bwMode="auto">
+          <a:xfrm>
+            <a:off x="4648200" y="1295400"/>
+            <a:ext cx="4038600" cy="2692400"/>
+          </a:xfrm>
+          <a:prstGeom prst="rect">
+            <a:avLst/>
+          </a:prstGeom>
+          <a:noFill/>
+          <a:ln w="9525">
+            <a:noFill/>
+            <a:headEnd/>
+            <a:tailEnd/>
+          </a:ln>
+        </p:spPr>
+      </p:pic>
+      <p:sp>
+        <p:nvSpPr>
+          <p:cNvPr id="1" name="TextBox 3"/>
+          <p:cNvSpPr txBox="1"/>
+          <p:nvPr/>
+        </p:nvSpPr>
+        <p:spPr>
+          <a:xfrm>
+            <a:off x="4648200" y="4076700"/>
+            <a:ext cx="4038600" cy="508000"/>
+          </a:xfrm>
+          <a:prstGeom prst="rect">
+            <a:avLst/>
+          </a:prstGeom>
+          <a:noFill/>
+        </p:spPr>
+        <p:txBody>
+          <a:bodyPr/>
+          <a:lstStyle/>
+          <a:p>
+            <a:pPr lvl="0" indent="0" marL="0" algn="ctr">
+              <a:buNone/>
+            </a:pPr>
+            <a:r>
+              <a:rPr/>
+              <a:t>An example of cross-time series anomaly</a:t>
+            </a:r>
+          </a:p>
+        </p:txBody>
+      </p:sp>
+    </p:spTree>
+  </p:cSld>
+</p:sld>
+</file>
+
+<file path=ppt/slides/slide14.xml><?xml version="1.0" encoding="utf-8"?>
 <p:sld xmlns:a="http://schemas.openxmlformats.org/drawingml/2006/main" xmlns:r="http://schemas.openxmlformats.org/officeDocument/2006/relationships" xmlns:p="http://schemas.openxmlformats.org/presentationml/2006/main">
   <p:cSld>
     <p:spTree>

</xml_diff>

<commit_message>
Deploying to gh-pages from @ ManuelePasini/slides-markdown@8189b0f393e3621083eb8e5231e0cfa8f946af91 🚀
</commit_message>
<xml_diff>
--- a/3rd_year_slides.pptx
+++ b/3rd_year_slides.pptx
@@ -4542,6 +4542,66 @@
             <a:r>
               <a:rPr/>
               <a:t>Prescriptive watering: Data-driven optimization of water consumption in kiwifruit orchards</a:t>
+            </a:r>
+          </a:p>
+        </p:txBody>
+      </p:sp>
+      <p:pic>
+        <p:nvPicPr>
+          <p:cNvPr descr="https://github.com/ManuelePasini/slides-markdown/blob/master/slides/images/phd3rdyear/smarter.svg?raw=true" id="0" name="Picture 1"/>
+          <p:cNvPicPr>
+            <a:picLocks noGrp="1" noChangeAspect="1"/>
+          </p:cNvPicPr>
+          <p:nvPr/>
+        </p:nvPicPr>
+        <p:blipFill>
+          <a:blip r:embed="rId2"/>
+          <a:stretch>
+            <a:fillRect/>
+          </a:stretch>
+        </p:blipFill>
+        <p:spPr bwMode="auto">
+          <a:xfrm>
+            <a:off x="1485900" y="1193800"/>
+            <a:ext cx="6172200" cy="2882900"/>
+          </a:xfrm>
+          <a:prstGeom prst="rect">
+            <a:avLst/>
+          </a:prstGeom>
+          <a:noFill/>
+          <a:ln w="9525">
+            <a:noFill/>
+            <a:headEnd/>
+            <a:tailEnd/>
+          </a:ln>
+        </p:spPr>
+      </p:pic>
+      <p:sp>
+        <p:nvSpPr>
+          <p:cNvPr id="1" name="TextBox 3"/>
+          <p:cNvSpPr txBox="1"/>
+          <p:nvPr/>
+        </p:nvSpPr>
+        <p:spPr>
+          <a:xfrm>
+            <a:off x="457200" y="4076700"/>
+            <a:ext cx="8229600" cy="508000"/>
+          </a:xfrm>
+          <a:prstGeom prst="rect">
+            <a:avLst/>
+          </a:prstGeom>
+          <a:noFill/>
+        </p:spPr>
+        <p:txBody>
+          <a:bodyPr/>
+          <a:lstStyle/>
+          <a:p>
+            <a:pPr lvl="0" indent="0" marL="0" algn="ctr">
+              <a:buNone/>
+            </a:pPr>
+            <a:r>
+              <a:rPr/>
+              <a:t>An overview of SMARTER</a:t>
             </a:r>
           </a:p>
         </p:txBody>

</xml_diff>

<commit_message>
Deploying to gh-pages from @ ManuelePasini/slides-markdown@813cc47dcb3adedd7b6eb706dd89844d6aebc88f 🚀
</commit_message>
<xml_diff>
--- a/3rd_year_slides.pptx
+++ b/3rd_year_slides.pptx
@@ -3283,7 +3283,7 @@
             </a:pPr>
             <a:r>
               <a:rPr/>
-              <a:t>STGraph: A Multistore for Temporal Property Graphs and Time-Series</a:t>
+              <a:t>STGraph: A Multistore for Temporal Graphs and Time-Series</a:t>
             </a:r>
           </a:p>
         </p:txBody>
@@ -4648,7 +4648,7 @@
             </a:pPr>
             <a:r>
               <a:rPr/>
-              <a:t>STGraph: A Multistore for Temporal Property Graphs and Time-Series</a:t>
+              <a:t>STGraph: A Multistore for Temporal Graphs and Time-Series</a:t>
             </a:r>
           </a:p>
         </p:txBody>
@@ -4671,7 +4671,7 @@
             <a:pPr lvl="0"/>
             <a:r>
               <a:rPr/>
-              <a:t>A multistore data structure for large spatio-temporal property graphs</a:t>
+              <a:t>A multistore solution for large spatio-temporal property graphs</a:t>
             </a:r>
           </a:p>
           <a:p>

</xml_diff>

<commit_message>
Deploying to gh-pages from @ ManuelePasini/slides-markdown@92e56733ba8b00bdb5aae92cc90735d8123f9c89 🚀
</commit_message>
<xml_diff>
--- a/3rd_year_slides.pptx
+++ b/3rd_year_slides.pptx
@@ -4546,62 +4546,39 @@
           </a:p>
         </p:txBody>
       </p:sp>
-      <p:pic>
-        <p:nvPicPr>
-          <p:cNvPr descr="https://github.com/ManuelePasini/slides-markdown/blob/master/slides/images/phd3rdyear/smarter.svg?raw=true" id="0" name="Picture 1"/>
-          <p:cNvPicPr>
-            <a:picLocks noGrp="1" noChangeAspect="1"/>
-          </p:cNvPicPr>
-          <p:nvPr/>
-        </p:nvPicPr>
-        <p:blipFill>
-          <a:blip r:embed="rId2"/>
-          <a:stretch>
-            <a:fillRect/>
-          </a:stretch>
-        </p:blipFill>
-        <p:spPr bwMode="auto">
-          <a:xfrm>
-            <a:off x="1485900" y="1193800"/>
-            <a:ext cx="6172200" cy="2882900"/>
-          </a:xfrm>
-          <a:prstGeom prst="rect">
-            <a:avLst/>
-          </a:prstGeom>
-          <a:noFill/>
-          <a:ln w="9525">
-            <a:noFill/>
-            <a:headEnd/>
-            <a:tailEnd/>
-          </a:ln>
-        </p:spPr>
-      </p:pic>
-      <p:sp>
-        <p:nvSpPr>
-          <p:cNvPr id="1" name="TextBox 3"/>
-          <p:cNvSpPr txBox="1"/>
-          <p:nvPr/>
-        </p:nvSpPr>
-        <p:spPr>
-          <a:xfrm>
-            <a:off x="457200" y="4076700"/>
-            <a:ext cx="8229600" cy="508000"/>
-          </a:xfrm>
-          <a:prstGeom prst="rect">
-            <a:avLst/>
-          </a:prstGeom>
-          <a:noFill/>
-        </p:spPr>
-        <p:txBody>
-          <a:bodyPr/>
-          <a:lstStyle/>
-          <a:p>
-            <a:pPr lvl="0" indent="0" marL="0" algn="ctr">
-              <a:buNone/>
-            </a:pPr>
-            <a:r>
-              <a:rPr/>
-              <a:t>An overview of SMARTER</a:t>
+      <p:sp>
+        <p:nvSpPr>
+          <p:cNvPr id="3" name="Content Placeholder 2"/>
+          <p:cNvSpPr>
+            <a:spLocks noGrp="1"/>
+          </p:cNvSpPr>
+          <p:nvPr>
+            <p:ph idx="1"/>
+          </p:nvPr>
+        </p:nvSpPr>
+        <p:spPr/>
+        <p:txBody>
+          <a:bodyPr/>
+          <a:lstStyle/>
+          <a:p>
+            <a:pPr lvl="0"/>
+            <a:r>
+              <a:rPr/>
+              <a:t>Two kiwifiruit orchards in Emilia-Romagna</a:t>
+            </a:r>
+          </a:p>
+          <a:p>
+            <a:pPr lvl="0"/>
+            <a:r>
+              <a:rPr/>
+              <a:t>Data collected from a grid of soil moisture sensors and weather stations</a:t>
+            </a:r>
+          </a:p>
+          <a:p>
+            <a:pPr lvl="0"/>
+            <a:r>
+              <a:rPr/>
+              <a:t>PID controller + simulation model to determine irrigaton amounts An overview of SMARTER</a:t>
             </a:r>
           </a:p>
         </p:txBody>
@@ -4759,7 +4736,7 @@
             </a:pPr>
             <a:r>
               <a:rPr/>
-              <a:t>STGraph System Architecture</a:t>
+              <a:t>STGraph Architecture</a:t>
             </a:r>
           </a:p>
         </p:txBody>
@@ -4802,8 +4779,8 @@
         </p:blipFill>
         <p:spPr bwMode="auto">
           <a:xfrm>
-            <a:off x="457200" y="1295400"/>
-            <a:ext cx="4038600" cy="2692400"/>
+            <a:off x="2413000" y="1193800"/>
+            <a:ext cx="4318000" cy="2882900"/>
           </a:xfrm>
           <a:prstGeom prst="rect">
             <a:avLst/>
@@ -4825,7 +4802,7 @@
         <p:spPr>
           <a:xfrm>
             <a:off x="457200" y="4076700"/>
-            <a:ext cx="4038600" cy="508000"/>
+            <a:ext cx="8229600" cy="508000"/>
           </a:xfrm>
           <a:prstGeom prst="rect">
             <a:avLst/>

</xml_diff>

<commit_message>
Deploying to gh-pages from @ ManuelePasini/slides-markdown@1dc66b1e1e35753f8f365f1ae9a988a0921457b2 🚀
</commit_message>
<xml_diff>
--- a/3rd_year_slides.pptx
+++ b/3rd_year_slides.pptx
@@ -19,6 +19,7 @@
     <p:sldId id="267" r:id="rId13"/>
     <p:sldId id="268" r:id="rId14"/>
     <p:sldId id="269" r:id="rId15"/>
+    <p:sldId id="270" r:id="rId16"/>
   </p:sldIdLst>
   <p:sldSz cx="9144000" cy="5143500" type="screen16x9"/>
   <p:notesSz cx="6858000" cy="9144000"/>
@@ -3305,8 +3306,12 @@
           <a:p>
             <a:pPr lvl="0"/>
             <a:r>
-              <a:rPr/>
-              <a:t>Property Graph data model:</a:t>
+              <a:rPr b="1"/>
+              <a:t>Property Graph data model</a:t>
+            </a:r>
+            <a:r>
+              <a:rPr/>
+              <a:t>:</a:t>
             </a:r>
           </a:p>
           <a:p>
@@ -3342,8 +3347,12 @@
           <a:p>
             <a:pPr lvl="0"/>
             <a:r>
-              <a:rPr/>
-              <a:t>Hybrid storage:</a:t>
+              <a:rPr b="1"/>
+              <a:t>Hybrid storage</a:t>
+            </a:r>
+            <a:r>
+              <a:rPr/>
+              <a:t>:</a:t>
             </a:r>
           </a:p>
           <a:p>
@@ -3391,57 +3400,31 @@
           <a:chExt cx="0" cy="0"/>
         </a:xfrm>
       </p:grpSpPr>
-      <p:pic>
-        <p:nvPicPr>
-          <p:cNvPr descr="https://github.com/ManuelePasini/slides-markdown/blob/master/slides/images/phd3rdyear/example.svg?raw=true" id="0" name="Picture 1"/>
-          <p:cNvPicPr>
-            <a:picLocks noGrp="1" noChangeAspect="1"/>
-          </p:cNvPicPr>
-          <p:nvPr/>
-        </p:nvPicPr>
-        <p:blipFill>
-          <a:blip r:embed="rId2"/>
-          <a:stretch>
-            <a:fillRect/>
-          </a:stretch>
-        </p:blipFill>
-        <p:spPr bwMode="auto">
-          <a:xfrm>
-            <a:off x="2413000" y="1193800"/>
-            <a:ext cx="4318000" cy="2882900"/>
-          </a:xfrm>
-          <a:prstGeom prst="rect">
-            <a:avLst/>
-          </a:prstGeom>
-          <a:noFill/>
-          <a:ln w="9525">
-            <a:noFill/>
-            <a:headEnd/>
-            <a:tailEnd/>
-          </a:ln>
-        </p:spPr>
-      </p:pic>
-      <p:sp>
-        <p:nvSpPr>
-          <p:cNvPr id="1" name="TextBox 3"/>
-          <p:cNvSpPr txBox="1"/>
-          <p:nvPr/>
-        </p:nvSpPr>
-        <p:spPr>
-          <a:xfrm>
-            <a:off x="457200" y="4076700"/>
-            <a:ext cx="8229600" cy="508000"/>
-          </a:xfrm>
-          <a:prstGeom prst="rect">
-            <a:avLst/>
-          </a:prstGeom>
-          <a:noFill/>
-        </p:spPr>
-        <p:txBody>
-          <a:bodyPr/>
-          <a:lstStyle/>
-          <a:p>
-            <a:pPr lvl="0" indent="0" marL="0" algn="ctr">
+      <p:sp>
+        <p:nvSpPr>
+          <p:cNvPr id="3" name="Content Placeholder 2"/>
+          <p:cNvSpPr>
+            <a:spLocks noGrp="1"/>
+          </p:cNvSpPr>
+          <p:nvPr>
+            <p:ph idx="1"/>
+          </p:nvPr>
+        </p:nvSpPr>
+        <p:spPr/>
+        <p:txBody>
+          <a:bodyPr/>
+          <a:lstStyle/>
+          <a:p>
+            <a:pPr lvl="0" indent="0" marL="0">
+              <a:buNone/>
+            </a:pPr>
+            <a:r>
+              <a:rPr/>
+              <a:t>Querying STGraph</a:t>
+            </a:r>
+          </a:p>
+          <a:p>
+            <a:pPr lvl="0" indent="0" marL="0">
               <a:buNone/>
             </a:pPr>
             <a:r>
@@ -3559,7 +3542,7 @@
       </p:grpSpPr>
       <p:pic>
         <p:nvPicPr>
-          <p:cNvPr descr="https://github.com/ManuelePasini/slides-markdown/blob/master/slides/images/phd3rdyear/n2g_agro.svg?raw=true" id="0" name="Picture 1"/>
+          <p:cNvPr descr="https://github.com/ManuelePasini/slides-markdown/blob/master/slides/images/phd3rdyear/n2g_er.svg?raw=true" id="0" name="Picture 1"/>
           <p:cNvPicPr>
             <a:picLocks noGrp="1" noChangeAspect="1"/>
           </p:cNvPicPr>
@@ -3619,7 +3602,7 @@
       </p:sp>
       <p:pic>
         <p:nvPicPr>
-          <p:cNvPr descr="https://github.com/ManuelePasini/slides-markdown/blob/master/slides/images/phd3rdyear/n2g_er.svg?raw=true" id="0" name="Picture 1"/>
+          <p:cNvPr descr="https://github.com/ManuelePasini/slides-markdown/blob/master/slides/images/phd3rdyear/n2g_agro.svg?raw=true" id="0" name="Picture 1"/>
           <p:cNvPicPr>
             <a:picLocks noGrp="1" noChangeAspect="1"/>
           </p:cNvPicPr>
@@ -3683,6 +3666,53 @@
 </file>
 
 <file path=ppt/slides/slide14.xml><?xml version="1.0" encoding="utf-8"?>
+<p:sld xmlns:a="http://schemas.openxmlformats.org/drawingml/2006/main" xmlns:r="http://schemas.openxmlformats.org/officeDocument/2006/relationships" xmlns:p="http://schemas.openxmlformats.org/presentationml/2006/main">
+  <p:cSld>
+    <p:spTree>
+      <p:nvGrpSpPr>
+        <p:cNvPr id="1" name=""/>
+        <p:cNvGrpSpPr/>
+        <p:nvPr/>
+      </p:nvGrpSpPr>
+      <p:grpSpPr>
+        <a:xfrm>
+          <a:off x="0" y="0"/>
+          <a:ext cx="0" cy="0"/>
+          <a:chOff x="0" y="0"/>
+          <a:chExt cx="0" cy="0"/>
+        </a:xfrm>
+      </p:grpSpPr>
+      <p:sp>
+        <p:nvSpPr>
+          <p:cNvPr id="2" name="Title 1"/>
+          <p:cNvSpPr>
+            <a:spLocks noGrp="1"/>
+          </p:cNvSpPr>
+          <p:nvPr>
+            <p:ph type="title"/>
+          </p:nvPr>
+        </p:nvSpPr>
+        <p:spPr/>
+        <p:txBody>
+          <a:bodyPr/>
+          <a:lstStyle/>
+          <a:p>
+            <a:pPr lvl="0" indent="0" marL="0">
+              <a:buNone/>
+            </a:pPr>
+            <a:r>
+              <a:rPr/>
+              <a:t>Anomaly Detection in Complex Sensor Networks</a:t>
+            </a:r>
+          </a:p>
+        </p:txBody>
+      </p:sp>
+    </p:spTree>
+  </p:cSld>
+</p:sld>
+</file>
+
+<file path=ppt/slides/slide15.xml><?xml version="1.0" encoding="utf-8"?>
 <p:sld xmlns:a="http://schemas.openxmlformats.org/drawingml/2006/main" xmlns:r="http://schemas.openxmlformats.org/officeDocument/2006/relationships" xmlns:p="http://schemas.openxmlformats.org/presentationml/2006/main">
   <p:cSld>
     <p:spTree>

</xml_diff>

<commit_message>
Deploying to gh-pages from @ ManuelePasini/slides-markdown@986d325a8464f6f70670d9d4341df69583ff0a1c 🚀
</commit_message>
<xml_diff>
--- a/3rd_year_slides.pptx
+++ b/3rd_year_slides.pptx
@@ -20,6 +20,8 @@
     <p:sldId id="268" r:id="rId14"/>
     <p:sldId id="269" r:id="rId15"/>
     <p:sldId id="270" r:id="rId16"/>
+    <p:sldId id="271" r:id="rId17"/>
+    <p:sldId id="272" r:id="rId18"/>
   </p:sldIdLst>
   <p:sldSz cx="9144000" cy="5143500" type="screen16x9"/>
   <p:notesSz cx="6858000" cy="9144000"/>
@@ -3306,74 +3308,96 @@
           <a:p>
             <a:pPr lvl="0"/>
             <a:r>
-              <a:rPr b="1"/>
-              <a:t>Property Graph data model</a:t>
-            </a:r>
-            <a:r>
-              <a:rPr/>
-              <a:t>:</a:t>
+              <a:rPr/>
+              <a:t>A multistore solution for large spatio-temporal property graphs</a:t>
             </a:r>
           </a:p>
           <a:p>
             <a:pPr lvl="1"/>
             <a:r>
               <a:rPr/>
-              <a:t>TS events (nodes) can hold edges and properties</a:t>
+              <a:t>Graph data model on top of heterogeneous storage</a:t>
+            </a:r>
+          </a:p>
+          <a:p>
+            <a:pPr lvl="2"/>
+            <a:r>
+              <a:rPr/>
+              <a:t>Low-evolving data on Graph storage</a:t>
+            </a:r>
+          </a:p>
+          <a:p>
+            <a:pPr lvl="2"/>
+            <a:r>
+              <a:rPr/>
+              <a:t>Highly-dynamic data on Time-Series storage</a:t>
             </a:r>
           </a:p>
           <a:p>
             <a:pPr lvl="1"/>
             <a:r>
               <a:rPr/>
-              <a:t>Edges built at query time</a:t>
-            </a:r>
-          </a:p>
-        </p:txBody>
-      </p:sp>
-      <p:sp>
-        <p:nvSpPr>
-          <p:cNvPr id="4" name="Content Placeholder 3"/>
-          <p:cNvSpPr>
-            <a:spLocks noGrp="1"/>
-          </p:cNvSpPr>
-          <p:nvPr>
-            <p:ph idx="2" sz="half"/>
-          </p:nvPr>
-        </p:nvSpPr>
-        <p:spPr/>
-        <p:txBody>
-          <a:bodyPr/>
-          <a:lstStyle/>
-          <a:p>
-            <a:pPr lvl="0"/>
-            <a:r>
-              <a:rPr b="1"/>
-              <a:t>Hybrid storage</a:t>
-            </a:r>
-            <a:r>
-              <a:rPr/>
-              <a:t>:</a:t>
-            </a:r>
-          </a:p>
-          <a:p>
-            <a:pPr lvl="1"/>
-            <a:r>
-              <a:rPr/>
-              <a:t>Dedicated Time-Series streaming ingestion of data</a:t>
-            </a:r>
-          </a:p>
-          <a:p>
-            <a:pPr lvl="1"/>
-            <a:r>
-              <a:rPr/>
-              <a:t>Query optimization through filter-pushdown</a:t>
-            </a:r>
-          </a:p>
-          <a:p>
-            <a:pPr lvl="1"/>
-            <a:r>
-              <a:rPr/>
-              <a:t>Efficient graph traversal &amp; temporal reasoning</a:t>
+              <a:t>Transparent graph query interface.</a:t>
+            </a:r>
+          </a:p>
+        </p:txBody>
+      </p:sp>
+      <p:pic>
+        <p:nvPicPr>
+          <p:cNvPr descr="https://github.com/ManuelePasini/slides-markdown/blob/master/slides/images/phd3rdyear/arch.svg?raw=true" id="0" name="Picture 1"/>
+          <p:cNvPicPr>
+            <a:picLocks noGrp="1" noChangeAspect="1"/>
+          </p:cNvPicPr>
+          <p:nvPr/>
+        </p:nvPicPr>
+        <p:blipFill>
+          <a:blip r:embed="rId2"/>
+          <a:stretch>
+            <a:fillRect/>
+          </a:stretch>
+        </p:blipFill>
+        <p:spPr bwMode="auto">
+          <a:xfrm>
+            <a:off x="4648200" y="1333500"/>
+            <a:ext cx="4038600" cy="2603500"/>
+          </a:xfrm>
+          <a:prstGeom prst="rect">
+            <a:avLst/>
+          </a:prstGeom>
+          <a:noFill/>
+          <a:ln w="9525">
+            <a:noFill/>
+            <a:headEnd/>
+            <a:tailEnd/>
+          </a:ln>
+        </p:spPr>
+      </p:pic>
+      <p:sp>
+        <p:nvSpPr>
+          <p:cNvPr id="1" name="TextBox 3"/>
+          <p:cNvSpPr txBox="1"/>
+          <p:nvPr/>
+        </p:nvSpPr>
+        <p:spPr>
+          <a:xfrm>
+            <a:off x="4648200" y="4076700"/>
+            <a:ext cx="4038600" cy="508000"/>
+          </a:xfrm>
+          <a:prstGeom prst="rect">
+            <a:avLst/>
+          </a:prstGeom>
+          <a:noFill/>
+        </p:spPr>
+        <p:txBody>
+          <a:bodyPr/>
+          <a:lstStyle/>
+          <a:p>
+            <a:pPr lvl="0" indent="0" marL="0" algn="ctr">
+              <a:buNone/>
+            </a:pPr>
+            <a:r>
+              <a:rPr/>
+              <a:t>STGraph Architecture</a:t>
             </a:r>
           </a:p>
         </p:txBody>
@@ -3400,36 +3424,62 @@
           <a:chExt cx="0" cy="0"/>
         </a:xfrm>
       </p:grpSpPr>
-      <p:sp>
-        <p:nvSpPr>
-          <p:cNvPr id="3" name="Content Placeholder 2"/>
-          <p:cNvSpPr>
-            <a:spLocks noGrp="1"/>
-          </p:cNvSpPr>
-          <p:nvPr>
-            <p:ph idx="1"/>
-          </p:nvPr>
-        </p:nvSpPr>
-        <p:spPr/>
-        <p:txBody>
-          <a:bodyPr/>
-          <a:lstStyle/>
-          <a:p>
-            <a:pPr lvl="0" indent="0" marL="0">
+      <p:pic>
+        <p:nvPicPr>
+          <p:cNvPr descr="https://github.com/ManuelePasini/slides-markdown/blob/master/slides/images/phd3rdyear/datamodel.svg?raw=true" id="0" name="Picture 1"/>
+          <p:cNvPicPr>
+            <a:picLocks noGrp="1" noChangeAspect="1"/>
+          </p:cNvPicPr>
+          <p:nvPr/>
+        </p:nvPicPr>
+        <p:blipFill>
+          <a:blip r:embed="rId2"/>
+          <a:stretch>
+            <a:fillRect/>
+          </a:stretch>
+        </p:blipFill>
+        <p:spPr bwMode="auto">
+          <a:xfrm>
+            <a:off x="2413000" y="1193800"/>
+            <a:ext cx="4318000" cy="2882900"/>
+          </a:xfrm>
+          <a:prstGeom prst="rect">
+            <a:avLst/>
+          </a:prstGeom>
+          <a:noFill/>
+          <a:ln w="9525">
+            <a:noFill/>
+            <a:headEnd/>
+            <a:tailEnd/>
+          </a:ln>
+        </p:spPr>
+      </p:pic>
+      <p:sp>
+        <p:nvSpPr>
+          <p:cNvPr id="1" name="TextBox 3"/>
+          <p:cNvSpPr txBox="1"/>
+          <p:nvPr/>
+        </p:nvSpPr>
+        <p:spPr>
+          <a:xfrm>
+            <a:off x="457200" y="4076700"/>
+            <a:ext cx="8229600" cy="508000"/>
+          </a:xfrm>
+          <a:prstGeom prst="rect">
+            <a:avLst/>
+          </a:prstGeom>
+          <a:noFill/>
+        </p:spPr>
+        <p:txBody>
+          <a:bodyPr/>
+          <a:lstStyle/>
+          <a:p>
+            <a:pPr lvl="0" indent="0" marL="0" algn="ctr">
               <a:buNone/>
             </a:pPr>
             <a:r>
               <a:rPr/>
-              <a:t>Querying STGraph</a:t>
-            </a:r>
-          </a:p>
-          <a:p>
-            <a:pPr lvl="0" indent="0" marL="0">
-              <a:buNone/>
-            </a:pPr>
-            <a:r>
-              <a:rPr/>
-              <a:t>Querying STGraph</a:t>
+              <a:t>STGraph Data Model</a:t>
             </a:r>
           </a:p>
         </p:txBody>
@@ -3476,7 +3526,7 @@
             </a:pPr>
             <a:r>
               <a:rPr/>
-              <a:t>Anomaly Detection in Complex Sensor Networks</a:t>
+              <a:t>STGraph: A Multistore for Temporal Graphs and Time-Series</a:t>
             </a:r>
           </a:p>
         </p:txBody>
@@ -3488,7 +3538,7 @@
             <a:spLocks noGrp="1"/>
           </p:cNvSpPr>
           <p:nvPr>
-            <p:ph idx="1"/>
+            <p:ph idx="1" sz="half"/>
           </p:nvPr>
         </p:nvSpPr>
         <p:spPr/>
@@ -3498,22 +3548,74 @@
           <a:p>
             <a:pPr lvl="0"/>
             <a:r>
-              <a:rPr/>
-              <a:t>Complex sensor networks are increasingly common</a:t>
-            </a:r>
-          </a:p>
+              <a:rPr b="1"/>
+              <a:t>Property Graph data model</a:t>
+            </a:r>
+            <a:r>
+              <a:rPr/>
+              <a:t>:</a:t>
+            </a:r>
+          </a:p>
+          <a:p>
+            <a:pPr lvl="1"/>
+            <a:r>
+              <a:rPr/>
+              <a:t>TS events (nodes) can hold edges and properties</a:t>
+            </a:r>
+          </a:p>
+          <a:p>
+            <a:pPr lvl="1"/>
+            <a:r>
+              <a:rPr/>
+              <a:t>Edges built at query time</a:t>
+            </a:r>
+          </a:p>
+        </p:txBody>
+      </p:sp>
+      <p:sp>
+        <p:nvSpPr>
+          <p:cNvPr id="4" name="Content Placeholder 3"/>
+          <p:cNvSpPr>
+            <a:spLocks noGrp="1"/>
+          </p:cNvSpPr>
+          <p:nvPr>
+            <p:ph idx="2" sz="half"/>
+          </p:nvPr>
+        </p:nvSpPr>
+        <p:spPr/>
+        <p:txBody>
+          <a:bodyPr/>
+          <a:lstStyle/>
           <a:p>
             <a:pPr lvl="0"/>
             <a:r>
-              <a:rPr/>
-              <a:t>Anomaly detection in time-series data is a well-known research field</a:t>
-            </a:r>
-          </a:p>
-          <a:p>
-            <a:pPr lvl="0"/>
-            <a:r>
               <a:rPr b="1"/>
-              <a:t>What about anomalies that are cross-time series?</a:t>
+              <a:t>Hybrid storage</a:t>
+            </a:r>
+            <a:r>
+              <a:rPr/>
+              <a:t>:</a:t>
+            </a:r>
+          </a:p>
+          <a:p>
+            <a:pPr lvl="1"/>
+            <a:r>
+              <a:rPr/>
+              <a:t>Dedicated Time-Series streaming ingestion of data</a:t>
+            </a:r>
+          </a:p>
+          <a:p>
+            <a:pPr lvl="1"/>
+            <a:r>
+              <a:rPr/>
+              <a:t>Query optimization through filter-pushdown</a:t>
+            </a:r>
+          </a:p>
+          <a:p>
+            <a:pPr lvl="1"/>
+            <a:r>
+              <a:rPr/>
+              <a:t>Efficient graph traversal &amp; temporal reasoning</a:t>
             </a:r>
           </a:p>
         </p:txBody>
@@ -3524,6 +3626,146 @@
 </file>
 
 <file path=ppt/slides/slide13.xml><?xml version="1.0" encoding="utf-8"?>
+<p:sld xmlns:a="http://schemas.openxmlformats.org/drawingml/2006/main" xmlns:r="http://schemas.openxmlformats.org/officeDocument/2006/relationships" xmlns:p="http://schemas.openxmlformats.org/presentationml/2006/main">
+  <p:cSld>
+    <p:spTree>
+      <p:nvGrpSpPr>
+        <p:cNvPr id="1" name=""/>
+        <p:cNvGrpSpPr/>
+        <p:nvPr/>
+      </p:nvGrpSpPr>
+      <p:grpSpPr>
+        <a:xfrm>
+          <a:off x="0" y="0"/>
+          <a:ext cx="0" cy="0"/>
+          <a:chOff x="0" y="0"/>
+          <a:chExt cx="0" cy="0"/>
+        </a:xfrm>
+      </p:grpSpPr>
+      <p:sp>
+        <p:nvSpPr>
+          <p:cNvPr id="3" name="Content Placeholder 2"/>
+          <p:cNvSpPr>
+            <a:spLocks noGrp="1"/>
+          </p:cNvSpPr>
+          <p:nvPr>
+            <p:ph idx="1"/>
+          </p:nvPr>
+        </p:nvSpPr>
+        <p:spPr/>
+        <p:txBody>
+          <a:bodyPr/>
+          <a:lstStyle/>
+          <a:p>
+            <a:pPr lvl="0" indent="0" marL="0">
+              <a:buNone/>
+            </a:pPr>
+            <a:r>
+              <a:rPr/>
+              <a:t>Querying STGraph</a:t>
+            </a:r>
+          </a:p>
+          <a:p>
+            <a:pPr lvl="0" indent="0" marL="0">
+              <a:buNone/>
+            </a:pPr>
+            <a:r>
+              <a:rPr/>
+              <a:t>Querying STGraph</a:t>
+            </a:r>
+          </a:p>
+        </p:txBody>
+      </p:sp>
+    </p:spTree>
+  </p:cSld>
+</p:sld>
+</file>
+
+<file path=ppt/slides/slide14.xml><?xml version="1.0" encoding="utf-8"?>
+<p:sld xmlns:a="http://schemas.openxmlformats.org/drawingml/2006/main" xmlns:r="http://schemas.openxmlformats.org/officeDocument/2006/relationships" xmlns:p="http://schemas.openxmlformats.org/presentationml/2006/main">
+  <p:cSld>
+    <p:spTree>
+      <p:nvGrpSpPr>
+        <p:cNvPr id="1" name=""/>
+        <p:cNvGrpSpPr/>
+        <p:nvPr/>
+      </p:nvGrpSpPr>
+      <p:grpSpPr>
+        <a:xfrm>
+          <a:off x="0" y="0"/>
+          <a:ext cx="0" cy="0"/>
+          <a:chOff x="0" y="0"/>
+          <a:chExt cx="0" cy="0"/>
+        </a:xfrm>
+      </p:grpSpPr>
+      <p:sp>
+        <p:nvSpPr>
+          <p:cNvPr id="2" name="Title 1"/>
+          <p:cNvSpPr>
+            <a:spLocks noGrp="1"/>
+          </p:cNvSpPr>
+          <p:nvPr>
+            <p:ph type="title"/>
+          </p:nvPr>
+        </p:nvSpPr>
+        <p:spPr/>
+        <p:txBody>
+          <a:bodyPr/>
+          <a:lstStyle/>
+          <a:p>
+            <a:pPr lvl="0" indent="0" marL="0">
+              <a:buNone/>
+            </a:pPr>
+            <a:r>
+              <a:rPr/>
+              <a:t>Anomaly Detection in Complex Sensor Networks</a:t>
+            </a:r>
+          </a:p>
+        </p:txBody>
+      </p:sp>
+      <p:sp>
+        <p:nvSpPr>
+          <p:cNvPr id="3" name="Content Placeholder 2"/>
+          <p:cNvSpPr>
+            <a:spLocks noGrp="1"/>
+          </p:cNvSpPr>
+          <p:nvPr>
+            <p:ph idx="1"/>
+          </p:nvPr>
+        </p:nvSpPr>
+        <p:spPr/>
+        <p:txBody>
+          <a:bodyPr/>
+          <a:lstStyle/>
+          <a:p>
+            <a:pPr lvl="0"/>
+            <a:r>
+              <a:rPr/>
+              <a:t>Complex sensor networks are increasingly common</a:t>
+            </a:r>
+          </a:p>
+          <a:p>
+            <a:pPr lvl="0"/>
+            <a:r>
+              <a:rPr/>
+              <a:t>Anomaly detection in time-series data is a well-known research field</a:t>
+            </a:r>
+          </a:p>
+          <a:p>
+            <a:pPr lvl="0"/>
+            <a:r>
+              <a:rPr b="1"/>
+              <a:t>What about anomalies that are cross-time series?</a:t>
+            </a:r>
+          </a:p>
+        </p:txBody>
+      </p:sp>
+    </p:spTree>
+  </p:cSld>
+</p:sld>
+</file>
+
+<file path=ppt/slides/slide15.xml><?xml version="1.0" encoding="utf-8"?>
 <p:sld xmlns:a="http://schemas.openxmlformats.org/drawingml/2006/main" xmlns:r="http://schemas.openxmlformats.org/officeDocument/2006/relationships" xmlns:p="http://schemas.openxmlformats.org/presentationml/2006/main">
   <p:cSld>
     <p:spTree>
@@ -3665,7 +3907,7 @@
 </p:sld>
 </file>
 
-<file path=ppt/slides/slide14.xml><?xml version="1.0" encoding="utf-8"?>
+<file path=ppt/slides/slide16.xml><?xml version="1.0" encoding="utf-8"?>
 <p:sld xmlns:a="http://schemas.openxmlformats.org/drawingml/2006/main" xmlns:r="http://schemas.openxmlformats.org/officeDocument/2006/relationships" xmlns:p="http://schemas.openxmlformats.org/presentationml/2006/main">
   <p:cSld>
     <p:spTree>
@@ -3712,7 +3954,7 @@
 </p:sld>
 </file>
 
-<file path=ppt/slides/slide15.xml><?xml version="1.0" encoding="utf-8"?>
+<file path=ppt/slides/slide17.xml><?xml version="1.0" encoding="utf-8"?>
 <p:sld xmlns:a="http://schemas.openxmlformats.org/drawingml/2006/main" xmlns:r="http://schemas.openxmlformats.org/officeDocument/2006/relationships" xmlns:p="http://schemas.openxmlformats.org/presentationml/2006/main">
   <p:cSld>
     <p:spTree>
@@ -4608,7 +4850,7 @@
             <a:pPr lvl="0"/>
             <a:r>
               <a:rPr/>
-              <a:t>PID controller + simulation model to determine irrigaton amounts An overview of SMARTER</a:t>
+              <a:t>Soil data is interpolated to obtain a 2-dimensional view of soil moisture</a:t>
             </a:r>
           </a:p>
         </p:txBody>
@@ -4635,85 +4877,9 @@
           <a:chExt cx="0" cy="0"/>
         </a:xfrm>
       </p:grpSpPr>
-      <p:sp>
-        <p:nvSpPr>
-          <p:cNvPr id="2" name="Title 1"/>
-          <p:cNvSpPr>
-            <a:spLocks noGrp="1"/>
-          </p:cNvSpPr>
-          <p:nvPr>
-            <p:ph type="title"/>
-          </p:nvPr>
-        </p:nvSpPr>
-        <p:spPr/>
-        <p:txBody>
-          <a:bodyPr/>
-          <a:lstStyle/>
-          <a:p>
-            <a:pPr lvl="0" indent="0" marL="0">
-              <a:buNone/>
-            </a:pPr>
-            <a:r>
-              <a:rPr/>
-              <a:t>STGraph: A Multistore for Temporal Graphs and Time-Series</a:t>
-            </a:r>
-          </a:p>
-        </p:txBody>
-      </p:sp>
-      <p:sp>
-        <p:nvSpPr>
-          <p:cNvPr id="3" name="Content Placeholder 2"/>
-          <p:cNvSpPr>
-            <a:spLocks noGrp="1"/>
-          </p:cNvSpPr>
-          <p:nvPr>
-            <p:ph idx="1" sz="half"/>
-          </p:nvPr>
-        </p:nvSpPr>
-        <p:spPr/>
-        <p:txBody>
-          <a:bodyPr/>
-          <a:lstStyle/>
-          <a:p>
-            <a:pPr lvl="0"/>
-            <a:r>
-              <a:rPr/>
-              <a:t>A multistore solution for large spatio-temporal property graphs</a:t>
-            </a:r>
-          </a:p>
-          <a:p>
-            <a:pPr lvl="1"/>
-            <a:r>
-              <a:rPr/>
-              <a:t>Graph data model on top of heterogeneous storage</a:t>
-            </a:r>
-          </a:p>
-          <a:p>
-            <a:pPr lvl="2"/>
-            <a:r>
-              <a:rPr/>
-              <a:t>Low-evolving data on Graph storage</a:t>
-            </a:r>
-          </a:p>
-          <a:p>
-            <a:pPr lvl="2"/>
-            <a:r>
-              <a:rPr/>
-              <a:t>Highly-dynamic data on Time-Series storage</a:t>
-            </a:r>
-          </a:p>
-          <a:p>
-            <a:pPr lvl="1"/>
-            <a:r>
-              <a:rPr/>
-              <a:t>Transparent graph query interface.</a:t>
-            </a:r>
-          </a:p>
-        </p:txBody>
-      </p:sp>
       <p:pic>
         <p:nvPicPr>
-          <p:cNvPr descr="https://github.com/ManuelePasini/slides-markdown/blob/master/slides/images/phd3rdyear/arch.svg?raw=true" id="0" name="Picture 1"/>
+          <p:cNvPr descr="https://github.com/ManuelePasini/slides-markdown/blob/master/slides/images/phd3rdyear/plant.svg?raw=true" id="0" name="Picture 1"/>
           <p:cNvPicPr>
             <a:picLocks noGrp="1" noChangeAspect="1"/>
           </p:cNvPicPr>
@@ -4727,8 +4893,8 @@
         </p:blipFill>
         <p:spPr bwMode="auto">
           <a:xfrm>
-            <a:off x="4648200" y="1333500"/>
-            <a:ext cx="4038600" cy="2603500"/>
+            <a:off x="508000" y="1193800"/>
+            <a:ext cx="3937000" cy="2882900"/>
           </a:xfrm>
           <a:prstGeom prst="rect">
             <a:avLst/>
@@ -4749,6 +4915,66 @@
         </p:nvSpPr>
         <p:spPr>
           <a:xfrm>
+            <a:off x="457200" y="4076700"/>
+            <a:ext cx="4038600" cy="508000"/>
+          </a:xfrm>
+          <a:prstGeom prst="rect">
+            <a:avLst/>
+          </a:prstGeom>
+          <a:noFill/>
+        </p:spPr>
+        <p:txBody>
+          <a:bodyPr/>
+          <a:lstStyle/>
+          <a:p>
+            <a:pPr lvl="0" indent="0" marL="0" algn="ctr">
+              <a:buNone/>
+            </a:pPr>
+            <a:r>
+              <a:rPr/>
+              <a:t>Grid positioning</a:t>
+            </a:r>
+          </a:p>
+        </p:txBody>
+      </p:sp>
+      <p:pic>
+        <p:nvPicPr>
+          <p:cNvPr descr="https://github.com/ManuelePasini/slides-markdown/blob/master/slides/images/phd3rdyear/moisture.png?raw=true" id="0" name="Picture 1"/>
+          <p:cNvPicPr>
+            <a:picLocks noGrp="1" noChangeAspect="1"/>
+          </p:cNvPicPr>
+          <p:nvPr/>
+        </p:nvPicPr>
+        <p:blipFill>
+          <a:blip r:embed="rId3"/>
+          <a:stretch>
+            <a:fillRect/>
+          </a:stretch>
+        </p:blipFill>
+        <p:spPr bwMode="auto">
+          <a:xfrm>
+            <a:off x="4648200" y="2082800"/>
+            <a:ext cx="4038600" cy="1104900"/>
+          </a:xfrm>
+          <a:prstGeom prst="rect">
+            <a:avLst/>
+          </a:prstGeom>
+          <a:noFill/>
+          <a:ln w="9525">
+            <a:noFill/>
+            <a:headEnd/>
+            <a:tailEnd/>
+          </a:ln>
+        </p:spPr>
+      </p:pic>
+      <p:sp>
+        <p:nvSpPr>
+          <p:cNvPr id="1" name="TextBox 3"/>
+          <p:cNvSpPr txBox="1"/>
+          <p:nvPr/>
+        </p:nvSpPr>
+        <p:spPr>
+          <a:xfrm>
             <a:off x="4648200" y="4076700"/>
             <a:ext cx="4038600" cy="508000"/>
           </a:xfrm>
@@ -4766,7 +4992,7 @@
             </a:pPr>
             <a:r>
               <a:rPr/>
-              <a:t>STGraph Architecture</a:t>
+              <a:t>From continuous humidity to a discrete representation</a:t>
             </a:r>
           </a:p>
         </p:txBody>
@@ -4793,9 +5019,57 @@
           <a:chExt cx="0" cy="0"/>
         </a:xfrm>
       </p:grpSpPr>
+      <p:sp>
+        <p:nvSpPr>
+          <p:cNvPr id="2" name="Title 1"/>
+          <p:cNvSpPr>
+            <a:spLocks noGrp="1"/>
+          </p:cNvSpPr>
+          <p:nvPr>
+            <p:ph type="title"/>
+          </p:nvPr>
+        </p:nvSpPr>
+        <p:spPr/>
+        <p:txBody>
+          <a:bodyPr/>
+          <a:lstStyle/>
+          <a:p>
+            <a:pPr lvl="0" indent="0" marL="0">
+              <a:buNone/>
+            </a:pPr>
+            <a:r>
+              <a:rPr/>
+              <a:t>Prescriptive watering: Data-driven optimization of water consumption in kiwifruit orchards</a:t>
+            </a:r>
+          </a:p>
+        </p:txBody>
+      </p:sp>
+      <p:sp>
+        <p:nvSpPr>
+          <p:cNvPr id="3" name="Content Placeholder 2"/>
+          <p:cNvSpPr>
+            <a:spLocks noGrp="1"/>
+          </p:cNvSpPr>
+          <p:nvPr>
+            <p:ph idx="1"/>
+          </p:nvPr>
+        </p:nvSpPr>
+        <p:spPr/>
+        <p:txBody>
+          <a:bodyPr/>
+          <a:lstStyle/>
+          <a:p>
+            <a:pPr lvl="0"/>
+            <a:r>
+              <a:rPr/>
+              <a:t>PID controller + simulation model to determine irrigaton amounts</a:t>
+            </a:r>
+          </a:p>
+        </p:txBody>
+      </p:sp>
       <p:pic>
         <p:nvPicPr>
-          <p:cNvPr descr="https://github.com/ManuelePasini/slides-markdown/blob/master/slides/images/phd3rdyear/datamodel.svg?raw=true" id="0" name="Picture 1"/>
+          <p:cNvPr descr="https://github.com/ManuelePasini/slides-markdown/blob/master/slides/images/phd3rdyear/smarter.svg?raw=true" id="0" name="Picture 1"/>
           <p:cNvPicPr>
             <a:picLocks noGrp="1" noChangeAspect="1"/>
           </p:cNvPicPr>
@@ -4809,8 +5083,8 @@
         </p:blipFill>
         <p:spPr bwMode="auto">
           <a:xfrm>
-            <a:off x="2413000" y="1193800"/>
-            <a:ext cx="4318000" cy="2882900"/>
+            <a:off x="1485900" y="1193800"/>
+            <a:ext cx="6172200" cy="2882900"/>
           </a:xfrm>
           <a:prstGeom prst="rect">
             <a:avLst/>
@@ -4848,7 +5122,7 @@
             </a:pPr>
             <a:r>
               <a:rPr/>
-              <a:t>STGraph Data Model</a:t>
+              <a:t>An overview of SMARTER</a:t>
             </a:r>
           </a:p>
         </p:txBody>

</xml_diff>

<commit_message>
Deploying to gh-pages from @ ManuelePasini/slides-markdown@9f777a4f50bc9d2469af3de0b10bc5d8721ad8ec 🚀
</commit_message>
<xml_diff>
--- a/3rd_year_slides.pptx
+++ b/3rd_year_slides.pptx
@@ -21,7 +21,6 @@
     <p:sldId id="269" r:id="rId15"/>
     <p:sldId id="270" r:id="rId16"/>
     <p:sldId id="271" r:id="rId17"/>
-    <p:sldId id="272" r:id="rId18"/>
   </p:sldIdLst>
   <p:sldSz cx="9144000" cy="5143500" type="screen16x9"/>
   <p:notesSz cx="6858000" cy="9144000"/>
@@ -3548,13 +3547,9 @@
           <a:p>
             <a:pPr lvl="0"/>
             <a:r>
-              <a:rPr b="1"/>
+              <a:rPr/>
               <a:t>Property Graph data model</a:t>
             </a:r>
-            <a:r>
-              <a:rPr/>
-              <a:t>:</a:t>
-            </a:r>
           </a:p>
           <a:p>
             <a:pPr lvl="1"/>
@@ -3572,6 +3567,66 @@
           </a:p>
         </p:txBody>
       </p:sp>
+      <p:pic>
+        <p:nvPicPr>
+          <p:cNvPr descr="https://github.com/ManuelePasini/slides-markdown/blob/master/slides/images/phd3rdyear/example.svg?raw=true" id="0" name="Picture 1"/>
+          <p:cNvPicPr>
+            <a:picLocks noGrp="1" noChangeAspect="1"/>
+          </p:cNvPicPr>
+          <p:nvPr/>
+        </p:nvPicPr>
+        <p:blipFill>
+          <a:blip r:embed="rId2"/>
+          <a:stretch>
+            <a:fillRect/>
+          </a:stretch>
+        </p:blipFill>
+        <p:spPr bwMode="auto">
+          <a:xfrm>
+            <a:off x="457200" y="1295400"/>
+            <a:ext cx="4038600" cy="2692400"/>
+          </a:xfrm>
+          <a:prstGeom prst="rect">
+            <a:avLst/>
+          </a:prstGeom>
+          <a:noFill/>
+          <a:ln w="9525">
+            <a:noFill/>
+            <a:headEnd/>
+            <a:tailEnd/>
+          </a:ln>
+        </p:spPr>
+      </p:pic>
+      <p:sp>
+        <p:nvSpPr>
+          <p:cNvPr id="1" name="TextBox 3"/>
+          <p:cNvSpPr txBox="1"/>
+          <p:nvPr/>
+        </p:nvSpPr>
+        <p:spPr>
+          <a:xfrm>
+            <a:off x="457200" y="4076700"/>
+            <a:ext cx="4038600" cy="508000"/>
+          </a:xfrm>
+          <a:prstGeom prst="rect">
+            <a:avLst/>
+          </a:prstGeom>
+          <a:noFill/>
+        </p:spPr>
+        <p:txBody>
+          <a:bodyPr/>
+          <a:lstStyle/>
+          <a:p>
+            <a:pPr lvl="0" indent="0" marL="0" algn="ctr">
+              <a:buNone/>
+            </a:pPr>
+            <a:r>
+              <a:rPr/>
+              <a:t>Querying STGraph</a:t>
+            </a:r>
+          </a:p>
+        </p:txBody>
+      </p:sp>
       <p:sp>
         <p:nvSpPr>
           <p:cNvPr id="4" name="Content Placeholder 3"/>
@@ -3589,12 +3644,8 @@
           <a:p>
             <a:pPr lvl="0"/>
             <a:r>
-              <a:rPr b="1"/>
+              <a:rPr/>
               <a:t>Hybrid storage</a:t>
-            </a:r>
-            <a:r>
-              <a:rPr/>
-              <a:t>:</a:t>
             </a:r>
           </a:p>
           <a:p>
@@ -3644,6 +3695,31 @@
       </p:grpSpPr>
       <p:sp>
         <p:nvSpPr>
+          <p:cNvPr id="2" name="Title 1"/>
+          <p:cNvSpPr>
+            <a:spLocks noGrp="1"/>
+          </p:cNvSpPr>
+          <p:nvPr>
+            <p:ph type="title"/>
+          </p:nvPr>
+        </p:nvSpPr>
+        <p:spPr/>
+        <p:txBody>
+          <a:bodyPr/>
+          <a:lstStyle/>
+          <a:p>
+            <a:pPr lvl="0" indent="0" marL="0">
+              <a:buNone/>
+            </a:pPr>
+            <a:r>
+              <a:rPr/>
+              <a:t>Anomaly Detection in Complex Sensor Networks</a:t>
+            </a:r>
+          </a:p>
+        </p:txBody>
+      </p:sp>
+      <p:sp>
+        <p:nvSpPr>
           <p:cNvPr id="3" name="Content Placeholder 2"/>
           <p:cNvSpPr>
             <a:spLocks noGrp="1"/>
@@ -3657,21 +3733,24 @@
           <a:bodyPr/>
           <a:lstStyle/>
           <a:p>
-            <a:pPr lvl="0" indent="0" marL="0">
-              <a:buNone/>
-            </a:pPr>
-            <a:r>
-              <a:rPr/>
-              <a:t>Querying STGraph</a:t>
-            </a:r>
-          </a:p>
-          <a:p>
-            <a:pPr lvl="0" indent="0" marL="0">
-              <a:buNone/>
-            </a:pPr>
-            <a:r>
-              <a:rPr/>
-              <a:t>Querying STGraph</a:t>
+            <a:pPr lvl="0"/>
+            <a:r>
+              <a:rPr/>
+              <a:t>Complex sensor networks are increasingly common</a:t>
+            </a:r>
+          </a:p>
+          <a:p>
+            <a:pPr lvl="0"/>
+            <a:r>
+              <a:rPr/>
+              <a:t>Anomaly detection in time-series data is a well-known research field</a:t>
+            </a:r>
+          </a:p>
+          <a:p>
+            <a:pPr lvl="0"/>
+            <a:r>
+              <a:rPr b="1"/>
+              <a:t>What about anomalies that are cross-time series?</a:t>
             </a:r>
           </a:p>
         </p:txBody>
@@ -3682,90 +3761,6 @@
 </file>
 
 <file path=ppt/slides/slide14.xml><?xml version="1.0" encoding="utf-8"?>
-<p:sld xmlns:a="http://schemas.openxmlformats.org/drawingml/2006/main" xmlns:r="http://schemas.openxmlformats.org/officeDocument/2006/relationships" xmlns:p="http://schemas.openxmlformats.org/presentationml/2006/main">
-  <p:cSld>
-    <p:spTree>
-      <p:nvGrpSpPr>
-        <p:cNvPr id="1" name=""/>
-        <p:cNvGrpSpPr/>
-        <p:nvPr/>
-      </p:nvGrpSpPr>
-      <p:grpSpPr>
-        <a:xfrm>
-          <a:off x="0" y="0"/>
-          <a:ext cx="0" cy="0"/>
-          <a:chOff x="0" y="0"/>
-          <a:chExt cx="0" cy="0"/>
-        </a:xfrm>
-      </p:grpSpPr>
-      <p:sp>
-        <p:nvSpPr>
-          <p:cNvPr id="2" name="Title 1"/>
-          <p:cNvSpPr>
-            <a:spLocks noGrp="1"/>
-          </p:cNvSpPr>
-          <p:nvPr>
-            <p:ph type="title"/>
-          </p:nvPr>
-        </p:nvSpPr>
-        <p:spPr/>
-        <p:txBody>
-          <a:bodyPr/>
-          <a:lstStyle/>
-          <a:p>
-            <a:pPr lvl="0" indent="0" marL="0">
-              <a:buNone/>
-            </a:pPr>
-            <a:r>
-              <a:rPr/>
-              <a:t>Anomaly Detection in Complex Sensor Networks</a:t>
-            </a:r>
-          </a:p>
-        </p:txBody>
-      </p:sp>
-      <p:sp>
-        <p:nvSpPr>
-          <p:cNvPr id="3" name="Content Placeholder 2"/>
-          <p:cNvSpPr>
-            <a:spLocks noGrp="1"/>
-          </p:cNvSpPr>
-          <p:nvPr>
-            <p:ph idx="1"/>
-          </p:nvPr>
-        </p:nvSpPr>
-        <p:spPr/>
-        <p:txBody>
-          <a:bodyPr/>
-          <a:lstStyle/>
-          <a:p>
-            <a:pPr lvl="0"/>
-            <a:r>
-              <a:rPr/>
-              <a:t>Complex sensor networks are increasingly common</a:t>
-            </a:r>
-          </a:p>
-          <a:p>
-            <a:pPr lvl="0"/>
-            <a:r>
-              <a:rPr/>
-              <a:t>Anomaly detection in time-series data is a well-known research field</a:t>
-            </a:r>
-          </a:p>
-          <a:p>
-            <a:pPr lvl="0"/>
-            <a:r>
-              <a:rPr b="1"/>
-              <a:t>What about anomalies that are cross-time series?</a:t>
-            </a:r>
-          </a:p>
-        </p:txBody>
-      </p:sp>
-    </p:spTree>
-  </p:cSld>
-</p:sld>
-</file>
-
-<file path=ppt/slides/slide15.xml><?xml version="1.0" encoding="utf-8"?>
 <p:sld xmlns:a="http://schemas.openxmlformats.org/drawingml/2006/main" xmlns:r="http://schemas.openxmlformats.org/officeDocument/2006/relationships" xmlns:p="http://schemas.openxmlformats.org/presentationml/2006/main">
   <p:cSld>
     <p:spTree>
@@ -3907,7 +3902,7 @@
 </p:sld>
 </file>
 
-<file path=ppt/slides/slide16.xml><?xml version="1.0" encoding="utf-8"?>
+<file path=ppt/slides/slide15.xml><?xml version="1.0" encoding="utf-8"?>
 <p:sld xmlns:a="http://schemas.openxmlformats.org/drawingml/2006/main" xmlns:r="http://schemas.openxmlformats.org/officeDocument/2006/relationships" xmlns:p="http://schemas.openxmlformats.org/presentationml/2006/main">
   <p:cSld>
     <p:spTree>
@@ -3954,7 +3949,7 @@
 </p:sld>
 </file>
 
-<file path=ppt/slides/slide17.xml><?xml version="1.0" encoding="utf-8"?>
+<file path=ppt/slides/slide16.xml><?xml version="1.0" encoding="utf-8"?>
 <p:sld xmlns:a="http://schemas.openxmlformats.org/drawingml/2006/main" xmlns:r="http://schemas.openxmlformats.org/officeDocument/2006/relationships" xmlns:p="http://schemas.openxmlformats.org/presentationml/2006/main">
   <p:cSld>
     <p:spTree>
@@ -4813,7 +4808,7 @@
             </a:pPr>
             <a:r>
               <a:rPr/>
-              <a:t>Prescriptive watering: Data-driven optimization of water consumption in kiwifruit orchards</a:t>
+              <a:t>SMARTER: Data-driven optimization of water consumption in kiwifruit orchards</a:t>
             </a:r>
           </a:p>
         </p:txBody>
@@ -5039,7 +5034,7 @@
             </a:pPr>
             <a:r>
               <a:rPr/>
-              <a:t>Prescriptive watering: Data-driven optimization of water consumption in kiwifruit orchards</a:t>
+              <a:t>SMARTER: Data-driven optimization of water consumption in kiwifruit orchards</a:t>
             </a:r>
           </a:p>
         </p:txBody>

</xml_diff>

<commit_message>
Deploying to gh-pages from @ ManuelePasini/slides-markdown@42cb4fb7b8bd27c552efc332ad2a89aaf59320a0 🚀
</commit_message>
<xml_diff>
--- a/3rd_year_slides.pptx
+++ b/3rd_year_slides.pptx
@@ -5046,7 +5046,7 @@
             <a:spLocks noGrp="1"/>
           </p:cNvSpPr>
           <p:nvPr>
-            <p:ph idx="1"/>
+            <p:ph idx="1" sz="half"/>
           </p:nvPr>
         </p:nvSpPr>
         <p:spPr/>
@@ -5078,8 +5078,8 @@
         </p:blipFill>
         <p:spPr bwMode="auto">
           <a:xfrm>
-            <a:off x="1485900" y="1193800"/>
-            <a:ext cx="6172200" cy="2882900"/>
+            <a:off x="457200" y="1689100"/>
+            <a:ext cx="4038600" cy="1892300"/>
           </a:xfrm>
           <a:prstGeom prst="rect">
             <a:avLst/>
@@ -5101,7 +5101,7 @@
         <p:spPr>
           <a:xfrm>
             <a:off x="457200" y="4076700"/>
-            <a:ext cx="8229600" cy="508000"/>
+            <a:ext cx="4038600" cy="508000"/>
           </a:xfrm>
           <a:prstGeom prst="rect">
             <a:avLst/>
@@ -5118,6 +5118,149 @@
             <a:r>
               <a:rPr/>
               <a:t>An overview of SMARTER</a:t>
+            </a:r>
+          </a:p>
+        </p:txBody>
+      </p:sp>
+      <p:sp>
+        <p:nvSpPr>
+          <p:cNvPr id="4" name="Content Placeholder 3"/>
+          <p:cNvSpPr>
+            <a:spLocks noGrp="1"/>
+          </p:cNvSpPr>
+          <p:nvPr>
+            <p:ph idx="2" sz="half"/>
+          </p:nvPr>
+        </p:nvSpPr>
+        <p:spPr/>
+        <p:txBody>
+          <a:bodyPr/>
+          <a:lstStyle/>
+          <a:p>
+            <a:pPr lvl="0"/>
+            <a:r>
+              <a:rPr/>
+              <a:t>Up to 40% in water savings, fruit quality preserved</a:t>
+            </a:r>
+          </a:p>
+        </p:txBody>
+      </p:sp>
+      <p:pic>
+        <p:nvPicPr>
+          <p:cNvPr descr="https://github.com/ManuelePasini/slides-markdown/blob/master/slides/images/phd3rdyear/smarter_results.png?raw=true" id="0" name="Picture 1"/>
+          <p:cNvPicPr>
+            <a:picLocks noGrp="1" noChangeAspect="1"/>
+          </p:cNvPicPr>
+          <p:nvPr/>
+        </p:nvPicPr>
+        <p:blipFill>
+          <a:blip r:embed="rId3"/>
+          <a:stretch>
+            <a:fillRect/>
+          </a:stretch>
+        </p:blipFill>
+        <p:spPr bwMode="auto">
+          <a:xfrm>
+            <a:off x="4648200" y="1701800"/>
+            <a:ext cx="4038600" cy="1866900"/>
+          </a:xfrm>
+          <a:prstGeom prst="rect">
+            <a:avLst/>
+          </a:prstGeom>
+          <a:noFill/>
+          <a:ln w="9525">
+            <a:noFill/>
+            <a:headEnd/>
+            <a:tailEnd/>
+          </a:ln>
+        </p:spPr>
+      </p:pic>
+      <p:sp>
+        <p:nvSpPr>
+          <p:cNvPr id="1" name="TextBox 3"/>
+          <p:cNvSpPr txBox="1"/>
+          <p:nvPr/>
+        </p:nvSpPr>
+        <p:spPr>
+          <a:xfrm>
+            <a:off x="4648200" y="4076700"/>
+            <a:ext cx="4038600" cy="508000"/>
+          </a:xfrm>
+          <a:prstGeom prst="rect">
+            <a:avLst/>
+          </a:prstGeom>
+          <a:noFill/>
+        </p:spPr>
+        <p:txBody>
+          <a:bodyPr/>
+          <a:lstStyle/>
+          <a:p>
+            <a:pPr lvl="0" indent="0" marL="0" algn="ctr">
+              <a:buNone/>
+            </a:pPr>
+            <a:r>
+              <a:rPr/>
+              <a:t>Water saving results</a:t>
+            </a:r>
+          </a:p>
+        </p:txBody>
+      </p:sp>
+      <p:pic>
+        <p:nvPicPr>
+          <p:cNvPr descr="https://github.com/ManuelePasini/slides-markdown/blob/master/slides/images/phd3rdyear/smarter_fruit_results.png?raw=true" id="0" name="Picture 1"/>
+          <p:cNvPicPr>
+            <a:picLocks noGrp="1" noChangeAspect="1"/>
+          </p:cNvPicPr>
+          <p:nvPr/>
+        </p:nvPicPr>
+        <p:blipFill>
+          <a:blip r:embed="rId4"/>
+          <a:stretch>
+            <a:fillRect/>
+          </a:stretch>
+        </p:blipFill>
+        <p:spPr bwMode="auto">
+          <a:xfrm>
+            <a:off x="4648200" y="1981200"/>
+            <a:ext cx="4038600" cy="1308100"/>
+          </a:xfrm>
+          <a:prstGeom prst="rect">
+            <a:avLst/>
+          </a:prstGeom>
+          <a:noFill/>
+          <a:ln w="9525">
+            <a:noFill/>
+            <a:headEnd/>
+            <a:tailEnd/>
+          </a:ln>
+        </p:spPr>
+      </p:pic>
+      <p:sp>
+        <p:nvSpPr>
+          <p:cNvPr id="1" name="TextBox 3"/>
+          <p:cNvSpPr txBox="1"/>
+          <p:nvPr/>
+        </p:nvSpPr>
+        <p:spPr>
+          <a:xfrm>
+            <a:off x="4648200" y="4076700"/>
+            <a:ext cx="4038600" cy="508000"/>
+          </a:xfrm>
+          <a:prstGeom prst="rect">
+            <a:avLst/>
+          </a:prstGeom>
+          <a:noFill/>
+        </p:spPr>
+        <p:txBody>
+          <a:bodyPr/>
+          <a:lstStyle/>
+          <a:p>
+            <a:pPr lvl="0" indent="0" marL="0" algn="ctr">
+              <a:buNone/>
+            </a:pPr>
+            <a:r>
+              <a:rPr/>
+              <a:t>Fruit quality results</a:t>
             </a:r>
           </a:p>
         </p:txBody>

</xml_diff>

<commit_message>
Deploying to gh-pages from @ ManuelePasini/slides-markdown@dcbee070561eb53c2fdd8ea5b1b3c4003a20b1ca 🚀
</commit_message>
<xml_diff>
--- a/3rd_year_slides.pptx
+++ b/3rd_year_slides.pptx
@@ -3343,6 +3343,66 @@
       </p:sp>
       <p:pic>
         <p:nvPicPr>
+          <p:cNvPr descr="https://github.com/ManuelePasini/slides-markdown/blob/master/slides/images/phd3rdyear/datamodel.svg?raw=true" id="0" name="Picture 1"/>
+          <p:cNvPicPr>
+            <a:picLocks noGrp="1" noChangeAspect="1"/>
+          </p:cNvPicPr>
+          <p:nvPr/>
+        </p:nvPicPr>
+        <p:blipFill>
+          <a:blip r:embed="rId2"/>
+          <a:stretch>
+            <a:fillRect/>
+          </a:stretch>
+        </p:blipFill>
+        <p:spPr bwMode="auto">
+          <a:xfrm>
+            <a:off x="457200" y="1295400"/>
+            <a:ext cx="4038600" cy="2692400"/>
+          </a:xfrm>
+          <a:prstGeom prst="rect">
+            <a:avLst/>
+          </a:prstGeom>
+          <a:noFill/>
+          <a:ln w="9525">
+            <a:noFill/>
+            <a:headEnd/>
+            <a:tailEnd/>
+          </a:ln>
+        </p:spPr>
+      </p:pic>
+      <p:sp>
+        <p:nvSpPr>
+          <p:cNvPr id="1" name="TextBox 3"/>
+          <p:cNvSpPr txBox="1"/>
+          <p:nvPr/>
+        </p:nvSpPr>
+        <p:spPr>
+          <a:xfrm>
+            <a:off x="457200" y="4076700"/>
+            <a:ext cx="4038600" cy="508000"/>
+          </a:xfrm>
+          <a:prstGeom prst="rect">
+            <a:avLst/>
+          </a:prstGeom>
+          <a:noFill/>
+        </p:spPr>
+        <p:txBody>
+          <a:bodyPr/>
+          <a:lstStyle/>
+          <a:p>
+            <a:pPr lvl="0" indent="0" marL="0" algn="ctr">
+              <a:buNone/>
+            </a:pPr>
+            <a:r>
+              <a:rPr/>
+              <a:t>STGraph Data Model</a:t>
+            </a:r>
+          </a:p>
+        </p:txBody>
+      </p:sp>
+      <p:pic>
+        <p:nvPicPr>
           <p:cNvPr descr="https://github.com/ManuelePasini/slides-markdown/blob/master/slides/images/phd3rdyear/arch.svg?raw=true" id="0" name="Picture 1"/>
           <p:cNvPicPr>
             <a:picLocks noGrp="1" noChangeAspect="1"/>
@@ -3350,7 +3410,7 @@
           <p:nvPr/>
         </p:nvPicPr>
         <p:blipFill>
-          <a:blip r:embed="rId2"/>
+          <a:blip r:embed="rId3"/>
           <a:stretch>
             <a:fillRect/>
           </a:stretch>
@@ -3423,9 +3483,137 @@
           <a:chExt cx="0" cy="0"/>
         </a:xfrm>
       </p:grpSpPr>
+      <p:sp>
+        <p:nvSpPr>
+          <p:cNvPr id="2" name="Title 1"/>
+          <p:cNvSpPr>
+            <a:spLocks noGrp="1"/>
+          </p:cNvSpPr>
+          <p:nvPr>
+            <p:ph type="title"/>
+          </p:nvPr>
+        </p:nvSpPr>
+        <p:spPr/>
+        <p:txBody>
+          <a:bodyPr/>
+          <a:lstStyle/>
+          <a:p>
+            <a:pPr lvl="0" indent="0" marL="0">
+              <a:buNone/>
+            </a:pPr>
+            <a:r>
+              <a:rPr/>
+              <a:t>STGraph: A Multistore for Temporal Graphs and Time-Series</a:t>
+            </a:r>
+          </a:p>
+        </p:txBody>
+      </p:sp>
+      <p:sp>
+        <p:nvSpPr>
+          <p:cNvPr id="3" name="Content Placeholder 2"/>
+          <p:cNvSpPr>
+            <a:spLocks noGrp="1"/>
+          </p:cNvSpPr>
+          <p:nvPr>
+            <p:ph idx="1" sz="half"/>
+          </p:nvPr>
+        </p:nvSpPr>
+        <p:spPr/>
+        <p:txBody>
+          <a:bodyPr/>
+          <a:lstStyle/>
+          <a:p>
+            <a:pPr lvl="0"/>
+            <a:r>
+              <a:rPr/>
+              <a:t>Property Graph data model</a:t>
+            </a:r>
+          </a:p>
+          <a:p>
+            <a:pPr lvl="1"/>
+            <a:r>
+              <a:rPr/>
+              <a:t>TS events (nodes) can hold edges and properties</a:t>
+            </a:r>
+          </a:p>
+          <a:p>
+            <a:pPr lvl="1"/>
+            <a:r>
+              <a:rPr/>
+              <a:t>Edges built at query time</a:t>
+            </a:r>
+          </a:p>
+        </p:txBody>
+      </p:sp>
+      <p:sp>
+        <p:nvSpPr>
+          <p:cNvPr id="4" name="Content Placeholder 3"/>
+          <p:cNvSpPr>
+            <a:spLocks noGrp="1"/>
+          </p:cNvSpPr>
+          <p:nvPr>
+            <p:ph idx="2" sz="half"/>
+          </p:nvPr>
+        </p:nvSpPr>
+        <p:spPr/>
+        <p:txBody>
+          <a:bodyPr/>
+          <a:lstStyle/>
+          <a:p>
+            <a:pPr lvl="0"/>
+            <a:r>
+              <a:rPr/>
+              <a:t>Hybrid storage</a:t>
+            </a:r>
+          </a:p>
+          <a:p>
+            <a:pPr lvl="1"/>
+            <a:r>
+              <a:rPr/>
+              <a:t>Dedicated Time-Series streaming ingestion of data</a:t>
+            </a:r>
+          </a:p>
+          <a:p>
+            <a:pPr lvl="1"/>
+            <a:r>
+              <a:rPr/>
+              <a:t>Query optimization through filter-pushdown</a:t>
+            </a:r>
+          </a:p>
+          <a:p>
+            <a:pPr lvl="1"/>
+            <a:r>
+              <a:rPr/>
+              <a:t>Efficient graph traversal &amp; temporal reasoning</a:t>
+            </a:r>
+          </a:p>
+        </p:txBody>
+      </p:sp>
+    </p:spTree>
+  </p:cSld>
+</p:sld>
+</file>
+
+<file path=ppt/slides/slide12.xml><?xml version="1.0" encoding="utf-8"?>
+<p:sld xmlns:a="http://schemas.openxmlformats.org/drawingml/2006/main" xmlns:r="http://schemas.openxmlformats.org/officeDocument/2006/relationships" xmlns:p="http://schemas.openxmlformats.org/presentationml/2006/main">
+  <p:cSld>
+    <p:spTree>
+      <p:nvGrpSpPr>
+        <p:cNvPr id="1" name=""/>
+        <p:cNvGrpSpPr/>
+        <p:nvPr/>
+      </p:nvGrpSpPr>
+      <p:grpSpPr>
+        <a:xfrm>
+          <a:off x="0" y="0"/>
+          <a:ext cx="0" cy="0"/>
+          <a:chOff x="0" y="0"/>
+          <a:chExt cx="0" cy="0"/>
+        </a:xfrm>
+      </p:grpSpPr>
       <p:pic>
         <p:nvPicPr>
-          <p:cNvPr descr="https://github.com/ManuelePasini/slides-markdown/blob/master/slides/images/phd3rdyear/datamodel.svg?raw=true" id="0" name="Picture 1"/>
+          <p:cNvPr descr="https://github.com/ManuelePasini/slides-markdown/blob/master/slides/images/phd3rdyear/example.svg?raw=true" id="0" name="Picture 1"/>
           <p:cNvPicPr>
             <a:picLocks noGrp="1" noChangeAspect="1"/>
           </p:cNvPicPr>
@@ -3478,195 +3666,7 @@
             </a:pPr>
             <a:r>
               <a:rPr/>
-              <a:t>STGraph Data Model</a:t>
-            </a:r>
-          </a:p>
-        </p:txBody>
-      </p:sp>
-    </p:spTree>
-  </p:cSld>
-</p:sld>
-</file>
-
-<file path=ppt/slides/slide12.xml><?xml version="1.0" encoding="utf-8"?>
-<p:sld xmlns:a="http://schemas.openxmlformats.org/drawingml/2006/main" xmlns:r="http://schemas.openxmlformats.org/officeDocument/2006/relationships" xmlns:p="http://schemas.openxmlformats.org/presentationml/2006/main">
-  <p:cSld>
-    <p:spTree>
-      <p:nvGrpSpPr>
-        <p:cNvPr id="1" name=""/>
-        <p:cNvGrpSpPr/>
-        <p:nvPr/>
-      </p:nvGrpSpPr>
-      <p:grpSpPr>
-        <a:xfrm>
-          <a:off x="0" y="0"/>
-          <a:ext cx="0" cy="0"/>
-          <a:chOff x="0" y="0"/>
-          <a:chExt cx="0" cy="0"/>
-        </a:xfrm>
-      </p:grpSpPr>
-      <p:sp>
-        <p:nvSpPr>
-          <p:cNvPr id="2" name="Title 1"/>
-          <p:cNvSpPr>
-            <a:spLocks noGrp="1"/>
-          </p:cNvSpPr>
-          <p:nvPr>
-            <p:ph type="title"/>
-          </p:nvPr>
-        </p:nvSpPr>
-        <p:spPr/>
-        <p:txBody>
-          <a:bodyPr/>
-          <a:lstStyle/>
-          <a:p>
-            <a:pPr lvl="0" indent="0" marL="0">
-              <a:buNone/>
-            </a:pPr>
-            <a:r>
-              <a:rPr/>
-              <a:t>STGraph: A Multistore for Temporal Graphs and Time-Series</a:t>
-            </a:r>
-          </a:p>
-        </p:txBody>
-      </p:sp>
-      <p:sp>
-        <p:nvSpPr>
-          <p:cNvPr id="3" name="Content Placeholder 2"/>
-          <p:cNvSpPr>
-            <a:spLocks noGrp="1"/>
-          </p:cNvSpPr>
-          <p:nvPr>
-            <p:ph idx="1" sz="half"/>
-          </p:nvPr>
-        </p:nvSpPr>
-        <p:spPr/>
-        <p:txBody>
-          <a:bodyPr/>
-          <a:lstStyle/>
-          <a:p>
-            <a:pPr lvl="0"/>
-            <a:r>
-              <a:rPr/>
-              <a:t>Property Graph data model</a:t>
-            </a:r>
-          </a:p>
-          <a:p>
-            <a:pPr lvl="1"/>
-            <a:r>
-              <a:rPr/>
-              <a:t>TS events (nodes) can hold edges and properties</a:t>
-            </a:r>
-          </a:p>
-          <a:p>
-            <a:pPr lvl="1"/>
-            <a:r>
-              <a:rPr/>
-              <a:t>Edges built at query time</a:t>
-            </a:r>
-          </a:p>
-        </p:txBody>
-      </p:sp>
-      <p:pic>
-        <p:nvPicPr>
-          <p:cNvPr descr="https://github.com/ManuelePasini/slides-markdown/blob/master/slides/images/phd3rdyear/example.svg?raw=true" id="0" name="Picture 1"/>
-          <p:cNvPicPr>
-            <a:picLocks noGrp="1" noChangeAspect="1"/>
-          </p:cNvPicPr>
-          <p:nvPr/>
-        </p:nvPicPr>
-        <p:blipFill>
-          <a:blip r:embed="rId2"/>
-          <a:stretch>
-            <a:fillRect/>
-          </a:stretch>
-        </p:blipFill>
-        <p:spPr bwMode="auto">
-          <a:xfrm>
-            <a:off x="457200" y="1295400"/>
-            <a:ext cx="4038600" cy="2692400"/>
-          </a:xfrm>
-          <a:prstGeom prst="rect">
-            <a:avLst/>
-          </a:prstGeom>
-          <a:noFill/>
-          <a:ln w="9525">
-            <a:noFill/>
-            <a:headEnd/>
-            <a:tailEnd/>
-          </a:ln>
-        </p:spPr>
-      </p:pic>
-      <p:sp>
-        <p:nvSpPr>
-          <p:cNvPr id="1" name="TextBox 3"/>
-          <p:cNvSpPr txBox="1"/>
-          <p:nvPr/>
-        </p:nvSpPr>
-        <p:spPr>
-          <a:xfrm>
-            <a:off x="457200" y="4076700"/>
-            <a:ext cx="4038600" cy="508000"/>
-          </a:xfrm>
-          <a:prstGeom prst="rect">
-            <a:avLst/>
-          </a:prstGeom>
-          <a:noFill/>
-        </p:spPr>
-        <p:txBody>
-          <a:bodyPr/>
-          <a:lstStyle/>
-          <a:p>
-            <a:pPr lvl="0" indent="0" marL="0" algn="ctr">
-              <a:buNone/>
-            </a:pPr>
-            <a:r>
-              <a:rPr/>
               <a:t>Querying STGraph</a:t>
-            </a:r>
-          </a:p>
-        </p:txBody>
-      </p:sp>
-      <p:sp>
-        <p:nvSpPr>
-          <p:cNvPr id="4" name="Content Placeholder 3"/>
-          <p:cNvSpPr>
-            <a:spLocks noGrp="1"/>
-          </p:cNvSpPr>
-          <p:nvPr>
-            <p:ph idx="2" sz="half"/>
-          </p:nvPr>
-        </p:nvSpPr>
-        <p:spPr/>
-        <p:txBody>
-          <a:bodyPr/>
-          <a:lstStyle/>
-          <a:p>
-            <a:pPr lvl="0"/>
-            <a:r>
-              <a:rPr/>
-              <a:t>Hybrid storage</a:t>
-            </a:r>
-          </a:p>
-          <a:p>
-            <a:pPr lvl="1"/>
-            <a:r>
-              <a:rPr/>
-              <a:t>Dedicated Time-Series streaming ingestion of data</a:t>
-            </a:r>
-          </a:p>
-          <a:p>
-            <a:pPr lvl="1"/>
-            <a:r>
-              <a:rPr/>
-              <a:t>Query optimization through filter-pushdown</a:t>
-            </a:r>
-          </a:p>
-          <a:p>
-            <a:pPr lvl="1"/>
-            <a:r>
-              <a:rPr/>
-              <a:t>Efficient graph traversal &amp; temporal reasoning</a:t>
             </a:r>
           </a:p>
         </p:txBody>

</xml_diff>

<commit_message>
Deploying to gh-pages from @ ManuelePasini/slides-markdown@7b825cf0adcbc845dab7ee5afc2e2b7e5df31059 🚀
</commit_message>
<xml_diff>
--- a/3rd_year_slides.pptx
+++ b/3rd_year_slides.pptx
@@ -21,6 +21,7 @@
     <p:sldId id="269" r:id="rId15"/>
     <p:sldId id="270" r:id="rId16"/>
     <p:sldId id="271" r:id="rId17"/>
+    <p:sldId id="272" r:id="rId18"/>
   </p:sldIdLst>
   <p:sldSz cx="9144000" cy="5143500" type="screen16x9"/>
   <p:notesSz cx="6858000" cy="9144000"/>
@@ -3267,31 +3268,6 @@
       </p:grpSpPr>
       <p:sp>
         <p:nvSpPr>
-          <p:cNvPr id="2" name="Title 1"/>
-          <p:cNvSpPr>
-            <a:spLocks noGrp="1"/>
-          </p:cNvSpPr>
-          <p:nvPr>
-            <p:ph type="title"/>
-          </p:nvPr>
-        </p:nvSpPr>
-        <p:spPr/>
-        <p:txBody>
-          <a:bodyPr/>
-          <a:lstStyle/>
-          <a:p>
-            <a:pPr lvl="0" indent="0" marL="0">
-              <a:buNone/>
-            </a:pPr>
-            <a:r>
-              <a:rPr/>
-              <a:t>STGraph: A Multistore for Temporal Graphs and Time-Series</a:t>
-            </a:r>
-          </a:p>
-        </p:txBody>
-      </p:sp>
-      <p:sp>
-        <p:nvSpPr>
           <p:cNvPr id="3" name="Content Placeholder 2"/>
           <p:cNvSpPr>
             <a:spLocks noGrp="1"/>
@@ -3308,42 +3284,14 @@
             <a:pPr lvl="0"/>
             <a:r>
               <a:rPr/>
-              <a:t>A multistore solution for large spatio-temporal property graphs</a:t>
-            </a:r>
-          </a:p>
-          <a:p>
-            <a:pPr lvl="1"/>
-            <a:r>
-              <a:rPr/>
-              <a:t>Graph data model on top of heterogeneous storage</a:t>
-            </a:r>
-          </a:p>
-          <a:p>
-            <a:pPr lvl="2"/>
-            <a:r>
-              <a:rPr/>
-              <a:t>Low-evolving data on Graph storage</a:t>
-            </a:r>
-          </a:p>
-          <a:p>
-            <a:pPr lvl="2"/>
-            <a:r>
-              <a:rPr/>
-              <a:t>Highly-dynamic data on Time-Series storage</a:t>
-            </a:r>
-          </a:p>
-          <a:p>
-            <a:pPr lvl="1"/>
-            <a:r>
-              <a:rPr/>
-              <a:t>Transparent graph query interface.</a:t>
+              <a:t>PID controller + simulation model to determine irrigaton amounts</a:t>
             </a:r>
           </a:p>
         </p:txBody>
       </p:sp>
       <p:pic>
         <p:nvPicPr>
-          <p:cNvPr descr="https://github.com/ManuelePasini/slides-markdown/blob/master/slides/images/phd3rdyear/datamodel.svg?raw=true" id="0" name="Picture 1"/>
+          <p:cNvPr descr="https://github.com/ManuelePasini/slides-markdown/blob/master/slides/images/phd3rdyear/smarter.svg?raw=true" id="0" name="Picture 1"/>
           <p:cNvPicPr>
             <a:picLocks noGrp="1" noChangeAspect="1"/>
           </p:cNvPicPr>
@@ -3357,8 +3305,8 @@
         </p:blipFill>
         <p:spPr bwMode="auto">
           <a:xfrm>
-            <a:off x="457200" y="1295400"/>
-            <a:ext cx="4038600" cy="2692400"/>
+            <a:off x="457200" y="1689100"/>
+            <a:ext cx="4038600" cy="1892300"/>
           </a:xfrm>
           <a:prstGeom prst="rect">
             <a:avLst/>
@@ -3396,14 +3344,44 @@
             </a:pPr>
             <a:r>
               <a:rPr/>
-              <a:t>STGraph Data Model</a:t>
+              <a:t>An overview of SMARTER</a:t>
+            </a:r>
+          </a:p>
+        </p:txBody>
+      </p:sp>
+      <p:sp>
+        <p:nvSpPr>
+          <p:cNvPr id="4" name="Content Placeholder 3"/>
+          <p:cNvSpPr>
+            <a:spLocks noGrp="1"/>
+          </p:cNvSpPr>
+          <p:nvPr>
+            <p:ph idx="2" sz="half"/>
+          </p:nvPr>
+        </p:nvSpPr>
+        <p:spPr/>
+        <p:txBody>
+          <a:bodyPr/>
+          <a:lstStyle/>
+          <a:p>
+            <a:pPr lvl="0"/>
+            <a:r>
+              <a:rPr/>
+              <a:t>Up to 40% in water savings</a:t>
+            </a:r>
+          </a:p>
+          <a:p>
+            <a:pPr lvl="0"/>
+            <a:r>
+              <a:rPr/>
+              <a:t>Fruit quality preserved, smaller fruit but of improved quality</a:t>
             </a:r>
           </a:p>
         </p:txBody>
       </p:sp>
       <p:pic>
         <p:nvPicPr>
-          <p:cNvPr descr="https://github.com/ManuelePasini/slides-markdown/blob/master/slides/images/phd3rdyear/arch.svg?raw=true" id="0" name="Picture 1"/>
+          <p:cNvPr descr="https://github.com/ManuelePasini/slides-markdown/blob/master/slides/images/phd3rdyear/smarter_results.png?raw=true" id="0" name="Picture 1"/>
           <p:cNvPicPr>
             <a:picLocks noGrp="1" noChangeAspect="1"/>
           </p:cNvPicPr>
@@ -3417,8 +3395,8 @@
         </p:blipFill>
         <p:spPr bwMode="auto">
           <a:xfrm>
-            <a:off x="4648200" y="1333500"/>
-            <a:ext cx="4038600" cy="2603500"/>
+            <a:off x="4648200" y="1701800"/>
+            <a:ext cx="4038600" cy="1866900"/>
           </a:xfrm>
           <a:prstGeom prst="rect">
             <a:avLst/>
@@ -3456,7 +3434,67 @@
             </a:pPr>
             <a:r>
               <a:rPr/>
-              <a:t>STGraph Architecture</a:t>
+              <a:t>Water saving results</a:t>
+            </a:r>
+          </a:p>
+        </p:txBody>
+      </p:sp>
+      <p:pic>
+        <p:nvPicPr>
+          <p:cNvPr descr="https://github.com/ManuelePasini/slides-markdown/blob/master/slides/images/phd3rdyear/smarter_fruit_results.png?raw=true" id="0" name="Picture 1"/>
+          <p:cNvPicPr>
+            <a:picLocks noGrp="1" noChangeAspect="1"/>
+          </p:cNvPicPr>
+          <p:nvPr/>
+        </p:nvPicPr>
+        <p:blipFill>
+          <a:blip r:embed="rId4"/>
+          <a:stretch>
+            <a:fillRect/>
+          </a:stretch>
+        </p:blipFill>
+        <p:spPr bwMode="auto">
+          <a:xfrm>
+            <a:off x="4648200" y="1981200"/>
+            <a:ext cx="4038600" cy="1308100"/>
+          </a:xfrm>
+          <a:prstGeom prst="rect">
+            <a:avLst/>
+          </a:prstGeom>
+          <a:noFill/>
+          <a:ln w="9525">
+            <a:noFill/>
+            <a:headEnd/>
+            <a:tailEnd/>
+          </a:ln>
+        </p:spPr>
+      </p:pic>
+      <p:sp>
+        <p:nvSpPr>
+          <p:cNvPr id="1" name="TextBox 3"/>
+          <p:cNvSpPr txBox="1"/>
+          <p:nvPr/>
+        </p:nvSpPr>
+        <p:spPr>
+          <a:xfrm>
+            <a:off x="4648200" y="4076700"/>
+            <a:ext cx="4038600" cy="508000"/>
+          </a:xfrm>
+          <a:prstGeom prst="rect">
+            <a:avLst/>
+          </a:prstGeom>
+          <a:noFill/>
+        </p:spPr>
+        <p:txBody>
+          <a:bodyPr/>
+          <a:lstStyle/>
+          <a:p>
+            <a:pPr lvl="0" indent="0" marL="0" algn="ctr">
+              <a:buNone/>
+            </a:pPr>
+            <a:r>
+              <a:rPr/>
+              <a:t>Fruit quality results</a:t>
             </a:r>
           </a:p>
         </p:txBody>
@@ -3526,65 +3564,168 @@
             <a:pPr lvl="0"/>
             <a:r>
               <a:rPr/>
-              <a:t>Property Graph data model</a:t>
+              <a:t>A multistore solution for large spatio-temporal property graphs</a:t>
             </a:r>
           </a:p>
           <a:p>
             <a:pPr lvl="1"/>
             <a:r>
               <a:rPr/>
-              <a:t>TS events (nodes) can hold edges and properties</a:t>
+              <a:t>Graph data model on top of heterogeneous storage</a:t>
+            </a:r>
+          </a:p>
+          <a:p>
+            <a:pPr lvl="2"/>
+            <a:r>
+              <a:rPr/>
+              <a:t>Low-evolving data on Graph storage</a:t>
+            </a:r>
+          </a:p>
+          <a:p>
+            <a:pPr lvl="2"/>
+            <a:r>
+              <a:rPr/>
+              <a:t>Highly-dynamic data on Time-Series storage</a:t>
             </a:r>
           </a:p>
           <a:p>
             <a:pPr lvl="1"/>
             <a:r>
               <a:rPr/>
-              <a:t>Edges built at query time</a:t>
-            </a:r>
-          </a:p>
-        </p:txBody>
-      </p:sp>
-      <p:sp>
-        <p:nvSpPr>
-          <p:cNvPr id="4" name="Content Placeholder 3"/>
-          <p:cNvSpPr>
-            <a:spLocks noGrp="1"/>
-          </p:cNvSpPr>
-          <p:nvPr>
-            <p:ph idx="2" sz="half"/>
-          </p:nvPr>
-        </p:nvSpPr>
-        <p:spPr/>
-        <p:txBody>
-          <a:bodyPr/>
-          <a:lstStyle/>
+              <a:t>Transparent graph query interface.</a:t>
+            </a:r>
+          </a:p>
           <a:p>
             <a:pPr lvl="0"/>
             <a:r>
               <a:rPr/>
-              <a:t>Hybrid storage</a:t>
-            </a:r>
-          </a:p>
-          <a:p>
-            <a:pPr lvl="1"/>
-            <a:r>
-              <a:rPr/>
-              <a:t>Dedicated Time-Series streaming ingestion of data</a:t>
-            </a:r>
-          </a:p>
-          <a:p>
-            <a:pPr lvl="1"/>
-            <a:r>
-              <a:rPr/>
-              <a:t>Query optimization through filter-pushdown</a:t>
-            </a:r>
-          </a:p>
-          <a:p>
-            <a:pPr lvl="1"/>
-            <a:r>
-              <a:rPr/>
-              <a:t>Efficient graph traversal &amp; temporal reasoning</a:t>
+              <a:t>Submitted to </a:t>
+            </a:r>
+            <a:r>
+              <a:rPr>
+                <a:hlinkClick r:id="rId2"/>
+              </a:rPr>
+              <a:t>VLDB 2027</a:t>
+            </a:r>
+          </a:p>
+        </p:txBody>
+      </p:sp>
+      <p:pic>
+        <p:nvPicPr>
+          <p:cNvPr descr="https://github.com/ManuelePasini/slides-markdown/blob/master/slides/images/phd3rdyear/datamodel.svg?raw=true" id="0" name="Picture 1"/>
+          <p:cNvPicPr>
+            <a:picLocks noGrp="1" noChangeAspect="1"/>
+          </p:cNvPicPr>
+          <p:nvPr/>
+        </p:nvPicPr>
+        <p:blipFill>
+          <a:blip r:embed="rId3"/>
+          <a:stretch>
+            <a:fillRect/>
+          </a:stretch>
+        </p:blipFill>
+        <p:spPr bwMode="auto">
+          <a:xfrm>
+            <a:off x="457200" y="1295400"/>
+            <a:ext cx="4038600" cy="2692400"/>
+          </a:xfrm>
+          <a:prstGeom prst="rect">
+            <a:avLst/>
+          </a:prstGeom>
+          <a:noFill/>
+          <a:ln w="9525">
+            <a:noFill/>
+            <a:headEnd/>
+            <a:tailEnd/>
+          </a:ln>
+        </p:spPr>
+      </p:pic>
+      <p:sp>
+        <p:nvSpPr>
+          <p:cNvPr id="1" name="TextBox 3"/>
+          <p:cNvSpPr txBox="1"/>
+          <p:nvPr/>
+        </p:nvSpPr>
+        <p:spPr>
+          <a:xfrm>
+            <a:off x="457200" y="4076700"/>
+            <a:ext cx="4038600" cy="508000"/>
+          </a:xfrm>
+          <a:prstGeom prst="rect">
+            <a:avLst/>
+          </a:prstGeom>
+          <a:noFill/>
+        </p:spPr>
+        <p:txBody>
+          <a:bodyPr/>
+          <a:lstStyle/>
+          <a:p>
+            <a:pPr lvl="0" indent="0" marL="0" algn="ctr">
+              <a:buNone/>
+            </a:pPr>
+            <a:r>
+              <a:rPr/>
+              <a:t>STGraph Data Model</a:t>
+            </a:r>
+          </a:p>
+        </p:txBody>
+      </p:sp>
+      <p:pic>
+        <p:nvPicPr>
+          <p:cNvPr descr="https://github.com/ManuelePasini/slides-markdown/blob/master/slides/images/phd3rdyear/arch.svg?raw=true" id="0" name="Picture 1"/>
+          <p:cNvPicPr>
+            <a:picLocks noGrp="1" noChangeAspect="1"/>
+          </p:cNvPicPr>
+          <p:nvPr/>
+        </p:nvPicPr>
+        <p:blipFill>
+          <a:blip r:embed="rId4"/>
+          <a:stretch>
+            <a:fillRect/>
+          </a:stretch>
+        </p:blipFill>
+        <p:spPr bwMode="auto">
+          <a:xfrm>
+            <a:off x="4648200" y="1333500"/>
+            <a:ext cx="4038600" cy="2603500"/>
+          </a:xfrm>
+          <a:prstGeom prst="rect">
+            <a:avLst/>
+          </a:prstGeom>
+          <a:noFill/>
+          <a:ln w="9525">
+            <a:noFill/>
+            <a:headEnd/>
+            <a:tailEnd/>
+          </a:ln>
+        </p:spPr>
+      </p:pic>
+      <p:sp>
+        <p:nvSpPr>
+          <p:cNvPr id="1" name="TextBox 3"/>
+          <p:cNvSpPr txBox="1"/>
+          <p:nvPr/>
+        </p:nvSpPr>
+        <p:spPr>
+          <a:xfrm>
+            <a:off x="4648200" y="4076700"/>
+            <a:ext cx="4038600" cy="508000"/>
+          </a:xfrm>
+          <a:prstGeom prst="rect">
+            <a:avLst/>
+          </a:prstGeom>
+          <a:noFill/>
+        </p:spPr>
+        <p:txBody>
+          <a:bodyPr/>
+          <a:lstStyle/>
+          <a:p>
+            <a:pPr lvl="0" indent="0" marL="0" algn="ctr">
+              <a:buNone/>
+            </a:pPr>
+            <a:r>
+              <a:rPr/>
+              <a:t>STGraph Architecture</a:t>
             </a:r>
           </a:p>
         </p:txBody>
@@ -3595,6 +3736,134 @@
 </file>
 
 <file path=ppt/slides/slide12.xml><?xml version="1.0" encoding="utf-8"?>
+<p:sld xmlns:a="http://schemas.openxmlformats.org/drawingml/2006/main" xmlns:r="http://schemas.openxmlformats.org/officeDocument/2006/relationships" xmlns:p="http://schemas.openxmlformats.org/presentationml/2006/main">
+  <p:cSld>
+    <p:spTree>
+      <p:nvGrpSpPr>
+        <p:cNvPr id="1" name=""/>
+        <p:cNvGrpSpPr/>
+        <p:nvPr/>
+      </p:nvGrpSpPr>
+      <p:grpSpPr>
+        <a:xfrm>
+          <a:off x="0" y="0"/>
+          <a:ext cx="0" cy="0"/>
+          <a:chOff x="0" y="0"/>
+          <a:chExt cx="0" cy="0"/>
+        </a:xfrm>
+      </p:grpSpPr>
+      <p:sp>
+        <p:nvSpPr>
+          <p:cNvPr id="2" name="Title 1"/>
+          <p:cNvSpPr>
+            <a:spLocks noGrp="1"/>
+          </p:cNvSpPr>
+          <p:nvPr>
+            <p:ph type="title"/>
+          </p:nvPr>
+        </p:nvSpPr>
+        <p:spPr/>
+        <p:txBody>
+          <a:bodyPr/>
+          <a:lstStyle/>
+          <a:p>
+            <a:pPr lvl="0" indent="0" marL="0">
+              <a:buNone/>
+            </a:pPr>
+            <a:r>
+              <a:rPr/>
+              <a:t>STGraph: A Multistore for Temporal Graphs and Time-Series</a:t>
+            </a:r>
+          </a:p>
+        </p:txBody>
+      </p:sp>
+      <p:sp>
+        <p:nvSpPr>
+          <p:cNvPr id="3" name="Content Placeholder 2"/>
+          <p:cNvSpPr>
+            <a:spLocks noGrp="1"/>
+          </p:cNvSpPr>
+          <p:nvPr>
+            <p:ph idx="1" sz="half"/>
+          </p:nvPr>
+        </p:nvSpPr>
+        <p:spPr/>
+        <p:txBody>
+          <a:bodyPr/>
+          <a:lstStyle/>
+          <a:p>
+            <a:pPr lvl="0"/>
+            <a:r>
+              <a:rPr/>
+              <a:t>Property Graph data model</a:t>
+            </a:r>
+          </a:p>
+          <a:p>
+            <a:pPr lvl="1"/>
+            <a:r>
+              <a:rPr/>
+              <a:t>TS events (nodes) can hold edges and properties</a:t>
+            </a:r>
+          </a:p>
+          <a:p>
+            <a:pPr lvl="1"/>
+            <a:r>
+              <a:rPr/>
+              <a:t>Edges built at query time</a:t>
+            </a:r>
+          </a:p>
+        </p:txBody>
+      </p:sp>
+      <p:sp>
+        <p:nvSpPr>
+          <p:cNvPr id="4" name="Content Placeholder 3"/>
+          <p:cNvSpPr>
+            <a:spLocks noGrp="1"/>
+          </p:cNvSpPr>
+          <p:nvPr>
+            <p:ph idx="2" sz="half"/>
+          </p:nvPr>
+        </p:nvSpPr>
+        <p:spPr/>
+        <p:txBody>
+          <a:bodyPr/>
+          <a:lstStyle/>
+          <a:p>
+            <a:pPr lvl="0"/>
+            <a:r>
+              <a:rPr/>
+              <a:t>Hybrid storage</a:t>
+            </a:r>
+          </a:p>
+          <a:p>
+            <a:pPr lvl="1"/>
+            <a:r>
+              <a:rPr/>
+              <a:t>Dedicated Time-Series streaming ingestion of data</a:t>
+            </a:r>
+          </a:p>
+          <a:p>
+            <a:pPr lvl="1"/>
+            <a:r>
+              <a:rPr/>
+              <a:t>Query optimization through filter-pushdown</a:t>
+            </a:r>
+          </a:p>
+          <a:p>
+            <a:pPr lvl="1"/>
+            <a:r>
+              <a:rPr/>
+              <a:t>Efficient graph traversal &amp; temporal reasoning</a:t>
+            </a:r>
+          </a:p>
+        </p:txBody>
+      </p:sp>
+    </p:spTree>
+  </p:cSld>
+</p:sld>
+</file>
+
+<file path=ppt/slides/slide13.xml><?xml version="1.0" encoding="utf-8"?>
 <p:sld xmlns:a="http://schemas.openxmlformats.org/drawingml/2006/main" xmlns:r="http://schemas.openxmlformats.org/officeDocument/2006/relationships" xmlns:p="http://schemas.openxmlformats.org/presentationml/2006/main">
   <p:cSld>
     <p:spTree>
@@ -3676,7 +3945,7 @@
 </p:sld>
 </file>
 
-<file path=ppt/slides/slide13.xml><?xml version="1.0" encoding="utf-8"?>
+<file path=ppt/slides/slide14.xml><?xml version="1.0" encoding="utf-8"?>
 <p:sld xmlns:a="http://schemas.openxmlformats.org/drawingml/2006/main" xmlns:r="http://schemas.openxmlformats.org/officeDocument/2006/relationships" xmlns:p="http://schemas.openxmlformats.org/presentationml/2006/main">
   <p:cSld>
     <p:spTree>
@@ -3753,6 +4022,13 @@
               <a:t>What about anomalies that are cross-time series?</a:t>
             </a:r>
           </a:p>
+          <a:p>
+            <a:pPr lvl="0"/>
+            <a:r>
+              <a:rPr/>
+              <a:t>Hopefully to be published</a:t>
+            </a:r>
+          </a:p>
         </p:txBody>
       </p:sp>
     </p:spTree>
@@ -3760,7 +4036,7 @@
 </p:sld>
 </file>
 
-<file path=ppt/slides/slide14.xml><?xml version="1.0" encoding="utf-8"?>
+<file path=ppt/slides/slide15.xml><?xml version="1.0" encoding="utf-8"?>
 <p:sld xmlns:a="http://schemas.openxmlformats.org/drawingml/2006/main" xmlns:r="http://schemas.openxmlformats.org/officeDocument/2006/relationships" xmlns:p="http://schemas.openxmlformats.org/presentationml/2006/main">
   <p:cSld>
     <p:spTree>
@@ -3902,53 +4178,6 @@
 </p:sld>
 </file>
 
-<file path=ppt/slides/slide15.xml><?xml version="1.0" encoding="utf-8"?>
-<p:sld xmlns:a="http://schemas.openxmlformats.org/drawingml/2006/main" xmlns:r="http://schemas.openxmlformats.org/officeDocument/2006/relationships" xmlns:p="http://schemas.openxmlformats.org/presentationml/2006/main">
-  <p:cSld>
-    <p:spTree>
-      <p:nvGrpSpPr>
-        <p:cNvPr id="1" name=""/>
-        <p:cNvGrpSpPr/>
-        <p:nvPr/>
-      </p:nvGrpSpPr>
-      <p:grpSpPr>
-        <a:xfrm>
-          <a:off x="0" y="0"/>
-          <a:ext cx="0" cy="0"/>
-          <a:chOff x="0" y="0"/>
-          <a:chExt cx="0" cy="0"/>
-        </a:xfrm>
-      </p:grpSpPr>
-      <p:sp>
-        <p:nvSpPr>
-          <p:cNvPr id="2" name="Title 1"/>
-          <p:cNvSpPr>
-            <a:spLocks noGrp="1"/>
-          </p:cNvSpPr>
-          <p:nvPr>
-            <p:ph type="title"/>
-          </p:nvPr>
-        </p:nvSpPr>
-        <p:spPr/>
-        <p:txBody>
-          <a:bodyPr/>
-          <a:lstStyle/>
-          <a:p>
-            <a:pPr lvl="0" indent="0" marL="0">
-              <a:buNone/>
-            </a:pPr>
-            <a:r>
-              <a:rPr/>
-              <a:t>Anomaly Detection in Complex Sensor Networks</a:t>
-            </a:r>
-          </a:p>
-        </p:txBody>
-      </p:sp>
-    </p:spTree>
-  </p:cSld>
-</p:sld>
-</file>
-
 <file path=ppt/slides/slide16.xml><?xml version="1.0" encoding="utf-8"?>
 <p:sld xmlns:a="http://schemas.openxmlformats.org/drawingml/2006/main" xmlns:r="http://schemas.openxmlformats.org/officeDocument/2006/relationships" xmlns:p="http://schemas.openxmlformats.org/presentationml/2006/main">
   <p:cSld>
@@ -3986,7 +4215,83 @@
             </a:pPr>
             <a:r>
               <a:rPr/>
+              <a:t>Anomaly Detection in Complex Sensor Networks</a:t>
+            </a:r>
+          </a:p>
+        </p:txBody>
+      </p:sp>
+    </p:spTree>
+  </p:cSld>
+</p:sld>
+</file>
+
+<file path=ppt/slides/slide17.xml><?xml version="1.0" encoding="utf-8"?>
+<p:sld xmlns:a="http://schemas.openxmlformats.org/drawingml/2006/main" xmlns:r="http://schemas.openxmlformats.org/officeDocument/2006/relationships" xmlns:p="http://schemas.openxmlformats.org/presentationml/2006/main">
+  <p:cSld>
+    <p:spTree>
+      <p:nvGrpSpPr>
+        <p:cNvPr id="1" name=""/>
+        <p:cNvGrpSpPr/>
+        <p:nvPr/>
+      </p:nvGrpSpPr>
+      <p:grpSpPr>
+        <a:xfrm>
+          <a:off x="0" y="0"/>
+          <a:ext cx="0" cy="0"/>
+          <a:chOff x="0" y="0"/>
+          <a:chExt cx="0" cy="0"/>
+        </a:xfrm>
+      </p:grpSpPr>
+      <p:sp>
+        <p:nvSpPr>
+          <p:cNvPr id="2" name="Title 1"/>
+          <p:cNvSpPr>
+            <a:spLocks noGrp="1"/>
+          </p:cNvSpPr>
+          <p:nvPr>
+            <p:ph type="title"/>
+          </p:nvPr>
+        </p:nvSpPr>
+        <p:spPr/>
+        <p:txBody>
+          <a:bodyPr/>
+          <a:lstStyle/>
+          <a:p>
+            <a:pPr lvl="0" indent="0" marL="0">
+              <a:buNone/>
+            </a:pPr>
+            <a:r>
+              <a:rPr/>
               <a:t>LLM-Assisted Metadata Query Answering on Data Warehouses</a:t>
+            </a:r>
+          </a:p>
+        </p:txBody>
+      </p:sp>
+      <p:sp>
+        <p:nvSpPr>
+          <p:cNvPr id="3" name="Content Placeholder 2"/>
+          <p:cNvSpPr>
+            <a:spLocks noGrp="1"/>
+          </p:cNvSpPr>
+          <p:nvPr>
+            <p:ph idx="1"/>
+          </p:nvPr>
+        </p:nvSpPr>
+        <p:spPr/>
+        <p:txBody>
+          <a:bodyPr/>
+          <a:lstStyle/>
+          <a:p>
+            <a:pPr lvl="0"/>
+            <a:r>
+              <a:rPr/>
+              <a:t>Published at </a:t>
+            </a:r>
+            <a:r>
+              <a:rPr>
+                <a:hlinkClick r:id="rId2"/>
+              </a:rPr>
+              <a:t>28th International Conference on Big Data Analytics and Knowledge Discovery (DAWAK)</a:t>
             </a:r>
           </a:p>
         </p:txBody>
@@ -4848,6 +5153,19 @@
               <a:t>Soil data is interpolated to obtain a 2-dimensional view of soil moisture</a:t>
             </a:r>
           </a:p>
+          <a:p>
+            <a:pPr lvl="0"/>
+            <a:r>
+              <a:rPr/>
+              <a:t>Published in </a:t>
+            </a:r>
+            <a:r>
+              <a:rPr>
+                <a:hlinkClick r:id="rId2"/>
+              </a:rPr>
+              <a:t>Computers and Electronics in Agriculture</a:t>
+            </a:r>
+          </a:p>
         </p:txBody>
       </p:sp>
     </p:spTree>
@@ -5046,7 +5364,7 @@
             <a:spLocks noGrp="1"/>
           </p:cNvSpPr>
           <p:nvPr>
-            <p:ph idx="1" sz="half"/>
+            <p:ph idx="1"/>
           </p:nvPr>
         </p:nvSpPr>
         <p:spPr/>
@@ -5057,210 +5375,7 @@
             <a:pPr lvl="0"/>
             <a:r>
               <a:rPr/>
-              <a:t>PID controller + simulation model to determine irrigaton amounts</a:t>
-            </a:r>
-          </a:p>
-        </p:txBody>
-      </p:sp>
-      <p:pic>
-        <p:nvPicPr>
-          <p:cNvPr descr="https://github.com/ManuelePasini/slides-markdown/blob/master/slides/images/phd3rdyear/smarter.svg?raw=true" id="0" name="Picture 1"/>
-          <p:cNvPicPr>
-            <a:picLocks noGrp="1" noChangeAspect="1"/>
-          </p:cNvPicPr>
-          <p:nvPr/>
-        </p:nvPicPr>
-        <p:blipFill>
-          <a:blip r:embed="rId2"/>
-          <a:stretch>
-            <a:fillRect/>
-          </a:stretch>
-        </p:blipFill>
-        <p:spPr bwMode="auto">
-          <a:xfrm>
-            <a:off x="457200" y="1689100"/>
-            <a:ext cx="4038600" cy="1892300"/>
-          </a:xfrm>
-          <a:prstGeom prst="rect">
-            <a:avLst/>
-          </a:prstGeom>
-          <a:noFill/>
-          <a:ln w="9525">
-            <a:noFill/>
-            <a:headEnd/>
-            <a:tailEnd/>
-          </a:ln>
-        </p:spPr>
-      </p:pic>
-      <p:sp>
-        <p:nvSpPr>
-          <p:cNvPr id="1" name="TextBox 3"/>
-          <p:cNvSpPr txBox="1"/>
-          <p:nvPr/>
-        </p:nvSpPr>
-        <p:spPr>
-          <a:xfrm>
-            <a:off x="457200" y="4076700"/>
-            <a:ext cx="4038600" cy="508000"/>
-          </a:xfrm>
-          <a:prstGeom prst="rect">
-            <a:avLst/>
-          </a:prstGeom>
-          <a:noFill/>
-        </p:spPr>
-        <p:txBody>
-          <a:bodyPr/>
-          <a:lstStyle/>
-          <a:p>
-            <a:pPr lvl="0" indent="0" marL="0" algn="ctr">
-              <a:buNone/>
-            </a:pPr>
-            <a:r>
-              <a:rPr/>
-              <a:t>An overview of SMARTER</a:t>
-            </a:r>
-          </a:p>
-        </p:txBody>
-      </p:sp>
-      <p:sp>
-        <p:nvSpPr>
-          <p:cNvPr id="4" name="Content Placeholder 3"/>
-          <p:cNvSpPr>
-            <a:spLocks noGrp="1"/>
-          </p:cNvSpPr>
-          <p:nvPr>
-            <p:ph idx="2" sz="half"/>
-          </p:nvPr>
-        </p:nvSpPr>
-        <p:spPr/>
-        <p:txBody>
-          <a:bodyPr/>
-          <a:lstStyle/>
-          <a:p>
-            <a:pPr lvl="0"/>
-            <a:r>
-              <a:rPr/>
-              <a:t>Up to 40% in water savings, fruit quality preserved</a:t>
-            </a:r>
-          </a:p>
-        </p:txBody>
-      </p:sp>
-      <p:pic>
-        <p:nvPicPr>
-          <p:cNvPr descr="https://github.com/ManuelePasini/slides-markdown/blob/master/slides/images/phd3rdyear/smarter_results.png?raw=true" id="0" name="Picture 1"/>
-          <p:cNvPicPr>
-            <a:picLocks noGrp="1" noChangeAspect="1"/>
-          </p:cNvPicPr>
-          <p:nvPr/>
-        </p:nvPicPr>
-        <p:blipFill>
-          <a:blip r:embed="rId3"/>
-          <a:stretch>
-            <a:fillRect/>
-          </a:stretch>
-        </p:blipFill>
-        <p:spPr bwMode="auto">
-          <a:xfrm>
-            <a:off x="4648200" y="1701800"/>
-            <a:ext cx="4038600" cy="1866900"/>
-          </a:xfrm>
-          <a:prstGeom prst="rect">
-            <a:avLst/>
-          </a:prstGeom>
-          <a:noFill/>
-          <a:ln w="9525">
-            <a:noFill/>
-            <a:headEnd/>
-            <a:tailEnd/>
-          </a:ln>
-        </p:spPr>
-      </p:pic>
-      <p:sp>
-        <p:nvSpPr>
-          <p:cNvPr id="1" name="TextBox 3"/>
-          <p:cNvSpPr txBox="1"/>
-          <p:nvPr/>
-        </p:nvSpPr>
-        <p:spPr>
-          <a:xfrm>
-            <a:off x="4648200" y="4076700"/>
-            <a:ext cx="4038600" cy="508000"/>
-          </a:xfrm>
-          <a:prstGeom prst="rect">
-            <a:avLst/>
-          </a:prstGeom>
-          <a:noFill/>
-        </p:spPr>
-        <p:txBody>
-          <a:bodyPr/>
-          <a:lstStyle/>
-          <a:p>
-            <a:pPr lvl="0" indent="0" marL="0" algn="ctr">
-              <a:buNone/>
-            </a:pPr>
-            <a:r>
-              <a:rPr/>
-              <a:t>Water saving results</a:t>
-            </a:r>
-          </a:p>
-        </p:txBody>
-      </p:sp>
-      <p:pic>
-        <p:nvPicPr>
-          <p:cNvPr descr="https://github.com/ManuelePasini/slides-markdown/blob/master/slides/images/phd3rdyear/smarter_fruit_results.png?raw=true" id="0" name="Picture 1"/>
-          <p:cNvPicPr>
-            <a:picLocks noGrp="1" noChangeAspect="1"/>
-          </p:cNvPicPr>
-          <p:nvPr/>
-        </p:nvPicPr>
-        <p:blipFill>
-          <a:blip r:embed="rId4"/>
-          <a:stretch>
-            <a:fillRect/>
-          </a:stretch>
-        </p:blipFill>
-        <p:spPr bwMode="auto">
-          <a:xfrm>
-            <a:off x="4648200" y="1981200"/>
-            <a:ext cx="4038600" cy="1308100"/>
-          </a:xfrm>
-          <a:prstGeom prst="rect">
-            <a:avLst/>
-          </a:prstGeom>
-          <a:noFill/>
-          <a:ln w="9525">
-            <a:noFill/>
-            <a:headEnd/>
-            <a:tailEnd/>
-          </a:ln>
-        </p:spPr>
-      </p:pic>
-      <p:sp>
-        <p:nvSpPr>
-          <p:cNvPr id="1" name="TextBox 3"/>
-          <p:cNvSpPr txBox="1"/>
-          <p:nvPr/>
-        </p:nvSpPr>
-        <p:spPr>
-          <a:xfrm>
-            <a:off x="4648200" y="4076700"/>
-            <a:ext cx="4038600" cy="508000"/>
-          </a:xfrm>
-          <a:prstGeom prst="rect">
-            <a:avLst/>
-          </a:prstGeom>
-          <a:noFill/>
-        </p:spPr>
-        <p:txBody>
-          <a:bodyPr/>
-          <a:lstStyle/>
-          <a:p>
-            <a:pPr lvl="0" indent="0" marL="0" algn="ctr">
-              <a:buNone/>
-            </a:pPr>
-            <a:r>
-              <a:rPr/>
-              <a:t>Fruit quality results</a:t>
+              <a:t> Results</a:t>
             </a:r>
           </a:p>
         </p:txBody>

</xml_diff>

<commit_message>
Deploying to gh-pages from @ ManuelePasini/slides-markdown@d8c5f30c5e07eeb85d9303458bba7212bc8b5fda 🚀
</commit_message>
<xml_diff>
--- a/3rd_year_slides.pptx
+++ b/3rd_year_slides.pptx
@@ -3595,19 +3595,6 @@
               <a:t>Transparent graph query interface.</a:t>
             </a:r>
           </a:p>
-          <a:p>
-            <a:pPr lvl="0"/>
-            <a:r>
-              <a:rPr/>
-              <a:t>Submitted to </a:t>
-            </a:r>
-            <a:r>
-              <a:rPr>
-                <a:hlinkClick r:id="rId2"/>
-              </a:rPr>
-              <a:t>VLDB 2027</a:t>
-            </a:r>
-          </a:p>
         </p:txBody>
       </p:sp>
       <p:pic>
@@ -3619,7 +3606,7 @@
           <p:nvPr/>
         </p:nvPicPr>
         <p:blipFill>
-          <a:blip r:embed="rId3"/>
+          <a:blip r:embed="rId2"/>
           <a:stretch>
             <a:fillRect/>
           </a:stretch>
@@ -3679,7 +3666,7 @@
           <p:nvPr/>
         </p:nvPicPr>
         <p:blipFill>
-          <a:blip r:embed="rId4"/>
+          <a:blip r:embed="rId3"/>
           <a:stretch>
             <a:fillRect/>
           </a:stretch>

</xml_diff>

<commit_message>
Deploying to gh-pages from @ ManuelePasini/slides-markdown@85b80d4ad971111e89ea7329b1daf02c0716d899 🚀
</commit_message>
<xml_diff>
--- a/3rd_year_slides.pptx
+++ b/3rd_year_slides.pptx
@@ -4203,6 +4203,31 @@
             <a:r>
               <a:rPr/>
               <a:t>Anomaly Detection in Complex Sensor Networks</a:t>
+            </a:r>
+          </a:p>
+        </p:txBody>
+      </p:sp>
+      <p:sp>
+        <p:nvSpPr>
+          <p:cNvPr id="3" name="Content Placeholder 2"/>
+          <p:cNvSpPr>
+            <a:spLocks noGrp="1"/>
+          </p:cNvSpPr>
+          <p:nvPr>
+            <p:ph idx="1"/>
+          </p:nvPr>
+        </p:nvSpPr>
+        <p:spPr/>
+        <p:txBody>
+          <a:bodyPr/>
+          <a:lstStyle/>
+          <a:p>
+            <a:pPr lvl="0" indent="0" marL="0">
+              <a:buNone/>
+            </a:pPr>
+            <a:r>
+              <a:rPr/>
+              <a:t>test</a:t>
             </a:r>
           </a:p>
         </p:txBody>

</xml_diff>

<commit_message>
Deploying to gh-pages from @ ManuelePasini/slides-markdown@ca37990c2f56aae081fab8c69c478a555a8c1a20 🚀
</commit_message>
<xml_diff>
--- a/3rd_year_slides.pptx
+++ b/3rd_year_slides.pptx
@@ -21,7 +21,6 @@
     <p:sldId id="269" r:id="rId15"/>
     <p:sldId id="270" r:id="rId16"/>
     <p:sldId id="271" r:id="rId17"/>
-    <p:sldId id="272" r:id="rId18"/>
   </p:sldIdLst>
   <p:sldSz cx="9144000" cy="5143500" type="screen16x9"/>
   <p:notesSz cx="6858000" cy="9144000"/>
@@ -3268,261 +3267,6 @@
       </p:grpSpPr>
       <p:sp>
         <p:nvSpPr>
-          <p:cNvPr id="3" name="Content Placeholder 2"/>
-          <p:cNvSpPr>
-            <a:spLocks noGrp="1"/>
-          </p:cNvSpPr>
-          <p:nvPr>
-            <p:ph idx="1" sz="half"/>
-          </p:nvPr>
-        </p:nvSpPr>
-        <p:spPr/>
-        <p:txBody>
-          <a:bodyPr/>
-          <a:lstStyle/>
-          <a:p>
-            <a:pPr lvl="0"/>
-            <a:r>
-              <a:rPr/>
-              <a:t>PID controller + simulation model to determine irrigaton amounts</a:t>
-            </a:r>
-          </a:p>
-        </p:txBody>
-      </p:sp>
-      <p:pic>
-        <p:nvPicPr>
-          <p:cNvPr descr="https://github.com/ManuelePasini/slides-markdown/blob/master/slides/images/phd3rdyear/smarter.svg?raw=true" id="0" name="Picture 1"/>
-          <p:cNvPicPr>
-            <a:picLocks noGrp="1" noChangeAspect="1"/>
-          </p:cNvPicPr>
-          <p:nvPr/>
-        </p:nvPicPr>
-        <p:blipFill>
-          <a:blip r:embed="rId2"/>
-          <a:stretch>
-            <a:fillRect/>
-          </a:stretch>
-        </p:blipFill>
-        <p:spPr bwMode="auto">
-          <a:xfrm>
-            <a:off x="457200" y="1689100"/>
-            <a:ext cx="4038600" cy="1892300"/>
-          </a:xfrm>
-          <a:prstGeom prst="rect">
-            <a:avLst/>
-          </a:prstGeom>
-          <a:noFill/>
-          <a:ln w="9525">
-            <a:noFill/>
-            <a:headEnd/>
-            <a:tailEnd/>
-          </a:ln>
-        </p:spPr>
-      </p:pic>
-      <p:sp>
-        <p:nvSpPr>
-          <p:cNvPr id="1" name="TextBox 3"/>
-          <p:cNvSpPr txBox="1"/>
-          <p:nvPr/>
-        </p:nvSpPr>
-        <p:spPr>
-          <a:xfrm>
-            <a:off x="457200" y="4076700"/>
-            <a:ext cx="4038600" cy="508000"/>
-          </a:xfrm>
-          <a:prstGeom prst="rect">
-            <a:avLst/>
-          </a:prstGeom>
-          <a:noFill/>
-        </p:spPr>
-        <p:txBody>
-          <a:bodyPr/>
-          <a:lstStyle/>
-          <a:p>
-            <a:pPr lvl="0" indent="0" marL="0" algn="ctr">
-              <a:buNone/>
-            </a:pPr>
-            <a:r>
-              <a:rPr/>
-              <a:t>An overview of SMARTER</a:t>
-            </a:r>
-          </a:p>
-        </p:txBody>
-      </p:sp>
-      <p:sp>
-        <p:nvSpPr>
-          <p:cNvPr id="4" name="Content Placeholder 3"/>
-          <p:cNvSpPr>
-            <a:spLocks noGrp="1"/>
-          </p:cNvSpPr>
-          <p:nvPr>
-            <p:ph idx="2" sz="half"/>
-          </p:nvPr>
-        </p:nvSpPr>
-        <p:spPr/>
-        <p:txBody>
-          <a:bodyPr/>
-          <a:lstStyle/>
-          <a:p>
-            <a:pPr lvl="0"/>
-            <a:r>
-              <a:rPr/>
-              <a:t>Up to 40% in water savings</a:t>
-            </a:r>
-          </a:p>
-          <a:p>
-            <a:pPr lvl="0"/>
-            <a:r>
-              <a:rPr/>
-              <a:t>Fruit quality preserved, smaller fruit but of improved quality</a:t>
-            </a:r>
-          </a:p>
-        </p:txBody>
-      </p:sp>
-      <p:pic>
-        <p:nvPicPr>
-          <p:cNvPr descr="https://github.com/ManuelePasini/slides-markdown/blob/master/slides/images/phd3rdyear/smarter_results.png?raw=true" id="0" name="Picture 1"/>
-          <p:cNvPicPr>
-            <a:picLocks noGrp="1" noChangeAspect="1"/>
-          </p:cNvPicPr>
-          <p:nvPr/>
-        </p:nvPicPr>
-        <p:blipFill>
-          <a:blip r:embed="rId3"/>
-          <a:stretch>
-            <a:fillRect/>
-          </a:stretch>
-        </p:blipFill>
-        <p:spPr bwMode="auto">
-          <a:xfrm>
-            <a:off x="4648200" y="1701800"/>
-            <a:ext cx="4038600" cy="1866900"/>
-          </a:xfrm>
-          <a:prstGeom prst="rect">
-            <a:avLst/>
-          </a:prstGeom>
-          <a:noFill/>
-          <a:ln w="9525">
-            <a:noFill/>
-            <a:headEnd/>
-            <a:tailEnd/>
-          </a:ln>
-        </p:spPr>
-      </p:pic>
-      <p:sp>
-        <p:nvSpPr>
-          <p:cNvPr id="1" name="TextBox 3"/>
-          <p:cNvSpPr txBox="1"/>
-          <p:nvPr/>
-        </p:nvSpPr>
-        <p:spPr>
-          <a:xfrm>
-            <a:off x="4648200" y="4076700"/>
-            <a:ext cx="4038600" cy="508000"/>
-          </a:xfrm>
-          <a:prstGeom prst="rect">
-            <a:avLst/>
-          </a:prstGeom>
-          <a:noFill/>
-        </p:spPr>
-        <p:txBody>
-          <a:bodyPr/>
-          <a:lstStyle/>
-          <a:p>
-            <a:pPr lvl="0" indent="0" marL="0" algn="ctr">
-              <a:buNone/>
-            </a:pPr>
-            <a:r>
-              <a:rPr/>
-              <a:t>Water saving results</a:t>
-            </a:r>
-          </a:p>
-        </p:txBody>
-      </p:sp>
-      <p:pic>
-        <p:nvPicPr>
-          <p:cNvPr descr="https://github.com/ManuelePasini/slides-markdown/blob/master/slides/images/phd3rdyear/smarter_fruit_results.png?raw=true" id="0" name="Picture 1"/>
-          <p:cNvPicPr>
-            <a:picLocks noGrp="1" noChangeAspect="1"/>
-          </p:cNvPicPr>
-          <p:nvPr/>
-        </p:nvPicPr>
-        <p:blipFill>
-          <a:blip r:embed="rId4"/>
-          <a:stretch>
-            <a:fillRect/>
-          </a:stretch>
-        </p:blipFill>
-        <p:spPr bwMode="auto">
-          <a:xfrm>
-            <a:off x="4648200" y="1981200"/>
-            <a:ext cx="4038600" cy="1308100"/>
-          </a:xfrm>
-          <a:prstGeom prst="rect">
-            <a:avLst/>
-          </a:prstGeom>
-          <a:noFill/>
-          <a:ln w="9525">
-            <a:noFill/>
-            <a:headEnd/>
-            <a:tailEnd/>
-          </a:ln>
-        </p:spPr>
-      </p:pic>
-      <p:sp>
-        <p:nvSpPr>
-          <p:cNvPr id="1" name="TextBox 3"/>
-          <p:cNvSpPr txBox="1"/>
-          <p:nvPr/>
-        </p:nvSpPr>
-        <p:spPr>
-          <a:xfrm>
-            <a:off x="4648200" y="4076700"/>
-            <a:ext cx="4038600" cy="508000"/>
-          </a:xfrm>
-          <a:prstGeom prst="rect">
-            <a:avLst/>
-          </a:prstGeom>
-          <a:noFill/>
-        </p:spPr>
-        <p:txBody>
-          <a:bodyPr/>
-          <a:lstStyle/>
-          <a:p>
-            <a:pPr lvl="0" indent="0" marL="0" algn="ctr">
-              <a:buNone/>
-            </a:pPr>
-            <a:r>
-              <a:rPr/>
-              <a:t>Fruit quality results</a:t>
-            </a:r>
-          </a:p>
-        </p:txBody>
-      </p:sp>
-    </p:spTree>
-  </p:cSld>
-</p:sld>
-</file>
-
-<file path=ppt/slides/slide11.xml><?xml version="1.0" encoding="utf-8"?>
-<p:sld xmlns:a="http://schemas.openxmlformats.org/drawingml/2006/main" xmlns:r="http://schemas.openxmlformats.org/officeDocument/2006/relationships" xmlns:p="http://schemas.openxmlformats.org/presentationml/2006/main">
-  <p:cSld>
-    <p:spTree>
-      <p:nvGrpSpPr>
-        <p:cNvPr id="1" name=""/>
-        <p:cNvGrpSpPr/>
-        <p:nvPr/>
-      </p:nvGrpSpPr>
-      <p:grpSpPr>
-        <a:xfrm>
-          <a:off x="0" y="0"/>
-          <a:ext cx="0" cy="0"/>
-          <a:chOff x="0" y="0"/>
-          <a:chExt cx="0" cy="0"/>
-        </a:xfrm>
-      </p:grpSpPr>
-      <p:sp>
-        <p:nvSpPr>
           <p:cNvPr id="2" name="Title 1"/>
           <p:cNvSpPr>
             <a:spLocks noGrp="1"/>
@@ -3722,7 +3466,7 @@
 </p:sld>
 </file>
 
-<file path=ppt/slides/slide12.xml><?xml version="1.0" encoding="utf-8"?>
+<file path=ppt/slides/slide11.xml><?xml version="1.0" encoding="utf-8"?>
 <p:sld xmlns:a="http://schemas.openxmlformats.org/drawingml/2006/main" xmlns:r="http://schemas.openxmlformats.org/officeDocument/2006/relationships" xmlns:p="http://schemas.openxmlformats.org/presentationml/2006/main">
   <p:cSld>
     <p:spTree>
@@ -3850,7 +3594,7 @@
 </p:sld>
 </file>
 
-<file path=ppt/slides/slide13.xml><?xml version="1.0" encoding="utf-8"?>
+<file path=ppt/slides/slide12.xml><?xml version="1.0" encoding="utf-8"?>
 <p:sld xmlns:a="http://schemas.openxmlformats.org/drawingml/2006/main" xmlns:r="http://schemas.openxmlformats.org/officeDocument/2006/relationships" xmlns:p="http://schemas.openxmlformats.org/presentationml/2006/main">
   <p:cSld>
     <p:spTree>
@@ -3932,7 +3676,7 @@
 </p:sld>
 </file>
 
-<file path=ppt/slides/slide14.xml><?xml version="1.0" encoding="utf-8"?>
+<file path=ppt/slides/slide13.xml><?xml version="1.0" encoding="utf-8"?>
 <p:sld xmlns:a="http://schemas.openxmlformats.org/drawingml/2006/main" xmlns:r="http://schemas.openxmlformats.org/officeDocument/2006/relationships" xmlns:p="http://schemas.openxmlformats.org/presentationml/2006/main">
   <p:cSld>
     <p:spTree>
@@ -4023,7 +3767,7 @@
 </p:sld>
 </file>
 
-<file path=ppt/slides/slide15.xml><?xml version="1.0" encoding="utf-8"?>
+<file path=ppt/slides/slide14.xml><?xml version="1.0" encoding="utf-8"?>
 <p:sld xmlns:a="http://schemas.openxmlformats.org/drawingml/2006/main" xmlns:r="http://schemas.openxmlformats.org/officeDocument/2006/relationships" xmlns:p="http://schemas.openxmlformats.org/presentationml/2006/main">
   <p:cSld>
     <p:spTree>
@@ -4165,7 +3909,7 @@
 </p:sld>
 </file>
 
-<file path=ppt/slides/slide16.xml><?xml version="1.0" encoding="utf-8"?>
+<file path=ppt/slides/slide15.xml><?xml version="1.0" encoding="utf-8"?>
 <p:sld xmlns:a="http://schemas.openxmlformats.org/drawingml/2006/main" xmlns:r="http://schemas.openxmlformats.org/officeDocument/2006/relationships" xmlns:p="http://schemas.openxmlformats.org/presentationml/2006/main">
   <p:cSld>
     <p:spTree>
@@ -4237,7 +3981,7 @@
 </p:sld>
 </file>
 
-<file path=ppt/slides/slide17.xml><?xml version="1.0" encoding="utf-8"?>
+<file path=ppt/slides/slide16.xml><?xml version="1.0" encoding="utf-8"?>
 <p:sld xmlns:a="http://schemas.openxmlformats.org/drawingml/2006/main" xmlns:r="http://schemas.openxmlformats.org/officeDocument/2006/relationships" xmlns:p="http://schemas.openxmlformats.org/presentationml/2006/main">
   <p:cSld>
     <p:spTree>
@@ -5364,7 +5108,7 @@
             </a:pPr>
             <a:r>
               <a:rPr/>
-              <a:t>SMARTER: Data-driven optimization of water consumption in kiwifruit orchards</a:t>
+              <a:t>SMARTER: Results</a:t>
             </a:r>
           </a:p>
         </p:txBody>
@@ -5376,7 +5120,7 @@
             <a:spLocks noGrp="1"/>
           </p:cNvSpPr>
           <p:nvPr>
-            <p:ph idx="1"/>
+            <p:ph idx="1" sz="half"/>
           </p:nvPr>
         </p:nvSpPr>
         <p:spPr/>
@@ -5387,7 +5131,217 @@
             <a:pPr lvl="0"/>
             <a:r>
               <a:rPr/>
-              <a:t> Results</a:t>
+              <a:t>PID controller + simulation model to determine irrigaton amounts</a:t>
+            </a:r>
+          </a:p>
+        </p:txBody>
+      </p:sp>
+      <p:pic>
+        <p:nvPicPr>
+          <p:cNvPr descr="https://github.com/ManuelePasini/slides-markdown/blob/master/slides/images/phd3rdyear/smarter.svg?raw=true" id="0" name="Picture 1"/>
+          <p:cNvPicPr>
+            <a:picLocks noGrp="1" noChangeAspect="1"/>
+          </p:cNvPicPr>
+          <p:nvPr/>
+        </p:nvPicPr>
+        <p:blipFill>
+          <a:blip r:embed="rId2"/>
+          <a:stretch>
+            <a:fillRect/>
+          </a:stretch>
+        </p:blipFill>
+        <p:spPr bwMode="auto">
+          <a:xfrm>
+            <a:off x="457200" y="1689100"/>
+            <a:ext cx="4038600" cy="1892300"/>
+          </a:xfrm>
+          <a:prstGeom prst="rect">
+            <a:avLst/>
+          </a:prstGeom>
+          <a:noFill/>
+          <a:ln w="9525">
+            <a:noFill/>
+            <a:headEnd/>
+            <a:tailEnd/>
+          </a:ln>
+        </p:spPr>
+      </p:pic>
+      <p:sp>
+        <p:nvSpPr>
+          <p:cNvPr id="1" name="TextBox 3"/>
+          <p:cNvSpPr txBox="1"/>
+          <p:nvPr/>
+        </p:nvSpPr>
+        <p:spPr>
+          <a:xfrm>
+            <a:off x="457200" y="4076700"/>
+            <a:ext cx="4038600" cy="508000"/>
+          </a:xfrm>
+          <a:prstGeom prst="rect">
+            <a:avLst/>
+          </a:prstGeom>
+          <a:noFill/>
+        </p:spPr>
+        <p:txBody>
+          <a:bodyPr/>
+          <a:lstStyle/>
+          <a:p>
+            <a:pPr lvl="0" indent="0" marL="0" algn="ctr">
+              <a:buNone/>
+            </a:pPr>
+            <a:r>
+              <a:rPr/>
+              <a:t>An overview of SMARTER</a:t>
+            </a:r>
+          </a:p>
+        </p:txBody>
+      </p:sp>
+      <p:sp>
+        <p:nvSpPr>
+          <p:cNvPr id="4" name="Content Placeholder 3"/>
+          <p:cNvSpPr>
+            <a:spLocks noGrp="1"/>
+          </p:cNvSpPr>
+          <p:nvPr>
+            <p:ph idx="2" sz="half"/>
+          </p:nvPr>
+        </p:nvSpPr>
+        <p:spPr/>
+        <p:txBody>
+          <a:bodyPr/>
+          <a:lstStyle/>
+          <a:p>
+            <a:pPr lvl="0"/>
+            <a:r>
+              <a:rPr/>
+              <a:t>Up to 40% in water savings</a:t>
+            </a:r>
+          </a:p>
+          <a:p>
+            <a:pPr lvl="0"/>
+            <a:r>
+              <a:rPr/>
+              <a:t>Fruit quality preserved, smaller fruit but of improved quality</a:t>
+            </a:r>
+          </a:p>
+        </p:txBody>
+      </p:sp>
+      <p:pic>
+        <p:nvPicPr>
+          <p:cNvPr descr="https://github.com/ManuelePasini/slides-markdown/blob/master/slides/images/phd3rdyear/smarter_results.png?raw=true" id="0" name="Picture 1"/>
+          <p:cNvPicPr>
+            <a:picLocks noGrp="1" noChangeAspect="1"/>
+          </p:cNvPicPr>
+          <p:nvPr/>
+        </p:nvPicPr>
+        <p:blipFill>
+          <a:blip r:embed="rId3"/>
+          <a:stretch>
+            <a:fillRect/>
+          </a:stretch>
+        </p:blipFill>
+        <p:spPr bwMode="auto">
+          <a:xfrm>
+            <a:off x="4648200" y="1701800"/>
+            <a:ext cx="4038600" cy="1866900"/>
+          </a:xfrm>
+          <a:prstGeom prst="rect">
+            <a:avLst/>
+          </a:prstGeom>
+          <a:noFill/>
+          <a:ln w="9525">
+            <a:noFill/>
+            <a:headEnd/>
+            <a:tailEnd/>
+          </a:ln>
+        </p:spPr>
+      </p:pic>
+      <p:sp>
+        <p:nvSpPr>
+          <p:cNvPr id="1" name="TextBox 3"/>
+          <p:cNvSpPr txBox="1"/>
+          <p:nvPr/>
+        </p:nvSpPr>
+        <p:spPr>
+          <a:xfrm>
+            <a:off x="4648200" y="4076700"/>
+            <a:ext cx="4038600" cy="508000"/>
+          </a:xfrm>
+          <a:prstGeom prst="rect">
+            <a:avLst/>
+          </a:prstGeom>
+          <a:noFill/>
+        </p:spPr>
+        <p:txBody>
+          <a:bodyPr/>
+          <a:lstStyle/>
+          <a:p>
+            <a:pPr lvl="0" indent="0" marL="0" algn="ctr">
+              <a:buNone/>
+            </a:pPr>
+            <a:r>
+              <a:rPr/>
+              <a:t>Water saving results</a:t>
+            </a:r>
+          </a:p>
+        </p:txBody>
+      </p:sp>
+      <p:pic>
+        <p:nvPicPr>
+          <p:cNvPr descr="https://github.com/ManuelePasini/slides-markdown/blob/master/slides/images/phd3rdyear/smarter_fruit_results.png?raw=true" id="0" name="Picture 1"/>
+          <p:cNvPicPr>
+            <a:picLocks noGrp="1" noChangeAspect="1"/>
+          </p:cNvPicPr>
+          <p:nvPr/>
+        </p:nvPicPr>
+        <p:blipFill>
+          <a:blip r:embed="rId4"/>
+          <a:stretch>
+            <a:fillRect/>
+          </a:stretch>
+        </p:blipFill>
+        <p:spPr bwMode="auto">
+          <a:xfrm>
+            <a:off x="4648200" y="1981200"/>
+            <a:ext cx="4038600" cy="1308100"/>
+          </a:xfrm>
+          <a:prstGeom prst="rect">
+            <a:avLst/>
+          </a:prstGeom>
+          <a:noFill/>
+          <a:ln w="9525">
+            <a:noFill/>
+            <a:headEnd/>
+            <a:tailEnd/>
+          </a:ln>
+        </p:spPr>
+      </p:pic>
+      <p:sp>
+        <p:nvSpPr>
+          <p:cNvPr id="1" name="TextBox 3"/>
+          <p:cNvSpPr txBox="1"/>
+          <p:nvPr/>
+        </p:nvSpPr>
+        <p:spPr>
+          <a:xfrm>
+            <a:off x="4648200" y="4076700"/>
+            <a:ext cx="4038600" cy="508000"/>
+          </a:xfrm>
+          <a:prstGeom prst="rect">
+            <a:avLst/>
+          </a:prstGeom>
+          <a:noFill/>
+        </p:spPr>
+        <p:txBody>
+          <a:bodyPr/>
+          <a:lstStyle/>
+          <a:p>
+            <a:pPr lvl="0" indent="0" marL="0" algn="ctr">
+              <a:buNone/>
+            </a:pPr>
+            <a:r>
+              <a:rPr/>
+              <a:t>Fruit quality results</a:t>
             </a:r>
           </a:p>
         </p:txBody>

</xml_diff>

<commit_message>
Deploying to gh-pages from @ ManuelePasini/slides-markdown@77e03b424a21255dc3e69e1217a0e71957e40a04 🚀
</commit_message>
<xml_diff>
--- a/3rd_year_slides.pptx
+++ b/3rd_year_slides.pptx
@@ -3339,6 +3339,19 @@
               <a:t>Transparent graph query interface.</a:t>
             </a:r>
           </a:p>
+          <a:p>
+            <a:pPr lvl="0"/>
+            <a:r>
+              <a:rPr/>
+              <a:t>Submitted to </a:t>
+            </a:r>
+            <a:r>
+              <a:rPr>
+                <a:hlinkClick r:id="rId2"/>
+              </a:rPr>
+              <a:t>53rd International Conference on Very Large Data Bases</a:t>
+            </a:r>
+          </a:p>
         </p:txBody>
       </p:sp>
       <p:pic>
@@ -3350,7 +3363,7 @@
           <p:nvPr/>
         </p:nvPicPr>
         <p:blipFill>
-          <a:blip r:embed="rId2"/>
+          <a:blip r:embed="rId3"/>
           <a:stretch>
             <a:fillRect/>
           </a:stretch>
@@ -3410,7 +3423,7 @@
           <p:nvPr/>
         </p:nvPicPr>
         <p:blipFill>
-          <a:blip r:embed="rId3"/>
+          <a:blip r:embed="rId4"/>
           <a:stretch>
             <a:fillRect/>
           </a:stretch>

</xml_diff>

<commit_message>
Deploying to gh-pages from @ ManuelePasini/slides-markdown@c0b4c3e083c156cc4123dcc52c26ad79e2222fde 🚀
</commit_message>
<xml_diff>
--- a/3rd_year_slides.pptx
+++ b/3rd_year_slides.pptx
@@ -3308,48 +3308,41 @@
             <a:pPr lvl="0"/>
             <a:r>
               <a:rPr/>
-              <a:t>A multistore solution for large spatio-temporal property graphs</a:t>
-            </a:r>
-          </a:p>
-          <a:p>
-            <a:pPr lvl="1"/>
-            <a:r>
-              <a:rPr/>
-              <a:t>Graph data model on top of heterogeneous storage</a:t>
-            </a:r>
-          </a:p>
-          <a:p>
-            <a:pPr lvl="2"/>
-            <a:r>
-              <a:rPr/>
-              <a:t>Low-evolving data on Graph storage</a:t>
-            </a:r>
-          </a:p>
-          <a:p>
-            <a:pPr lvl="2"/>
-            <a:r>
-              <a:rPr/>
-              <a:t>Highly-dynamic data on Time-Series storage</a:t>
-            </a:r>
-          </a:p>
-          <a:p>
-            <a:pPr lvl="1"/>
-            <a:r>
-              <a:rPr/>
-              <a:t>Transparent graph query interface.</a:t>
-            </a:r>
-          </a:p>
-          <a:p>
-            <a:pPr lvl="0"/>
-            <a:r>
-              <a:rPr/>
-              <a:t>Submitted to </a:t>
+              <a:t>A multistore solution for large spatio-temporal property graphs Currently on review at </a:t>
             </a:r>
             <a:r>
               <a:rPr>
                 <a:hlinkClick r:id="rId2"/>
               </a:rPr>
               <a:t>53rd International Conference on Very Large Data Bases</a:t>
+            </a:r>
+          </a:p>
+          <a:p>
+            <a:pPr lvl="1"/>
+            <a:r>
+              <a:rPr/>
+              <a:t>Graph data model on top of heterogeneous storage</a:t>
+            </a:r>
+          </a:p>
+          <a:p>
+            <a:pPr lvl="2"/>
+            <a:r>
+              <a:rPr/>
+              <a:t>Low-evolving data on Graph storage</a:t>
+            </a:r>
+          </a:p>
+          <a:p>
+            <a:pPr lvl="2"/>
+            <a:r>
+              <a:rPr/>
+              <a:t>Highly-dynamic data on Time-Series storage</a:t>
+            </a:r>
+          </a:p>
+          <a:p>
+            <a:pPr lvl="1"/>
+            <a:r>
+              <a:rPr/>
+              <a:t>Transparent graph query interface.</a:t>
             </a:r>
           </a:p>
         </p:txBody>
@@ -3416,7 +3409,7 @@
       </p:sp>
       <p:pic>
         <p:nvPicPr>
-          <p:cNvPr descr="https://github.com/ManuelePasini/slides-markdown/blob/master/slides/images/phd3rdyear/arch.svg?raw=true" id="0" name="Picture 1"/>
+          <p:cNvPr descr="https://github.com/ManuelePasini/slides-markdown/blob/master/slides/images/phd3rdyear/stgraph_results.svg?raw=true" id="0" name="Picture 1"/>
           <p:cNvPicPr>
             <a:picLocks noGrp="1" noChangeAspect="1"/>
           </p:cNvPicPr>
@@ -3430,8 +3423,8 @@
         </p:blipFill>
         <p:spPr bwMode="auto">
           <a:xfrm>
-            <a:off x="4648200" y="1333500"/>
-            <a:ext cx="4038600" cy="2603500"/>
+            <a:off x="-3424605421912711804224326388453092117542246144885094021058843046054807474094793347678096492991863561202338169411550043463399945095914636658488743553681982069396478369743687494513557283403738092975581230237219359896366770498623917892078044755802758867961827228541368981470995035128038595607113538079341469813964800" y="1193800"/>
+            <a:ext cx="-3424605421912711804224326388453092117542246144885094021058843046054807474094793347678096492991863561202338169411550043463399945095914636658488743553681982069396478369743687494513557283403738092975581230237219359896366770498623917892078044755802758867961827228541368981470995035128038595607113538079341469813964800" cy="2882900"/>
           </a:xfrm>
           <a:prstGeom prst="rect">
             <a:avLst/>
@@ -3640,8 +3633,8 @@
         </p:blipFill>
         <p:spPr bwMode="auto">
           <a:xfrm>
-            <a:off x="2413000" y="1193800"/>
-            <a:ext cx="4318000" cy="2882900"/>
+            <a:off x="457200" y="1295400"/>
+            <a:ext cx="4038600" cy="2692400"/>
           </a:xfrm>
           <a:prstGeom prst="rect">
             <a:avLst/>
@@ -3663,7 +3656,7 @@
         <p:spPr>
           <a:xfrm>
             <a:off x="457200" y="4076700"/>
-            <a:ext cx="8229600" cy="508000"/>
+            <a:ext cx="4038600" cy="508000"/>
           </a:xfrm>
           <a:prstGeom prst="rect">
             <a:avLst/>
@@ -3680,6 +3673,89 @@
             <a:r>
               <a:rPr/>
               <a:t>Querying STGraph</a:t>
+            </a:r>
+          </a:p>
+        </p:txBody>
+      </p:sp>
+      <p:sp>
+        <p:nvSpPr>
+          <p:cNvPr id="4" name="Content Placeholder 3"/>
+          <p:cNvSpPr>
+            <a:spLocks noGrp="1"/>
+          </p:cNvSpPr>
+          <p:nvPr>
+            <p:ph idx="2" sz="half"/>
+          </p:nvPr>
+        </p:nvSpPr>
+        <p:spPr/>
+        <p:txBody>
+          <a:bodyPr/>
+          <a:lstStyle/>
+          <a:p>
+            <a:pPr lvl="0"/>
+            <a:r>
+              <a:rPr/>
+              <a:t>Results</a:t>
+            </a:r>
+          </a:p>
+        </p:txBody>
+      </p:sp>
+      <p:pic>
+        <p:nvPicPr>
+          <p:cNvPr descr="https://github.com/ManuelePasini/slides-markdown/blob/master/slides/images/phd3rdyear/example.svg?raw=true" id="0" name="Picture 1"/>
+          <p:cNvPicPr>
+            <a:picLocks noGrp="1" noChangeAspect="1"/>
+          </p:cNvPicPr>
+          <p:nvPr/>
+        </p:nvPicPr>
+        <p:blipFill>
+          <a:blip r:embed="rId3"/>
+          <a:stretch>
+            <a:fillRect/>
+          </a:stretch>
+        </p:blipFill>
+        <p:spPr bwMode="auto">
+          <a:xfrm>
+            <a:off x="4648200" y="1295400"/>
+            <a:ext cx="4038600" cy="2692400"/>
+          </a:xfrm>
+          <a:prstGeom prst="rect">
+            <a:avLst/>
+          </a:prstGeom>
+          <a:noFill/>
+          <a:ln w="9525">
+            <a:noFill/>
+            <a:headEnd/>
+            <a:tailEnd/>
+          </a:ln>
+        </p:spPr>
+      </p:pic>
+      <p:sp>
+        <p:nvSpPr>
+          <p:cNvPr id="1" name="TextBox 3"/>
+          <p:cNvSpPr txBox="1"/>
+          <p:nvPr/>
+        </p:nvSpPr>
+        <p:spPr>
+          <a:xfrm>
+            <a:off x="4648200" y="4076700"/>
+            <a:ext cx="4038600" cy="508000"/>
+          </a:xfrm>
+          <a:prstGeom prst="rect">
+            <a:avLst/>
+          </a:prstGeom>
+          <a:noFill/>
+        </p:spPr>
+        <p:txBody>
+          <a:bodyPr/>
+          <a:lstStyle/>
+          <a:p>
+            <a:pPr lvl="0" indent="0" marL="0" algn="ctr">
+              <a:buNone/>
+            </a:pPr>
+            <a:r>
+              <a:rPr/>
+              <a:t>Ingestion and query results</a:t>
             </a:r>
           </a:p>
         </p:txBody>

</xml_diff>

<commit_message>
Deploying to gh-pages from @ ManuelePasini/slides-markdown@38fb223b15fb5b603ce4cab45ddc17af11618b91 🚀
</commit_message>
<xml_diff>
--- a/3rd_year_slides.pptx
+++ b/3rd_year_slides.pptx
@@ -3308,7 +3308,7 @@
             <a:pPr lvl="0"/>
             <a:r>
               <a:rPr/>
-              <a:t>A multistore solution for large spatio-temporal property graphs Currently on review at </a:t>
+              <a:t>A multistore solution for large spatio-temporal property graphs Currently under review at </a:t>
             </a:r>
             <a:r>
               <a:rPr>
@@ -4127,7 +4127,9 @@
           <a:bodyPr/>
           <a:lstStyle/>
           <a:p>
-            <a:pPr lvl="0"/>
+            <a:pPr lvl="0" indent="0" marL="0">
+              <a:buNone/>
+            </a:pPr>
             <a:r>
               <a:rPr/>
               <a:t>Published at </a:t>
@@ -4995,14 +4997,7 @@
             <a:pPr lvl="0"/>
             <a:r>
               <a:rPr/>
-              <a:t>Soil data is interpolated to obtain a 2-dimensional view of soil moisture</a:t>
-            </a:r>
-          </a:p>
-          <a:p>
-            <a:pPr lvl="0"/>
-            <a:r>
-              <a:rPr/>
-              <a:t>Published in </a:t>
+              <a:t>Soil data is interpolated to obtain a 2-dimensional view of soil moisture  Published in </a:t>
             </a:r>
             <a:r>
               <a:rPr>

</xml_diff>

<commit_message>
Deploying to gh-pages from @ ManuelePasini/slides-markdown@0983af13c606d9ce1b4e72a847e34201ec29dcd2 🚀
</commit_message>
<xml_diff>
--- a/3rd_year_slides.pptx
+++ b/3rd_year_slides.pptx
@@ -21,6 +21,7 @@
     <p:sldId id="269" r:id="rId15"/>
     <p:sldId id="270" r:id="rId16"/>
     <p:sldId id="271" r:id="rId17"/>
+    <p:sldId id="272" r:id="rId18"/>
   </p:sldIdLst>
   <p:sldSz cx="9144000" cy="5143500" type="screen16x9"/>
   <p:notesSz cx="6858000" cy="9144000"/>
@@ -3297,172 +3298,26 @@
             <a:spLocks noGrp="1"/>
           </p:cNvSpPr>
           <p:nvPr>
-            <p:ph idx="1" sz="half"/>
-          </p:nvPr>
-        </p:nvSpPr>
-        <p:spPr/>
-        <p:txBody>
-          <a:bodyPr/>
-          <a:lstStyle/>
-          <a:p>
-            <a:pPr lvl="0"/>
-            <a:r>
-              <a:rPr/>
-              <a:t>A multistore solution for large spatio-temporal property graphs Currently under review at </a:t>
+            <p:ph idx="1"/>
+          </p:nvPr>
+        </p:nvSpPr>
+        <p:spPr/>
+        <p:txBody>
+          <a:bodyPr/>
+          <a:lstStyle/>
+          <a:p>
+            <a:pPr lvl="0" indent="0" marL="0">
+              <a:buNone/>
+            </a:pPr>
+            <a:r>
+              <a:rPr/>
+              <a:t>Currently under review at </a:t>
             </a:r>
             <a:r>
               <a:rPr>
                 <a:hlinkClick r:id="rId2"/>
               </a:rPr>
               <a:t>53rd International Conference on Very Large Data Bases</a:t>
-            </a:r>
-          </a:p>
-          <a:p>
-            <a:pPr lvl="1"/>
-            <a:r>
-              <a:rPr/>
-              <a:t>Graph data model on top of heterogeneous storage</a:t>
-            </a:r>
-          </a:p>
-          <a:p>
-            <a:pPr lvl="2"/>
-            <a:r>
-              <a:rPr/>
-              <a:t>Low-evolving data on Graph storage</a:t>
-            </a:r>
-          </a:p>
-          <a:p>
-            <a:pPr lvl="2"/>
-            <a:r>
-              <a:rPr/>
-              <a:t>Highly-dynamic data on Time-Series storage</a:t>
-            </a:r>
-          </a:p>
-          <a:p>
-            <a:pPr lvl="1"/>
-            <a:r>
-              <a:rPr/>
-              <a:t>Transparent graph query interface.</a:t>
-            </a:r>
-          </a:p>
-        </p:txBody>
-      </p:sp>
-      <p:pic>
-        <p:nvPicPr>
-          <p:cNvPr descr="https://github.com/ManuelePasini/slides-markdown/blob/master/slides/images/phd3rdyear/datamodel.svg?raw=true" id="0" name="Picture 1"/>
-          <p:cNvPicPr>
-            <a:picLocks noGrp="1" noChangeAspect="1"/>
-          </p:cNvPicPr>
-          <p:nvPr/>
-        </p:nvPicPr>
-        <p:blipFill>
-          <a:blip r:embed="rId3"/>
-          <a:stretch>
-            <a:fillRect/>
-          </a:stretch>
-        </p:blipFill>
-        <p:spPr bwMode="auto">
-          <a:xfrm>
-            <a:off x="457200" y="1295400"/>
-            <a:ext cx="4038600" cy="2692400"/>
-          </a:xfrm>
-          <a:prstGeom prst="rect">
-            <a:avLst/>
-          </a:prstGeom>
-          <a:noFill/>
-          <a:ln w="9525">
-            <a:noFill/>
-            <a:headEnd/>
-            <a:tailEnd/>
-          </a:ln>
-        </p:spPr>
-      </p:pic>
-      <p:sp>
-        <p:nvSpPr>
-          <p:cNvPr id="1" name="TextBox 3"/>
-          <p:cNvSpPr txBox="1"/>
-          <p:nvPr/>
-        </p:nvSpPr>
-        <p:spPr>
-          <a:xfrm>
-            <a:off x="457200" y="4076700"/>
-            <a:ext cx="4038600" cy="508000"/>
-          </a:xfrm>
-          <a:prstGeom prst="rect">
-            <a:avLst/>
-          </a:prstGeom>
-          <a:noFill/>
-        </p:spPr>
-        <p:txBody>
-          <a:bodyPr/>
-          <a:lstStyle/>
-          <a:p>
-            <a:pPr lvl="0" indent="0" marL="0" algn="ctr">
-              <a:buNone/>
-            </a:pPr>
-            <a:r>
-              <a:rPr/>
-              <a:t>STGraph Data Model</a:t>
-            </a:r>
-          </a:p>
-        </p:txBody>
-      </p:sp>
-      <p:pic>
-        <p:nvPicPr>
-          <p:cNvPr descr="https://github.com/ManuelePasini/slides-markdown/blob/master/slides/images/phd3rdyear/stgraph_results.svg?raw=true" id="0" name="Picture 1"/>
-          <p:cNvPicPr>
-            <a:picLocks noGrp="1" noChangeAspect="1"/>
-          </p:cNvPicPr>
-          <p:nvPr/>
-        </p:nvPicPr>
-        <p:blipFill>
-          <a:blip r:embed="rId4"/>
-          <a:stretch>
-            <a:fillRect/>
-          </a:stretch>
-        </p:blipFill>
-        <p:spPr bwMode="auto">
-          <a:xfrm>
-            <a:off x="-3424605421912711804224326388453092117542246144885094021058843046054807474094793347678096492991863561202338169411550043463399945095914636658488743553681982069396478369743687494513557283403738092975581230237219359896366770498623917892078044755802758867961827228541368981470995035128038595607113538079341469813964800" y="1193800"/>
-            <a:ext cx="-3424605421912711804224326388453092117542246144885094021058843046054807474094793347678096492991863561202338169411550043463399945095914636658488743553681982069396478369743687494513557283403738092975581230237219359896366770498623917892078044755802758867961827228541368981470995035128038595607113538079341469813964800" cy="2882900"/>
-          </a:xfrm>
-          <a:prstGeom prst="rect">
-            <a:avLst/>
-          </a:prstGeom>
-          <a:noFill/>
-          <a:ln w="9525">
-            <a:noFill/>
-            <a:headEnd/>
-            <a:tailEnd/>
-          </a:ln>
-        </p:spPr>
-      </p:pic>
-      <p:sp>
-        <p:nvSpPr>
-          <p:cNvPr id="1" name="TextBox 3"/>
-          <p:cNvSpPr txBox="1"/>
-          <p:nvPr/>
-        </p:nvSpPr>
-        <p:spPr>
-          <a:xfrm>
-            <a:off x="4648200" y="4076700"/>
-            <a:ext cx="4038600" cy="508000"/>
-          </a:xfrm>
-          <a:prstGeom prst="rect">
-            <a:avLst/>
-          </a:prstGeom>
-          <a:noFill/>
-        </p:spPr>
-        <p:txBody>
-          <a:bodyPr/>
-          <a:lstStyle/>
-          <a:p>
-            <a:pPr lvl="0" indent="0" marL="0" algn="ctr">
-              <a:buNone/>
-            </a:pPr>
-            <a:r>
-              <a:rPr/>
-              <a:t>STGraph Architecture</a:t>
             </a:r>
           </a:p>
         </p:txBody>
@@ -3491,106 +3346,171 @@
       </p:grpSpPr>
       <p:sp>
         <p:nvSpPr>
-          <p:cNvPr id="2" name="Title 1"/>
-          <p:cNvSpPr>
-            <a:spLocks noGrp="1"/>
-          </p:cNvSpPr>
-          <p:nvPr>
-            <p:ph type="title"/>
-          </p:nvPr>
-        </p:nvSpPr>
-        <p:spPr/>
-        <p:txBody>
-          <a:bodyPr/>
-          <a:lstStyle/>
-          <a:p>
-            <a:pPr lvl="0" indent="0" marL="0">
+          <p:cNvPr id="3" name="Content Placeholder 2"/>
+          <p:cNvSpPr>
+            <a:spLocks noGrp="1"/>
+          </p:cNvSpPr>
+          <p:nvPr>
+            <p:ph idx="1" sz="half"/>
+          </p:nvPr>
+        </p:nvSpPr>
+        <p:spPr/>
+        <p:txBody>
+          <a:bodyPr/>
+          <a:lstStyle/>
+          <a:p>
+            <a:pPr lvl="0"/>
+            <a:r>
+              <a:rPr/>
+              <a:t>A multistore solution for large spatio-temporal property graphs</a:t>
+            </a:r>
+          </a:p>
+          <a:p>
+            <a:pPr lvl="1"/>
+            <a:r>
+              <a:rPr/>
+              <a:t>Graph data model on top of heterogeneous storage</a:t>
+            </a:r>
+          </a:p>
+          <a:p>
+            <a:pPr lvl="2"/>
+            <a:r>
+              <a:rPr/>
+              <a:t>Low-evolving data on Graph storage</a:t>
+            </a:r>
+          </a:p>
+          <a:p>
+            <a:pPr lvl="2"/>
+            <a:r>
+              <a:rPr/>
+              <a:t>Highly-dynamic data on Time-Series storage</a:t>
+            </a:r>
+          </a:p>
+          <a:p>
+            <a:pPr lvl="1"/>
+            <a:r>
+              <a:rPr/>
+              <a:t>Transparent graph query interface.</a:t>
+            </a:r>
+          </a:p>
+        </p:txBody>
+      </p:sp>
+      <p:pic>
+        <p:nvPicPr>
+          <p:cNvPr descr="https://github.com/ManuelePasini/slides-markdown/blob/master/slides/images/phd3rdyear/datamodel.svg?raw=true" id="0" name="Picture 1"/>
+          <p:cNvPicPr>
+            <a:picLocks noGrp="1" noChangeAspect="1"/>
+          </p:cNvPicPr>
+          <p:nvPr/>
+        </p:nvPicPr>
+        <p:blipFill>
+          <a:blip r:embed="rId2"/>
+          <a:stretch>
+            <a:fillRect/>
+          </a:stretch>
+        </p:blipFill>
+        <p:spPr bwMode="auto">
+          <a:xfrm>
+            <a:off x="457200" y="1295400"/>
+            <a:ext cx="4038600" cy="2692400"/>
+          </a:xfrm>
+          <a:prstGeom prst="rect">
+            <a:avLst/>
+          </a:prstGeom>
+          <a:noFill/>
+          <a:ln w="9525">
+            <a:noFill/>
+            <a:headEnd/>
+            <a:tailEnd/>
+          </a:ln>
+        </p:spPr>
+      </p:pic>
+      <p:sp>
+        <p:nvSpPr>
+          <p:cNvPr id="1" name="TextBox 3"/>
+          <p:cNvSpPr txBox="1"/>
+          <p:nvPr/>
+        </p:nvSpPr>
+        <p:spPr>
+          <a:xfrm>
+            <a:off x="457200" y="4076700"/>
+            <a:ext cx="4038600" cy="508000"/>
+          </a:xfrm>
+          <a:prstGeom prst="rect">
+            <a:avLst/>
+          </a:prstGeom>
+          <a:noFill/>
+        </p:spPr>
+        <p:txBody>
+          <a:bodyPr/>
+          <a:lstStyle/>
+          <a:p>
+            <a:pPr lvl="0" indent="0" marL="0" algn="ctr">
               <a:buNone/>
             </a:pPr>
             <a:r>
               <a:rPr/>
-              <a:t>STGraph: A Multistore for Temporal Graphs and Time-Series</a:t>
-            </a:r>
-          </a:p>
-        </p:txBody>
-      </p:sp>
-      <p:sp>
-        <p:nvSpPr>
-          <p:cNvPr id="3" name="Content Placeholder 2"/>
-          <p:cNvSpPr>
-            <a:spLocks noGrp="1"/>
-          </p:cNvSpPr>
-          <p:nvPr>
-            <p:ph idx="1" sz="half"/>
-          </p:nvPr>
-        </p:nvSpPr>
-        <p:spPr/>
-        <p:txBody>
-          <a:bodyPr/>
-          <a:lstStyle/>
-          <a:p>
-            <a:pPr lvl="0"/>
-            <a:r>
-              <a:rPr/>
-              <a:t>Property Graph data model</a:t>
-            </a:r>
-          </a:p>
-          <a:p>
-            <a:pPr lvl="1"/>
-            <a:r>
-              <a:rPr/>
-              <a:t>TS events (nodes) can hold edges and properties</a:t>
-            </a:r>
-          </a:p>
-          <a:p>
-            <a:pPr lvl="1"/>
-            <a:r>
-              <a:rPr/>
-              <a:t>Edges built at query time</a:t>
-            </a:r>
-          </a:p>
-        </p:txBody>
-      </p:sp>
-      <p:sp>
-        <p:nvSpPr>
-          <p:cNvPr id="4" name="Content Placeholder 3"/>
-          <p:cNvSpPr>
-            <a:spLocks noGrp="1"/>
-          </p:cNvSpPr>
-          <p:nvPr>
-            <p:ph idx="2" sz="half"/>
-          </p:nvPr>
-        </p:nvSpPr>
-        <p:spPr/>
-        <p:txBody>
-          <a:bodyPr/>
-          <a:lstStyle/>
-          <a:p>
-            <a:pPr lvl="0"/>
-            <a:r>
-              <a:rPr/>
-              <a:t>Hybrid storage</a:t>
-            </a:r>
-          </a:p>
-          <a:p>
-            <a:pPr lvl="1"/>
-            <a:r>
-              <a:rPr/>
-              <a:t>Dedicated Time-Series streaming ingestion of data</a:t>
-            </a:r>
-          </a:p>
-          <a:p>
-            <a:pPr lvl="1"/>
-            <a:r>
-              <a:rPr/>
-              <a:t>Query optimization through filter-pushdown</a:t>
-            </a:r>
-          </a:p>
-          <a:p>
-            <a:pPr lvl="1"/>
-            <a:r>
-              <a:rPr/>
-              <a:t>Efficient graph traversal &amp; temporal reasoning</a:t>
+              <a:t>STGraph Data Model</a:t>
+            </a:r>
+          </a:p>
+        </p:txBody>
+      </p:sp>
+      <p:pic>
+        <p:nvPicPr>
+          <p:cNvPr descr="https://github.com/ManuelePasini/slides-markdown/blob/master/slides/images/phd3rdyear/arch.svg?raw=true" id="0" name="Picture 1"/>
+          <p:cNvPicPr>
+            <a:picLocks noGrp="1" noChangeAspect="1"/>
+          </p:cNvPicPr>
+          <p:nvPr/>
+        </p:nvPicPr>
+        <p:blipFill>
+          <a:blip r:embed="rId3"/>
+          <a:stretch>
+            <a:fillRect/>
+          </a:stretch>
+        </p:blipFill>
+        <p:spPr bwMode="auto">
+          <a:xfrm>
+            <a:off x="4648200" y="1333500"/>
+            <a:ext cx="4038600" cy="2603500"/>
+          </a:xfrm>
+          <a:prstGeom prst="rect">
+            <a:avLst/>
+          </a:prstGeom>
+          <a:noFill/>
+          <a:ln w="9525">
+            <a:noFill/>
+            <a:headEnd/>
+            <a:tailEnd/>
+          </a:ln>
+        </p:spPr>
+      </p:pic>
+      <p:sp>
+        <p:nvSpPr>
+          <p:cNvPr id="1" name="TextBox 3"/>
+          <p:cNvSpPr txBox="1"/>
+          <p:nvPr/>
+        </p:nvSpPr>
+        <p:spPr>
+          <a:xfrm>
+            <a:off x="4648200" y="4076700"/>
+            <a:ext cx="4038600" cy="508000"/>
+          </a:xfrm>
+          <a:prstGeom prst="rect">
+            <a:avLst/>
+          </a:prstGeom>
+          <a:noFill/>
+        </p:spPr>
+        <p:txBody>
+          <a:bodyPr/>
+          <a:lstStyle/>
+          <a:p>
+            <a:pPr lvl="0" indent="0" marL="0" algn="ctr">
+              <a:buNone/>
+            </a:pPr>
+            <a:r>
+              <a:rPr/>
+              <a:t>STGraph Architecture</a:t>
             </a:r>
           </a:p>
         </p:txBody>
@@ -3617,6 +3537,157 @@
           <a:chExt cx="0" cy="0"/>
         </a:xfrm>
       </p:grpSpPr>
+      <p:sp>
+        <p:nvSpPr>
+          <p:cNvPr id="2" name="Title 1"/>
+          <p:cNvSpPr>
+            <a:spLocks noGrp="1"/>
+          </p:cNvSpPr>
+          <p:nvPr>
+            <p:ph type="title"/>
+          </p:nvPr>
+        </p:nvSpPr>
+        <p:spPr/>
+        <p:txBody>
+          <a:bodyPr/>
+          <a:lstStyle/>
+          <a:p>
+            <a:pPr lvl="0" indent="0" marL="0">
+              <a:buNone/>
+            </a:pPr>
+            <a:r>
+              <a:rPr/>
+              <a:t>STGraph: A Multistore for Temporal Graphs and Time-Series</a:t>
+            </a:r>
+          </a:p>
+        </p:txBody>
+      </p:sp>
+      <p:sp>
+        <p:nvSpPr>
+          <p:cNvPr id="3" name="Content Placeholder 2"/>
+          <p:cNvSpPr>
+            <a:spLocks noGrp="1"/>
+          </p:cNvSpPr>
+          <p:nvPr>
+            <p:ph idx="1" sz="half"/>
+          </p:nvPr>
+        </p:nvSpPr>
+        <p:spPr/>
+        <p:txBody>
+          <a:bodyPr/>
+          <a:lstStyle/>
+          <a:p>
+            <a:pPr lvl="0"/>
+            <a:r>
+              <a:rPr/>
+              <a:t>Property Graph data model</a:t>
+            </a:r>
+          </a:p>
+          <a:p>
+            <a:pPr lvl="1"/>
+            <a:r>
+              <a:rPr/>
+              <a:t>TS events (nodes) can hold edges and properties</a:t>
+            </a:r>
+          </a:p>
+          <a:p>
+            <a:pPr lvl="1"/>
+            <a:r>
+              <a:rPr/>
+              <a:t>Edges built at query time</a:t>
+            </a:r>
+          </a:p>
+        </p:txBody>
+      </p:sp>
+      <p:sp>
+        <p:nvSpPr>
+          <p:cNvPr id="4" name="Content Placeholder 3"/>
+          <p:cNvSpPr>
+            <a:spLocks noGrp="1"/>
+          </p:cNvSpPr>
+          <p:nvPr>
+            <p:ph idx="2" sz="half"/>
+          </p:nvPr>
+        </p:nvSpPr>
+        <p:spPr/>
+        <p:txBody>
+          <a:bodyPr/>
+          <a:lstStyle/>
+          <a:p>
+            <a:pPr lvl="0"/>
+            <a:r>
+              <a:rPr/>
+              <a:t>Hybrid storage</a:t>
+            </a:r>
+          </a:p>
+          <a:p>
+            <a:pPr lvl="1"/>
+            <a:r>
+              <a:rPr/>
+              <a:t>Dedicated Time-Series streaming ingestion of data</a:t>
+            </a:r>
+          </a:p>
+          <a:p>
+            <a:pPr lvl="1"/>
+            <a:r>
+              <a:rPr/>
+              <a:t>Query optimization through filter-pushdown</a:t>
+            </a:r>
+          </a:p>
+          <a:p>
+            <a:pPr lvl="1"/>
+            <a:r>
+              <a:rPr/>
+              <a:t>Efficient graph traversal &amp; temporal reasoning</a:t>
+            </a:r>
+          </a:p>
+        </p:txBody>
+      </p:sp>
+    </p:spTree>
+  </p:cSld>
+</p:sld>
+</file>
+
+<file path=ppt/slides/slide13.xml><?xml version="1.0" encoding="utf-8"?>
+<p:sld xmlns:a="http://schemas.openxmlformats.org/drawingml/2006/main" xmlns:r="http://schemas.openxmlformats.org/officeDocument/2006/relationships" xmlns:p="http://schemas.openxmlformats.org/presentationml/2006/main">
+  <p:cSld>
+    <p:spTree>
+      <p:nvGrpSpPr>
+        <p:cNvPr id="1" name=""/>
+        <p:cNvGrpSpPr/>
+        <p:nvPr/>
+      </p:nvGrpSpPr>
+      <p:grpSpPr>
+        <a:xfrm>
+          <a:off x="0" y="0"/>
+          <a:ext cx="0" cy="0"/>
+          <a:chOff x="0" y="0"/>
+          <a:chExt cx="0" cy="0"/>
+        </a:xfrm>
+      </p:grpSpPr>
+      <p:sp>
+        <p:nvSpPr>
+          <p:cNvPr id="3" name="Content Placeholder 2"/>
+          <p:cNvSpPr>
+            <a:spLocks noGrp="1"/>
+          </p:cNvSpPr>
+          <p:nvPr>
+            <p:ph idx="1" sz="half"/>
+          </p:nvPr>
+        </p:nvSpPr>
+        <p:spPr/>
+        <p:txBody>
+          <a:bodyPr/>
+          <a:lstStyle/>
+          <a:p>
+            <a:pPr lvl="0"/>
+            <a:r>
+              <a:rPr/>
+              <a:t>Toy Example</a:t>
+            </a:r>
+          </a:p>
+        </p:txBody>
+      </p:sp>
       <p:pic>
         <p:nvPicPr>
           <p:cNvPr descr="https://github.com/ManuelePasini/slides-markdown/blob/master/slides/images/phd3rdyear/example.svg?raw=true" id="0" name="Picture 1"/>
@@ -3702,7 +3773,7 @@
       </p:sp>
       <p:pic>
         <p:nvPicPr>
-          <p:cNvPr descr="https://github.com/ManuelePasini/slides-markdown/blob/master/slides/images/phd3rdyear/example.svg?raw=true" id="0" name="Picture 1"/>
+          <p:cNvPr descr="https://github.com/ManuelePasini/slides-markdown/blob/master/slides/images/phd3rdyear/stgraph_results.svg?raw=true" id="0" name="Picture 1"/>
           <p:cNvPicPr>
             <a:picLocks noGrp="1" noChangeAspect="1"/>
           </p:cNvPicPr>
@@ -3716,8 +3787,8 @@
         </p:blipFill>
         <p:spPr bwMode="auto">
           <a:xfrm>
-            <a:off x="4648200" y="1295400"/>
-            <a:ext cx="4038600" cy="2692400"/>
+            <a:off x="-3424605421912711804224326388453092117542246144885094021058843046054807474094793347678096492991863561202338169411550043463399945095914636658488743553681982069396478369743687494513557283403738092975581230237219359896366770498623917892078044755802758867961827228541368981470995035128038595607113538079341469813964800" y="1193800"/>
+            <a:ext cx="-3424605421912711804224326388453092117542246144885094021058843046054807474094793347678096492991863561202338169411550043463399945095914636658488743553681982069396478369743687494513557283403738092975581230237219359896366770498623917892078044755802758867961827228541368981470995035128038595607113538079341469813964800" cy="2882900"/>
           </a:xfrm>
           <a:prstGeom prst="rect">
             <a:avLst/>
@@ -3765,7 +3836,7 @@
 </p:sld>
 </file>
 
-<file path=ppt/slides/slide13.xml><?xml version="1.0" encoding="utf-8"?>
+<file path=ppt/slides/slide14.xml><?xml version="1.0" encoding="utf-8"?>
 <p:sld xmlns:a="http://schemas.openxmlformats.org/drawingml/2006/main" xmlns:r="http://schemas.openxmlformats.org/officeDocument/2006/relationships" xmlns:p="http://schemas.openxmlformats.org/presentationml/2006/main">
   <p:cSld>
     <p:spTree>
@@ -3856,7 +3927,7 @@
 </p:sld>
 </file>
 
-<file path=ppt/slides/slide14.xml><?xml version="1.0" encoding="utf-8"?>
+<file path=ppt/slides/slide15.xml><?xml version="1.0" encoding="utf-8"?>
 <p:sld xmlns:a="http://schemas.openxmlformats.org/drawingml/2006/main" xmlns:r="http://schemas.openxmlformats.org/officeDocument/2006/relationships" xmlns:p="http://schemas.openxmlformats.org/presentationml/2006/main">
   <p:cSld>
     <p:spTree>
@@ -3998,7 +4069,7 @@
 </p:sld>
 </file>
 
-<file path=ppt/slides/slide15.xml><?xml version="1.0" encoding="utf-8"?>
+<file path=ppt/slides/slide16.xml><?xml version="1.0" encoding="utf-8"?>
 <p:sld xmlns:a="http://schemas.openxmlformats.org/drawingml/2006/main" xmlns:r="http://schemas.openxmlformats.org/officeDocument/2006/relationships" xmlns:p="http://schemas.openxmlformats.org/presentationml/2006/main">
   <p:cSld>
     <p:spTree>
@@ -4070,7 +4141,7 @@
 </p:sld>
 </file>
 
-<file path=ppt/slides/slide16.xml><?xml version="1.0" encoding="utf-8"?>
+<file path=ppt/slides/slide17.xml><?xml version="1.0" encoding="utf-8"?>
 <p:sld xmlns:a="http://schemas.openxmlformats.org/drawingml/2006/main" xmlns:r="http://schemas.openxmlformats.org/officeDocument/2006/relationships" xmlns:p="http://schemas.openxmlformats.org/presentationml/2006/main">
   <p:cSld>
     <p:spTree>
@@ -4980,30 +5051,39 @@
           <a:bodyPr/>
           <a:lstStyle/>
           <a:p>
-            <a:pPr lvl="0"/>
-            <a:r>
-              <a:rPr/>
-              <a:t>Two kiwifiruit orchards in Emilia-Romagna</a:t>
-            </a:r>
-          </a:p>
-          <a:p>
-            <a:pPr lvl="0"/>
-            <a:r>
-              <a:rPr/>
-              <a:t>Data collected from a grid of soil moisture sensors and weather stations</a:t>
-            </a:r>
-          </a:p>
-          <a:p>
-            <a:pPr lvl="0"/>
-            <a:r>
-              <a:rPr/>
-              <a:t>Soil data is interpolated to obtain a 2-dimensional view of soil moisture  Published in </a:t>
+            <a:pPr lvl="0" indent="0" marL="0">
+              <a:buNone/>
+            </a:pPr>
+            <a:r>
+              <a:rPr/>
+              <a:t> Published in </a:t>
             </a:r>
             <a:r>
               <a:rPr>
                 <a:hlinkClick r:id="rId2"/>
               </a:rPr>
               <a:t>Computers and Electronics in Agriculture</a:t>
+            </a:r>
+          </a:p>
+          <a:p>
+            <a:pPr lvl="0"/>
+            <a:r>
+              <a:rPr/>
+              <a:t>Two kiwifiruit orchards in Emilia-Romagna</a:t>
+            </a:r>
+          </a:p>
+          <a:p>
+            <a:pPr lvl="0"/>
+            <a:r>
+              <a:rPr/>
+              <a:t>Data collected from a grid of soil moisture sensors and weather stations</a:t>
+            </a:r>
+          </a:p>
+          <a:p>
+            <a:pPr lvl="0"/>
+            <a:r>
+              <a:rPr/>
+              <a:t>Soil data is interpolated to obtain a 2-dimensional view of soil moisture</a:t>
             </a:r>
           </a:p>
         </p:txBody>

</xml_diff>

<commit_message>
Deploying to gh-pages from @ ManuelePasini/slides-markdown@9c6c04d4faea799e0153d4983cb2ff1d4d188705 🚀
</commit_message>
<xml_diff>
--- a/3rd_year_slides.pptx
+++ b/3rd_year_slides.pptx
@@ -3893,6 +3893,15 @@
           <a:bodyPr/>
           <a:lstStyle/>
           <a:p>
+            <a:pPr lvl="0" indent="0" marL="0">
+              <a:buNone/>
+            </a:pPr>
+            <a:r>
+              <a:rPr/>
+              <a:t>Currently under development, in collaboration with Angela Bonifati @ Lyon1</a:t>
+            </a:r>
+          </a:p>
+          <a:p>
             <a:pPr lvl="0"/>
             <a:r>
               <a:rPr/>
@@ -3911,13 +3920,6 @@
             <a:r>
               <a:rPr b="1"/>
               <a:t>What about anomalies that are cross-time series?</a:t>
-            </a:r>
-          </a:p>
-          <a:p>
-            <a:pPr lvl="0"/>
-            <a:r>
-              <a:rPr/>
-              <a:t>Hopefully to be published</a:t>
             </a:r>
           </a:p>
         </p:txBody>
@@ -5392,7 +5394,7 @@
       </p:sp>
       <p:pic>
         <p:nvPicPr>
-          <p:cNvPr descr="https://github.com/ManuelePasini/slides-markdown/blob/master/slides/images/phd3rdyear/smarter_results.png?raw=true" id="0" name="Picture 1"/>
+          <p:cNvPr descr="https://github.com/ManuelePasini/slides-markdown/blob/master/slides/images/phd3rdyear/smarter_results.svg?raw=true" id="0" name="Picture 1"/>
           <p:cNvPicPr>
             <a:picLocks noGrp="1" noChangeAspect="1"/>
           </p:cNvPicPr>
@@ -5406,8 +5408,8 @@
         </p:blipFill>
         <p:spPr bwMode="auto">
           <a:xfrm>
-            <a:off x="4648200" y="1701800"/>
-            <a:ext cx="4038600" cy="1866900"/>
+            <a:off x="-3424605421912711804224326388453092117542246144885094021058843046054807474094793347678096492991863561202338169411550043463399945095914636658488743553681982069396478369743687494513557283403738092975581230237219359896366770498623917892078044755802758867961827228541368981470995035128038595607113538079341469813964800" y="1193800"/>
+            <a:ext cx="-3424605421912711804224326388453092117542246144885094021058843046054807474094793347678096492991863561202338169411550043463399945095914636658488743553681982069396478369743687494513557283403738092975581230237219359896366770498623917892078044755802758867961827228541368981470995035128038595607113538079341469813964800" cy="2882900"/>
           </a:xfrm>
           <a:prstGeom prst="rect">
             <a:avLst/>
@@ -5445,67 +5447,7 @@
             </a:pPr>
             <a:r>
               <a:rPr/>
-              <a:t>Water saving results</a:t>
-            </a:r>
-          </a:p>
-        </p:txBody>
-      </p:sp>
-      <p:pic>
-        <p:nvPicPr>
-          <p:cNvPr descr="https://github.com/ManuelePasini/slides-markdown/blob/master/slides/images/phd3rdyear/smarter_fruit_results.png?raw=true" id="0" name="Picture 1"/>
-          <p:cNvPicPr>
-            <a:picLocks noGrp="1" noChangeAspect="1"/>
-          </p:cNvPicPr>
-          <p:nvPr/>
-        </p:nvPicPr>
-        <p:blipFill>
-          <a:blip r:embed="rId4"/>
-          <a:stretch>
-            <a:fillRect/>
-          </a:stretch>
-        </p:blipFill>
-        <p:spPr bwMode="auto">
-          <a:xfrm>
-            <a:off x="4648200" y="1981200"/>
-            <a:ext cx="4038600" cy="1308100"/>
-          </a:xfrm>
-          <a:prstGeom prst="rect">
-            <a:avLst/>
-          </a:prstGeom>
-          <a:noFill/>
-          <a:ln w="9525">
-            <a:noFill/>
-            <a:headEnd/>
-            <a:tailEnd/>
-          </a:ln>
-        </p:spPr>
-      </p:pic>
-      <p:sp>
-        <p:nvSpPr>
-          <p:cNvPr id="1" name="TextBox 3"/>
-          <p:cNvSpPr txBox="1"/>
-          <p:nvPr/>
-        </p:nvSpPr>
-        <p:spPr>
-          <a:xfrm>
-            <a:off x="4648200" y="4076700"/>
-            <a:ext cx="4038600" cy="508000"/>
-          </a:xfrm>
-          <a:prstGeom prst="rect">
-            <a:avLst/>
-          </a:prstGeom>
-          <a:noFill/>
-        </p:spPr>
-        <p:txBody>
-          <a:bodyPr/>
-          <a:lstStyle/>
-          <a:p>
-            <a:pPr lvl="0" indent="0" marL="0" algn="ctr">
-              <a:buNone/>
-            </a:pPr>
-            <a:r>
-              <a:rPr/>
-              <a:t>Fruit quality results</a:t>
+              <a:t>Smarter results</a:t>
             </a:r>
           </a:p>
         </p:txBody>

</xml_diff>

<commit_message>
Deploying to gh-pages from @ ManuelePasini/slides-markdown@31c43eff2621453d54970eaf9b8c25059a7b0adb 🚀
</commit_message>
<xml_diff>
--- a/3rd_year_slides.pptx
+++ b/3rd_year_slides.pptx
@@ -5274,7 +5274,7 @@
             </a:pPr>
             <a:r>
               <a:rPr/>
-              <a:t>SMARTER: Results</a:t>
+              <a:t>SMARTER: Data-driven optimization of water consumption in kiwifruit orchards</a:t>
             </a:r>
           </a:p>
         </p:txBody>
@@ -5295,6 +5295,13 @@
           <a:lstStyle/>
           <a:p>
             <a:pPr lvl="0"/>
+            <a:r>
+              <a:rPr/>
+              <a:t> Architecture</a:t>
+            </a:r>
+          </a:p>
+          <a:p>
+            <a:pPr lvl="1"/>
             <a:r>
               <a:rPr/>
               <a:t>PID controller + simulation model to determine irrigaton amounts</a:t>
@@ -5380,11 +5387,18 @@
             <a:pPr lvl="0"/>
             <a:r>
               <a:rPr/>
+              <a:t> Results</a:t>
+            </a:r>
+          </a:p>
+          <a:p>
+            <a:pPr lvl="1"/>
+            <a:r>
+              <a:rPr/>
               <a:t>Up to 40% in water savings</a:t>
             </a:r>
           </a:p>
           <a:p>
-            <a:pPr lvl="0"/>
+            <a:pPr lvl="1"/>
             <a:r>
               <a:rPr/>
               <a:t>Fruit quality preserved, smaller fruit but of improved quality</a:t>

</xml_diff>

<commit_message>
Deploying to gh-pages from @ ManuelePasini/slides-markdown@93a40cd6cdb02b73982d06579da2921150084381 🚀
</commit_message>
<xml_diff>
--- a/3rd_year_slides.pptx
+++ b/3rd_year_slides.pptx
@@ -22,6 +22,7 @@
     <p:sldId id="270" r:id="rId16"/>
     <p:sldId id="271" r:id="rId17"/>
     <p:sldId id="272" r:id="rId18"/>
+    <p:sldId id="273" r:id="rId19"/>
   </p:sldIdLst>
   <p:sldSz cx="9144000" cy="5143500" type="screen16x9"/>
   <p:notesSz cx="6858000" cy="9144000"/>
@@ -3901,27 +3902,6 @@
               <a:t>Currently under development, in collaboration with Angela Bonifati @ Lyon1</a:t>
             </a:r>
           </a:p>
-          <a:p>
-            <a:pPr lvl="0"/>
-            <a:r>
-              <a:rPr/>
-              <a:t>Complex sensor networks are increasingly common</a:t>
-            </a:r>
-          </a:p>
-          <a:p>
-            <a:pPr lvl="0"/>
-            <a:r>
-              <a:rPr/>
-              <a:t>Anomaly detection in time-series data is a well-known research field</a:t>
-            </a:r>
-          </a:p>
-          <a:p>
-            <a:pPr lvl="0"/>
-            <a:r>
-              <a:rPr b="1"/>
-              <a:t>What about anomalies that are cross-time series?</a:t>
-            </a:r>
-          </a:p>
         </p:txBody>
       </p:sp>
     </p:spTree>
@@ -3930,6 +3910,95 @@
 </file>
 
 <file path=ppt/slides/slide15.xml><?xml version="1.0" encoding="utf-8"?>
+<p:sld xmlns:a="http://schemas.openxmlformats.org/drawingml/2006/main" xmlns:r="http://schemas.openxmlformats.org/officeDocument/2006/relationships" xmlns:p="http://schemas.openxmlformats.org/presentationml/2006/main">
+  <p:cSld>
+    <p:spTree>
+      <p:nvGrpSpPr>
+        <p:cNvPr id="1" name=""/>
+        <p:cNvGrpSpPr/>
+        <p:nvPr/>
+      </p:nvGrpSpPr>
+      <p:grpSpPr>
+        <a:xfrm>
+          <a:off x="0" y="0"/>
+          <a:ext cx="0" cy="0"/>
+          <a:chOff x="0" y="0"/>
+          <a:chExt cx="0" cy="0"/>
+        </a:xfrm>
+      </p:grpSpPr>
+      <p:sp>
+        <p:nvSpPr>
+          <p:cNvPr id="3" name="Content Placeholder 2"/>
+          <p:cNvSpPr>
+            <a:spLocks noGrp="1"/>
+          </p:cNvSpPr>
+          <p:nvPr>
+            <p:ph idx="1" sz="half"/>
+          </p:nvPr>
+        </p:nvSpPr>
+        <p:spPr/>
+        <p:txBody>
+          <a:bodyPr/>
+          <a:lstStyle/>
+          <a:p>
+            <a:pPr lvl="0"/>
+            <a:r>
+              <a:rPr/>
+              <a:t>Complex sensor networks are increasingly common (e.g., transportation networks)</a:t>
+            </a:r>
+          </a:p>
+          <a:p>
+            <a:pPr lvl="0"/>
+            <a:r>
+              <a:rPr/>
+              <a:t>Anomaly detection in single time-series is a well-known research field</a:t>
+            </a:r>
+          </a:p>
+        </p:txBody>
+      </p:sp>
+      <p:sp>
+        <p:nvSpPr>
+          <p:cNvPr id="4" name="Content Placeholder 3"/>
+          <p:cNvSpPr>
+            <a:spLocks noGrp="1"/>
+          </p:cNvSpPr>
+          <p:nvPr>
+            <p:ph idx="2" sz="half"/>
+          </p:nvPr>
+        </p:nvSpPr>
+        <p:spPr/>
+        <p:txBody>
+          <a:bodyPr/>
+          <a:lstStyle/>
+          <a:p>
+            <a:pPr lvl="0"/>
+            <a:r>
+              <a:rPr b="1"/>
+              <a:t>What about topological anomalies?</a:t>
+            </a:r>
+          </a:p>
+          <a:p>
+            <a:pPr lvl="1"/>
+            <a:r>
+              <a:rPr/>
+              <a:t>Normal behavior taken individually</a:t>
+            </a:r>
+          </a:p>
+          <a:p>
+            <a:pPr lvl="1"/>
+            <a:r>
+              <a:rPr/>
+              <a:t>Topological context makes it anomalous</a:t>
+            </a:r>
+          </a:p>
+        </p:txBody>
+      </p:sp>
+    </p:spTree>
+  </p:cSld>
+</p:sld>
+</file>
+
+<file path=ppt/slides/slide16.xml><?xml version="1.0" encoding="utf-8"?>
 <p:sld xmlns:a="http://schemas.openxmlformats.org/drawingml/2006/main" xmlns:r="http://schemas.openxmlformats.org/officeDocument/2006/relationships" xmlns:p="http://schemas.openxmlformats.org/presentationml/2006/main">
   <p:cSld>
     <p:spTree>
@@ -3962,7 +4031,7 @@
         </p:blipFill>
         <p:spPr bwMode="auto">
           <a:xfrm>
-            <a:off x="457200" y="1295400"/>
+            <a:off x="457200" y="1549400"/>
             <a:ext cx="4038600" cy="2692400"/>
           </a:xfrm>
           <a:prstGeom prst="rect">
@@ -3976,36 +4045,6 @@
           </a:ln>
         </p:spPr>
       </p:pic>
-      <p:sp>
-        <p:nvSpPr>
-          <p:cNvPr id="1" name="TextBox 3"/>
-          <p:cNvSpPr txBox="1"/>
-          <p:nvPr/>
-        </p:nvSpPr>
-        <p:spPr>
-          <a:xfrm>
-            <a:off x="457200" y="4076700"/>
-            <a:ext cx="4038600" cy="508000"/>
-          </a:xfrm>
-          <a:prstGeom prst="rect">
-            <a:avLst/>
-          </a:prstGeom>
-          <a:noFill/>
-        </p:spPr>
-        <p:txBody>
-          <a:bodyPr/>
-          <a:lstStyle/>
-          <a:p>
-            <a:pPr lvl="0" indent="0" marL="0" algn="ctr">
-              <a:buNone/>
-            </a:pPr>
-            <a:r>
-              <a:rPr/>
-              <a:t>An example of cross-time series anomaly</a:t>
-            </a:r>
-          </a:p>
-        </p:txBody>
-      </p:sp>
       <p:pic>
         <p:nvPicPr>
           <p:cNvPr descr="https://github.com/ManuelePasini/slides-markdown/blob/master/slides/images/phd3rdyear/n2g_agro.svg?raw=true" id="0" name="Picture 1"/>
@@ -4022,7 +4061,7 @@
         </p:blipFill>
         <p:spPr bwMode="auto">
           <a:xfrm>
-            <a:off x="4648200" y="1295400"/>
+            <a:off x="4648200" y="1549400"/>
             <a:ext cx="4038600" cy="2692400"/>
           </a:xfrm>
           <a:prstGeom prst="rect">
@@ -4036,42 +4075,12 @@
           </a:ln>
         </p:spPr>
       </p:pic>
-      <p:sp>
-        <p:nvSpPr>
-          <p:cNvPr id="1" name="TextBox 3"/>
-          <p:cNvSpPr txBox="1"/>
-          <p:nvPr/>
-        </p:nvSpPr>
-        <p:spPr>
-          <a:xfrm>
-            <a:off x="4648200" y="4076700"/>
-            <a:ext cx="4038600" cy="508000"/>
-          </a:xfrm>
-          <a:prstGeom prst="rect">
-            <a:avLst/>
-          </a:prstGeom>
-          <a:noFill/>
-        </p:spPr>
-        <p:txBody>
-          <a:bodyPr/>
-          <a:lstStyle/>
-          <a:p>
-            <a:pPr lvl="0" indent="0" marL="0" algn="ctr">
-              <a:buNone/>
-            </a:pPr>
-            <a:r>
-              <a:rPr/>
-              <a:t>An example of cross-time series anomaly</a:t>
-            </a:r>
-          </a:p>
-        </p:txBody>
-      </p:sp>
     </p:spTree>
   </p:cSld>
 </p:sld>
 </file>
 
-<file path=ppt/slides/slide16.xml><?xml version="1.0" encoding="utf-8"?>
+<file path=ppt/slides/slide17.xml><?xml version="1.0" encoding="utf-8"?>
 <p:sld xmlns:a="http://schemas.openxmlformats.org/drawingml/2006/main" xmlns:r="http://schemas.openxmlformats.org/officeDocument/2006/relationships" xmlns:p="http://schemas.openxmlformats.org/presentationml/2006/main">
   <p:cSld>
     <p:spTree>
@@ -4143,7 +4152,7 @@
 </p:sld>
 </file>
 
-<file path=ppt/slides/slide17.xml><?xml version="1.0" encoding="utf-8"?>
+<file path=ppt/slides/slide18.xml><?xml version="1.0" encoding="utf-8"?>
 <p:sld xmlns:a="http://schemas.openxmlformats.org/drawingml/2006/main" xmlns:r="http://schemas.openxmlformats.org/officeDocument/2006/relationships" xmlns:p="http://schemas.openxmlformats.org/presentationml/2006/main">
   <p:cSld>
     <p:spTree>

</xml_diff>

<commit_message>
Deploying to gh-pages from @ ManuelePasini/slides-markdown@acfcb14591880ee01634baa16cd7dd5958b2b3b5 🚀
</commit_message>
<xml_diff>
--- a/3rd_year_slides.pptx
+++ b/3rd_year_slides.pptx
@@ -23,6 +23,10 @@
     <p:sldId id="271" r:id="rId17"/>
     <p:sldId id="272" r:id="rId18"/>
     <p:sldId id="273" r:id="rId19"/>
+    <p:sldId id="274" r:id="rId20"/>
+    <p:sldId id="275" r:id="rId21"/>
+    <p:sldId id="276" r:id="rId22"/>
+    <p:sldId id="277" r:id="rId23"/>
   </p:sldIdLst>
   <p:sldSz cx="9144000" cy="5143500" type="screen16x9"/>
   <p:notesSz cx="6858000" cy="9144000"/>
@@ -4122,31 +4126,36 @@
           </a:p>
         </p:txBody>
       </p:sp>
-      <p:sp>
-        <p:nvSpPr>
-          <p:cNvPr id="3" name="Content Placeholder 2"/>
-          <p:cNvSpPr>
-            <a:spLocks noGrp="1"/>
-          </p:cNvSpPr>
-          <p:nvPr>
-            <p:ph idx="1"/>
-          </p:nvPr>
-        </p:nvSpPr>
-        <p:spPr/>
-        <p:txBody>
-          <a:bodyPr/>
-          <a:lstStyle/>
-          <a:p>
-            <a:pPr lvl="0" indent="0" marL="0">
-              <a:buNone/>
-            </a:pPr>
-            <a:r>
-              <a:rPr/>
-              <a:t>test</a:t>
-            </a:r>
-          </a:p>
-        </p:txBody>
-      </p:sp>
+      <p:pic>
+        <p:nvPicPr>
+          <p:cNvPr descr="https://github.com/ManuelePasini/slides-markdown/blob/master/slides/images/phd3rdyear/n2g/1.svg?raw=true" id="0" name="Picture 1"/>
+          <p:cNvPicPr>
+            <a:picLocks noGrp="1" noChangeAspect="1"/>
+          </p:cNvPicPr>
+          <p:nvPr/>
+        </p:nvPicPr>
+        <p:blipFill>
+          <a:blip r:embed="rId2"/>
+          <a:stretch>
+            <a:fillRect/>
+          </a:stretch>
+        </p:blipFill>
+        <p:spPr bwMode="auto">
+          <a:xfrm>
+            <a:off x="2032000" y="1193800"/>
+            <a:ext cx="5080000" cy="3390900"/>
+          </a:xfrm>
+          <a:prstGeom prst="rect">
+            <a:avLst/>
+          </a:prstGeom>
+          <a:noFill/>
+          <a:ln w="9525">
+            <a:noFill/>
+            <a:headEnd/>
+            <a:tailEnd/>
+          </a:ln>
+        </p:spPr>
+      </p:pic>
     </p:spTree>
   </p:cSld>
 </p:sld>
@@ -4189,19 +4198,71 @@
             </a:pPr>
             <a:r>
               <a:rPr/>
-              <a:t>LLM-Assisted Metadata Query Answering on Data Warehouses</a:t>
-            </a:r>
-          </a:p>
-        </p:txBody>
-      </p:sp>
-      <p:sp>
-        <p:nvSpPr>
-          <p:cNvPr id="3" name="Content Placeholder 2"/>
-          <p:cNvSpPr>
-            <a:spLocks noGrp="1"/>
-          </p:cNvSpPr>
-          <p:nvPr>
-            <p:ph idx="1"/>
+              <a:t>Anomaly Detection in Complex Sensor Networks</a:t>
+            </a:r>
+          </a:p>
+        </p:txBody>
+      </p:sp>
+      <p:pic>
+        <p:nvPicPr>
+          <p:cNvPr descr="https://github.com/ManuelePasini/slides-markdown/blob/master/slides/images/phd3rdyear/n2g/2.svg?raw=true" id="0" name="Picture 1"/>
+          <p:cNvPicPr>
+            <a:picLocks noGrp="1" noChangeAspect="1"/>
+          </p:cNvPicPr>
+          <p:nvPr/>
+        </p:nvPicPr>
+        <p:blipFill>
+          <a:blip r:embed="rId2"/>
+          <a:stretch>
+            <a:fillRect/>
+          </a:stretch>
+        </p:blipFill>
+        <p:spPr bwMode="auto">
+          <a:xfrm>
+            <a:off x="2032000" y="1193800"/>
+            <a:ext cx="5080000" cy="3390900"/>
+          </a:xfrm>
+          <a:prstGeom prst="rect">
+            <a:avLst/>
+          </a:prstGeom>
+          <a:noFill/>
+          <a:ln w="9525">
+            <a:noFill/>
+            <a:headEnd/>
+            <a:tailEnd/>
+          </a:ln>
+        </p:spPr>
+      </p:pic>
+    </p:spTree>
+  </p:cSld>
+</p:sld>
+</file>
+
+<file path=ppt/slides/slide19.xml><?xml version="1.0" encoding="utf-8"?>
+<p:sld xmlns:a="http://schemas.openxmlformats.org/drawingml/2006/main" xmlns:r="http://schemas.openxmlformats.org/officeDocument/2006/relationships" xmlns:p="http://schemas.openxmlformats.org/presentationml/2006/main">
+  <p:cSld>
+    <p:spTree>
+      <p:nvGrpSpPr>
+        <p:cNvPr id="1" name=""/>
+        <p:cNvGrpSpPr/>
+        <p:nvPr/>
+      </p:nvGrpSpPr>
+      <p:grpSpPr>
+        <a:xfrm>
+          <a:off x="0" y="0"/>
+          <a:ext cx="0" cy="0"/>
+          <a:chOff x="0" y="0"/>
+          <a:chExt cx="0" cy="0"/>
+        </a:xfrm>
+      </p:grpSpPr>
+      <p:sp>
+        <p:nvSpPr>
+          <p:cNvPr id="2" name="Title 1"/>
+          <p:cNvSpPr>
+            <a:spLocks noGrp="1"/>
+          </p:cNvSpPr>
+          <p:nvPr>
+            <p:ph type="title"/>
           </p:nvPr>
         </p:nvSpPr>
         <p:spPr/>
@@ -4214,17 +4275,41 @@
             </a:pPr>
             <a:r>
               <a:rPr/>
-              <a:t>Published at </a:t>
-            </a:r>
-            <a:r>
-              <a:rPr>
-                <a:hlinkClick r:id="rId2"/>
-              </a:rPr>
-              <a:t>28th International Conference on Big Data Analytics and Knowledge Discovery (DAWAK)</a:t>
-            </a:r>
-          </a:p>
-        </p:txBody>
-      </p:sp>
+              <a:t>Anomaly Detection in Complex Sensor Networks</a:t>
+            </a:r>
+          </a:p>
+        </p:txBody>
+      </p:sp>
+      <p:pic>
+        <p:nvPicPr>
+          <p:cNvPr descr="https://github.com/ManuelePasini/slides-markdown/blob/master/slides/images/phd3rdyear/n2g/3.svg?raw=true" id="0" name="Picture 1"/>
+          <p:cNvPicPr>
+            <a:picLocks noGrp="1" noChangeAspect="1"/>
+          </p:cNvPicPr>
+          <p:nvPr/>
+        </p:nvPicPr>
+        <p:blipFill>
+          <a:blip r:embed="rId2"/>
+          <a:stretch>
+            <a:fillRect/>
+          </a:stretch>
+        </p:blipFill>
+        <p:spPr bwMode="auto">
+          <a:xfrm>
+            <a:off x="2032000" y="1193800"/>
+            <a:ext cx="5080000" cy="3390900"/>
+          </a:xfrm>
+          <a:prstGeom prst="rect">
+            <a:avLst/>
+          </a:prstGeom>
+          <a:noFill/>
+          <a:ln w="9525">
+            <a:noFill/>
+            <a:headEnd/>
+            <a:tailEnd/>
+          </a:ln>
+        </p:spPr>
+      </p:pic>
     </p:spTree>
   </p:cSld>
 </p:sld>
@@ -4363,6 +4448,238 @@
             <a:r>
               <a:rPr/>
               <a:t>An example of a generic data platform with its components and layers</a:t>
+            </a:r>
+          </a:p>
+        </p:txBody>
+      </p:sp>
+    </p:spTree>
+  </p:cSld>
+</p:sld>
+</file>
+
+<file path=ppt/slides/slide20.xml><?xml version="1.0" encoding="utf-8"?>
+<p:sld xmlns:a="http://schemas.openxmlformats.org/drawingml/2006/main" xmlns:r="http://schemas.openxmlformats.org/officeDocument/2006/relationships" xmlns:p="http://schemas.openxmlformats.org/presentationml/2006/main">
+  <p:cSld>
+    <p:spTree>
+      <p:nvGrpSpPr>
+        <p:cNvPr id="1" name=""/>
+        <p:cNvGrpSpPr/>
+        <p:nvPr/>
+      </p:nvGrpSpPr>
+      <p:grpSpPr>
+        <a:xfrm>
+          <a:off x="0" y="0"/>
+          <a:ext cx="0" cy="0"/>
+          <a:chOff x="0" y="0"/>
+          <a:chExt cx="0" cy="0"/>
+        </a:xfrm>
+      </p:grpSpPr>
+      <p:sp>
+        <p:nvSpPr>
+          <p:cNvPr id="2" name="Title 1"/>
+          <p:cNvSpPr>
+            <a:spLocks noGrp="1"/>
+          </p:cNvSpPr>
+          <p:nvPr>
+            <p:ph type="title"/>
+          </p:nvPr>
+        </p:nvSpPr>
+        <p:spPr/>
+        <p:txBody>
+          <a:bodyPr/>
+          <a:lstStyle/>
+          <a:p>
+            <a:pPr lvl="0" indent="0" marL="0">
+              <a:buNone/>
+            </a:pPr>
+            <a:r>
+              <a:rPr/>
+              <a:t>Anomaly Detection in Complex Sensor Networks</a:t>
+            </a:r>
+          </a:p>
+        </p:txBody>
+      </p:sp>
+      <p:pic>
+        <p:nvPicPr>
+          <p:cNvPr descr="https://github.com/ManuelePasini/slides-markdown/blob/master/slides/images/phd3rdyear/n2g/4.svg?raw=true" id="0" name="Picture 1"/>
+          <p:cNvPicPr>
+            <a:picLocks noGrp="1" noChangeAspect="1"/>
+          </p:cNvPicPr>
+          <p:nvPr/>
+        </p:nvPicPr>
+        <p:blipFill>
+          <a:blip r:embed="rId2"/>
+          <a:stretch>
+            <a:fillRect/>
+          </a:stretch>
+        </p:blipFill>
+        <p:spPr bwMode="auto">
+          <a:xfrm>
+            <a:off x="2032000" y="1193800"/>
+            <a:ext cx="5080000" cy="3390900"/>
+          </a:xfrm>
+          <a:prstGeom prst="rect">
+            <a:avLst/>
+          </a:prstGeom>
+          <a:noFill/>
+          <a:ln w="9525">
+            <a:noFill/>
+            <a:headEnd/>
+            <a:tailEnd/>
+          </a:ln>
+        </p:spPr>
+      </p:pic>
+    </p:spTree>
+  </p:cSld>
+</p:sld>
+</file>
+
+<file path=ppt/slides/slide21.xml><?xml version="1.0" encoding="utf-8"?>
+<p:sld xmlns:a="http://schemas.openxmlformats.org/drawingml/2006/main" xmlns:r="http://schemas.openxmlformats.org/officeDocument/2006/relationships" xmlns:p="http://schemas.openxmlformats.org/presentationml/2006/main">
+  <p:cSld>
+    <p:spTree>
+      <p:nvGrpSpPr>
+        <p:cNvPr id="1" name=""/>
+        <p:cNvGrpSpPr/>
+        <p:nvPr/>
+      </p:nvGrpSpPr>
+      <p:grpSpPr>
+        <a:xfrm>
+          <a:off x="0" y="0"/>
+          <a:ext cx="0" cy="0"/>
+          <a:chOff x="0" y="0"/>
+          <a:chExt cx="0" cy="0"/>
+        </a:xfrm>
+      </p:grpSpPr>
+      <p:sp>
+        <p:nvSpPr>
+          <p:cNvPr id="2" name="Title 1"/>
+          <p:cNvSpPr>
+            <a:spLocks noGrp="1"/>
+          </p:cNvSpPr>
+          <p:nvPr>
+            <p:ph type="title"/>
+          </p:nvPr>
+        </p:nvSpPr>
+        <p:spPr/>
+        <p:txBody>
+          <a:bodyPr/>
+          <a:lstStyle/>
+          <a:p>
+            <a:pPr lvl="0" indent="0" marL="0">
+              <a:buNone/>
+            </a:pPr>
+            <a:r>
+              <a:rPr/>
+              <a:t>Anomaly Detection in Complex Sensor Networks</a:t>
+            </a:r>
+          </a:p>
+        </p:txBody>
+      </p:sp>
+      <p:pic>
+        <p:nvPicPr>
+          <p:cNvPr descr="https://github.com/ManuelePasini/slides-markdown/blob/master/slides/images/phd3rdyear/n2g/5.svg?raw=true" id="0" name="Picture 1"/>
+          <p:cNvPicPr>
+            <a:picLocks noGrp="1" noChangeAspect="1"/>
+          </p:cNvPicPr>
+          <p:nvPr/>
+        </p:nvPicPr>
+        <p:blipFill>
+          <a:blip r:embed="rId2"/>
+          <a:stretch>
+            <a:fillRect/>
+          </a:stretch>
+        </p:blipFill>
+        <p:spPr bwMode="auto">
+          <a:xfrm>
+            <a:off x="2032000" y="1193800"/>
+            <a:ext cx="5080000" cy="3390900"/>
+          </a:xfrm>
+          <a:prstGeom prst="rect">
+            <a:avLst/>
+          </a:prstGeom>
+          <a:noFill/>
+          <a:ln w="9525">
+            <a:noFill/>
+            <a:headEnd/>
+            <a:tailEnd/>
+          </a:ln>
+        </p:spPr>
+      </p:pic>
+    </p:spTree>
+  </p:cSld>
+</p:sld>
+</file>
+
+<file path=ppt/slides/slide22.xml><?xml version="1.0" encoding="utf-8"?>
+<p:sld xmlns:a="http://schemas.openxmlformats.org/drawingml/2006/main" xmlns:r="http://schemas.openxmlformats.org/officeDocument/2006/relationships" xmlns:p="http://schemas.openxmlformats.org/presentationml/2006/main">
+  <p:cSld>
+    <p:spTree>
+      <p:nvGrpSpPr>
+        <p:cNvPr id="1" name=""/>
+        <p:cNvGrpSpPr/>
+        <p:nvPr/>
+      </p:nvGrpSpPr>
+      <p:grpSpPr>
+        <a:xfrm>
+          <a:off x="0" y="0"/>
+          <a:ext cx="0" cy="0"/>
+          <a:chOff x="0" y="0"/>
+          <a:chExt cx="0" cy="0"/>
+        </a:xfrm>
+      </p:grpSpPr>
+      <p:sp>
+        <p:nvSpPr>
+          <p:cNvPr id="2" name="Title 1"/>
+          <p:cNvSpPr>
+            <a:spLocks noGrp="1"/>
+          </p:cNvSpPr>
+          <p:nvPr>
+            <p:ph type="title"/>
+          </p:nvPr>
+        </p:nvSpPr>
+        <p:spPr/>
+        <p:txBody>
+          <a:bodyPr/>
+          <a:lstStyle/>
+          <a:p>
+            <a:pPr lvl="0" indent="0" marL="0">
+              <a:buNone/>
+            </a:pPr>
+            <a:r>
+              <a:rPr/>
+              <a:t>LLM-Assisted Metadata Query Answering on Data Warehouses</a:t>
+            </a:r>
+          </a:p>
+        </p:txBody>
+      </p:sp>
+      <p:sp>
+        <p:nvSpPr>
+          <p:cNvPr id="3" name="Content Placeholder 2"/>
+          <p:cNvSpPr>
+            <a:spLocks noGrp="1"/>
+          </p:cNvSpPr>
+          <p:nvPr>
+            <p:ph idx="1"/>
+          </p:nvPr>
+        </p:nvSpPr>
+        <p:spPr/>
+        <p:txBody>
+          <a:bodyPr/>
+          <a:lstStyle/>
+          <a:p>
+            <a:pPr lvl="0" indent="0" marL="0">
+              <a:buNone/>
+            </a:pPr>
+            <a:r>
+              <a:rPr/>
+              <a:t>Published at </a:t>
+            </a:r>
+            <a:r>
+              <a:rPr>
+                <a:hlinkClick r:id="rId2"/>
+              </a:rPr>
+              <a:t>28th International Conference on Big Data Analytics and Knowledge Discovery (DAWAK)</a:t>
             </a:r>
           </a:p>
         </p:txBody>

</xml_diff>

<commit_message>
Deploying to gh-pages from @ ManuelePasini/slides-markdown@d62a8b1569f1acc77ecbb9a282ffb910cb9d42b9 🚀
</commit_message>
<xml_diff>
--- a/3rd_year_slides.pptx
+++ b/3rd_year_slides.pptx
@@ -4126,36 +4126,39 @@
           </a:p>
         </p:txBody>
       </p:sp>
-      <p:pic>
-        <p:nvPicPr>
-          <p:cNvPr descr="https://github.com/ManuelePasini/slides-markdown/blob/master/slides/images/phd3rdyear/n2g/1.svg?raw=true" id="0" name="Picture 1"/>
-          <p:cNvPicPr>
-            <a:picLocks noGrp="1" noChangeAspect="1"/>
-          </p:cNvPicPr>
-          <p:nvPr/>
-        </p:nvPicPr>
-        <p:blipFill>
-          <a:blip r:embed="rId2"/>
-          <a:stretch>
-            <a:fillRect/>
-          </a:stretch>
-        </p:blipFill>
-        <p:spPr bwMode="auto">
-          <a:xfrm>
-            <a:off x="2032000" y="1193800"/>
-            <a:ext cx="5080000" cy="3390900"/>
-          </a:xfrm>
-          <a:prstGeom prst="rect">
-            <a:avLst/>
-          </a:prstGeom>
-          <a:noFill/>
-          <a:ln w="9525">
-            <a:noFill/>
-            <a:headEnd/>
-            <a:tailEnd/>
-          </a:ln>
-        </p:spPr>
-      </p:pic>
+      <p:sp>
+        <p:nvSpPr>
+          <p:cNvPr id="3" name="Content Placeholder 2"/>
+          <p:cNvSpPr>
+            <a:spLocks noGrp="1"/>
+          </p:cNvSpPr>
+          <p:nvPr>
+            <p:ph idx="1"/>
+          </p:nvPr>
+        </p:nvSpPr>
+        <p:spPr/>
+        <p:txBody>
+          <a:bodyPr/>
+          <a:lstStyle/>
+          <a:p>
+            <a:pPr lvl="0" indent="0" marL="0">
+              <a:spcBef>
+                <a:spcPts val="3000"/>
+              </a:spcBef>
+              <a:buNone/>
+            </a:pPr>
+            <a:r>
+              <a:rPr b="1"/>
+              <a:t>A running example</a:t>
+            </a:r>
+          </a:p>
+          <a:p>
+            <a:pPr lvl="0" indent="0" marL="0">
+              <a:buNone/>
+            </a:pPr>
+          </a:p>
+        </p:txBody>
+      </p:sp>
     </p:spTree>
   </p:cSld>
 </p:sld>
@@ -4203,36 +4206,39 @@
           </a:p>
         </p:txBody>
       </p:sp>
-      <p:pic>
-        <p:nvPicPr>
-          <p:cNvPr descr="https://github.com/ManuelePasini/slides-markdown/blob/master/slides/images/phd3rdyear/n2g/2.svg?raw=true" id="0" name="Picture 1"/>
-          <p:cNvPicPr>
-            <a:picLocks noGrp="1" noChangeAspect="1"/>
-          </p:cNvPicPr>
-          <p:nvPr/>
-        </p:nvPicPr>
-        <p:blipFill>
-          <a:blip r:embed="rId2"/>
-          <a:stretch>
-            <a:fillRect/>
-          </a:stretch>
-        </p:blipFill>
-        <p:spPr bwMode="auto">
-          <a:xfrm>
-            <a:off x="2032000" y="1193800"/>
-            <a:ext cx="5080000" cy="3390900"/>
-          </a:xfrm>
-          <a:prstGeom prst="rect">
-            <a:avLst/>
-          </a:prstGeom>
-          <a:noFill/>
-          <a:ln w="9525">
-            <a:noFill/>
-            <a:headEnd/>
-            <a:tailEnd/>
-          </a:ln>
-        </p:spPr>
-      </p:pic>
+      <p:sp>
+        <p:nvSpPr>
+          <p:cNvPr id="3" name="Content Placeholder 2"/>
+          <p:cNvSpPr>
+            <a:spLocks noGrp="1"/>
+          </p:cNvSpPr>
+          <p:nvPr>
+            <p:ph idx="1"/>
+          </p:nvPr>
+        </p:nvSpPr>
+        <p:spPr/>
+        <p:txBody>
+          <a:bodyPr/>
+          <a:lstStyle/>
+          <a:p>
+            <a:pPr lvl="0" indent="0" marL="0">
+              <a:spcBef>
+                <a:spcPts val="3000"/>
+              </a:spcBef>
+              <a:buNone/>
+            </a:pPr>
+            <a:r>
+              <a:rPr b="1"/>
+              <a:t>A running example</a:t>
+            </a:r>
+          </a:p>
+          <a:p>
+            <a:pPr lvl="0" indent="0" marL="0">
+              <a:buNone/>
+            </a:pPr>
+          </a:p>
+        </p:txBody>
+      </p:sp>
     </p:spTree>
   </p:cSld>
 </p:sld>
@@ -4280,36 +4286,39 @@
           </a:p>
         </p:txBody>
       </p:sp>
-      <p:pic>
-        <p:nvPicPr>
-          <p:cNvPr descr="https://github.com/ManuelePasini/slides-markdown/blob/master/slides/images/phd3rdyear/n2g/3.svg?raw=true" id="0" name="Picture 1"/>
-          <p:cNvPicPr>
-            <a:picLocks noGrp="1" noChangeAspect="1"/>
-          </p:cNvPicPr>
-          <p:nvPr/>
-        </p:nvPicPr>
-        <p:blipFill>
-          <a:blip r:embed="rId2"/>
-          <a:stretch>
-            <a:fillRect/>
-          </a:stretch>
-        </p:blipFill>
-        <p:spPr bwMode="auto">
-          <a:xfrm>
-            <a:off x="2032000" y="1193800"/>
-            <a:ext cx="5080000" cy="3390900"/>
-          </a:xfrm>
-          <a:prstGeom prst="rect">
-            <a:avLst/>
-          </a:prstGeom>
-          <a:noFill/>
-          <a:ln w="9525">
-            <a:noFill/>
-            <a:headEnd/>
-            <a:tailEnd/>
-          </a:ln>
-        </p:spPr>
-      </p:pic>
+      <p:sp>
+        <p:nvSpPr>
+          <p:cNvPr id="3" name="Content Placeholder 2"/>
+          <p:cNvSpPr>
+            <a:spLocks noGrp="1"/>
+          </p:cNvSpPr>
+          <p:nvPr>
+            <p:ph idx="1"/>
+          </p:nvPr>
+        </p:nvSpPr>
+        <p:spPr/>
+        <p:txBody>
+          <a:bodyPr/>
+          <a:lstStyle/>
+          <a:p>
+            <a:pPr lvl="0" indent="0" marL="0">
+              <a:spcBef>
+                <a:spcPts val="3000"/>
+              </a:spcBef>
+              <a:buNone/>
+            </a:pPr>
+            <a:r>
+              <a:rPr b="1"/>
+              <a:t>A running example</a:t>
+            </a:r>
+          </a:p>
+          <a:p>
+            <a:pPr lvl="0" indent="0" marL="0">
+              <a:buNone/>
+            </a:pPr>
+          </a:p>
+        </p:txBody>
+      </p:sp>
     </p:spTree>
   </p:cSld>
 </p:sld>
@@ -4499,36 +4508,39 @@
           </a:p>
         </p:txBody>
       </p:sp>
-      <p:pic>
-        <p:nvPicPr>
-          <p:cNvPr descr="https://github.com/ManuelePasini/slides-markdown/blob/master/slides/images/phd3rdyear/n2g/4.svg?raw=true" id="0" name="Picture 1"/>
-          <p:cNvPicPr>
-            <a:picLocks noGrp="1" noChangeAspect="1"/>
-          </p:cNvPicPr>
-          <p:nvPr/>
-        </p:nvPicPr>
-        <p:blipFill>
-          <a:blip r:embed="rId2"/>
-          <a:stretch>
-            <a:fillRect/>
-          </a:stretch>
-        </p:blipFill>
-        <p:spPr bwMode="auto">
-          <a:xfrm>
-            <a:off x="2032000" y="1193800"/>
-            <a:ext cx="5080000" cy="3390900"/>
-          </a:xfrm>
-          <a:prstGeom prst="rect">
-            <a:avLst/>
-          </a:prstGeom>
-          <a:noFill/>
-          <a:ln w="9525">
-            <a:noFill/>
-            <a:headEnd/>
-            <a:tailEnd/>
-          </a:ln>
-        </p:spPr>
-      </p:pic>
+      <p:sp>
+        <p:nvSpPr>
+          <p:cNvPr id="3" name="Content Placeholder 2"/>
+          <p:cNvSpPr>
+            <a:spLocks noGrp="1"/>
+          </p:cNvSpPr>
+          <p:nvPr>
+            <p:ph idx="1"/>
+          </p:nvPr>
+        </p:nvSpPr>
+        <p:spPr/>
+        <p:txBody>
+          <a:bodyPr/>
+          <a:lstStyle/>
+          <a:p>
+            <a:pPr lvl="0" indent="0" marL="0">
+              <a:spcBef>
+                <a:spcPts val="3000"/>
+              </a:spcBef>
+              <a:buNone/>
+            </a:pPr>
+            <a:r>
+              <a:rPr b="1"/>
+              <a:t>A running example</a:t>
+            </a:r>
+          </a:p>
+          <a:p>
+            <a:pPr lvl="0" indent="0" marL="0">
+              <a:buNone/>
+            </a:pPr>
+          </a:p>
+        </p:txBody>
+      </p:sp>
     </p:spTree>
   </p:cSld>
 </p:sld>
@@ -4576,36 +4588,39 @@
           </a:p>
         </p:txBody>
       </p:sp>
-      <p:pic>
-        <p:nvPicPr>
-          <p:cNvPr descr="https://github.com/ManuelePasini/slides-markdown/blob/master/slides/images/phd3rdyear/n2g/5.svg?raw=true" id="0" name="Picture 1"/>
-          <p:cNvPicPr>
-            <a:picLocks noGrp="1" noChangeAspect="1"/>
-          </p:cNvPicPr>
-          <p:nvPr/>
-        </p:nvPicPr>
-        <p:blipFill>
-          <a:blip r:embed="rId2"/>
-          <a:stretch>
-            <a:fillRect/>
-          </a:stretch>
-        </p:blipFill>
-        <p:spPr bwMode="auto">
-          <a:xfrm>
-            <a:off x="2032000" y="1193800"/>
-            <a:ext cx="5080000" cy="3390900"/>
-          </a:xfrm>
-          <a:prstGeom prst="rect">
-            <a:avLst/>
-          </a:prstGeom>
-          <a:noFill/>
-          <a:ln w="9525">
-            <a:noFill/>
-            <a:headEnd/>
-            <a:tailEnd/>
-          </a:ln>
-        </p:spPr>
-      </p:pic>
+      <p:sp>
+        <p:nvSpPr>
+          <p:cNvPr id="3" name="Content Placeholder 2"/>
+          <p:cNvSpPr>
+            <a:spLocks noGrp="1"/>
+          </p:cNvSpPr>
+          <p:nvPr>
+            <p:ph idx="1"/>
+          </p:nvPr>
+        </p:nvSpPr>
+        <p:spPr/>
+        <p:txBody>
+          <a:bodyPr/>
+          <a:lstStyle/>
+          <a:p>
+            <a:pPr lvl="0" indent="0" marL="0">
+              <a:spcBef>
+                <a:spcPts val="3000"/>
+              </a:spcBef>
+              <a:buNone/>
+            </a:pPr>
+            <a:r>
+              <a:rPr b="1"/>
+              <a:t>A running example</a:t>
+            </a:r>
+          </a:p>
+          <a:p>
+            <a:pPr lvl="0" indent="0" marL="0">
+              <a:buNone/>
+            </a:pPr>
+          </a:p>
+        </p:txBody>
+      </p:sp>
     </p:spTree>
   </p:cSld>
 </p:sld>

</xml_diff>

<commit_message>
Deploying to gh-pages from @ ManuelePasini/slides-markdown@46aa44badc330fc70ff3cc3ee5da0ae8236ebe53 🚀
</commit_message>
<xml_diff>
--- a/3rd_year_slides.pptx
+++ b/3rd_year_slides.pptx
@@ -4111,7 +4111,12 @@
             <p:ph type="title"/>
           </p:nvPr>
         </p:nvSpPr>
-        <p:spPr/>
+        <p:spPr>
+          <a:xfrm>
+            <a:off x="457201" y="204787"/>
+            <a:ext cx="3008313" cy="871538"/>
+          </a:xfrm>
+        </p:spPr>
         <p:txBody>
           <a:bodyPr/>
           <a:lstStyle/>
@@ -4128,12 +4133,12 @@
       </p:sp>
       <p:sp>
         <p:nvSpPr>
-          <p:cNvPr id="3" name="Content Placeholder 2"/>
-          <p:cNvSpPr>
-            <a:spLocks noGrp="1"/>
-          </p:cNvSpPr>
-          <p:nvPr>
-            <p:ph idx="1"/>
+          <p:cNvPr id="4" name="Text Placeholder 3"/>
+          <p:cNvSpPr>
+            <a:spLocks noGrp="1"/>
+          </p:cNvSpPr>
+          <p:nvPr>
+            <p:ph idx="2" sz="half" type="body"/>
           </p:nvPr>
         </p:nvSpPr>
         <p:spPr/>
@@ -4152,13 +4157,38 @@
               <a:t>A running example</a:t>
             </a:r>
           </a:p>
-          <a:p>
-            <a:pPr lvl="0" indent="0" marL="0">
-              <a:buNone/>
-            </a:pPr>
-          </a:p>
-        </p:txBody>
-      </p:sp>
+        </p:txBody>
+      </p:sp>
+      <p:pic>
+        <p:nvPicPr>
+          <p:cNvPr descr="https://github.com/ManuelePasini/slides-markdown/blob/master/slides/images/phd3rdyear/n2g/1.svg?raw=true" id="0" name="Picture 1"/>
+          <p:cNvPicPr>
+            <a:picLocks noGrp="1" noChangeAspect="1"/>
+          </p:cNvPicPr>
+          <p:nvPr/>
+        </p:nvPicPr>
+        <p:blipFill>
+          <a:blip r:embed="rId2"/>
+          <a:stretch>
+            <a:fillRect/>
+          </a:stretch>
+        </p:blipFill>
+        <p:spPr bwMode="auto">
+          <a:xfrm>
+            <a:off x="3568700" y="685800"/>
+            <a:ext cx="5105400" cy="3403600"/>
+          </a:xfrm>
+          <a:prstGeom prst="rect">
+            <a:avLst/>
+          </a:prstGeom>
+          <a:noFill/>
+          <a:ln w="9525">
+            <a:noFill/>
+            <a:headEnd/>
+            <a:tailEnd/>
+          </a:ln>
+        </p:spPr>
+      </p:pic>
     </p:spTree>
   </p:cSld>
 </p:sld>
@@ -4191,7 +4221,12 @@
             <p:ph type="title"/>
           </p:nvPr>
         </p:nvSpPr>
-        <p:spPr/>
+        <p:spPr>
+          <a:xfrm>
+            <a:off x="457201" y="204787"/>
+            <a:ext cx="3008313" cy="871538"/>
+          </a:xfrm>
+        </p:spPr>
         <p:txBody>
           <a:bodyPr/>
           <a:lstStyle/>
@@ -4208,12 +4243,12 @@
       </p:sp>
       <p:sp>
         <p:nvSpPr>
-          <p:cNvPr id="3" name="Content Placeholder 2"/>
-          <p:cNvSpPr>
-            <a:spLocks noGrp="1"/>
-          </p:cNvSpPr>
-          <p:nvPr>
-            <p:ph idx="1"/>
+          <p:cNvPr id="4" name="Text Placeholder 3"/>
+          <p:cNvSpPr>
+            <a:spLocks noGrp="1"/>
+          </p:cNvSpPr>
+          <p:nvPr>
+            <p:ph idx="2" sz="half" type="body"/>
           </p:nvPr>
         </p:nvSpPr>
         <p:spPr/>
@@ -4232,13 +4267,38 @@
               <a:t>A running example</a:t>
             </a:r>
           </a:p>
-          <a:p>
-            <a:pPr lvl="0" indent="0" marL="0">
-              <a:buNone/>
-            </a:pPr>
-          </a:p>
-        </p:txBody>
-      </p:sp>
+        </p:txBody>
+      </p:sp>
+      <p:pic>
+        <p:nvPicPr>
+          <p:cNvPr descr="https://github.com/ManuelePasini/slides-markdown/blob/master/slides/images/phd3rdyear/n2g/2.svg?raw=true" id="0" name="Picture 1"/>
+          <p:cNvPicPr>
+            <a:picLocks noGrp="1" noChangeAspect="1"/>
+          </p:cNvPicPr>
+          <p:nvPr/>
+        </p:nvPicPr>
+        <p:blipFill>
+          <a:blip r:embed="rId2"/>
+          <a:stretch>
+            <a:fillRect/>
+          </a:stretch>
+        </p:blipFill>
+        <p:spPr bwMode="auto">
+          <a:xfrm>
+            <a:off x="3568700" y="685800"/>
+            <a:ext cx="5105400" cy="3403600"/>
+          </a:xfrm>
+          <a:prstGeom prst="rect">
+            <a:avLst/>
+          </a:prstGeom>
+          <a:noFill/>
+          <a:ln w="9525">
+            <a:noFill/>
+            <a:headEnd/>
+            <a:tailEnd/>
+          </a:ln>
+        </p:spPr>
+      </p:pic>
     </p:spTree>
   </p:cSld>
 </p:sld>
@@ -4271,7 +4331,12 @@
             <p:ph type="title"/>
           </p:nvPr>
         </p:nvSpPr>
-        <p:spPr/>
+        <p:spPr>
+          <a:xfrm>
+            <a:off x="457201" y="204787"/>
+            <a:ext cx="3008313" cy="871538"/>
+          </a:xfrm>
+        </p:spPr>
         <p:txBody>
           <a:bodyPr/>
           <a:lstStyle/>
@@ -4288,12 +4353,12 @@
       </p:sp>
       <p:sp>
         <p:nvSpPr>
-          <p:cNvPr id="3" name="Content Placeholder 2"/>
-          <p:cNvSpPr>
-            <a:spLocks noGrp="1"/>
-          </p:cNvSpPr>
-          <p:nvPr>
-            <p:ph idx="1"/>
+          <p:cNvPr id="4" name="Text Placeholder 3"/>
+          <p:cNvSpPr>
+            <a:spLocks noGrp="1"/>
+          </p:cNvSpPr>
+          <p:nvPr>
+            <p:ph idx="2" sz="half" type="body"/>
           </p:nvPr>
         </p:nvSpPr>
         <p:spPr/>
@@ -4312,13 +4377,38 @@
               <a:t>A running example</a:t>
             </a:r>
           </a:p>
-          <a:p>
-            <a:pPr lvl="0" indent="0" marL="0">
-              <a:buNone/>
-            </a:pPr>
-          </a:p>
-        </p:txBody>
-      </p:sp>
+        </p:txBody>
+      </p:sp>
+      <p:pic>
+        <p:nvPicPr>
+          <p:cNvPr descr="https://github.com/ManuelePasini/slides-markdown/blob/master/slides/images/phd3rdyear/n2g/3.svg?raw=true" id="0" name="Picture 1"/>
+          <p:cNvPicPr>
+            <a:picLocks noGrp="1" noChangeAspect="1"/>
+          </p:cNvPicPr>
+          <p:nvPr/>
+        </p:nvPicPr>
+        <p:blipFill>
+          <a:blip r:embed="rId2"/>
+          <a:stretch>
+            <a:fillRect/>
+          </a:stretch>
+        </p:blipFill>
+        <p:spPr bwMode="auto">
+          <a:xfrm>
+            <a:off x="3568700" y="685800"/>
+            <a:ext cx="5105400" cy="3403600"/>
+          </a:xfrm>
+          <a:prstGeom prst="rect">
+            <a:avLst/>
+          </a:prstGeom>
+          <a:noFill/>
+          <a:ln w="9525">
+            <a:noFill/>
+            <a:headEnd/>
+            <a:tailEnd/>
+          </a:ln>
+        </p:spPr>
+      </p:pic>
     </p:spTree>
   </p:cSld>
 </p:sld>
@@ -4493,7 +4583,12 @@
             <p:ph type="title"/>
           </p:nvPr>
         </p:nvSpPr>
-        <p:spPr/>
+        <p:spPr>
+          <a:xfrm>
+            <a:off x="457201" y="204787"/>
+            <a:ext cx="3008313" cy="871538"/>
+          </a:xfrm>
+        </p:spPr>
         <p:txBody>
           <a:bodyPr/>
           <a:lstStyle/>
@@ -4510,12 +4605,12 @@
       </p:sp>
       <p:sp>
         <p:nvSpPr>
-          <p:cNvPr id="3" name="Content Placeholder 2"/>
-          <p:cNvSpPr>
-            <a:spLocks noGrp="1"/>
-          </p:cNvSpPr>
-          <p:nvPr>
-            <p:ph idx="1"/>
+          <p:cNvPr id="4" name="Text Placeholder 3"/>
+          <p:cNvSpPr>
+            <a:spLocks noGrp="1"/>
+          </p:cNvSpPr>
+          <p:nvPr>
+            <p:ph idx="2" sz="half" type="body"/>
           </p:nvPr>
         </p:nvSpPr>
         <p:spPr/>
@@ -4534,13 +4629,38 @@
               <a:t>A running example</a:t>
             </a:r>
           </a:p>
-          <a:p>
-            <a:pPr lvl="0" indent="0" marL="0">
-              <a:buNone/>
-            </a:pPr>
-          </a:p>
-        </p:txBody>
-      </p:sp>
+        </p:txBody>
+      </p:sp>
+      <p:pic>
+        <p:nvPicPr>
+          <p:cNvPr descr="https://github.com/ManuelePasini/slides-markdown/blob/master/slides/images/phd3rdyear/n2g/4.svg?raw=true" id="0" name="Picture 1"/>
+          <p:cNvPicPr>
+            <a:picLocks noGrp="1" noChangeAspect="1"/>
+          </p:cNvPicPr>
+          <p:nvPr/>
+        </p:nvPicPr>
+        <p:blipFill>
+          <a:blip r:embed="rId2"/>
+          <a:stretch>
+            <a:fillRect/>
+          </a:stretch>
+        </p:blipFill>
+        <p:spPr bwMode="auto">
+          <a:xfrm>
+            <a:off x="3568700" y="685800"/>
+            <a:ext cx="5105400" cy="3403600"/>
+          </a:xfrm>
+          <a:prstGeom prst="rect">
+            <a:avLst/>
+          </a:prstGeom>
+          <a:noFill/>
+          <a:ln w="9525">
+            <a:noFill/>
+            <a:headEnd/>
+            <a:tailEnd/>
+          </a:ln>
+        </p:spPr>
+      </p:pic>
     </p:spTree>
   </p:cSld>
 </p:sld>
@@ -4573,7 +4693,12 @@
             <p:ph type="title"/>
           </p:nvPr>
         </p:nvSpPr>
-        <p:spPr/>
+        <p:spPr>
+          <a:xfrm>
+            <a:off x="457201" y="204787"/>
+            <a:ext cx="3008313" cy="871538"/>
+          </a:xfrm>
+        </p:spPr>
         <p:txBody>
           <a:bodyPr/>
           <a:lstStyle/>
@@ -4590,12 +4715,12 @@
       </p:sp>
       <p:sp>
         <p:nvSpPr>
-          <p:cNvPr id="3" name="Content Placeholder 2"/>
-          <p:cNvSpPr>
-            <a:spLocks noGrp="1"/>
-          </p:cNvSpPr>
-          <p:nvPr>
-            <p:ph idx="1"/>
+          <p:cNvPr id="4" name="Text Placeholder 3"/>
+          <p:cNvSpPr>
+            <a:spLocks noGrp="1"/>
+          </p:cNvSpPr>
+          <p:nvPr>
+            <p:ph idx="2" sz="half" type="body"/>
           </p:nvPr>
         </p:nvSpPr>
         <p:spPr/>
@@ -4614,13 +4739,38 @@
               <a:t>A running example</a:t>
             </a:r>
           </a:p>
-          <a:p>
-            <a:pPr lvl="0" indent="0" marL="0">
-              <a:buNone/>
-            </a:pPr>
-          </a:p>
-        </p:txBody>
-      </p:sp>
+        </p:txBody>
+      </p:sp>
+      <p:pic>
+        <p:nvPicPr>
+          <p:cNvPr descr="https://github.com/ManuelePasini/slides-markdown/blob/master/slides/images/phd3rdyear/n2g/5.svg?raw=true" id="0" name="Picture 1"/>
+          <p:cNvPicPr>
+            <a:picLocks noGrp="1" noChangeAspect="1"/>
+          </p:cNvPicPr>
+          <p:nvPr/>
+        </p:nvPicPr>
+        <p:blipFill>
+          <a:blip r:embed="rId2"/>
+          <a:stretch>
+            <a:fillRect/>
+          </a:stretch>
+        </p:blipFill>
+        <p:spPr bwMode="auto">
+          <a:xfrm>
+            <a:off x="3568700" y="685800"/>
+            <a:ext cx="5105400" cy="3403600"/>
+          </a:xfrm>
+          <a:prstGeom prst="rect">
+            <a:avLst/>
+          </a:prstGeom>
+          <a:noFill/>
+          <a:ln w="9525">
+            <a:noFill/>
+            <a:headEnd/>
+            <a:tailEnd/>
+          </a:ln>
+        </p:spPr>
+      </p:pic>
     </p:spTree>
   </p:cSld>
 </p:sld>

</xml_diff>

<commit_message>
Deploying to gh-pages from @ ManuelePasini/slides-markdown@0f6ead66353ee93c1d8fa39442c02de449f8a160 🚀
</commit_message>
<xml_diff>
--- a/3rd_year_slides.pptx
+++ b/3rd_year_slides.pptx
@@ -27,6 +27,7 @@
     <p:sldId id="275" r:id="rId21"/>
     <p:sldId id="276" r:id="rId22"/>
     <p:sldId id="277" r:id="rId23"/>
+    <p:sldId id="278" r:id="rId24"/>
   </p:sldIdLst>
   <p:sldSz cx="9144000" cy="5143500" type="screen16x9"/>
   <p:notesSz cx="6858000" cy="9144000"/>
@@ -4777,6 +4778,116 @@
 </file>
 
 <file path=ppt/slides/slide22.xml><?xml version="1.0" encoding="utf-8"?>
+<p:sld xmlns:a="http://schemas.openxmlformats.org/drawingml/2006/main" xmlns:r="http://schemas.openxmlformats.org/officeDocument/2006/relationships" xmlns:p="http://schemas.openxmlformats.org/presentationml/2006/main">
+  <p:cSld>
+    <p:spTree>
+      <p:nvGrpSpPr>
+        <p:cNvPr id="1" name=""/>
+        <p:cNvGrpSpPr/>
+        <p:nvPr/>
+      </p:nvGrpSpPr>
+      <p:grpSpPr>
+        <a:xfrm>
+          <a:off x="0" y="0"/>
+          <a:ext cx="0" cy="0"/>
+          <a:chOff x="0" y="0"/>
+          <a:chExt cx="0" cy="0"/>
+        </a:xfrm>
+      </p:grpSpPr>
+      <p:sp>
+        <p:nvSpPr>
+          <p:cNvPr id="2" name="Title 1"/>
+          <p:cNvSpPr>
+            <a:spLocks noGrp="1"/>
+          </p:cNvSpPr>
+          <p:nvPr>
+            <p:ph type="title"/>
+          </p:nvPr>
+        </p:nvSpPr>
+        <p:spPr>
+          <a:xfrm>
+            <a:off x="457201" y="204787"/>
+            <a:ext cx="3008313" cy="871538"/>
+          </a:xfrm>
+        </p:spPr>
+        <p:txBody>
+          <a:bodyPr/>
+          <a:lstStyle/>
+          <a:p>
+            <a:pPr lvl="0" indent="0" marL="0">
+              <a:buNone/>
+            </a:pPr>
+            <a:r>
+              <a:rPr/>
+              <a:t>Anomaly Detection in Complex Sensor Networks</a:t>
+            </a:r>
+          </a:p>
+        </p:txBody>
+      </p:sp>
+      <p:sp>
+        <p:nvSpPr>
+          <p:cNvPr id="4" name="Text Placeholder 3"/>
+          <p:cNvSpPr>
+            <a:spLocks noGrp="1"/>
+          </p:cNvSpPr>
+          <p:nvPr>
+            <p:ph idx="2" sz="half" type="body"/>
+          </p:nvPr>
+        </p:nvSpPr>
+        <p:spPr/>
+        <p:txBody>
+          <a:bodyPr/>
+          <a:lstStyle/>
+          <a:p>
+            <a:pPr lvl="0" indent="0" marL="0">
+              <a:spcBef>
+                <a:spcPts val="3000"/>
+              </a:spcBef>
+              <a:buNone/>
+            </a:pPr>
+            <a:r>
+              <a:rPr b="1"/>
+              <a:t>A real data example</a:t>
+            </a:r>
+          </a:p>
+        </p:txBody>
+      </p:sp>
+      <p:pic>
+        <p:nvPicPr>
+          <p:cNvPr descr="https://github.com/ManuelePasini/slides-markdown/blob/master/slides/images/phd3rdyear/n2g/n2g_real.svg?raw=true" id="0" name="Picture 1"/>
+          <p:cNvPicPr>
+            <a:picLocks noGrp="1" noChangeAspect="1"/>
+          </p:cNvPicPr>
+          <p:nvPr/>
+        </p:nvPicPr>
+        <p:blipFill>
+          <a:blip r:embed="rId2"/>
+          <a:stretch>
+            <a:fillRect/>
+          </a:stretch>
+        </p:blipFill>
+        <p:spPr bwMode="auto">
+          <a:xfrm>
+            <a:off x="3568700" y="571500"/>
+            <a:ext cx="5105400" cy="3632200"/>
+          </a:xfrm>
+          <a:prstGeom prst="rect">
+            <a:avLst/>
+          </a:prstGeom>
+          <a:noFill/>
+          <a:ln w="9525">
+            <a:noFill/>
+            <a:headEnd/>
+            <a:tailEnd/>
+          </a:ln>
+        </p:spPr>
+      </p:pic>
+    </p:spTree>
+  </p:cSld>
+</p:sld>
+</file>
+
+<file path=ppt/slides/slide23.xml><?xml version="1.0" encoding="utf-8"?>
 <p:sld xmlns:a="http://schemas.openxmlformats.org/drawingml/2006/main" xmlns:r="http://schemas.openxmlformats.org/officeDocument/2006/relationships" xmlns:p="http://schemas.openxmlformats.org/presentationml/2006/main">
   <p:cSld>
     <p:spTree>

</xml_diff>

<commit_message>
Deploying to gh-pages from @ ManuelePasini/slides-markdown@b7459dbe329c6fe6f8b84bbf0870300569bc2d25 🚀
</commit_message>
<xml_diff>
--- a/3rd_year_slides.pptx
+++ b/3rd_year_slides.pptx
@@ -28,6 +28,7 @@
     <p:sldId id="276" r:id="rId22"/>
     <p:sldId id="277" r:id="rId23"/>
     <p:sldId id="278" r:id="rId24"/>
+    <p:sldId id="279" r:id="rId25"/>
   </p:sldIdLst>
   <p:sldSz cx="9144000" cy="5143500" type="screen16x9"/>
   <p:notesSz cx="6858000" cy="9144000"/>
@@ -4155,7 +4156,13 @@
             </a:pPr>
             <a:r>
               <a:rPr b="1"/>
-              <a:t>A running example</a:t>
+              <a:t>A running example - Series2Graph algorithm from </a:t>
+            </a:r>
+            <a:r>
+              <a:rPr b="1">
+                <a:hlinkClick r:id="rId2"/>
+              </a:rPr>
+              <a:t>P. Boniol et al.</a:t>
             </a:r>
           </a:p>
         </p:txBody>
@@ -4169,7 +4176,7 @@
           <p:nvPr/>
         </p:nvPicPr>
         <p:blipFill>
-          <a:blip r:embed="rId2"/>
+          <a:blip r:embed="rId3"/>
           <a:stretch>
             <a:fillRect/>
           </a:stretch>
@@ -4265,7 +4272,13 @@
             </a:pPr>
             <a:r>
               <a:rPr b="1"/>
-              <a:t>A running example</a:t>
+              <a:t>A running example - Series2Graph algorithm from </a:t>
+            </a:r>
+            <a:r>
+              <a:rPr b="1">
+                <a:hlinkClick r:id="rId2"/>
+              </a:rPr>
+              <a:t>P. Boniol et al.</a:t>
             </a:r>
           </a:p>
         </p:txBody>
@@ -4279,7 +4292,7 @@
           <p:nvPr/>
         </p:nvPicPr>
         <p:blipFill>
-          <a:blip r:embed="rId2"/>
+          <a:blip r:embed="rId3"/>
           <a:stretch>
             <a:fillRect/>
           </a:stretch>
@@ -4375,7 +4388,13 @@
             </a:pPr>
             <a:r>
               <a:rPr b="1"/>
-              <a:t>A running example</a:t>
+              <a:t>A running example - Series2Graph algorithm from </a:t>
+            </a:r>
+            <a:r>
+              <a:rPr b="1">
+                <a:hlinkClick r:id="rId2"/>
+              </a:rPr>
+              <a:t>P. Boniol et al.</a:t>
             </a:r>
           </a:p>
         </p:txBody>
@@ -4389,7 +4408,7 @@
           <p:nvPr/>
         </p:nvPicPr>
         <p:blipFill>
-          <a:blip r:embed="rId2"/>
+          <a:blip r:embed="rId3"/>
           <a:stretch>
             <a:fillRect/>
           </a:stretch>
@@ -4627,7 +4646,13 @@
             </a:pPr>
             <a:r>
               <a:rPr b="1"/>
-              <a:t>A running example</a:t>
+              <a:t>A running example - Series2Graph algorithm from </a:t>
+            </a:r>
+            <a:r>
+              <a:rPr b="1">
+                <a:hlinkClick r:id="rId2"/>
+              </a:rPr>
+              <a:t>P. Boniol et al.</a:t>
             </a:r>
           </a:p>
         </p:txBody>
@@ -4641,7 +4666,7 @@
           <p:nvPr/>
         </p:nvPicPr>
         <p:blipFill>
-          <a:blip r:embed="rId2"/>
+          <a:blip r:embed="rId3"/>
           <a:stretch>
             <a:fillRect/>
           </a:stretch>
@@ -4737,7 +4762,13 @@
             </a:pPr>
             <a:r>
               <a:rPr b="1"/>
-              <a:t>A running example</a:t>
+              <a:t>A running example - Series2Graph algorithm from </a:t>
+            </a:r>
+            <a:r>
+              <a:rPr b="1">
+                <a:hlinkClick r:id="rId2"/>
+              </a:rPr>
+              <a:t>P. Boniol et al.</a:t>
             </a:r>
           </a:p>
         </p:txBody>
@@ -4751,7 +4782,7 @@
           <p:nvPr/>
         </p:nvPicPr>
         <p:blipFill>
-          <a:blip r:embed="rId2"/>
+          <a:blip r:embed="rId3"/>
           <a:stretch>
             <a:fillRect/>
           </a:stretch>
@@ -4804,12 +4835,7 @@
             <p:ph type="title"/>
           </p:nvPr>
         </p:nvSpPr>
-        <p:spPr>
-          <a:xfrm>
-            <a:off x="457201" y="204787"/>
-            <a:ext cx="3008313" cy="871538"/>
-          </a:xfrm>
-        </p:spPr>
+        <p:spPr/>
         <p:txBody>
           <a:bodyPr/>
           <a:lstStyle/>
@@ -4826,12 +4852,12 @@
       </p:sp>
       <p:sp>
         <p:nvSpPr>
-          <p:cNvPr id="4" name="Text Placeholder 3"/>
-          <p:cNvSpPr>
-            <a:spLocks noGrp="1"/>
-          </p:cNvSpPr>
-          <p:nvPr>
-            <p:ph idx="2" sz="half" type="body"/>
+          <p:cNvPr id="3" name="Content Placeholder 2"/>
+          <p:cNvSpPr>
+            <a:spLocks noGrp="1"/>
+          </p:cNvSpPr>
+          <p:nvPr>
+            <p:ph idx="1"/>
           </p:nvPr>
         </p:nvSpPr>
         <p:spPr/>
@@ -4847,11 +4873,39 @@
             </a:pPr>
             <a:r>
               <a:rPr b="1"/>
-              <a:t>A real data example</a:t>
-            </a:r>
-          </a:p>
-        </p:txBody>
-      </p:sp>
+              <a:t>A real data example - Series2Graph algorithm from </a:t>
+            </a:r>
+            <a:r>
+              <a:rPr b="1">
+                <a:hlinkClick r:id="rId2"/>
+              </a:rPr>
+              <a:t>P. Boniol et al.</a:t>
+            </a:r>
+          </a:p>
+        </p:txBody>
+      </p:sp>
+    </p:spTree>
+  </p:cSld>
+</p:sld>
+</file>
+
+<file path=ppt/slides/slide23.xml><?xml version="1.0" encoding="utf-8"?>
+<p:sld xmlns:a="http://schemas.openxmlformats.org/drawingml/2006/main" xmlns:r="http://schemas.openxmlformats.org/officeDocument/2006/relationships" xmlns:p="http://schemas.openxmlformats.org/presentationml/2006/main">
+  <p:cSld>
+    <p:spTree>
+      <p:nvGrpSpPr>
+        <p:cNvPr id="1" name=""/>
+        <p:cNvGrpSpPr/>
+        <p:nvPr/>
+      </p:nvGrpSpPr>
+      <p:grpSpPr>
+        <a:xfrm>
+          <a:off x="0" y="0"/>
+          <a:ext cx="0" cy="0"/>
+          <a:chOff x="0" y="0"/>
+          <a:chExt cx="0" cy="0"/>
+        </a:xfrm>
+      </p:grpSpPr>
       <p:pic>
         <p:nvPicPr>
           <p:cNvPr descr="https://github.com/ManuelePasini/slides-markdown/blob/master/slides/images/phd3rdyear/n2g/n2g_real.svg?raw=true" id="0" name="Picture 1"/>
@@ -4868,8 +4922,38 @@
         </p:blipFill>
         <p:spPr bwMode="auto">
           <a:xfrm>
-            <a:off x="3568700" y="571500"/>
-            <a:ext cx="5105400" cy="3632200"/>
+            <a:off x="457200" y="1447800"/>
+            <a:ext cx="4038600" cy="2870200"/>
+          </a:xfrm>
+          <a:prstGeom prst="rect">
+            <a:avLst/>
+          </a:prstGeom>
+          <a:noFill/>
+          <a:ln w="9525">
+            <a:noFill/>
+            <a:headEnd/>
+            <a:tailEnd/>
+          </a:ln>
+        </p:spPr>
+      </p:pic>
+      <p:pic>
+        <p:nvPicPr>
+          <p:cNvPr descr="https://github.com/ManuelePasini/slides-markdown/blob/master/slides/images/phd3rdyear/n2g/anom_top1.svg?raw=true" id="0" name="Picture 1"/>
+          <p:cNvPicPr>
+            <a:picLocks noGrp="1" noChangeAspect="1"/>
+          </p:cNvPicPr>
+          <p:nvPr/>
+        </p:nvPicPr>
+        <p:blipFill>
+          <a:blip r:embed="rId3"/>
+          <a:stretch>
+            <a:fillRect/>
+          </a:stretch>
+        </p:blipFill>
+        <p:spPr bwMode="auto">
+          <a:xfrm>
+            <a:off x="4787900" y="1193800"/>
+            <a:ext cx="3746500" cy="3390900"/>
           </a:xfrm>
           <a:prstGeom prst="rect">
             <a:avLst/>
@@ -4887,7 +4971,7 @@
 </p:sld>
 </file>
 
-<file path=ppt/slides/slide23.xml><?xml version="1.0" encoding="utf-8"?>
+<file path=ppt/slides/slide24.xml><?xml version="1.0" encoding="utf-8"?>
 <p:sld xmlns:a="http://schemas.openxmlformats.org/drawingml/2006/main" xmlns:r="http://schemas.openxmlformats.org/officeDocument/2006/relationships" xmlns:p="http://schemas.openxmlformats.org/presentationml/2006/main">
   <p:cSld>
     <p:spTree>
@@ -5900,6 +5984,13 @@
             <a:r>
               <a:rPr/>
               <a:t> Architecture</a:t>
+            </a:r>
+          </a:p>
+          <a:p>
+            <a:pPr lvl="1"/>
+            <a:r>
+              <a:rPr/>
+              <a:t>Data collected and transformed through a Data Platform</a:t>
             </a:r>
           </a:p>
           <a:p>

</xml_diff>